<commit_message>
Add test-cell diligence to Thesis II share slide
Co-Authored-By: Claude Opus 5.5 <noreply@anthropic.com>
Claude-Session: https://claude.ai/code/session_01UfcjrwVkNc9oEPnjB82u2w
</commit_message>
<xml_diff>
--- a/ftai_pitch/FTAI_Long_Pitch.pptx
+++ b/ftai_pitch/FTAI_Long_Pitch.pptx
@@ -2141,282 +2141,6 @@
   <c:date1904 val="0"/>
   <c:roundedCorners val="1"/>
   <c:chart>
-    <c:title>
-      <c:tx>
-        <c:rich>
-          <a:bodyPr/>
-          <a:lstStyle/>
-          <a:p>
-            <a:pPr>
-              <a:defRPr sz="1050" b="0" i="0" u="none" strike="noStrike">
-                <a:solidFill>
-                  <a:srgbClr val="262626"/>
-                </a:solidFill>
-                <a:latin typeface="Garamond"/>
-              </a:defRPr>
-            </a:pPr>
-            <a:r>
-              <a:rPr sz="1050" b="0" i="0" u="none" strike="noStrike">
-                <a:solidFill>
-                  <a:srgbClr val="262626"/>
-                </a:solidFill>
-                <a:latin typeface="Garamond"/>
-              </a:rPr>
-              <a:t>Lease Cost Idle</a:t>
-            </a:r>
-          </a:p>
-        </c:rich>
-      </c:tx>
-      <c:layout/>
-      <c:overlay val="0"/>
-    </c:title>
-    <c:autoTitleDeleted val="0"/>
-    <c:plotArea>
-      <c:layout/>
-      <c:barChart>
-        <c:barDir val="col"/>
-        <c:grouping val="clustered"/>
-        <c:varyColors val="0"/>
-        <c:ser>
-          <c:idx val="0"/>
-          <c:order val="0"/>
-          <c:tx>
-            <c:strRef>
-              <c:f>Sheet1!$B$1</c:f>
-              <c:strCache>
-                <c:ptCount val="1"/>
-                <c:pt idx="0">
-                  <c:v>Lease cost</c:v>
-                </c:pt>
-              </c:strCache>
-            </c:strRef>
-          </c:tx>
-          <c:spPr>
-            <a:solidFill>
-              <a:srgbClr val="A6A6A6"/>
-            </a:solidFill>
-            <a:effectLst/>
-          </c:spPr>
-          <c:invertIfNegative val="0"/>
-          <c:dLbls>
-            <c:numFmt formatCode="$0&quot;K&quot;" sourceLinked="0"/>
-            <c:txPr>
-              <a:bodyPr/>
-              <a:lstStyle/>
-              <a:p>
-                <a:pPr>
-                  <a:defRPr b="0" i="0" strike="noStrike" sz="900" u="none">
-                    <a:solidFill>
-                      <a:srgbClr val="262626"/>
-                    </a:solidFill>
-                    <a:latin typeface="Garamond"/>
-                  </a:defRPr>
-                </a:pPr>
-              </a:p>
-            </c:txPr>
-            <c:showLegendKey val="0"/>
-            <c:showVal val="1"/>
-            <c:showCatName val="0"/>
-            <c:showSerName val="0"/>
-            <c:showPercent val="0"/>
-            <c:showBubbleSize val="0"/>
-            <c:showLeaderLines val="0"/>
-          </c:dLbls>
-          <c:dPt>
-            <c:idx val="0"/>
-            <c:invertIfNegative val="0"/>
-            <c:bubble3D val="0"/>
-            <c:spPr>
-              <a:solidFill>
-                <a:srgbClr val="A6A6A6"/>
-              </a:solidFill>
-              <a:effectLst/>
-            </c:spPr>
-          </c:dPt>
-          <c:dPt>
-            <c:idx val="1"/>
-            <c:invertIfNegative val="0"/>
-            <c:bubble3D val="0"/>
-            <c:spPr>
-              <a:solidFill>
-                <a:srgbClr val="E8702A"/>
-              </a:solidFill>
-              <a:effectLst/>
-            </c:spPr>
-          </c:dPt>
-          <c:cat>
-            <c:multiLvlStrRef>
-              <c:f>Sheet1!$A$2:$A$3</c:f>
-              <c:multiLvlStrCache>
-                <c:ptCount val="2"/>
-                <c:lvl>
-                  <c:pt idx="0">
-                    <c:v>Shop visit</c:v>
-                  </c:pt>
-                  <c:pt idx="1">
-                    <c:v>FTAI swap</c:v>
-                  </c:pt>
-                </c:lvl>
-              </c:multiLvlStrCache>
-            </c:multiLvlStrRef>
-          </c:cat>
-          <c:val>
-            <c:numRef>
-              <c:f>Sheet1!$B$2:$B$3</c:f>
-              <c:numCache>
-                <c:formatCode>General</c:formatCode>
-                <c:ptCount val="2"/>
-                <c:pt idx="0">
-                  <c:v>425</c:v>
-                </c:pt>
-                <c:pt idx="1">
-                  <c:v>43</c:v>
-                </c:pt>
-              </c:numCache>
-            </c:numRef>
-          </c:val>
-        </c:ser>
-        <c:dLbls>
-          <c:numFmt formatCode="$0&quot;K&quot;" sourceLinked="0"/>
-          <c:txPr>
-            <a:bodyPr/>
-            <a:lstStyle/>
-            <a:p>
-              <a:pPr>
-                <a:defRPr b="0" i="0" strike="noStrike" sz="900" u="none">
-                  <a:solidFill>
-                    <a:srgbClr val="262626"/>
-                  </a:solidFill>
-                  <a:latin typeface="Garamond"/>
-                </a:defRPr>
-              </a:pPr>
-            </a:p>
-          </c:txPr>
-          <c:showLegendKey val="0"/>
-          <c:showVal val="1"/>
-          <c:showCatName val="0"/>
-          <c:showSerName val="0"/>
-          <c:showPercent val="0"/>
-          <c:showBubbleSize val="0"/>
-          <c:showLeaderLines val="0"/>
-        </c:dLbls>
-        <c:gapWidth val="45"/>
-        <c:overlap val="0"/>
-        <c:axId val="2094734554"/>
-        <c:axId val="2094734552"/>
-        <c:axId val="2094734556"/>
-      </c:barChart>
-      <c:catAx>
-        <c:axId val="2094734554"/>
-        <c:scaling>
-          <c:orientation val="minMax"/>
-        </c:scaling>
-        <c:delete val="0"/>
-        <c:axPos val="b"/>
-        <c:numFmt formatCode="General" sourceLinked="1"/>
-        <c:majorTickMark val="out"/>
-        <c:minorTickMark val="none"/>
-        <c:tickLblPos val="low"/>
-        <c:spPr>
-          <a:ln w="12700" cap="flat">
-            <a:solidFill>
-              <a:srgbClr val="7F7F7F"/>
-            </a:solidFill>
-            <a:prstDash val="solid"/>
-            <a:round/>
-          </a:ln>
-        </c:spPr>
-        <c:txPr>
-          <a:bodyPr/>
-          <a:lstStyle/>
-          <a:p>
-            <a:pPr>
-              <a:defRPr sz="950" b="0" i="0" u="none" strike="noStrike">
-                <a:solidFill>
-                  <a:srgbClr val="262626"/>
-                </a:solidFill>
-                <a:latin typeface="Garamond"/>
-              </a:defRPr>
-            </a:pPr>
-            <a:endParaRPr lang="en-US"/>
-          </a:p>
-        </c:txPr>
-        <c:crossAx val="2094734552"/>
-        <c:crosses val="autoZero"/>
-        <c:auto val="1"/>
-        <c:lblAlgn val="ctr"/>
-        <c:noMultiLvlLbl val="1"/>
-      </c:catAx>
-      <c:valAx>
-        <c:axId val="2094734552"/>
-        <c:scaling>
-          <c:orientation val="minMax"/>
-          <c:max val="510"/>
-          <c:min val="0"/>
-        </c:scaling>
-        <c:delete val="1"/>
-        <c:axPos val="l"/>
-        <c:numFmt formatCode="General" sourceLinked="0"/>
-        <c:majorTickMark val="out"/>
-        <c:minorTickMark val="none"/>
-        <c:tickLblPos val="nextTo"/>
-        <c:spPr>
-          <a:ln w="12700" cap="flat">
-            <a:solidFill>
-              <a:srgbClr val="888888"/>
-            </a:solidFill>
-            <a:prstDash val="solid"/>
-            <a:round/>
-          </a:ln>
-        </c:spPr>
-        <c:txPr>
-          <a:bodyPr/>
-          <a:lstStyle/>
-          <a:p>
-            <a:pPr>
-              <a:defRPr sz="900" b="0" i="0" u="none" strike="noStrike">
-                <a:solidFill>
-                  <a:srgbClr val="262626"/>
-                </a:solidFill>
-                <a:latin typeface="Garamond"/>
-              </a:defRPr>
-            </a:pPr>
-            <a:endParaRPr lang="en-US"/>
-          </a:p>
-        </c:txPr>
-        <c:crossAx val="2094734554"/>
-        <c:crosses val="autoZero"/>
-        <c:crossBetween val="between"/>
-      </c:valAx>
-      <c:spPr>
-        <a:noFill/>
-        <a:ln>
-          <a:noFill/>
-        </a:ln>
-        <a:effectLst/>
-      </c:spPr>
-    </c:plotArea>
-    <c:plotVisOnly val="1"/>
-    <c:dispBlanksAs val="span"/>
-  </c:chart>
-  <c:spPr>
-    <a:noFill/>
-    <a:ln>
-      <a:noFill/>
-    </a:ln>
-    <a:effectLst/>
-  </c:spPr>
-  <c:externalData r:id="rId1">
-    <c:autoUpdate val="0"/>
-  </c:externalData>
-</c:chartSpace>
-</file>
-
-<file path=ppt/charts/chart16.xml><?xml version="1.0" encoding="utf-8"?>
-<c:chartSpace xmlns:c="http://schemas.openxmlformats.org/drawingml/2006/chart" xmlns:a="http://schemas.openxmlformats.org/drawingml/2006/main" xmlns:r="http://schemas.openxmlformats.org/officeDocument/2006/relationships">
-  <c:date1904 val="0"/>
-  <c:roundedCorners val="1"/>
-  <c:chart>
     <c:autoTitleDeleted val="1"/>
     <c:plotArea>
       <c:layout/>
@@ -2817,7 +2541,7 @@
 </c:chartSpace>
 </file>
 
-<file path=ppt/charts/chart17.xml><?xml version="1.0" encoding="utf-8"?>
+<file path=ppt/charts/chart16.xml><?xml version="1.0" encoding="utf-8"?>
 <c:chartSpace xmlns:c="http://schemas.openxmlformats.org/drawingml/2006/chart" xmlns:a="http://schemas.openxmlformats.org/drawingml/2006/main" xmlns:r="http://schemas.openxmlformats.org/officeDocument/2006/relationships">
   <c:date1904 val="0"/>
   <c:roundedCorners val="1"/>
@@ -3181,7 +2905,7 @@
 </c:chartSpace>
 </file>
 
-<file path=ppt/charts/chart18.xml><?xml version="1.0" encoding="utf-8"?>
+<file path=ppt/charts/chart17.xml><?xml version="1.0" encoding="utf-8"?>
 <c:chartSpace xmlns:c="http://schemas.openxmlformats.org/drawingml/2006/chart" xmlns:a="http://schemas.openxmlformats.org/drawingml/2006/main" xmlns:r="http://schemas.openxmlformats.org/officeDocument/2006/relationships">
   <c:date1904 val="0"/>
   <c:roundedCorners val="1"/>
@@ -3471,7 +3195,7 @@
 </c:chartSpace>
 </file>
 
-<file path=ppt/charts/chart19.xml><?xml version="1.0" encoding="utf-8"?>
+<file path=ppt/charts/chart18.xml><?xml version="1.0" encoding="utf-8"?>
 <c:chartSpace xmlns:c="http://schemas.openxmlformats.org/drawingml/2006/chart" xmlns:a="http://schemas.openxmlformats.org/drawingml/2006/main" xmlns:r="http://schemas.openxmlformats.org/officeDocument/2006/relationships">
   <c:date1904 val="0"/>
   <c:roundedCorners val="1"/>
@@ -3755,262 +3479,7 @@
 </c:chartSpace>
 </file>
 
-<file path=ppt/charts/chart2.xml><?xml version="1.0" encoding="utf-8"?>
-<c:chartSpace xmlns:c="http://schemas.openxmlformats.org/drawingml/2006/chart" xmlns:a="http://schemas.openxmlformats.org/drawingml/2006/main" xmlns:r="http://schemas.openxmlformats.org/officeDocument/2006/relationships">
-  <c:date1904 val="0"/>
-  <c:roundedCorners val="1"/>
-  <c:chart>
-    <c:autoTitleDeleted val="1"/>
-    <c:plotArea>
-      <c:layout/>
-      <c:barChart>
-        <c:barDir val="col"/>
-        <c:grouping val="clustered"/>
-        <c:varyColors val="0"/>
-        <c:ser>
-          <c:idx val="0"/>
-          <c:order val="0"/>
-          <c:tx>
-            <c:strRef>
-              <c:f>Sheet1!$B$1</c:f>
-              <c:strCache>
-                <c:ptCount val="1"/>
-                <c:pt idx="0">
-                  <c:v>CFM56 shop visits</c:v>
-                </c:pt>
-              </c:strCache>
-            </c:strRef>
-          </c:tx>
-          <c:spPr>
-            <a:solidFill>
-              <a:srgbClr val="1F3864"/>
-            </a:solidFill>
-            <a:effectLst/>
-          </c:spPr>
-          <c:invertIfNegative val="0"/>
-          <c:dLbls>
-            <c:numFmt formatCode="#,##0" sourceLinked="0"/>
-            <c:txPr>
-              <a:bodyPr/>
-              <a:lstStyle/>
-              <a:p>
-                <a:pPr>
-                  <a:defRPr b="0" i="0" strike="noStrike" sz="900" u="none">
-                    <a:solidFill>
-                      <a:srgbClr val="262626"/>
-                    </a:solidFill>
-                    <a:latin typeface="Garamond"/>
-                  </a:defRPr>
-                </a:pPr>
-              </a:p>
-            </c:txPr>
-            <c:showLegendKey val="0"/>
-            <c:showVal val="1"/>
-            <c:showCatName val="0"/>
-            <c:showSerName val="0"/>
-            <c:showPercent val="0"/>
-            <c:showBubbleSize val="0"/>
-            <c:showLeaderLines val="0"/>
-          </c:dLbls>
-          <c:cat>
-            <c:multiLvlStrRef>
-              <c:f>Sheet1!$A$2:$A$8</c:f>
-              <c:multiLvlStrCache>
-                <c:ptCount val="7"/>
-                <c:lvl>
-                  <c:pt idx="0">
-                    <c:v>2025</c:v>
-                  </c:pt>
-                  <c:pt idx="1">
-                    <c:v>2026</c:v>
-                  </c:pt>
-                  <c:pt idx="2">
-                    <c:v>2027</c:v>
-                  </c:pt>
-                  <c:pt idx="3">
-                    <c:v>2028</c:v>
-                  </c:pt>
-                  <c:pt idx="4">
-                    <c:v>2029</c:v>
-                  </c:pt>
-                  <c:pt idx="5">
-                    <c:v>2030</c:v>
-                  </c:pt>
-                  <c:pt idx="6">
-                    <c:v>2031</c:v>
-                  </c:pt>
-                </c:lvl>
-              </c:multiLvlStrCache>
-            </c:multiLvlStrRef>
-          </c:cat>
-          <c:val>
-            <c:numRef>
-              <c:f>Sheet1!$B$2:$B$8</c:f>
-              <c:numCache>
-                <c:formatCode>General</c:formatCode>
-                <c:ptCount val="7"/>
-                <c:pt idx="0">
-                  <c:v>2350</c:v>
-                </c:pt>
-                <c:pt idx="1">
-                  <c:v>2400</c:v>
-                </c:pt>
-                <c:pt idx="2">
-                  <c:v>2400</c:v>
-                </c:pt>
-                <c:pt idx="3">
-                  <c:v>2350</c:v>
-                </c:pt>
-                <c:pt idx="4">
-                  <c:v>2250</c:v>
-                </c:pt>
-                <c:pt idx="5">
-                  <c:v>2150</c:v>
-                </c:pt>
-                <c:pt idx="6">
-                  <c:v>2085</c:v>
-                </c:pt>
-              </c:numCache>
-            </c:numRef>
-          </c:val>
-        </c:ser>
-        <c:dLbls>
-          <c:numFmt formatCode="#,##0" sourceLinked="0"/>
-          <c:txPr>
-            <a:bodyPr/>
-            <a:lstStyle/>
-            <a:p>
-              <a:pPr>
-                <a:defRPr b="0" i="0" strike="noStrike" sz="900" u="none">
-                  <a:solidFill>
-                    <a:srgbClr val="262626"/>
-                  </a:solidFill>
-                  <a:latin typeface="Garamond"/>
-                </a:defRPr>
-              </a:pPr>
-            </a:p>
-          </c:txPr>
-          <c:showLegendKey val="0"/>
-          <c:showVal val="1"/>
-          <c:showCatName val="0"/>
-          <c:showSerName val="0"/>
-          <c:showPercent val="0"/>
-          <c:showBubbleSize val="0"/>
-          <c:showLeaderLines val="0"/>
-        </c:dLbls>
-        <c:gapWidth val="45"/>
-        <c:overlap val="0"/>
-        <c:axId val="2094734554"/>
-        <c:axId val="2094734552"/>
-        <c:axId val="2094734556"/>
-      </c:barChart>
-      <c:catAx>
-        <c:axId val="2094734554"/>
-        <c:scaling>
-          <c:orientation val="minMax"/>
-        </c:scaling>
-        <c:delete val="0"/>
-        <c:axPos val="b"/>
-        <c:numFmt formatCode="General" sourceLinked="1"/>
-        <c:majorTickMark val="out"/>
-        <c:minorTickMark val="none"/>
-        <c:tickLblPos val="low"/>
-        <c:spPr>
-          <a:ln w="12700" cap="flat">
-            <a:solidFill>
-              <a:srgbClr val="7F7F7F"/>
-            </a:solidFill>
-            <a:prstDash val="solid"/>
-            <a:round/>
-          </a:ln>
-        </c:spPr>
-        <c:txPr>
-          <a:bodyPr/>
-          <a:lstStyle/>
-          <a:p>
-            <a:pPr>
-              <a:defRPr sz="1000" b="0" i="0" u="none" strike="noStrike">
-                <a:solidFill>
-                  <a:srgbClr val="262626"/>
-                </a:solidFill>
-                <a:latin typeface="Garamond"/>
-              </a:defRPr>
-            </a:pPr>
-            <a:endParaRPr lang="en-US"/>
-          </a:p>
-        </c:txPr>
-        <c:crossAx val="2094734552"/>
-        <c:crosses val="autoZero"/>
-        <c:auto val="1"/>
-        <c:lblAlgn val="ctr"/>
-        <c:noMultiLvlLbl val="1"/>
-      </c:catAx>
-      <c:valAx>
-        <c:axId val="2094734552"/>
-        <c:scaling>
-          <c:orientation val="minMax"/>
-          <c:max val="2900"/>
-          <c:min val="0"/>
-        </c:scaling>
-        <c:delete val="1"/>
-        <c:axPos val="l"/>
-        <c:numFmt formatCode="General" sourceLinked="0"/>
-        <c:majorTickMark val="out"/>
-        <c:minorTickMark val="none"/>
-        <c:tickLblPos val="nextTo"/>
-        <c:spPr>
-          <a:ln w="12700" cap="flat">
-            <a:solidFill>
-              <a:srgbClr val="888888"/>
-            </a:solidFill>
-            <a:prstDash val="solid"/>
-            <a:round/>
-          </a:ln>
-        </c:spPr>
-        <c:txPr>
-          <a:bodyPr/>
-          <a:lstStyle/>
-          <a:p>
-            <a:pPr>
-              <a:defRPr sz="1000" b="0" i="0" u="none" strike="noStrike">
-                <a:solidFill>
-                  <a:srgbClr val="262626"/>
-                </a:solidFill>
-                <a:latin typeface="Garamond"/>
-              </a:defRPr>
-            </a:pPr>
-            <a:endParaRPr lang="en-US"/>
-          </a:p>
-        </c:txPr>
-        <c:crossAx val="2094734554"/>
-        <c:crosses val="autoZero"/>
-        <c:crossBetween val="between"/>
-      </c:valAx>
-      <c:spPr>
-        <a:noFill/>
-        <a:ln>
-          <a:noFill/>
-        </a:ln>
-        <a:effectLst/>
-      </c:spPr>
-    </c:plotArea>
-    <c:plotVisOnly val="1"/>
-    <c:dispBlanksAs val="span"/>
-  </c:chart>
-  <c:spPr>
-    <a:noFill/>
-    <a:ln>
-      <a:noFill/>
-    </a:ln>
-    <a:effectLst/>
-  </c:spPr>
-  <c:externalData r:id="rId1">
-    <c:autoUpdate val="0"/>
-  </c:externalData>
-</c:chartSpace>
-</file>
-
-<file path=ppt/charts/chart20.xml><?xml version="1.0" encoding="utf-8"?>
+<file path=ppt/charts/chart19.xml><?xml version="1.0" encoding="utf-8"?>
 <c:chartSpace xmlns:c="http://schemas.openxmlformats.org/drawingml/2006/chart" xmlns:a="http://schemas.openxmlformats.org/drawingml/2006/main" xmlns:r="http://schemas.openxmlformats.org/officeDocument/2006/relationships">
   <c:date1904 val="0"/>
   <c:roundedCorners val="1"/>
@@ -4505,7 +3974,262 @@
 </c:chartSpace>
 </file>
 
-<file path=ppt/charts/chart21.xml><?xml version="1.0" encoding="utf-8"?>
+<file path=ppt/charts/chart2.xml><?xml version="1.0" encoding="utf-8"?>
+<c:chartSpace xmlns:c="http://schemas.openxmlformats.org/drawingml/2006/chart" xmlns:a="http://schemas.openxmlformats.org/drawingml/2006/main" xmlns:r="http://schemas.openxmlformats.org/officeDocument/2006/relationships">
+  <c:date1904 val="0"/>
+  <c:roundedCorners val="1"/>
+  <c:chart>
+    <c:autoTitleDeleted val="1"/>
+    <c:plotArea>
+      <c:layout/>
+      <c:barChart>
+        <c:barDir val="col"/>
+        <c:grouping val="clustered"/>
+        <c:varyColors val="0"/>
+        <c:ser>
+          <c:idx val="0"/>
+          <c:order val="0"/>
+          <c:tx>
+            <c:strRef>
+              <c:f>Sheet1!$B$1</c:f>
+              <c:strCache>
+                <c:ptCount val="1"/>
+                <c:pt idx="0">
+                  <c:v>CFM56 shop visits</c:v>
+                </c:pt>
+              </c:strCache>
+            </c:strRef>
+          </c:tx>
+          <c:spPr>
+            <a:solidFill>
+              <a:srgbClr val="1F3864"/>
+            </a:solidFill>
+            <a:effectLst/>
+          </c:spPr>
+          <c:invertIfNegative val="0"/>
+          <c:dLbls>
+            <c:numFmt formatCode="#,##0" sourceLinked="0"/>
+            <c:txPr>
+              <a:bodyPr/>
+              <a:lstStyle/>
+              <a:p>
+                <a:pPr>
+                  <a:defRPr b="0" i="0" strike="noStrike" sz="900" u="none">
+                    <a:solidFill>
+                      <a:srgbClr val="262626"/>
+                    </a:solidFill>
+                    <a:latin typeface="Garamond"/>
+                  </a:defRPr>
+                </a:pPr>
+              </a:p>
+            </c:txPr>
+            <c:showLegendKey val="0"/>
+            <c:showVal val="1"/>
+            <c:showCatName val="0"/>
+            <c:showSerName val="0"/>
+            <c:showPercent val="0"/>
+            <c:showBubbleSize val="0"/>
+            <c:showLeaderLines val="0"/>
+          </c:dLbls>
+          <c:cat>
+            <c:multiLvlStrRef>
+              <c:f>Sheet1!$A$2:$A$8</c:f>
+              <c:multiLvlStrCache>
+                <c:ptCount val="7"/>
+                <c:lvl>
+                  <c:pt idx="0">
+                    <c:v>2025</c:v>
+                  </c:pt>
+                  <c:pt idx="1">
+                    <c:v>2026</c:v>
+                  </c:pt>
+                  <c:pt idx="2">
+                    <c:v>2027</c:v>
+                  </c:pt>
+                  <c:pt idx="3">
+                    <c:v>2028</c:v>
+                  </c:pt>
+                  <c:pt idx="4">
+                    <c:v>2029</c:v>
+                  </c:pt>
+                  <c:pt idx="5">
+                    <c:v>2030</c:v>
+                  </c:pt>
+                  <c:pt idx="6">
+                    <c:v>2031</c:v>
+                  </c:pt>
+                </c:lvl>
+              </c:multiLvlStrCache>
+            </c:multiLvlStrRef>
+          </c:cat>
+          <c:val>
+            <c:numRef>
+              <c:f>Sheet1!$B$2:$B$8</c:f>
+              <c:numCache>
+                <c:formatCode>General</c:formatCode>
+                <c:ptCount val="7"/>
+                <c:pt idx="0">
+                  <c:v>2350</c:v>
+                </c:pt>
+                <c:pt idx="1">
+                  <c:v>2400</c:v>
+                </c:pt>
+                <c:pt idx="2">
+                  <c:v>2400</c:v>
+                </c:pt>
+                <c:pt idx="3">
+                  <c:v>2350</c:v>
+                </c:pt>
+                <c:pt idx="4">
+                  <c:v>2250</c:v>
+                </c:pt>
+                <c:pt idx="5">
+                  <c:v>2150</c:v>
+                </c:pt>
+                <c:pt idx="6">
+                  <c:v>2085</c:v>
+                </c:pt>
+              </c:numCache>
+            </c:numRef>
+          </c:val>
+        </c:ser>
+        <c:dLbls>
+          <c:numFmt formatCode="#,##0" sourceLinked="0"/>
+          <c:txPr>
+            <a:bodyPr/>
+            <a:lstStyle/>
+            <a:p>
+              <a:pPr>
+                <a:defRPr b="0" i="0" strike="noStrike" sz="900" u="none">
+                  <a:solidFill>
+                    <a:srgbClr val="262626"/>
+                  </a:solidFill>
+                  <a:latin typeface="Garamond"/>
+                </a:defRPr>
+              </a:pPr>
+            </a:p>
+          </c:txPr>
+          <c:showLegendKey val="0"/>
+          <c:showVal val="1"/>
+          <c:showCatName val="0"/>
+          <c:showSerName val="0"/>
+          <c:showPercent val="0"/>
+          <c:showBubbleSize val="0"/>
+          <c:showLeaderLines val="0"/>
+        </c:dLbls>
+        <c:gapWidth val="45"/>
+        <c:overlap val="0"/>
+        <c:axId val="2094734554"/>
+        <c:axId val="2094734552"/>
+        <c:axId val="2094734556"/>
+      </c:barChart>
+      <c:catAx>
+        <c:axId val="2094734554"/>
+        <c:scaling>
+          <c:orientation val="minMax"/>
+        </c:scaling>
+        <c:delete val="0"/>
+        <c:axPos val="b"/>
+        <c:numFmt formatCode="General" sourceLinked="1"/>
+        <c:majorTickMark val="out"/>
+        <c:minorTickMark val="none"/>
+        <c:tickLblPos val="low"/>
+        <c:spPr>
+          <a:ln w="12700" cap="flat">
+            <a:solidFill>
+              <a:srgbClr val="7F7F7F"/>
+            </a:solidFill>
+            <a:prstDash val="solid"/>
+            <a:round/>
+          </a:ln>
+        </c:spPr>
+        <c:txPr>
+          <a:bodyPr/>
+          <a:lstStyle/>
+          <a:p>
+            <a:pPr>
+              <a:defRPr sz="1000" b="0" i="0" u="none" strike="noStrike">
+                <a:solidFill>
+                  <a:srgbClr val="262626"/>
+                </a:solidFill>
+                <a:latin typeface="Garamond"/>
+              </a:defRPr>
+            </a:pPr>
+            <a:endParaRPr lang="en-US"/>
+          </a:p>
+        </c:txPr>
+        <c:crossAx val="2094734552"/>
+        <c:crosses val="autoZero"/>
+        <c:auto val="1"/>
+        <c:lblAlgn val="ctr"/>
+        <c:noMultiLvlLbl val="1"/>
+      </c:catAx>
+      <c:valAx>
+        <c:axId val="2094734552"/>
+        <c:scaling>
+          <c:orientation val="minMax"/>
+          <c:max val="2900"/>
+          <c:min val="0"/>
+        </c:scaling>
+        <c:delete val="1"/>
+        <c:axPos val="l"/>
+        <c:numFmt formatCode="General" sourceLinked="0"/>
+        <c:majorTickMark val="out"/>
+        <c:minorTickMark val="none"/>
+        <c:tickLblPos val="nextTo"/>
+        <c:spPr>
+          <a:ln w="12700" cap="flat">
+            <a:solidFill>
+              <a:srgbClr val="888888"/>
+            </a:solidFill>
+            <a:prstDash val="solid"/>
+            <a:round/>
+          </a:ln>
+        </c:spPr>
+        <c:txPr>
+          <a:bodyPr/>
+          <a:lstStyle/>
+          <a:p>
+            <a:pPr>
+              <a:defRPr sz="1000" b="0" i="0" u="none" strike="noStrike">
+                <a:solidFill>
+                  <a:srgbClr val="262626"/>
+                </a:solidFill>
+                <a:latin typeface="Garamond"/>
+              </a:defRPr>
+            </a:pPr>
+            <a:endParaRPr lang="en-US"/>
+          </a:p>
+        </c:txPr>
+        <c:crossAx val="2094734554"/>
+        <c:crosses val="autoZero"/>
+        <c:crossBetween val="between"/>
+      </c:valAx>
+      <c:spPr>
+        <a:noFill/>
+        <a:ln>
+          <a:noFill/>
+        </a:ln>
+        <a:effectLst/>
+      </c:spPr>
+    </c:plotArea>
+    <c:plotVisOnly val="1"/>
+    <c:dispBlanksAs val="span"/>
+  </c:chart>
+  <c:spPr>
+    <a:noFill/>
+    <a:ln>
+      <a:noFill/>
+    </a:ln>
+    <a:effectLst/>
+  </c:spPr>
+  <c:externalData r:id="rId1">
+    <c:autoUpdate val="0"/>
+  </c:externalData>
+</c:chartSpace>
+</file>
+
+<file path=ppt/charts/chart20.xml><?xml version="1.0" encoding="utf-8"?>
 <c:chartSpace xmlns:c="http://schemas.openxmlformats.org/drawingml/2006/chart" xmlns:a="http://schemas.openxmlformats.org/drawingml/2006/main" xmlns:r="http://schemas.openxmlformats.org/officeDocument/2006/relationships">
   <c:date1904 val="0"/>
   <c:roundedCorners val="1"/>
@@ -4984,7 +4708,7 @@
 </c:chartSpace>
 </file>
 
-<file path=ppt/charts/chart22.xml><?xml version="1.0" encoding="utf-8"?>
+<file path=ppt/charts/chart21.xml><?xml version="1.0" encoding="utf-8"?>
 <c:chartSpace xmlns:c="http://schemas.openxmlformats.org/drawingml/2006/chart" xmlns:a="http://schemas.openxmlformats.org/drawingml/2006/main" xmlns:r="http://schemas.openxmlformats.org/officeDocument/2006/relationships">
   <c:date1904 val="0"/>
   <c:roundedCorners val="1"/>
@@ -46845,7 +46569,7 @@
         </p:nvGraphicFramePr>
         <p:xfrm>
           <a:off x="621792" y="1170432"/>
-          <a:ext cx="2011680" cy="1600200"/>
+          <a:ext cx="1783080" cy="1572768"/>
         </p:xfrm>
         <a:graphic xmlns:a="http://schemas.openxmlformats.org/drawingml/2006/main">
           <a:graphicData uri="http://schemas.openxmlformats.org/drawingml/2006/chart">
@@ -46853,54 +46577,16 @@
           </a:graphicData>
         </a:graphic>
       </p:graphicFrame>
-      <p:graphicFrame>
-        <p:nvGraphicFramePr>
-          <p:cNvPr id="6" name="Chart 1" descr=""/>
-          <p:cNvGraphicFramePr/>
-          <p:nvPr/>
-        </p:nvGraphicFramePr>
-        <p:xfrm>
-          <a:off x="2679192" y="1170432"/>
-          <a:ext cx="2011680" cy="1600200"/>
-        </p:xfrm>
-        <a:graphic xmlns:a="http://schemas.openxmlformats.org/drawingml/2006/main">
-          <a:graphicData uri="http://schemas.openxmlformats.org/drawingml/2006/chart">
-            <c:chart xmlns:c="http://schemas.openxmlformats.org/drawingml/2006/chart" r:id="rId2"/>
-          </a:graphicData>
-        </a:graphic>
-      </p:graphicFrame>
-      <p:sp>
-        <p:nvSpPr>
-          <p:cNvPr id="7" name="Shape 3"/>
-          <p:cNvSpPr/>
+      <p:sp>
+        <p:nvSpPr>
+          <p:cNvPr id="6" name="Text 3"/>
+          <p:cNvSpPr txBox="1"/>
           <p:nvPr/>
         </p:nvSpPr>
         <p:spPr>
           <a:xfrm>
-            <a:off x="4782312" y="1188720"/>
-            <a:ext cx="1325880" cy="1554480"/>
-          </a:xfrm>
-          <a:prstGeom prst="rect">
-            <a:avLst/>
-          </a:prstGeom>
-          <a:ln w="15875">
-            <a:solidFill>
-              <a:srgbClr val="1A1A1A"/>
-            </a:solidFill>
-            <a:prstDash val="dash"/>
-          </a:ln>
-        </p:spPr>
-      </p:sp>
-      <p:sp>
-        <p:nvSpPr>
-          <p:cNvPr id="8" name="Text 4"/>
-          <p:cNvSpPr txBox="1"/>
-          <p:nvPr/>
-        </p:nvSpPr>
-        <p:spPr>
-          <a:xfrm>
-            <a:off x="4828032" y="1207008"/>
-            <a:ext cx="1252728" cy="1517904"/>
+            <a:off x="2496312" y="1152144"/>
+            <a:ext cx="3611880" cy="219456"/>
           </a:xfrm>
           <a:prstGeom prst="rect">
             <a:avLst/>
@@ -46909,7 +46595,878 @@
           <a:ln/>
         </p:spPr>
         <p:txBody>
-          <a:bodyPr wrap="square" lIns="25400" tIns="25400" rIns="25400" bIns="25400" rtlCol="0" anchor="ctr"/>
+          <a:bodyPr wrap="square" lIns="25400" tIns="25400" rIns="25400" bIns="25400" rtlCol="0" anchor="t"/>
+          <a:lstStyle/>
+          <a:p>
+            <a:pPr algn="ctr" indent="0" marL="0">
+              <a:lnSpc>
+                <a:spcPct val="100000"/>
+              </a:lnSpc>
+              <a:buNone/>
+            </a:pPr>
+            <a:r>
+              <a:rPr lang="en-US" sz="1050" b="1" u="sng" dirty="0">
+                <a:solidFill>
+                  <a:srgbClr val="1A1A1A"/>
+                </a:solidFill>
+                <a:latin typeface="Garamond" pitchFamily="34" charset="0"/>
+                <a:ea typeface="Garamond" pitchFamily="34" charset="-122"/>
+                <a:cs typeface="Garamond" pitchFamily="34" charset="-120"/>
+              </a:rPr>
+              <a:t>Test cells: LEAP now shares CFM56's scarcest slot</a:t>
+            </a:r>
+            <a:r>
+              <a:rPr lang="en-US" sz="1050" baseline="30000" dirty="0">
+                <a:solidFill>
+                  <a:srgbClr val="1A1A1A"/>
+                </a:solidFill>
+                <a:latin typeface="Garamond" pitchFamily="34" charset="0"/>
+                <a:ea typeface="Garamond" pitchFamily="34" charset="-122"/>
+                <a:cs typeface="Garamond" pitchFamily="34" charset="-120"/>
+              </a:rPr>
+              <a:t>1</a:t>
+            </a:r>
+            <a:endParaRPr lang="en-US" sz="1050" dirty="0"/>
+          </a:p>
+        </p:txBody>
+      </p:sp>
+      <p:graphicFrame>
+        <p:nvGraphicFramePr>
+          <p:cNvPr id="10" name="Table 0"/>
+          <p:cNvGraphicFramePr>
+            <a:graphicFrameLocks noGrp="1"/>
+          </p:cNvGraphicFramePr>
+          <p:nvPr>
+            <p:extLst>
+              <p:ext uri="{D42A27DB-BD31-4B8C-83A1-F6EECF244321}">
+                <p14:modId xmlns:p14="http://schemas.microsoft.com/office/powerpoint/2010/main" val="1579011935"/>
+              </p:ext>
+            </p:extLst>
+          </p:nvPr>
+        </p:nvGraphicFramePr>
+        <p:xfrm>
+          <a:off x="2496312" y="1371600"/>
+          <a:ext cx="3611880" cy="914400"/>
+        </p:xfrm>
+        <a:graphic>
+          <a:graphicData uri="http://schemas.openxmlformats.org/drawingml/2006/table">
+            <a:tbl>
+              <a:tblPr/>
+              <a:tblGrid>
+                <a:gridCol w="2880360"/>
+                <a:gridCol w="731520"/>
+              </a:tblGrid>
+              <a:tr h="182880">
+                <a:tc>
+                  <a:txBody>
+                    <a:bodyPr/>
+                    <a:lstStyle/>
+                    <a:p>
+                      <a:pPr algn="ctr" indent="0" marL="0">
+                        <a:buNone/>
+                      </a:pPr>
+                      <a:r>
+                        <a:rPr lang="en-US" sz="900" b="1" dirty="0">
+                          <a:solidFill>
+                            <a:srgbClr val="FFFFFF"/>
+                          </a:solidFill>
+                          <a:latin typeface="Garamond" pitchFamily="34" charset="0"/>
+                          <a:ea typeface="Garamond" pitchFamily="34" charset="-122"/>
+                          <a:cs typeface="Garamond" pitchFamily="34" charset="-120"/>
+                        </a:rPr>
+                        <a:t>Engine test cells tracked (18)</a:t>
+                      </a:r>
+                      <a:endParaRPr lang="en-US" sz="900" dirty="0">
+                        <a:latin typeface="Garamond" charset="0"/>
+                        <a:ea typeface="Garamond" charset="0"/>
+                        <a:cs typeface="Garamond" charset="0"/>
+                      </a:endParaRPr>
+                    </a:p>
+                  </a:txBody>
+                  <a:tcPr marL="38100" marR="38100" marT="12700" marB="12700">
+                    <a:lnL w="6350" cap="flat" cmpd="sng" algn="ctr">
+                      <a:solidFill>
+                        <a:srgbClr val="BFBFBF"/>
+                      </a:solidFill>
+                      <a:prstDash val="solid"/>
+                      <a:round/>
+                      <a:headEnd type="none" w="med" len="med"/>
+                      <a:tailEnd type="none" w="med" len="med"/>
+                    </a:lnL>
+                    <a:lnR w="6350" cap="flat" cmpd="sng" algn="ctr">
+                      <a:solidFill>
+                        <a:srgbClr val="BFBFBF"/>
+                      </a:solidFill>
+                      <a:prstDash val="solid"/>
+                      <a:round/>
+                      <a:headEnd type="none" w="med" len="med"/>
+                      <a:tailEnd type="none" w="med" len="med"/>
+                    </a:lnR>
+                    <a:lnT w="6350" cap="flat" cmpd="sng" algn="ctr">
+                      <a:solidFill>
+                        <a:srgbClr val="BFBFBF"/>
+                      </a:solidFill>
+                      <a:prstDash val="solid"/>
+                      <a:round/>
+                      <a:headEnd type="none" w="med" len="med"/>
+                      <a:tailEnd type="none" w="med" len="med"/>
+                    </a:lnT>
+                    <a:lnB w="6350" cap="flat" cmpd="sng" algn="ctr">
+                      <a:solidFill>
+                        <a:srgbClr val="BFBFBF"/>
+                      </a:solidFill>
+                      <a:prstDash val="solid"/>
+                      <a:round/>
+                      <a:headEnd type="none" w="med" len="med"/>
+                      <a:tailEnd type="none" w="med" len="med"/>
+                    </a:lnB>
+                    <a:solidFill>
+                      <a:srgbClr val="1F3864"/>
+                    </a:solidFill>
+                  </a:tcPr>
+                </a:tc>
+                <a:tc>
+                  <a:txBody>
+                    <a:bodyPr/>
+                    <a:lstStyle/>
+                    <a:p>
+                      <a:pPr algn="ctr" indent="0" marL="0">
+                        <a:buNone/>
+                      </a:pPr>
+                      <a:r>
+                        <a:rPr lang="en-US" sz="900" b="1" dirty="0">
+                          <a:solidFill>
+                            <a:srgbClr val="FFFFFF"/>
+                          </a:solidFill>
+                          <a:latin typeface="Garamond" pitchFamily="34" charset="0"/>
+                          <a:ea typeface="Garamond" pitchFamily="34" charset="-122"/>
+                          <a:cs typeface="Garamond" pitchFamily="34" charset="-120"/>
+                        </a:rPr>
+                        <a:t>Cells</a:t>
+                      </a:r>
+                      <a:endParaRPr lang="en-US" sz="900" dirty="0">
+                        <a:latin typeface="Garamond" charset="0"/>
+                        <a:ea typeface="Garamond" charset="0"/>
+                        <a:cs typeface="Garamond" charset="0"/>
+                      </a:endParaRPr>
+                    </a:p>
+                  </a:txBody>
+                  <a:tcPr marL="38100" marR="38100" marT="12700" marB="12700">
+                    <a:lnL w="6350" cap="flat" cmpd="sng" algn="ctr">
+                      <a:solidFill>
+                        <a:srgbClr val="BFBFBF"/>
+                      </a:solidFill>
+                      <a:prstDash val="solid"/>
+                      <a:round/>
+                      <a:headEnd type="none" w="med" len="med"/>
+                      <a:tailEnd type="none" w="med" len="med"/>
+                    </a:lnL>
+                    <a:lnR w="6350" cap="flat" cmpd="sng" algn="ctr">
+                      <a:solidFill>
+                        <a:srgbClr val="BFBFBF"/>
+                      </a:solidFill>
+                      <a:prstDash val="solid"/>
+                      <a:round/>
+                      <a:headEnd type="none" w="med" len="med"/>
+                      <a:tailEnd type="none" w="med" len="med"/>
+                    </a:lnR>
+                    <a:lnT w="6350" cap="flat" cmpd="sng" algn="ctr">
+                      <a:solidFill>
+                        <a:srgbClr val="BFBFBF"/>
+                      </a:solidFill>
+                      <a:prstDash val="solid"/>
+                      <a:round/>
+                      <a:headEnd type="none" w="med" len="med"/>
+                      <a:tailEnd type="none" w="med" len="med"/>
+                    </a:lnT>
+                    <a:lnB w="6350" cap="flat" cmpd="sng" algn="ctr">
+                      <a:solidFill>
+                        <a:srgbClr val="BFBFBF"/>
+                      </a:solidFill>
+                      <a:prstDash val="solid"/>
+                      <a:round/>
+                      <a:headEnd type="none" w="med" len="med"/>
+                      <a:tailEnd type="none" w="med" len="med"/>
+                    </a:lnB>
+                    <a:solidFill>
+                      <a:srgbClr val="1F3864"/>
+                    </a:solidFill>
+                  </a:tcPr>
+                </a:tc>
+              </a:tr>
+              <a:tr h="182880">
+                <a:tc>
+                  <a:txBody>
+                    <a:bodyPr/>
+                    <a:lstStyle/>
+                    <a:p>
+                      <a:pPr algn="l" indent="0" marL="0">
+                        <a:buNone/>
+                      </a:pPr>
+                      <a:r>
+                        <a:rPr lang="en-US" sz="900" dirty="0">
+                          <a:solidFill>
+                            <a:srgbClr val="1A1A1A"/>
+                          </a:solidFill>
+                          <a:latin typeface="Garamond" pitchFamily="34" charset="0"/>
+                          <a:ea typeface="Garamond" pitchFamily="34" charset="-122"/>
+                          <a:cs typeface="Garamond" pitchFamily="34" charset="-120"/>
+                        </a:rPr>
+                        <a:t>Existing cells adapted to test LEAP</a:t>
+                      </a:r>
+                      <a:endParaRPr lang="en-US" sz="1200" dirty="0"/>
+                    </a:p>
+                  </a:txBody>
+                  <a:tcPr marL="38100" marR="38100" marT="12700" marB="12700">
+                    <a:lnL w="6350" cap="flat" cmpd="sng" algn="ctr">
+                      <a:solidFill>
+                        <a:srgbClr val="BFBFBF"/>
+                      </a:solidFill>
+                      <a:prstDash val="solid"/>
+                      <a:round/>
+                      <a:headEnd type="none" w="med" len="med"/>
+                      <a:tailEnd type="none" w="med" len="med"/>
+                    </a:lnL>
+                    <a:lnR w="6350" cap="flat" cmpd="sng" algn="ctr">
+                      <a:solidFill>
+                        <a:srgbClr val="BFBFBF"/>
+                      </a:solidFill>
+                      <a:prstDash val="solid"/>
+                      <a:round/>
+                      <a:headEnd type="none" w="med" len="med"/>
+                      <a:tailEnd type="none" w="med" len="med"/>
+                    </a:lnR>
+                    <a:lnT w="6350" cap="flat" cmpd="sng" algn="ctr">
+                      <a:solidFill>
+                        <a:srgbClr val="BFBFBF"/>
+                      </a:solidFill>
+                      <a:prstDash val="solid"/>
+                      <a:round/>
+                      <a:headEnd type="none" w="med" len="med"/>
+                      <a:tailEnd type="none" w="med" len="med"/>
+                    </a:lnT>
+                    <a:lnB w="6350" cap="flat" cmpd="sng" algn="ctr">
+                      <a:solidFill>
+                        <a:srgbClr val="BFBFBF"/>
+                      </a:solidFill>
+                      <a:prstDash val="solid"/>
+                      <a:round/>
+                      <a:headEnd type="none" w="med" len="med"/>
+                      <a:tailEnd type="none" w="med" len="med"/>
+                    </a:lnB>
+                    <a:solidFill>
+                      <a:srgbClr val="FFFFFF"/>
+                    </a:solidFill>
+                  </a:tcPr>
+                </a:tc>
+                <a:tc>
+                  <a:txBody>
+                    <a:bodyPr/>
+                    <a:lstStyle/>
+                    <a:p>
+                      <a:pPr algn="ctr" indent="0" marL="0">
+                        <a:buNone/>
+                      </a:pPr>
+                      <a:r>
+                        <a:rPr lang="en-US" sz="900" b="1" dirty="0">
+                          <a:solidFill>
+                            <a:srgbClr val="1A1A1A"/>
+                          </a:solidFill>
+                          <a:latin typeface="Garamond" pitchFamily="34" charset="0"/>
+                          <a:ea typeface="Garamond" pitchFamily="34" charset="-122"/>
+                          <a:cs typeface="Garamond" pitchFamily="34" charset="-120"/>
+                        </a:rPr>
+                        <a:t>9</a:t>
+                      </a:r>
+                      <a:endParaRPr lang="en-US" sz="1200" dirty="0"/>
+                    </a:p>
+                  </a:txBody>
+                  <a:tcPr marL="38100" marR="38100" marT="12700" marB="12700">
+                    <a:lnL w="6350" cap="flat" cmpd="sng" algn="ctr">
+                      <a:solidFill>
+                        <a:srgbClr val="BFBFBF"/>
+                      </a:solidFill>
+                      <a:prstDash val="solid"/>
+                      <a:round/>
+                      <a:headEnd type="none" w="med" len="med"/>
+                      <a:tailEnd type="none" w="med" len="med"/>
+                    </a:lnL>
+                    <a:lnR w="6350" cap="flat" cmpd="sng" algn="ctr">
+                      <a:solidFill>
+                        <a:srgbClr val="BFBFBF"/>
+                      </a:solidFill>
+                      <a:prstDash val="solid"/>
+                      <a:round/>
+                      <a:headEnd type="none" w="med" len="med"/>
+                      <a:tailEnd type="none" w="med" len="med"/>
+                    </a:lnR>
+                    <a:lnT w="6350" cap="flat" cmpd="sng" algn="ctr">
+                      <a:solidFill>
+                        <a:srgbClr val="BFBFBF"/>
+                      </a:solidFill>
+                      <a:prstDash val="solid"/>
+                      <a:round/>
+                      <a:headEnd type="none" w="med" len="med"/>
+                      <a:tailEnd type="none" w="med" len="med"/>
+                    </a:lnT>
+                    <a:lnB w="6350" cap="flat" cmpd="sng" algn="ctr">
+                      <a:solidFill>
+                        <a:srgbClr val="BFBFBF"/>
+                      </a:solidFill>
+                      <a:prstDash val="solid"/>
+                      <a:round/>
+                      <a:headEnd type="none" w="med" len="med"/>
+                      <a:tailEnd type="none" w="med" len="med"/>
+                    </a:lnB>
+                    <a:solidFill>
+                      <a:srgbClr val="FFFFFF"/>
+                    </a:solidFill>
+                  </a:tcPr>
+                </a:tc>
+              </a:tr>
+              <a:tr h="182880">
+                <a:tc>
+                  <a:txBody>
+                    <a:bodyPr/>
+                    <a:lstStyle/>
+                    <a:p>
+                      <a:pPr algn="l" indent="0" marL="0">
+                        <a:buNone/>
+                      </a:pPr>
+                      <a:r>
+                        <a:rPr lang="en-US" sz="900" dirty="0">
+                          <a:solidFill>
+                            <a:srgbClr val="1A1A1A"/>
+                          </a:solidFill>
+                          <a:latin typeface="Garamond" pitchFamily="34" charset="0"/>
+                          <a:ea typeface="Garamond" pitchFamily="34" charset="-122"/>
+                          <a:cs typeface="Garamond" pitchFamily="34" charset="-120"/>
+                        </a:rPr>
+                        <a:t>...still testing CFM56 (where disclosed)</a:t>
+                      </a:r>
+                      <a:endParaRPr lang="en-US" sz="1200" dirty="0"/>
+                    </a:p>
+                  </a:txBody>
+                  <a:tcPr marL="38100" marR="38100" marT="12700" marB="12700">
+                    <a:lnL w="6350" cap="flat" cmpd="sng" algn="ctr">
+                      <a:solidFill>
+                        <a:srgbClr val="BFBFBF"/>
+                      </a:solidFill>
+                      <a:prstDash val="solid"/>
+                      <a:round/>
+                      <a:headEnd type="none" w="med" len="med"/>
+                      <a:tailEnd type="none" w="med" len="med"/>
+                    </a:lnL>
+                    <a:lnR w="6350" cap="flat" cmpd="sng" algn="ctr">
+                      <a:solidFill>
+                        <a:srgbClr val="BFBFBF"/>
+                      </a:solidFill>
+                      <a:prstDash val="solid"/>
+                      <a:round/>
+                      <a:headEnd type="none" w="med" len="med"/>
+                      <a:tailEnd type="none" w="med" len="med"/>
+                    </a:lnR>
+                    <a:lnT w="6350" cap="flat" cmpd="sng" algn="ctr">
+                      <a:solidFill>
+                        <a:srgbClr val="BFBFBF"/>
+                      </a:solidFill>
+                      <a:prstDash val="solid"/>
+                      <a:round/>
+                      <a:headEnd type="none" w="med" len="med"/>
+                      <a:tailEnd type="none" w="med" len="med"/>
+                    </a:lnT>
+                    <a:lnB w="6350" cap="flat" cmpd="sng" algn="ctr">
+                      <a:solidFill>
+                        <a:srgbClr val="BFBFBF"/>
+                      </a:solidFill>
+                      <a:prstDash val="solid"/>
+                      <a:round/>
+                      <a:headEnd type="none" w="med" len="med"/>
+                      <a:tailEnd type="none" w="med" len="med"/>
+                    </a:lnB>
+                    <a:solidFill>
+                      <a:srgbClr val="F2F2F2"/>
+                    </a:solidFill>
+                  </a:tcPr>
+                </a:tc>
+                <a:tc>
+                  <a:txBody>
+                    <a:bodyPr/>
+                    <a:lstStyle/>
+                    <a:p>
+                      <a:pPr algn="ctr" indent="0" marL="0">
+                        <a:buNone/>
+                      </a:pPr>
+                      <a:r>
+                        <a:rPr lang="en-US" sz="900" dirty="0">
+                          <a:solidFill>
+                            <a:srgbClr val="1A1A1A"/>
+                          </a:solidFill>
+                          <a:latin typeface="Garamond" pitchFamily="34" charset="0"/>
+                          <a:ea typeface="Garamond" pitchFamily="34" charset="-122"/>
+                          <a:cs typeface="Garamond" pitchFamily="34" charset="-120"/>
+                        </a:rPr>
+                        <a:t>4 of 4</a:t>
+                      </a:r>
+                      <a:endParaRPr lang="en-US" sz="1200" dirty="0"/>
+                    </a:p>
+                  </a:txBody>
+                  <a:tcPr marL="38100" marR="38100" marT="12700" marB="12700">
+                    <a:lnL w="6350" cap="flat" cmpd="sng" algn="ctr">
+                      <a:solidFill>
+                        <a:srgbClr val="BFBFBF"/>
+                      </a:solidFill>
+                      <a:prstDash val="solid"/>
+                      <a:round/>
+                      <a:headEnd type="none" w="med" len="med"/>
+                      <a:tailEnd type="none" w="med" len="med"/>
+                    </a:lnL>
+                    <a:lnR w="6350" cap="flat" cmpd="sng" algn="ctr">
+                      <a:solidFill>
+                        <a:srgbClr val="BFBFBF"/>
+                      </a:solidFill>
+                      <a:prstDash val="solid"/>
+                      <a:round/>
+                      <a:headEnd type="none" w="med" len="med"/>
+                      <a:tailEnd type="none" w="med" len="med"/>
+                    </a:lnR>
+                    <a:lnT w="6350" cap="flat" cmpd="sng" algn="ctr">
+                      <a:solidFill>
+                        <a:srgbClr val="BFBFBF"/>
+                      </a:solidFill>
+                      <a:prstDash val="solid"/>
+                      <a:round/>
+                      <a:headEnd type="none" w="med" len="med"/>
+                      <a:tailEnd type="none" w="med" len="med"/>
+                    </a:lnT>
+                    <a:lnB w="6350" cap="flat" cmpd="sng" algn="ctr">
+                      <a:solidFill>
+                        <a:srgbClr val="BFBFBF"/>
+                      </a:solidFill>
+                      <a:prstDash val="solid"/>
+                      <a:round/>
+                      <a:headEnd type="none" w="med" len="med"/>
+                      <a:tailEnd type="none" w="med" len="med"/>
+                    </a:lnB>
+                    <a:solidFill>
+                      <a:srgbClr val="F2F2F2"/>
+                    </a:solidFill>
+                  </a:tcPr>
+                </a:tc>
+              </a:tr>
+              <a:tr h="182880">
+                <a:tc>
+                  <a:txBody>
+                    <a:bodyPr/>
+                    <a:lstStyle/>
+                    <a:p>
+                      <a:pPr algn="l" indent="0" marL="0">
+                        <a:buNone/>
+                      </a:pPr>
+                      <a:r>
+                        <a:rPr lang="en-US" sz="900" dirty="0">
+                          <a:solidFill>
+                            <a:srgbClr val="1A1A1A"/>
+                          </a:solidFill>
+                          <a:latin typeface="Garamond" pitchFamily="34" charset="0"/>
+                          <a:ea typeface="Garamond" pitchFamily="34" charset="-122"/>
+                          <a:cs typeface="Garamond" pitchFamily="34" charset="-120"/>
+                        </a:rPr>
+                        <a:t>...dropped CFM56</a:t>
+                      </a:r>
+                      <a:endParaRPr lang="en-US" sz="1200" dirty="0"/>
+                    </a:p>
+                  </a:txBody>
+                  <a:tcPr marL="38100" marR="38100" marT="12700" marB="12700">
+                    <a:lnL w="6350" cap="flat" cmpd="sng" algn="ctr">
+                      <a:solidFill>
+                        <a:srgbClr val="BFBFBF"/>
+                      </a:solidFill>
+                      <a:prstDash val="solid"/>
+                      <a:round/>
+                      <a:headEnd type="none" w="med" len="med"/>
+                      <a:tailEnd type="none" w="med" len="med"/>
+                    </a:lnL>
+                    <a:lnR w="6350" cap="flat" cmpd="sng" algn="ctr">
+                      <a:solidFill>
+                        <a:srgbClr val="BFBFBF"/>
+                      </a:solidFill>
+                      <a:prstDash val="solid"/>
+                      <a:round/>
+                      <a:headEnd type="none" w="med" len="med"/>
+                      <a:tailEnd type="none" w="med" len="med"/>
+                    </a:lnR>
+                    <a:lnT w="6350" cap="flat" cmpd="sng" algn="ctr">
+                      <a:solidFill>
+                        <a:srgbClr val="BFBFBF"/>
+                      </a:solidFill>
+                      <a:prstDash val="solid"/>
+                      <a:round/>
+                      <a:headEnd type="none" w="med" len="med"/>
+                      <a:tailEnd type="none" w="med" len="med"/>
+                    </a:lnT>
+                    <a:lnB w="6350" cap="flat" cmpd="sng" algn="ctr">
+                      <a:solidFill>
+                        <a:srgbClr val="BFBFBF"/>
+                      </a:solidFill>
+                      <a:prstDash val="solid"/>
+                      <a:round/>
+                      <a:headEnd type="none" w="med" len="med"/>
+                      <a:tailEnd type="none" w="med" len="med"/>
+                    </a:lnB>
+                    <a:solidFill>
+                      <a:srgbClr val="FFFFFF"/>
+                    </a:solidFill>
+                  </a:tcPr>
+                </a:tc>
+                <a:tc>
+                  <a:txBody>
+                    <a:bodyPr/>
+                    <a:lstStyle/>
+                    <a:p>
+                      <a:pPr algn="ctr" indent="0" marL="0">
+                        <a:buNone/>
+                      </a:pPr>
+                      <a:r>
+                        <a:rPr lang="en-US" sz="900" b="1" dirty="0">
+                          <a:solidFill>
+                            <a:srgbClr val="1A1A1A"/>
+                          </a:solidFill>
+                          <a:latin typeface="Garamond" pitchFamily="34" charset="0"/>
+                          <a:ea typeface="Garamond" pitchFamily="34" charset="-122"/>
+                          <a:cs typeface="Garamond" pitchFamily="34" charset="-120"/>
+                        </a:rPr>
+                        <a:t>0</a:t>
+                      </a:r>
+                      <a:endParaRPr lang="en-US" sz="1200" dirty="0"/>
+                    </a:p>
+                  </a:txBody>
+                  <a:tcPr marL="38100" marR="38100" marT="12700" marB="12700">
+                    <a:lnL w="6350" cap="flat" cmpd="sng" algn="ctr">
+                      <a:solidFill>
+                        <a:srgbClr val="BFBFBF"/>
+                      </a:solidFill>
+                      <a:prstDash val="solid"/>
+                      <a:round/>
+                      <a:headEnd type="none" w="med" len="med"/>
+                      <a:tailEnd type="none" w="med" len="med"/>
+                    </a:lnL>
+                    <a:lnR w="6350" cap="flat" cmpd="sng" algn="ctr">
+                      <a:solidFill>
+                        <a:srgbClr val="BFBFBF"/>
+                      </a:solidFill>
+                      <a:prstDash val="solid"/>
+                      <a:round/>
+                      <a:headEnd type="none" w="med" len="med"/>
+                      <a:tailEnd type="none" w="med" len="med"/>
+                    </a:lnR>
+                    <a:lnT w="6350" cap="flat" cmpd="sng" algn="ctr">
+                      <a:solidFill>
+                        <a:srgbClr val="BFBFBF"/>
+                      </a:solidFill>
+                      <a:prstDash val="solid"/>
+                      <a:round/>
+                      <a:headEnd type="none" w="med" len="med"/>
+                      <a:tailEnd type="none" w="med" len="med"/>
+                    </a:lnT>
+                    <a:lnB w="6350" cap="flat" cmpd="sng" algn="ctr">
+                      <a:solidFill>
+                        <a:srgbClr val="BFBFBF"/>
+                      </a:solidFill>
+                      <a:prstDash val="solid"/>
+                      <a:round/>
+                      <a:headEnd type="none" w="med" len="med"/>
+                      <a:tailEnd type="none" w="med" len="med"/>
+                    </a:lnB>
+                    <a:solidFill>
+                      <a:srgbClr val="FFFFFF"/>
+                    </a:solidFill>
+                  </a:tcPr>
+                </a:tc>
+              </a:tr>
+              <a:tr h="182880">
+                <a:tc>
+                  <a:txBody>
+                    <a:bodyPr/>
+                    <a:lstStyle/>
+                    <a:p>
+                      <a:pPr algn="l" indent="0" marL="0">
+                        <a:buNone/>
+                      </a:pPr>
+                      <a:r>
+                        <a:rPr lang="en-US" sz="900" dirty="0">
+                          <a:solidFill>
+                            <a:srgbClr val="1A1A1A"/>
+                          </a:solidFill>
+                          <a:latin typeface="Garamond" pitchFamily="34" charset="0"/>
+                          <a:ea typeface="Garamond" pitchFamily="34" charset="-122"/>
+                          <a:cs typeface="Garamond" pitchFamily="34" charset="-120"/>
+                        </a:rPr>
+                        <a:t>New cells built for LEAP</a:t>
+                      </a:r>
+                      <a:endParaRPr lang="en-US" sz="1200" dirty="0"/>
+                    </a:p>
+                  </a:txBody>
+                  <a:tcPr marL="38100" marR="38100" marT="12700" marB="12700">
+                    <a:lnL w="6350" cap="flat" cmpd="sng" algn="ctr">
+                      <a:solidFill>
+                        <a:srgbClr val="BFBFBF"/>
+                      </a:solidFill>
+                      <a:prstDash val="solid"/>
+                      <a:round/>
+                      <a:headEnd type="none" w="med" len="med"/>
+                      <a:tailEnd type="none" w="med" len="med"/>
+                    </a:lnL>
+                    <a:lnR w="6350" cap="flat" cmpd="sng" algn="ctr">
+                      <a:solidFill>
+                        <a:srgbClr val="BFBFBF"/>
+                      </a:solidFill>
+                      <a:prstDash val="solid"/>
+                      <a:round/>
+                      <a:headEnd type="none" w="med" len="med"/>
+                      <a:tailEnd type="none" w="med" len="med"/>
+                    </a:lnR>
+                    <a:lnT w="6350" cap="flat" cmpd="sng" algn="ctr">
+                      <a:solidFill>
+                        <a:srgbClr val="BFBFBF"/>
+                      </a:solidFill>
+                      <a:prstDash val="solid"/>
+                      <a:round/>
+                      <a:headEnd type="none" w="med" len="med"/>
+                      <a:tailEnd type="none" w="med" len="med"/>
+                    </a:lnT>
+                    <a:lnB w="6350" cap="flat" cmpd="sng" algn="ctr">
+                      <a:solidFill>
+                        <a:srgbClr val="BFBFBF"/>
+                      </a:solidFill>
+                      <a:prstDash val="solid"/>
+                      <a:round/>
+                      <a:headEnd type="none" w="med" len="med"/>
+                      <a:tailEnd type="none" w="med" len="med"/>
+                    </a:lnB>
+                    <a:solidFill>
+                      <a:srgbClr val="F2F2F2"/>
+                    </a:solidFill>
+                  </a:tcPr>
+                </a:tc>
+                <a:tc>
+                  <a:txBody>
+                    <a:bodyPr/>
+                    <a:lstStyle/>
+                    <a:p>
+                      <a:pPr algn="ctr" indent="0" marL="0">
+                        <a:buNone/>
+                      </a:pPr>
+                      <a:r>
+                        <a:rPr lang="en-US" sz="900" dirty="0">
+                          <a:solidFill>
+                            <a:srgbClr val="1A1A1A"/>
+                          </a:solidFill>
+                          <a:latin typeface="Garamond" pitchFamily="34" charset="0"/>
+                          <a:ea typeface="Garamond" pitchFamily="34" charset="-122"/>
+                          <a:cs typeface="Garamond" pitchFamily="34" charset="-120"/>
+                        </a:rPr>
+                        <a:t>7</a:t>
+                      </a:r>
+                      <a:endParaRPr lang="en-US" sz="1200" dirty="0"/>
+                    </a:p>
+                  </a:txBody>
+                  <a:tcPr marL="38100" marR="38100" marT="12700" marB="12700">
+                    <a:lnL w="6350" cap="flat" cmpd="sng" algn="ctr">
+                      <a:solidFill>
+                        <a:srgbClr val="BFBFBF"/>
+                      </a:solidFill>
+                      <a:prstDash val="solid"/>
+                      <a:round/>
+                      <a:headEnd type="none" w="med" len="med"/>
+                      <a:tailEnd type="none" w="med" len="med"/>
+                    </a:lnL>
+                    <a:lnR w="6350" cap="flat" cmpd="sng" algn="ctr">
+                      <a:solidFill>
+                        <a:srgbClr val="BFBFBF"/>
+                      </a:solidFill>
+                      <a:prstDash val="solid"/>
+                      <a:round/>
+                      <a:headEnd type="none" w="med" len="med"/>
+                      <a:tailEnd type="none" w="med" len="med"/>
+                    </a:lnR>
+                    <a:lnT w="6350" cap="flat" cmpd="sng" algn="ctr">
+                      <a:solidFill>
+                        <a:srgbClr val="BFBFBF"/>
+                      </a:solidFill>
+                      <a:prstDash val="solid"/>
+                      <a:round/>
+                      <a:headEnd type="none" w="med" len="med"/>
+                      <a:tailEnd type="none" w="med" len="med"/>
+                    </a:lnT>
+                    <a:lnB w="6350" cap="flat" cmpd="sng" algn="ctr">
+                      <a:solidFill>
+                        <a:srgbClr val="BFBFBF"/>
+                      </a:solidFill>
+                      <a:prstDash val="solid"/>
+                      <a:round/>
+                      <a:headEnd type="none" w="med" len="med"/>
+                      <a:tailEnd type="none" w="med" len="med"/>
+                    </a:lnB>
+                    <a:solidFill>
+                      <a:srgbClr val="F2F2F2"/>
+                    </a:solidFill>
+                  </a:tcPr>
+                </a:tc>
+              </a:tr>
+              <a:tr h="182880">
+                <a:tc>
+                  <a:txBody>
+                    <a:bodyPr/>
+                    <a:lstStyle/>
+                    <a:p>
+                      <a:pPr algn="l" indent="0" marL="0">
+                        <a:buNone/>
+                      </a:pPr>
+                      <a:r>
+                        <a:rPr lang="en-US" sz="900" dirty="0">
+                          <a:solidFill>
+                            <a:srgbClr val="1A1A1A"/>
+                          </a:solidFill>
+                          <a:latin typeface="Garamond" pitchFamily="34" charset="0"/>
+                          <a:ea typeface="Garamond" pitchFamily="34" charset="-122"/>
+                          <a:cs typeface="Garamond" pitchFamily="34" charset="-120"/>
+                        </a:rPr>
+                        <a:t>New cell built first for CFM56 (Willis + GEM)</a:t>
+                      </a:r>
+                      <a:endParaRPr lang="en-US" sz="1200" dirty="0"/>
+                    </a:p>
+                  </a:txBody>
+                  <a:tcPr marL="38100" marR="38100" marT="12700" marB="12700">
+                    <a:lnL w="6350" cap="flat" cmpd="sng" algn="ctr">
+                      <a:solidFill>
+                        <a:srgbClr val="BFBFBF"/>
+                      </a:solidFill>
+                      <a:prstDash val="solid"/>
+                      <a:round/>
+                      <a:headEnd type="none" w="med" len="med"/>
+                      <a:tailEnd type="none" w="med" len="med"/>
+                    </a:lnL>
+                    <a:lnR w="6350" cap="flat" cmpd="sng" algn="ctr">
+                      <a:solidFill>
+                        <a:srgbClr val="BFBFBF"/>
+                      </a:solidFill>
+                      <a:prstDash val="solid"/>
+                      <a:round/>
+                      <a:headEnd type="none" w="med" len="med"/>
+                      <a:tailEnd type="none" w="med" len="med"/>
+                    </a:lnR>
+                    <a:lnT w="6350" cap="flat" cmpd="sng" algn="ctr">
+                      <a:solidFill>
+                        <a:srgbClr val="BFBFBF"/>
+                      </a:solidFill>
+                      <a:prstDash val="solid"/>
+                      <a:round/>
+                      <a:headEnd type="none" w="med" len="med"/>
+                      <a:tailEnd type="none" w="med" len="med"/>
+                    </a:lnT>
+                    <a:lnB w="6350" cap="flat" cmpd="sng" algn="ctr">
+                      <a:solidFill>
+                        <a:srgbClr val="BFBFBF"/>
+                      </a:solidFill>
+                      <a:prstDash val="solid"/>
+                      <a:round/>
+                      <a:headEnd type="none" w="med" len="med"/>
+                      <a:tailEnd type="none" w="med" len="med"/>
+                    </a:lnB>
+                    <a:solidFill>
+                      <a:srgbClr val="FFFFFF"/>
+                    </a:solidFill>
+                  </a:tcPr>
+                </a:tc>
+                <a:tc>
+                  <a:txBody>
+                    <a:bodyPr/>
+                    <a:lstStyle/>
+                    <a:p>
+                      <a:pPr algn="ctr" indent="0" marL="0">
+                        <a:buNone/>
+                      </a:pPr>
+                      <a:r>
+                        <a:rPr lang="en-US" sz="900" b="1" dirty="0">
+                          <a:solidFill>
+                            <a:srgbClr val="1A1A1A"/>
+                          </a:solidFill>
+                          <a:latin typeface="Garamond" pitchFamily="34" charset="0"/>
+                          <a:ea typeface="Garamond" pitchFamily="34" charset="-122"/>
+                          <a:cs typeface="Garamond" pitchFamily="34" charset="-120"/>
+                        </a:rPr>
+                        <a:t>1</a:t>
+                      </a:r>
+                      <a:endParaRPr lang="en-US" sz="1200" dirty="0"/>
+                    </a:p>
+                  </a:txBody>
+                  <a:tcPr marL="38100" marR="38100" marT="12700" marB="12700">
+                    <a:lnL w="6350" cap="flat" cmpd="sng" algn="ctr">
+                      <a:solidFill>
+                        <a:srgbClr val="BFBFBF"/>
+                      </a:solidFill>
+                      <a:prstDash val="solid"/>
+                      <a:round/>
+                      <a:headEnd type="none" w="med" len="med"/>
+                      <a:tailEnd type="none" w="med" len="med"/>
+                    </a:lnL>
+                    <a:lnR w="6350" cap="flat" cmpd="sng" algn="ctr">
+                      <a:solidFill>
+                        <a:srgbClr val="BFBFBF"/>
+                      </a:solidFill>
+                      <a:prstDash val="solid"/>
+                      <a:round/>
+                      <a:headEnd type="none" w="med" len="med"/>
+                      <a:tailEnd type="none" w="med" len="med"/>
+                    </a:lnR>
+                    <a:lnT w="6350" cap="flat" cmpd="sng" algn="ctr">
+                      <a:solidFill>
+                        <a:srgbClr val="BFBFBF"/>
+                      </a:solidFill>
+                      <a:prstDash val="solid"/>
+                      <a:round/>
+                      <a:headEnd type="none" w="med" len="med"/>
+                      <a:tailEnd type="none" w="med" len="med"/>
+                    </a:lnT>
+                    <a:lnB w="6350" cap="flat" cmpd="sng" algn="ctr">
+                      <a:solidFill>
+                        <a:srgbClr val="BFBFBF"/>
+                      </a:solidFill>
+                      <a:prstDash val="solid"/>
+                      <a:round/>
+                      <a:headEnd type="none" w="med" len="med"/>
+                      <a:tailEnd type="none" w="med" len="med"/>
+                    </a:lnB>
+                    <a:solidFill>
+                      <a:srgbClr val="FFFFFF"/>
+                    </a:solidFill>
+                  </a:tcPr>
+                </a:tc>
+              </a:tr>
+            </a:tbl>
+          </a:graphicData>
+        </a:graphic>
+      </p:graphicFrame>
+      <p:sp>
+        <p:nvSpPr>
+          <p:cNvPr id="8" name="Text 4"/>
+          <p:cNvSpPr txBox="1"/>
+          <p:nvPr/>
+        </p:nvSpPr>
+        <p:spPr>
+          <a:xfrm>
+            <a:off x="2496312" y="2487168"/>
+            <a:ext cx="3611880" cy="329184"/>
+          </a:xfrm>
+          <a:prstGeom prst="rect">
+            <a:avLst/>
+          </a:prstGeom>
+          <a:noFill/>
+          <a:ln/>
+        </p:spPr>
+        <p:txBody>
+          <a:bodyPr wrap="square" lIns="25400" tIns="25400" rIns="25400" bIns="25400" rtlCol="0" anchor="t"/>
           <a:lstStyle/>
           <a:p>
             <a:pPr algn="l" indent="0" marL="0">
@@ -46919,116 +47476,45 @@
               <a:buNone/>
             </a:pPr>
             <a:r>
-              <a:rPr lang="en-US" sz="1000" dirty="0">
-                <a:solidFill>
-                  <a:srgbClr val="1A1A1A"/>
-                </a:solidFill>
-                <a:latin typeface="Garamond" pitchFamily="34" charset="0"/>
-                <a:ea typeface="Garamond" pitchFamily="34" charset="-122"/>
-                <a:cs typeface="Garamond" pitchFamily="34" charset="-120"/>
-              </a:rPr>
-              <a:t>Shop visit </a:t>
-            </a:r>
-            <a:r>
-              <a:rPr lang="en-US" sz="1000" u="sng" dirty="0">
-                <a:solidFill>
-                  <a:srgbClr val="1A1A1A"/>
-                </a:solidFill>
-                <a:latin typeface="Garamond" pitchFamily="34" charset="0"/>
-                <a:ea typeface="Garamond" pitchFamily="34" charset="-122"/>
-                <a:cs typeface="Garamond" pitchFamily="34" charset="-120"/>
-              </a:rPr>
-              <a:t>120–180 days</a:t>
-            </a:r>
-            <a:r>
-              <a:rPr lang="en-US" sz="1000" dirty="0">
-                <a:solidFill>
-                  <a:srgbClr val="1A1A1A"/>
-                </a:solidFill>
-                <a:latin typeface="Garamond" pitchFamily="34" charset="0"/>
-                <a:ea typeface="Garamond" pitchFamily="34" charset="-122"/>
-                <a:cs typeface="Garamond" pitchFamily="34" charset="-120"/>
-              </a:rPr>
-              <a:t> vs. swap </a:t>
-            </a:r>
-            <a:r>
-              <a:rPr lang="en-US" sz="1000" u="sng" dirty="0">
-                <a:solidFill>
-                  <a:srgbClr val="1A1A1A"/>
-                </a:solidFill>
-                <a:latin typeface="Garamond" pitchFamily="34" charset="0"/>
-                <a:ea typeface="Garamond" pitchFamily="34" charset="-122"/>
-                <a:cs typeface="Garamond" pitchFamily="34" charset="-120"/>
-              </a:rPr>
-              <a:t>5–25</a:t>
-            </a:r>
-            <a:endParaRPr lang="en-US" sz="1000" dirty="0"/>
-          </a:p>
-          <a:p>
-            <a:pPr algn="l" indent="0" marL="0">
-              <a:lnSpc>
-                <a:spcPct val="100000"/>
-              </a:lnSpc>
-              <a:buNone/>
-            </a:pPr>
-            <a:endParaRPr lang="en-US" sz="1000" dirty="0"/>
-          </a:p>
-          <a:p>
-            <a:pPr algn="l" indent="0" marL="0">
-              <a:lnSpc>
-                <a:spcPct val="100000"/>
-              </a:lnSpc>
-              <a:buNone/>
-            </a:pPr>
-            <a:r>
-              <a:rPr lang="en-US" sz="1000" dirty="0">
-                <a:solidFill>
-                  <a:srgbClr val="1A1A1A"/>
-                </a:solidFill>
-                <a:latin typeface="Garamond" pitchFamily="34" charset="0"/>
-                <a:ea typeface="Garamond" pitchFamily="34" charset="-122"/>
-                <a:cs typeface="Garamond" pitchFamily="34" charset="-120"/>
-              </a:rPr>
-              <a:t>Most swaps take </a:t>
-            </a:r>
-            <a:endParaRPr lang="en-US" sz="1000" dirty="0"/>
-          </a:p>
-          <a:p>
-            <a:pPr algn="l" indent="0" marL="0">
-              <a:lnSpc>
-                <a:spcPct val="100000"/>
-              </a:lnSpc>
-              <a:buNone/>
-            </a:pPr>
-            <a:r>
-              <a:rPr lang="en-US" sz="1000" u="sng" dirty="0">
-                <a:solidFill>
-                  <a:srgbClr val="1A1A1A"/>
-                </a:solidFill>
-                <a:latin typeface="Garamond" pitchFamily="34" charset="0"/>
-                <a:ea typeface="Garamond" pitchFamily="34" charset="-122"/>
-                <a:cs typeface="Garamond" pitchFamily="34" charset="-120"/>
-              </a:rPr>
-              <a:t>5–7 days</a:t>
-            </a:r>
-            <a:r>
-              <a:rPr lang="en-US" sz="1000" dirty="0">
-                <a:solidFill>
-                  <a:srgbClr val="1A1A1A"/>
-                </a:solidFill>
-                <a:latin typeface="Garamond" pitchFamily="34" charset="0"/>
-                <a:ea typeface="Garamond" pitchFamily="34" charset="-122"/>
-                <a:cs typeface="Garamond" pitchFamily="34" charset="-120"/>
-              </a:rPr>
-              <a:t> – In Practise expert</a:t>
-            </a:r>
-            <a:endParaRPr lang="en-US" sz="1000" dirty="0"/>
+              <a:rPr lang="en-US" sz="900" dirty="0">
+                <a:solidFill>
+                  <a:srgbClr val="595959"/>
+                </a:solidFill>
+                <a:latin typeface="Garamond" pitchFamily="34" charset="0"/>
+                <a:ea typeface="Garamond" pitchFamily="34" charset="-122"/>
+                <a:cs typeface="Garamond" pitchFamily="34" charset="-120"/>
+              </a:rPr>
+              <a:t>“</a:t>
+            </a:r>
+            <a:r>
+              <a:rPr lang="en-US" sz="900" u="sng" dirty="0">
+                <a:solidFill>
+                  <a:srgbClr val="595959"/>
+                </a:solidFill>
+                <a:latin typeface="Garamond" pitchFamily="34" charset="0"/>
+                <a:ea typeface="Garamond" pitchFamily="34" charset="-122"/>
+                <a:cs typeface="Garamond" pitchFamily="34" charset="-120"/>
+              </a:rPr>
+              <a:t>Ongoing shortage of testing capacity</a:t>
+            </a:r>
+            <a:r>
+              <a:rPr lang="en-US" sz="900" dirty="0">
+                <a:solidFill>
+                  <a:srgbClr val="595959"/>
+                </a:solidFill>
+                <a:latin typeface="Garamond" pitchFamily="34" charset="0"/>
+                <a:ea typeface="Garamond" pitchFamily="34" charset="-122"/>
+                <a:cs typeface="Garamond" pitchFamily="34" charset="-120"/>
+              </a:rPr>
+              <a:t>” – Willis Lease; “Europe-wide testing capacity constraints” – SR Technics</a:t>
+            </a:r>
+            <a:endParaRPr lang="en-US" sz="900" dirty="0"/>
           </a:p>
         </p:txBody>
       </p:sp>
       <p:graphicFrame>
         <p:nvGraphicFramePr>
-          <p:cNvPr id="10" name="Table 0"/>
+          <p:cNvPr id="19" name="Table 1"/>
           <p:cNvGraphicFramePr>
             <a:graphicFrameLocks noGrp="1"/>
           </p:cNvGraphicFramePr>
@@ -47053,7 +47539,7 @@
                 <a:gridCol w="2560320"/>
                 <a:gridCol w="2057400"/>
               </a:tblGrid>
-              <a:tr h="219456">
+              <a:tr h="192024">
                 <a:tc>
                   <a:txBody>
                     <a:bodyPr/>
@@ -47063,7 +47549,7 @@
                         <a:buNone/>
                       </a:pPr>
                       <a:r>
-                        <a:rPr lang="en-US" sz="1000" b="1" dirty="0">
+                        <a:rPr lang="en-US" sz="950" b="1" dirty="0">
                           <a:solidFill>
                             <a:srgbClr val="FFFFFF"/>
                           </a:solidFill>
@@ -47073,7 +47559,7 @@
                         </a:rPr>
                         <a:t>Edge</a:t>
                       </a:r>
-                      <a:endParaRPr lang="en-US" sz="1000" dirty="0">
+                      <a:endParaRPr lang="en-US" sz="950" dirty="0">
                         <a:latin typeface="Garamond" charset="0"/>
                         <a:ea typeface="Garamond" charset="0"/>
                         <a:cs typeface="Garamond" charset="0"/>
@@ -47131,7 +47617,7 @@
                         <a:buNone/>
                       </a:pPr>
                       <a:r>
-                        <a:rPr lang="en-US" sz="1000" b="1" dirty="0">
+                        <a:rPr lang="en-US" sz="950" b="1" dirty="0">
                           <a:solidFill>
                             <a:srgbClr val="FFFFFF"/>
                           </a:solidFill>
@@ -47141,7 +47627,7 @@
                         </a:rPr>
                         <a:t>FTAI</a:t>
                       </a:r>
-                      <a:endParaRPr lang="en-US" sz="1000" dirty="0">
+                      <a:endParaRPr lang="en-US" sz="950" dirty="0">
                         <a:latin typeface="Garamond" charset="0"/>
                         <a:ea typeface="Garamond" charset="0"/>
                         <a:cs typeface="Garamond" charset="0"/>
@@ -47199,7 +47685,7 @@
                         <a:buNone/>
                       </a:pPr>
                       <a:r>
-                        <a:rPr lang="en-US" sz="1000" b="1" dirty="0">
+                        <a:rPr lang="en-US" sz="950" b="1" dirty="0">
                           <a:solidFill>
                             <a:srgbClr val="FFFFFF"/>
                           </a:solidFill>
@@ -47209,7 +47695,7 @@
                         </a:rPr>
                         <a:t>OEM / large MRO shops</a:t>
                       </a:r>
-                      <a:endParaRPr lang="en-US" sz="1000" dirty="0">
+                      <a:endParaRPr lang="en-US" sz="950" dirty="0">
                         <a:latin typeface="Garamond" charset="0"/>
                         <a:ea typeface="Garamond" charset="0"/>
                         <a:cs typeface="Garamond" charset="0"/>
@@ -47259,7 +47745,7 @@
                   </a:tcPr>
                 </a:tc>
               </a:tr>
-              <a:tr h="219456">
+              <a:tr h="192024">
                 <a:tc>
                   <a:txBody>
                     <a:bodyPr/>
@@ -47269,7 +47755,7 @@
                         <a:buNone/>
                       </a:pPr>
                       <a:r>
-                        <a:rPr lang="en-US" sz="1000" dirty="0">
+                        <a:rPr lang="en-US" sz="950" dirty="0">
                           <a:solidFill>
                             <a:srgbClr val="1A1A1A"/>
                           </a:solidFill>
@@ -47333,7 +47819,7 @@
                         <a:buNone/>
                       </a:pPr>
                       <a:r>
-                        <a:rPr lang="en-US" sz="1000" dirty="0">
+                        <a:rPr lang="en-US" sz="950" dirty="0">
                           <a:solidFill>
                             <a:srgbClr val="1A1A1A"/>
                           </a:solidFill>
@@ -47397,7 +47883,7 @@
                         <a:buNone/>
                       </a:pPr>
                       <a:r>
-                        <a:rPr lang="en-US" sz="1000" dirty="0">
+                        <a:rPr lang="en-US" sz="950" dirty="0">
                           <a:solidFill>
                             <a:srgbClr val="1A1A1A"/>
                           </a:solidFill>
@@ -47453,7 +47939,7 @@
                   </a:tcPr>
                 </a:tc>
               </a:tr>
-              <a:tr h="219456">
+              <a:tr h="192024">
                 <a:tc>
                   <a:txBody>
                     <a:bodyPr/>
@@ -47463,7 +47949,7 @@
                         <a:buNone/>
                       </a:pPr>
                       <a:r>
-                        <a:rPr lang="en-US" sz="1000" dirty="0">
+                        <a:rPr lang="en-US" sz="950" dirty="0">
                           <a:solidFill>
                             <a:srgbClr val="1A1A1A"/>
                           </a:solidFill>
@@ -47527,7 +48013,7 @@
                         <a:buNone/>
                       </a:pPr>
                       <a:r>
-                        <a:rPr lang="en-US" sz="1000" dirty="0">
+                        <a:rPr lang="en-US" sz="950" dirty="0">
                           <a:solidFill>
                             <a:srgbClr val="1A1A1A"/>
                           </a:solidFill>
@@ -47591,7 +48077,7 @@
                         <a:buNone/>
                       </a:pPr>
                       <a:r>
-                        <a:rPr lang="en-US" sz="1000" dirty="0">
+                        <a:rPr lang="en-US" sz="950" dirty="0">
                           <a:solidFill>
                             <a:srgbClr val="1A1A1A"/>
                           </a:solidFill>
@@ -47647,7 +48133,7 @@
                   </a:tcPr>
                 </a:tc>
               </a:tr>
-              <a:tr h="219456">
+              <a:tr h="192024">
                 <a:tc>
                   <a:txBody>
                     <a:bodyPr/>
@@ -47657,7 +48143,7 @@
                         <a:buNone/>
                       </a:pPr>
                       <a:r>
-                        <a:rPr lang="en-US" sz="1000" dirty="0">
+                        <a:rPr lang="en-US" sz="950" dirty="0">
                           <a:solidFill>
                             <a:srgbClr val="1A1A1A"/>
                           </a:solidFill>
@@ -47721,7 +48207,7 @@
                         <a:buNone/>
                       </a:pPr>
                       <a:r>
-                        <a:rPr lang="en-US" sz="1000" dirty="0">
+                        <a:rPr lang="en-US" sz="950" dirty="0">
                           <a:solidFill>
                             <a:srgbClr val="1A1A1A"/>
                           </a:solidFill>
@@ -47785,7 +48271,7 @@
                         <a:buNone/>
                       </a:pPr>
                       <a:r>
-                        <a:rPr lang="en-US" sz="1000" dirty="0">
+                        <a:rPr lang="en-US" sz="950" dirty="0">
                           <a:solidFill>
                             <a:srgbClr val="1A1A1A"/>
                           </a:solidFill>
@@ -47837,6 +48323,200 @@
                     </a:lnB>
                     <a:solidFill>
                       <a:srgbClr val="FFFFFF"/>
+                    </a:solidFill>
+                  </a:tcPr>
+                </a:tc>
+              </a:tr>
+              <a:tr h="192024">
+                <a:tc>
+                  <a:txBody>
+                    <a:bodyPr/>
+                    <a:lstStyle/>
+                    <a:p>
+                      <a:pPr algn="l" indent="0" marL="0">
+                        <a:buNone/>
+                      </a:pPr>
+                      <a:r>
+                        <a:rPr lang="en-US" sz="950" dirty="0">
+                          <a:solidFill>
+                            <a:srgbClr val="1A1A1A"/>
+                          </a:solidFill>
+                          <a:latin typeface="Garamond" pitchFamily="34" charset="0"/>
+                          <a:ea typeface="Garamond" pitchFamily="34" charset="-122"/>
+                          <a:cs typeface="Garamond" pitchFamily="34" charset="-120"/>
+                        </a:rPr>
+                        <a:t>Test</a:t>
+                      </a:r>
+                      <a:endParaRPr lang="en-US" sz="1200" dirty="0"/>
+                    </a:p>
+                  </a:txBody>
+                  <a:tcPr marL="38100" marR="38100" marT="12700" marB="12700">
+                    <a:lnL w="6350" cap="flat" cmpd="sng" algn="ctr">
+                      <a:solidFill>
+                        <a:srgbClr val="BFBFBF"/>
+                      </a:solidFill>
+                      <a:prstDash val="solid"/>
+                      <a:round/>
+                      <a:headEnd type="none" w="med" len="med"/>
+                      <a:tailEnd type="none" w="med" len="med"/>
+                    </a:lnL>
+                    <a:lnR w="6350" cap="flat" cmpd="sng" algn="ctr">
+                      <a:solidFill>
+                        <a:srgbClr val="BFBFBF"/>
+                      </a:solidFill>
+                      <a:prstDash val="solid"/>
+                      <a:round/>
+                      <a:headEnd type="none" w="med" len="med"/>
+                      <a:tailEnd type="none" w="med" len="med"/>
+                    </a:lnR>
+                    <a:lnT w="6350" cap="flat" cmpd="sng" algn="ctr">
+                      <a:solidFill>
+                        <a:srgbClr val="BFBFBF"/>
+                      </a:solidFill>
+                      <a:prstDash val="solid"/>
+                      <a:round/>
+                      <a:headEnd type="none" w="med" len="med"/>
+                      <a:tailEnd type="none" w="med" len="med"/>
+                    </a:lnT>
+                    <a:lnB w="6350" cap="flat" cmpd="sng" algn="ctr">
+                      <a:solidFill>
+                        <a:srgbClr val="BFBFBF"/>
+                      </a:solidFill>
+                      <a:prstDash val="solid"/>
+                      <a:round/>
+                      <a:headEnd type="none" w="med" len="med"/>
+                      <a:tailEnd type="none" w="med" len="med"/>
+                    </a:lnB>
+                    <a:solidFill>
+                      <a:srgbClr val="F2F2F2"/>
+                    </a:solidFill>
+                  </a:tcPr>
+                </a:tc>
+                <a:tc>
+                  <a:txBody>
+                    <a:bodyPr/>
+                    <a:lstStyle/>
+                    <a:p>
+                      <a:pPr algn="ctr" indent="0" marL="0">
+                        <a:buNone/>
+                      </a:pPr>
+                      <a:r>
+                        <a:rPr lang="en-US" sz="950" dirty="0">
+                          <a:solidFill>
+                            <a:srgbClr val="1A1A1A"/>
+                          </a:solidFill>
+                          <a:latin typeface="Garamond" pitchFamily="34" charset="0"/>
+                          <a:ea typeface="Garamond" pitchFamily="34" charset="-122"/>
+                          <a:cs typeface="Garamond" pitchFamily="34" charset="-120"/>
+                        </a:rPr>
+                        <a:t>Rome adding a cell; Jakarta, Cairo come with cells</a:t>
+                      </a:r>
+                      <a:endParaRPr lang="en-US" sz="1200" dirty="0"/>
+                    </a:p>
+                  </a:txBody>
+                  <a:tcPr marL="38100" marR="38100" marT="12700" marB="12700">
+                    <a:lnL w="6350" cap="flat" cmpd="sng" algn="ctr">
+                      <a:solidFill>
+                        <a:srgbClr val="BFBFBF"/>
+                      </a:solidFill>
+                      <a:prstDash val="solid"/>
+                      <a:round/>
+                      <a:headEnd type="none" w="med" len="med"/>
+                      <a:tailEnd type="none" w="med" len="med"/>
+                    </a:lnL>
+                    <a:lnR w="6350" cap="flat" cmpd="sng" algn="ctr">
+                      <a:solidFill>
+                        <a:srgbClr val="BFBFBF"/>
+                      </a:solidFill>
+                      <a:prstDash val="solid"/>
+                      <a:round/>
+                      <a:headEnd type="none" w="med" len="med"/>
+                      <a:tailEnd type="none" w="med" len="med"/>
+                    </a:lnR>
+                    <a:lnT w="6350" cap="flat" cmpd="sng" algn="ctr">
+                      <a:solidFill>
+                        <a:srgbClr val="BFBFBF"/>
+                      </a:solidFill>
+                      <a:prstDash val="solid"/>
+                      <a:round/>
+                      <a:headEnd type="none" w="med" len="med"/>
+                      <a:tailEnd type="none" w="med" len="med"/>
+                    </a:lnT>
+                    <a:lnB w="6350" cap="flat" cmpd="sng" algn="ctr">
+                      <a:solidFill>
+                        <a:srgbClr val="BFBFBF"/>
+                      </a:solidFill>
+                      <a:prstDash val="solid"/>
+                      <a:round/>
+                      <a:headEnd type="none" w="med" len="med"/>
+                      <a:tailEnd type="none" w="med" len="med"/>
+                    </a:lnB>
+                    <a:solidFill>
+                      <a:srgbClr val="F2F2F2"/>
+                    </a:solidFill>
+                  </a:tcPr>
+                </a:tc>
+                <a:tc>
+                  <a:txBody>
+                    <a:bodyPr/>
+                    <a:lstStyle/>
+                    <a:p>
+                      <a:pPr algn="ctr" indent="0" marL="0">
+                        <a:buNone/>
+                      </a:pPr>
+                      <a:r>
+                        <a:rPr lang="en-US" sz="950" dirty="0">
+                          <a:solidFill>
+                            <a:srgbClr val="1A1A1A"/>
+                          </a:solidFill>
+                          <a:latin typeface="Garamond" pitchFamily="34" charset="0"/>
+                          <a:ea typeface="Garamond" pitchFamily="34" charset="-122"/>
+                          <a:cs typeface="Garamond" pitchFamily="34" charset="-120"/>
+                        </a:rPr>
+                        <a:t>LEAP competes for same cells</a:t>
+                      </a:r>
+                      <a:endParaRPr lang="en-US" sz="1200" dirty="0"/>
+                    </a:p>
+                  </a:txBody>
+                  <a:tcPr marL="38100" marR="38100" marT="12700" marB="12700">
+                    <a:lnL w="6350" cap="flat" cmpd="sng" algn="ctr">
+                      <a:solidFill>
+                        <a:srgbClr val="BFBFBF"/>
+                      </a:solidFill>
+                      <a:prstDash val="solid"/>
+                      <a:round/>
+                      <a:headEnd type="none" w="med" len="med"/>
+                      <a:tailEnd type="none" w="med" len="med"/>
+                    </a:lnL>
+                    <a:lnR w="6350" cap="flat" cmpd="sng" algn="ctr">
+                      <a:solidFill>
+                        <a:srgbClr val="BFBFBF"/>
+                      </a:solidFill>
+                      <a:prstDash val="solid"/>
+                      <a:round/>
+                      <a:headEnd type="none" w="med" len="med"/>
+                      <a:tailEnd type="none" w="med" len="med"/>
+                    </a:lnR>
+                    <a:lnT w="6350" cap="flat" cmpd="sng" algn="ctr">
+                      <a:solidFill>
+                        <a:srgbClr val="BFBFBF"/>
+                      </a:solidFill>
+                      <a:prstDash val="solid"/>
+                      <a:round/>
+                      <a:headEnd type="none" w="med" len="med"/>
+                      <a:tailEnd type="none" w="med" len="med"/>
+                    </a:lnT>
+                    <a:lnB w="6350" cap="flat" cmpd="sng" algn="ctr">
+                      <a:solidFill>
+                        <a:srgbClr val="BFBFBF"/>
+                      </a:solidFill>
+                      <a:prstDash val="solid"/>
+                      <a:round/>
+                      <a:headEnd type="none" w="med" len="med"/>
+                      <a:tailEnd type="none" w="med" len="med"/>
+                    </a:lnB>
+                    <a:solidFill>
+                      <a:srgbClr val="F2F2F2"/>
                     </a:solidFill>
                   </a:tcPr>
                 </a:tc>
@@ -47912,7 +48592,7 @@
       </p:sp>
       <p:graphicFrame>
         <p:nvGraphicFramePr>
-          <p:cNvPr id="12" name="Chart 2" descr=""/>
+          <p:cNvPr id="12" name="Chart 1" descr=""/>
           <p:cNvGraphicFramePr/>
           <p:nvPr/>
         </p:nvGraphicFramePr>
@@ -47922,7 +48602,7 @@
         </p:xfrm>
         <a:graphic xmlns:a="http://schemas.openxmlformats.org/drawingml/2006/main">
           <a:graphicData uri="http://schemas.openxmlformats.org/drawingml/2006/chart">
-            <c:chart xmlns:c="http://schemas.openxmlformats.org/drawingml/2006/chart" r:id="rId3"/>
+            <c:chart xmlns:c="http://schemas.openxmlformats.org/drawingml/2006/chart" r:id="rId2"/>
           </a:graphicData>
         </a:graphic>
       </p:graphicFrame>
@@ -48250,7 +48930,7 @@
       </p:sp>
       <p:graphicFrame>
         <p:nvGraphicFramePr>
-          <p:cNvPr id="16" name="Chart 3" descr=""/>
+          <p:cNvPr id="16" name="Chart 2" descr=""/>
           <p:cNvGraphicFramePr/>
           <p:nvPr/>
         </p:nvGraphicFramePr>
@@ -48260,13 +48940,13 @@
         </p:xfrm>
         <a:graphic xmlns:a="http://schemas.openxmlformats.org/drawingml/2006/main">
           <a:graphicData uri="http://schemas.openxmlformats.org/drawingml/2006/chart">
-            <c:chart xmlns:c="http://schemas.openxmlformats.org/drawingml/2006/chart" r:id="rId4"/>
+            <c:chart xmlns:c="http://schemas.openxmlformats.org/drawingml/2006/chart" r:id="rId3"/>
           </a:graphicData>
         </a:graphic>
       </p:graphicFrame>
       <p:graphicFrame>
         <p:nvGraphicFramePr>
-          <p:cNvPr id="19" name="Table 1"/>
+          <p:cNvPr id="28" name="Table 2"/>
           <p:cNvGraphicFramePr>
             <a:graphicFrameLocks noGrp="1"/>
           </p:cNvGraphicFramePr>
@@ -49802,7 +50482,7 @@
                 <a:ea typeface="Garamond" pitchFamily="34" charset="-122"/>
                 <a:cs typeface="Garamond" pitchFamily="34" charset="-120"/>
               </a:rPr>
-              <a:t>Source: FTAI Calls and Supplement, United / FTAI (Oct-26), GMF / FTAI (Sep-26), IBA, In Practise, GPS Model</a:t>
+              <a:t>Source: FTAI Calls and Supplement, United / FTAI (Oct-26), GMF / FTAI (Sep-26), Willis Lease, SR Technics, In Practise, GPS Model</a:t>
             </a:r>
             <a:endParaRPr lang="en-US" sz="1100" dirty="0"/>
           </a:p>
@@ -49841,7 +50521,7 @@
                 <a:ea typeface="Garamond" pitchFamily="34" charset="-122"/>
                 <a:cs typeface="Garamond" pitchFamily="34" charset="-120"/>
               </a:rPr>
-              <a:t>1.  CFM56-7B lease ~$85K / month (IBA) × days off wing.</a:t>
+              <a:t>1.  GPS Test Cell Tracker (18 cells, Oct-26); no public case of a cell dropping CFM56 for LEAP.</a:t>
             </a:r>
             <a:endParaRPr lang="en-US" sz="700" dirty="0"/>
           </a:p>

</xml_diff>

<commit_message>
Add Power next-contract model to Thesis III pipeline slide
Replace the 24-campus screen with the site-level next-order model:
~75% blended odds of another J&F order in 12 months (61% ex-xAI),
group probabilities, top candidate sites and 2027 capacity check.
Cite the probability on the Story and Catalysts slides.

Co-Authored-By: Claude Opus 5.5 <noreply@anthropic.com>
Claude-Session: https://claude.ai/code/session_01UfcjrwVkNc9oEPnjB82u2w
</commit_message>
<xml_diff>
--- a/ftai_pitch/FTAI_Long_Pitch.pptx
+++ b/ftai_pitch/FTAI_Long_Pitch.pptx
@@ -4255,6 +4255,296 @@
                 </a:solidFill>
                 <a:latin typeface="Garamond"/>
               </a:rPr>
+              <a:t>P(≥1 order) by buyer group, 12M</a:t>
+            </a:r>
+          </a:p>
+        </c:rich>
+      </c:tx>
+      <c:layout/>
+      <c:overlay val="0"/>
+    </c:title>
+    <c:autoTitleDeleted val="0"/>
+    <c:plotArea>
+      <c:layout/>
+      <c:barChart>
+        <c:barDir val="bar"/>
+        <c:grouping val="clustered"/>
+        <c:varyColors val="0"/>
+        <c:ser>
+          <c:idx val="0"/>
+          <c:order val="0"/>
+          <c:tx>
+            <c:strRef>
+              <c:f>Sheet1!$B$1</c:f>
+              <c:strCache>
+                <c:ptCount val="1"/>
+                <c:pt idx="0">
+                  <c:v>P</c:v>
+                </c:pt>
+              </c:strCache>
+            </c:strRef>
+          </c:tx>
+          <c:spPr>
+            <a:solidFill>
+              <a:srgbClr val="1F3864"/>
+            </a:solidFill>
+            <a:effectLst/>
+          </c:spPr>
+          <c:invertIfNegative val="0"/>
+          <c:dLbls>
+            <c:numFmt formatCode="0&quot;%&quot;" sourceLinked="0"/>
+            <c:txPr>
+              <a:bodyPr/>
+              <a:lstStyle/>
+              <a:p>
+                <a:pPr>
+                  <a:defRPr b="0" i="0" strike="noStrike" sz="850" u="none">
+                    <a:solidFill>
+                      <a:srgbClr val="262626"/>
+                    </a:solidFill>
+                    <a:latin typeface="Garamond"/>
+                  </a:defRPr>
+                </a:pPr>
+              </a:p>
+            </c:txPr>
+            <c:showLegendKey val="0"/>
+            <c:showVal val="1"/>
+            <c:showCatName val="0"/>
+            <c:showSerName val="0"/>
+            <c:showPercent val="0"/>
+            <c:showBubbleSize val="0"/>
+            <c:showLeaderLines val="0"/>
+          </c:dLbls>
+          <c:cat>
+            <c:multiLvlStrRef>
+              <c:f>Sheet1!$A$2:$A$9</c:f>
+              <c:multiLvlStrCache>
+                <c:ptCount val="8"/>
+                <c:lvl>
+                  <c:pt idx="0">
+                    <c:v>Anthropic / neoclouds</c:v>
+                  </c:pt>
+                  <c:pt idx="1">
+                    <c:v>Unidentified (residual)</c:v>
+                  </c:pt>
+                  <c:pt idx="2">
+                    <c:v>Oracle / OpenAI</c:v>
+                  </c:pt>
+                  <c:pt idx="3">
+                    <c:v>Developers (Fermi, Pacifico)</c:v>
+                  </c:pt>
+                  <c:pt idx="4">
+                    <c:v>Crusoe</c:v>
+                  </c:pt>
+                  <c:pt idx="5">
+                    <c:v>Cipher (BYOG, 2.5 GW)</c:v>
+                  </c:pt>
+                  <c:pt idx="6">
+                    <c:v>xAI / SpaceX (4 sites)</c:v>
+                  </c:pt>
+                  <c:pt idx="7">
+                    <c:v>Jereh repeat buyers (B–E)</c:v>
+                  </c:pt>
+                </c:lvl>
+              </c:multiLvlStrCache>
+            </c:multiLvlStrRef>
+          </c:cat>
+          <c:val>
+            <c:numRef>
+              <c:f>Sheet1!$B$2:$B$9</c:f>
+              <c:numCache>
+                <c:formatCode>General</c:formatCode>
+                <c:ptCount val="8"/>
+                <c:pt idx="0">
+                  <c:v>6</c:v>
+                </c:pt>
+                <c:pt idx="1">
+                  <c:v>8</c:v>
+                </c:pt>
+                <c:pt idx="2">
+                  <c:v>8.4</c:v>
+                </c:pt>
+                <c:pt idx="3">
+                  <c:v>9.4</c:v>
+                </c:pt>
+                <c:pt idx="4">
+                  <c:v>11.5</c:v>
+                </c:pt>
+                <c:pt idx="5">
+                  <c:v>17</c:v>
+                </c:pt>
+                <c:pt idx="6">
+                  <c:v>30.4</c:v>
+                </c:pt>
+                <c:pt idx="7">
+                  <c:v>35.8</c:v>
+                </c:pt>
+              </c:numCache>
+            </c:numRef>
+          </c:val>
+        </c:ser>
+        <c:dLbls>
+          <c:numFmt formatCode="0&quot;%&quot;" sourceLinked="0"/>
+          <c:txPr>
+            <a:bodyPr/>
+            <a:lstStyle/>
+            <a:p>
+              <a:pPr>
+                <a:defRPr b="0" i="0" strike="noStrike" sz="850" u="none">
+                  <a:solidFill>
+                    <a:srgbClr val="262626"/>
+                  </a:solidFill>
+                  <a:latin typeface="Garamond"/>
+                </a:defRPr>
+              </a:pPr>
+            </a:p>
+          </c:txPr>
+          <c:showLegendKey val="0"/>
+          <c:showVal val="1"/>
+          <c:showCatName val="0"/>
+          <c:showSerName val="0"/>
+          <c:showPercent val="0"/>
+          <c:showBubbleSize val="0"/>
+          <c:showLeaderLines val="0"/>
+        </c:dLbls>
+        <c:gapWidth val="35"/>
+        <c:overlap val="0"/>
+        <c:axId val="2094734554"/>
+        <c:axId val="2094734552"/>
+        <c:axId val="2094734556"/>
+      </c:barChart>
+      <c:catAx>
+        <c:axId val="2094734554"/>
+        <c:scaling>
+          <c:orientation val="minMax"/>
+        </c:scaling>
+        <c:delete val="0"/>
+        <c:axPos val="l"/>
+        <c:numFmt formatCode="General" sourceLinked="1"/>
+        <c:majorTickMark val="out"/>
+        <c:minorTickMark val="none"/>
+        <c:tickLblPos val="nextTo"/>
+        <c:spPr>
+          <a:ln w="12700" cap="flat">
+            <a:solidFill>
+              <a:srgbClr val="7F7F7F"/>
+            </a:solidFill>
+            <a:prstDash val="solid"/>
+            <a:round/>
+          </a:ln>
+        </c:spPr>
+        <c:txPr>
+          <a:bodyPr/>
+          <a:lstStyle/>
+          <a:p>
+            <a:pPr>
+              <a:defRPr sz="850" b="0" i="0" u="none" strike="noStrike">
+                <a:solidFill>
+                  <a:srgbClr val="262626"/>
+                </a:solidFill>
+                <a:latin typeface="Garamond"/>
+              </a:defRPr>
+            </a:pPr>
+            <a:endParaRPr lang="en-US"/>
+          </a:p>
+        </c:txPr>
+        <c:crossAx val="2094734552"/>
+        <c:crosses val="autoZero"/>
+        <c:auto val="1"/>
+        <c:lblAlgn val="ctr"/>
+        <c:noMultiLvlLbl val="1"/>
+      </c:catAx>
+      <c:valAx>
+        <c:axId val="2094734552"/>
+        <c:scaling>
+          <c:orientation val="minMax"/>
+          <c:max val="44"/>
+          <c:min val="0"/>
+        </c:scaling>
+        <c:delete val="1"/>
+        <c:axPos val="b"/>
+        <c:numFmt formatCode="General" sourceLinked="0"/>
+        <c:majorTickMark val="out"/>
+        <c:minorTickMark val="none"/>
+        <c:tickLblPos val="low"/>
+        <c:spPr>
+          <a:ln w="12700" cap="flat">
+            <a:solidFill>
+              <a:srgbClr val="888888"/>
+            </a:solidFill>
+            <a:prstDash val="solid"/>
+            <a:round/>
+          </a:ln>
+        </c:spPr>
+        <c:txPr>
+          <a:bodyPr/>
+          <a:lstStyle/>
+          <a:p>
+            <a:pPr>
+              <a:defRPr sz="900" b="0" i="0" u="none" strike="noStrike">
+                <a:solidFill>
+                  <a:srgbClr val="262626"/>
+                </a:solidFill>
+                <a:latin typeface="Garamond"/>
+              </a:defRPr>
+            </a:pPr>
+            <a:endParaRPr lang="en-US"/>
+          </a:p>
+        </c:txPr>
+        <c:crossAx val="2094734554"/>
+        <c:crosses val="autoZero"/>
+        <c:crossBetween val="between"/>
+      </c:valAx>
+      <c:spPr>
+        <a:noFill/>
+        <a:ln>
+          <a:noFill/>
+        </a:ln>
+        <a:effectLst/>
+      </c:spPr>
+    </c:plotArea>
+    <c:plotVisOnly val="1"/>
+    <c:dispBlanksAs val="span"/>
+  </c:chart>
+  <c:spPr>
+    <a:noFill/>
+    <a:ln>
+      <a:noFill/>
+    </a:ln>
+    <a:effectLst/>
+  </c:spPr>
+  <c:externalData r:id="rId1">
+    <c:autoUpdate val="0"/>
+  </c:externalData>
+</c:chartSpace>
+</file>
+
+<file path=ppt/charts/chart21.xml><?xml version="1.0" encoding="utf-8"?>
+<c:chartSpace xmlns:c="http://schemas.openxmlformats.org/drawingml/2006/chart" xmlns:a="http://schemas.openxmlformats.org/drawingml/2006/main" xmlns:r="http://schemas.openxmlformats.org/officeDocument/2006/relationships">
+  <c:date1904 val="0"/>
+  <c:roundedCorners val="1"/>
+  <c:chart>
+    <c:title>
+      <c:tx>
+        <c:rich>
+          <a:bodyPr/>
+          <a:lstStyle/>
+          <a:p>
+            <a:pPr>
+              <a:defRPr sz="1050" b="0" i="0" u="none" strike="noStrike">
+                <a:solidFill>
+                  <a:srgbClr val="262626"/>
+                </a:solidFill>
+                <a:latin typeface="Garamond"/>
+              </a:defRPr>
+            </a:pPr>
+            <a:r>
+              <a:rPr sz="1050" b="0" i="0" u="none" strike="noStrike">
+                <a:solidFill>
+                  <a:srgbClr val="262626"/>
+                </a:solidFill>
+                <a:latin typeface="Garamond"/>
+              </a:rPr>
               <a:t>Mod-1 Units Delivered</a:t>
             </a:r>
           </a:p>
@@ -4708,7 +4998,7 @@
 </c:chartSpace>
 </file>
 
-<file path=ppt/charts/chart21.xml><?xml version="1.0" encoding="utf-8"?>
+<file path=ppt/charts/chart22.xml><?xml version="1.0" encoding="utf-8"?>
 <c:chartSpace xmlns:c="http://schemas.openxmlformats.org/drawingml/2006/chart" xmlns:a="http://schemas.openxmlformats.org/drawingml/2006/main" xmlns:r="http://schemas.openxmlformats.org/officeDocument/2006/relationships">
   <c:date1904 val="0"/>
   <c:roundedCorners val="1"/>
@@ -13233,7 +13523,7 @@
                 <a:ea typeface="Garamond" pitchFamily="34" charset="-122"/>
                 <a:cs typeface="Garamond" pitchFamily="34" charset="-120"/>
               </a:rPr>
-              <a:t>We screened 24 US AI campuses: 9 meet the first buyer's conditions – ~10 GW of load with no locked bridge supplier.</a:t>
+              <a:t>Our site-level model puts the odds of another J&amp;F order within 12 months at ~75% – and ~61% from a buyer other than xAI.</a:t>
             </a:r>
             <a:endParaRPr lang="en-US" sz="1350" dirty="0"/>
           </a:p>
@@ -13264,6 +13554,330 @@
       </p:sp>
       <p:graphicFrame>
         <p:nvGraphicFramePr>
+          <p:cNvPr id="5" name="Chart 0" descr=""/>
+          <p:cNvGraphicFramePr/>
+          <p:nvPr/>
+        </p:nvGraphicFramePr>
+        <p:xfrm>
+          <a:off x="621792" y="1115568"/>
+          <a:ext cx="3611880" cy="1938528"/>
+        </p:xfrm>
+        <a:graphic xmlns:a="http://schemas.openxmlformats.org/drawingml/2006/main">
+          <a:graphicData uri="http://schemas.openxmlformats.org/drawingml/2006/chart">
+            <c:chart xmlns:c="http://schemas.openxmlformats.org/drawingml/2006/chart" r:id="rId1"/>
+          </a:graphicData>
+        </a:graphic>
+      </p:graphicFrame>
+      <p:sp>
+        <p:nvSpPr>
+          <p:cNvPr id="6" name="Text 3"/>
+          <p:cNvSpPr txBox="1"/>
+          <p:nvPr/>
+        </p:nvSpPr>
+        <p:spPr>
+          <a:xfrm>
+            <a:off x="4325112" y="1143000"/>
+            <a:ext cx="868680" cy="566928"/>
+          </a:xfrm>
+          <a:prstGeom prst="rect">
+            <a:avLst/>
+          </a:prstGeom>
+          <a:noFill/>
+          <a:ln/>
+        </p:spPr>
+        <p:txBody>
+          <a:bodyPr wrap="square" lIns="0" tIns="0" rIns="0" bIns="0" rtlCol="0" anchor="ctr"/>
+          <a:lstStyle/>
+          <a:p>
+            <a:pPr indent="0" marL="0">
+              <a:buNone/>
+            </a:pPr>
+            <a:r>
+              <a:rPr lang="en-US" sz="2200" b="1" dirty="0">
+                <a:solidFill>
+                  <a:srgbClr val="E8702A"/>
+                </a:solidFill>
+                <a:latin typeface="Garamond" pitchFamily="34" charset="0"/>
+                <a:ea typeface="Garamond" pitchFamily="34" charset="-122"/>
+                <a:cs typeface="Garamond" pitchFamily="34" charset="-120"/>
+              </a:rPr>
+              <a:t>75%</a:t>
+            </a:r>
+            <a:endParaRPr lang="en-US" sz="2200" dirty="0"/>
+          </a:p>
+        </p:txBody>
+      </p:sp>
+      <p:sp>
+        <p:nvSpPr>
+          <p:cNvPr id="7" name="Text 4"/>
+          <p:cNvSpPr txBox="1"/>
+          <p:nvPr/>
+        </p:nvSpPr>
+        <p:spPr>
+          <a:xfrm>
+            <a:off x="5193792" y="1143000"/>
+            <a:ext cx="1280160" cy="566928"/>
+          </a:xfrm>
+          <a:prstGeom prst="rect">
+            <a:avLst/>
+          </a:prstGeom>
+          <a:noFill/>
+          <a:ln/>
+        </p:spPr>
+        <p:txBody>
+          <a:bodyPr wrap="square" lIns="25400" tIns="25400" rIns="25400" bIns="25400" rtlCol="0" anchor="ctr"/>
+          <a:lstStyle/>
+          <a:p>
+            <a:pPr algn="l" indent="0" marL="0">
+              <a:lnSpc>
+                <a:spcPct val="100000"/>
+              </a:lnSpc>
+              <a:buNone/>
+            </a:pPr>
+            <a:r>
+              <a:rPr lang="en-US" sz="900" dirty="0">
+                <a:solidFill>
+                  <a:srgbClr val="1A1A1A"/>
+                </a:solidFill>
+                <a:latin typeface="Garamond" pitchFamily="34" charset="0"/>
+                <a:ea typeface="Garamond" pitchFamily="34" charset="-122"/>
+                <a:cs typeface="Garamond" pitchFamily="34" charset="-120"/>
+              </a:rPr>
+              <a:t>60/40 blend: site-level 71%, top-down 82% (56–97%)</a:t>
+            </a:r>
+            <a:endParaRPr lang="en-US" sz="900" dirty="0"/>
+          </a:p>
+        </p:txBody>
+      </p:sp>
+      <p:sp>
+        <p:nvSpPr>
+          <p:cNvPr id="8" name="Text 5"/>
+          <p:cNvSpPr txBox="1"/>
+          <p:nvPr/>
+        </p:nvSpPr>
+        <p:spPr>
+          <a:xfrm>
+            <a:off x="4325112" y="1783080"/>
+            <a:ext cx="868680" cy="566928"/>
+          </a:xfrm>
+          <a:prstGeom prst="rect">
+            <a:avLst/>
+          </a:prstGeom>
+          <a:noFill/>
+          <a:ln/>
+        </p:spPr>
+        <p:txBody>
+          <a:bodyPr wrap="square" lIns="0" tIns="0" rIns="0" bIns="0" rtlCol="0" anchor="ctr"/>
+          <a:lstStyle/>
+          <a:p>
+            <a:pPr indent="0" marL="0">
+              <a:buNone/>
+            </a:pPr>
+            <a:r>
+              <a:rPr lang="en-US" sz="2200" b="1" dirty="0">
+                <a:solidFill>
+                  <a:srgbClr val="1F3864"/>
+                </a:solidFill>
+                <a:latin typeface="Garamond" pitchFamily="34" charset="0"/>
+                <a:ea typeface="Garamond" pitchFamily="34" charset="-122"/>
+                <a:cs typeface="Garamond" pitchFamily="34" charset="-120"/>
+              </a:rPr>
+              <a:t>61%</a:t>
+            </a:r>
+            <a:endParaRPr lang="en-US" sz="2200" dirty="0"/>
+          </a:p>
+        </p:txBody>
+      </p:sp>
+      <p:sp>
+        <p:nvSpPr>
+          <p:cNvPr id="9" name="Text 6"/>
+          <p:cNvSpPr txBox="1"/>
+          <p:nvPr/>
+        </p:nvSpPr>
+        <p:spPr>
+          <a:xfrm>
+            <a:off x="5193792" y="1783080"/>
+            <a:ext cx="1280160" cy="566928"/>
+          </a:xfrm>
+          <a:prstGeom prst="rect">
+            <a:avLst/>
+          </a:prstGeom>
+          <a:noFill/>
+          <a:ln/>
+        </p:spPr>
+        <p:txBody>
+          <a:bodyPr wrap="square" lIns="25400" tIns="25400" rIns="25400" bIns="25400" rtlCol="0" anchor="ctr"/>
+          <a:lstStyle/>
+          <a:p>
+            <a:pPr algn="l" indent="0" marL="0">
+              <a:lnSpc>
+                <a:spcPct val="100000"/>
+              </a:lnSpc>
+              <a:buNone/>
+            </a:pPr>
+            <a:r>
+              <a:rPr lang="en-US" sz="900" dirty="0">
+                <a:solidFill>
+                  <a:srgbClr val="1A1A1A"/>
+                </a:solidFill>
+                <a:latin typeface="Garamond" pitchFamily="34" charset="0"/>
+                <a:ea typeface="Garamond" pitchFamily="34" charset="-122"/>
+                <a:cs typeface="Garamond" pitchFamily="34" charset="-120"/>
+              </a:rPr>
+              <a:t>From a customer other than xAI – the option is not one buyer</a:t>
+            </a:r>
+            <a:endParaRPr lang="en-US" sz="900" dirty="0"/>
+          </a:p>
+        </p:txBody>
+      </p:sp>
+      <p:sp>
+        <p:nvSpPr>
+          <p:cNvPr id="10" name="Text 7"/>
+          <p:cNvSpPr txBox="1"/>
+          <p:nvPr/>
+        </p:nvSpPr>
+        <p:spPr>
+          <a:xfrm>
+            <a:off x="4325112" y="2423160"/>
+            <a:ext cx="868680" cy="566928"/>
+          </a:xfrm>
+          <a:prstGeom prst="rect">
+            <a:avLst/>
+          </a:prstGeom>
+          <a:noFill/>
+          <a:ln/>
+        </p:spPr>
+        <p:txBody>
+          <a:bodyPr wrap="square" lIns="0" tIns="0" rIns="0" bIns="0" rtlCol="0" anchor="ctr"/>
+          <a:lstStyle/>
+          <a:p>
+            <a:pPr indent="0" marL="0">
+              <a:buNone/>
+            </a:pPr>
+            <a:r>
+              <a:rPr lang="en-US" sz="2200" b="1" dirty="0">
+                <a:solidFill>
+                  <a:srgbClr val="1F3864"/>
+                </a:solidFill>
+                <a:latin typeface="Garamond" pitchFamily="34" charset="0"/>
+                <a:ea typeface="Garamond" pitchFamily="34" charset="-122"/>
+                <a:cs typeface="Garamond" pitchFamily="34" charset="-120"/>
+              </a:rPr>
+              <a:t>51–71</a:t>
+            </a:r>
+            <a:endParaRPr lang="en-US" sz="2200" dirty="0"/>
+          </a:p>
+        </p:txBody>
+      </p:sp>
+      <p:sp>
+        <p:nvSpPr>
+          <p:cNvPr id="11" name="Text 8"/>
+          <p:cNvSpPr txBox="1"/>
+          <p:nvPr/>
+        </p:nvSpPr>
+        <p:spPr>
+          <a:xfrm>
+            <a:off x="5193792" y="2423160"/>
+            <a:ext cx="1280160" cy="566928"/>
+          </a:xfrm>
+          <a:prstGeom prst="rect">
+            <a:avLst/>
+          </a:prstGeom>
+          <a:noFill/>
+          <a:ln/>
+        </p:spPr>
+        <p:txBody>
+          <a:bodyPr wrap="square" lIns="25400" tIns="25400" rIns="25400" bIns="25400" rtlCol="0" anchor="ctr"/>
+          <a:lstStyle/>
+          <a:p>
+            <a:pPr algn="l" indent="0" marL="0">
+              <a:lnSpc>
+                <a:spcPct val="100000"/>
+              </a:lnSpc>
+              <a:buNone/>
+            </a:pPr>
+            <a:r>
+              <a:rPr lang="en-US" sz="900" dirty="0">
+                <a:solidFill>
+                  <a:srgbClr val="1A1A1A"/>
+                </a:solidFill>
+                <a:latin typeface="Garamond" pitchFamily="34" charset="0"/>
+                <a:ea typeface="Garamond" pitchFamily="34" charset="-122"/>
+                <a:cs typeface="Garamond" pitchFamily="34" charset="-120"/>
+              </a:rPr>
+              <a:t>2027 Mod-1 units left after the first order: room for 1–3+ more</a:t>
+            </a:r>
+            <a:endParaRPr lang="en-US" sz="900" dirty="0"/>
+          </a:p>
+        </p:txBody>
+      </p:sp>
+      <p:sp>
+        <p:nvSpPr>
+          <p:cNvPr id="12" name="Text 9"/>
+          <p:cNvSpPr txBox="1"/>
+          <p:nvPr/>
+        </p:nvSpPr>
+        <p:spPr>
+          <a:xfrm>
+            <a:off x="4325112" y="3044952"/>
+            <a:ext cx="2148840" cy="384048"/>
+          </a:xfrm>
+          <a:prstGeom prst="rect">
+            <a:avLst/>
+          </a:prstGeom>
+          <a:noFill/>
+          <a:ln/>
+        </p:spPr>
+        <p:txBody>
+          <a:bodyPr wrap="square" lIns="25400" tIns="25400" rIns="25400" bIns="25400" rtlCol="0" anchor="t"/>
+          <a:lstStyle/>
+          <a:p>
+            <a:pPr algn="l" indent="0" marL="0">
+              <a:lnSpc>
+                <a:spcPct val="100000"/>
+              </a:lnSpc>
+              <a:buNone/>
+            </a:pPr>
+            <a:r>
+              <a:rPr lang="en-US" sz="850" dirty="0">
+                <a:solidFill>
+                  <a:srgbClr val="595959"/>
+                </a:solidFill>
+                <a:latin typeface="Garamond" pitchFamily="34" charset="0"/>
+                <a:ea typeface="Garamond" pitchFamily="34" charset="-122"/>
+                <a:cs typeface="Garamond" pitchFamily="34" charset="-120"/>
+              </a:rPr>
+              <a:t>Top-down: Jereh wins ~4 DC orders / yr × 45% routed to J&amp;F × 95% disclosed → λ ≈ 1.7.</a:t>
+            </a:r>
+            <a:endParaRPr lang="en-US" sz="850" dirty="0"/>
+          </a:p>
+        </p:txBody>
+      </p:sp>
+      <p:sp>
+        <p:nvSpPr>
+          <p:cNvPr id="13" name="Shape 10"/>
+          <p:cNvSpPr/>
+          <p:nvPr/>
+        </p:nvSpPr>
+        <p:spPr>
+          <a:xfrm>
+            <a:off x="6519672" y="1152144"/>
+            <a:ext cx="0" cy="2240280"/>
+          </a:xfrm>
+          <a:prstGeom prst="line">
+            <a:avLst/>
+          </a:prstGeom>
+          <a:noFill/>
+          <a:ln w="12700">
+            <a:solidFill>
+              <a:srgbClr val="1A1A1A"/>
+            </a:solidFill>
+            <a:prstDash val="sysDot"/>
+          </a:ln>
+        </p:spPr>
+      </p:sp>
+      <p:graphicFrame>
+        <p:nvGraphicFramePr>
           <p:cNvPr id="12" name="Table 0"/>
           <p:cNvGraphicFramePr>
             <a:graphicFrameLocks noGrp="1"/>
@@ -13277,21 +13891,18 @@
           </p:nvPr>
         </p:nvGraphicFramePr>
         <p:xfrm>
-          <a:off x="621792" y="1170432"/>
-          <a:ext cx="11201400" cy="914400"/>
+          <a:off x="6611112" y="1133856"/>
+          <a:ext cx="5212080" cy="914400"/>
         </p:xfrm>
         <a:graphic>
           <a:graphicData uri="http://schemas.openxmlformats.org/drawingml/2006/table">
             <a:tbl>
               <a:tblPr/>
               <a:tblGrid>
+                <a:gridCol w="1600200"/>
                 <a:gridCol w="2514600"/>
-                <a:gridCol w="1280160"/>
-                <a:gridCol w="1051560"/>
-                <a:gridCol w="3474720"/>
-                <a:gridCol w="1188720"/>
-                <a:gridCol w="868680"/>
-                <a:gridCol w="822960"/>
+                <a:gridCol w="548640"/>
+                <a:gridCol w="548640"/>
               </a:tblGrid>
               <a:tr h="219456">
                 <a:tc>
@@ -13303,7 +13914,7 @@
                         <a:buNone/>
                       </a:pPr>
                       <a:r>
-                        <a:rPr lang="en-US" sz="950" b="1" dirty="0">
+                        <a:rPr lang="en-US" sz="900" b="1" dirty="0">
                           <a:solidFill>
                             <a:srgbClr val="FFFFFF"/>
                           </a:solidFill>
@@ -13311,9 +13922,9 @@
                           <a:ea typeface="Garamond" pitchFamily="34" charset="-122"/>
                           <a:cs typeface="Garamond" pitchFamily="34" charset="-120"/>
                         </a:rPr>
-                        <a:t>Project (tenant)</a:t>
+                        <a:t>Most likely next buyers</a:t>
                       </a:r>
-                      <a:endParaRPr lang="en-US" sz="950" dirty="0">
+                      <a:endParaRPr lang="en-US" sz="900" dirty="0">
                         <a:latin typeface="Garamond" charset="0"/>
                         <a:ea typeface="Garamond" charset="0"/>
                         <a:cs typeface="Garamond" charset="0"/>
@@ -13371,7 +13982,7 @@
                         <a:buNone/>
                       </a:pPr>
                       <a:r>
-                        <a:rPr lang="en-US" sz="950" b="1" dirty="0">
+                        <a:rPr lang="en-US" sz="900" b="1" dirty="0">
                           <a:solidFill>
                             <a:srgbClr val="FFFFFF"/>
                           </a:solidFill>
@@ -13379,9 +13990,9 @@
                           <a:ea typeface="Garamond" pitchFamily="34" charset="-122"/>
                           <a:cs typeface="Garamond" pitchFamily="34" charset="-120"/>
                         </a:rPr>
-                        <a:t>Location</a:t>
+                        <a:t>Why the gap is open</a:t>
                       </a:r>
-                      <a:endParaRPr lang="en-US" sz="950" dirty="0">
+                      <a:endParaRPr lang="en-US" sz="900" dirty="0">
                         <a:latin typeface="Garamond" charset="0"/>
                         <a:ea typeface="Garamond" charset="0"/>
                         <a:cs typeface="Garamond" charset="0"/>
@@ -13439,7 +14050,7 @@
                         <a:buNone/>
                       </a:pPr>
                       <a:r>
-                        <a:rPr lang="en-US" sz="950" b="1" dirty="0">
+                        <a:rPr lang="en-US" sz="900" b="1" dirty="0">
                           <a:solidFill>
                             <a:srgbClr val="FFFFFF"/>
                           </a:solidFill>
@@ -13447,9 +14058,9 @@
                           <a:ea typeface="Garamond" pitchFamily="34" charset="-122"/>
                           <a:cs typeface="Garamond" pitchFamily="34" charset="-120"/>
                         </a:rPr>
-                        <a:t>Target</a:t>
+                        <a:t>p</a:t>
                       </a:r>
-                      <a:endParaRPr lang="en-US" sz="950" dirty="0">
+                      <a:endParaRPr lang="en-US" sz="900" dirty="0">
                         <a:latin typeface="Garamond" charset="0"/>
                         <a:ea typeface="Garamond" charset="0"/>
                         <a:cs typeface="Garamond" charset="0"/>
@@ -13507,7 +14118,7 @@
                         <a:buNone/>
                       </a:pPr>
                       <a:r>
-                        <a:rPr lang="en-US" sz="950" b="1" dirty="0">
+                        <a:rPr lang="en-US" sz="900" b="1" dirty="0">
                           <a:solidFill>
                             <a:srgbClr val="FFFFFF"/>
                           </a:solidFill>
@@ -13515,213 +14126,9 @@
                           <a:ea typeface="Garamond" pitchFamily="34" charset="-122"/>
                           <a:cs typeface="Garamond" pitchFamily="34" charset="-120"/>
                         </a:rPr>
-                        <a:t>Power plan today</a:t>
+                        <a:t>Gap MW</a:t>
                       </a:r>
-                      <a:endParaRPr lang="en-US" sz="950" dirty="0">
-                        <a:latin typeface="Garamond" charset="0"/>
-                        <a:ea typeface="Garamond" charset="0"/>
-                        <a:cs typeface="Garamond" charset="0"/>
-                      </a:endParaRPr>
-                    </a:p>
-                  </a:txBody>
-                  <a:tcPr marL="38100" marR="38100" marT="12700" marB="12700">
-                    <a:lnL w="6350" cap="flat" cmpd="sng" algn="ctr">
-                      <a:solidFill>
-                        <a:srgbClr val="BFBFBF"/>
-                      </a:solidFill>
-                      <a:prstDash val="solid"/>
-                      <a:round/>
-                      <a:headEnd type="none" w="med" len="med"/>
-                      <a:tailEnd type="none" w="med" len="med"/>
-                    </a:lnL>
-                    <a:lnR w="6350" cap="flat" cmpd="sng" algn="ctr">
-                      <a:solidFill>
-                        <a:srgbClr val="BFBFBF"/>
-                      </a:solidFill>
-                      <a:prstDash val="solid"/>
-                      <a:round/>
-                      <a:headEnd type="none" w="med" len="med"/>
-                      <a:tailEnd type="none" w="med" len="med"/>
-                    </a:lnR>
-                    <a:lnT w="6350" cap="flat" cmpd="sng" algn="ctr">
-                      <a:solidFill>
-                        <a:srgbClr val="BFBFBF"/>
-                      </a:solidFill>
-                      <a:prstDash val="solid"/>
-                      <a:round/>
-                      <a:headEnd type="none" w="med" len="med"/>
-                      <a:tailEnd type="none" w="med" len="med"/>
-                    </a:lnT>
-                    <a:lnB w="6350" cap="flat" cmpd="sng" algn="ctr">
-                      <a:solidFill>
-                        <a:srgbClr val="BFBFBF"/>
-                      </a:solidFill>
-                      <a:prstDash val="solid"/>
-                      <a:round/>
-                      <a:headEnd type="none" w="med" len="med"/>
-                      <a:tailEnd type="none" w="med" len="med"/>
-                    </a:lnB>
-                    <a:solidFill>
-                      <a:srgbClr val="1F3864"/>
-                    </a:solidFill>
-                  </a:tcPr>
-                </a:tc>
-                <a:tc>
-                  <a:txBody>
-                    <a:bodyPr/>
-                    <a:lstStyle/>
-                    <a:p>
-                      <a:pPr algn="ctr" indent="0" marL="0">
-                        <a:buNone/>
-                      </a:pPr>
-                      <a:r>
-                        <a:rPr lang="en-US" sz="950" b="1" dirty="0">
-                          <a:solidFill>
-                            <a:srgbClr val="FFFFFF"/>
-                          </a:solidFill>
-                          <a:latin typeface="Garamond" pitchFamily="34" charset="0"/>
-                          <a:ea typeface="Garamond" pitchFamily="34" charset="-122"/>
-                          <a:cs typeface="Garamond" pitchFamily="34" charset="-120"/>
-                        </a:rPr>
-                        <a:t>Grid timing</a:t>
-                      </a:r>
-                      <a:endParaRPr lang="en-US" sz="950" dirty="0">
-                        <a:latin typeface="Garamond" charset="0"/>
-                        <a:ea typeface="Garamond" charset="0"/>
-                        <a:cs typeface="Garamond" charset="0"/>
-                      </a:endParaRPr>
-                    </a:p>
-                  </a:txBody>
-                  <a:tcPr marL="38100" marR="38100" marT="12700" marB="12700">
-                    <a:lnL w="6350" cap="flat" cmpd="sng" algn="ctr">
-                      <a:solidFill>
-                        <a:srgbClr val="BFBFBF"/>
-                      </a:solidFill>
-                      <a:prstDash val="solid"/>
-                      <a:round/>
-                      <a:headEnd type="none" w="med" len="med"/>
-                      <a:tailEnd type="none" w="med" len="med"/>
-                    </a:lnL>
-                    <a:lnR w="6350" cap="flat" cmpd="sng" algn="ctr">
-                      <a:solidFill>
-                        <a:srgbClr val="BFBFBF"/>
-                      </a:solidFill>
-                      <a:prstDash val="solid"/>
-                      <a:round/>
-                      <a:headEnd type="none" w="med" len="med"/>
-                      <a:tailEnd type="none" w="med" len="med"/>
-                    </a:lnR>
-                    <a:lnT w="6350" cap="flat" cmpd="sng" algn="ctr">
-                      <a:solidFill>
-                        <a:srgbClr val="BFBFBF"/>
-                      </a:solidFill>
-                      <a:prstDash val="solid"/>
-                      <a:round/>
-                      <a:headEnd type="none" w="med" len="med"/>
-                      <a:tailEnd type="none" w="med" len="med"/>
-                    </a:lnT>
-                    <a:lnB w="6350" cap="flat" cmpd="sng" algn="ctr">
-                      <a:solidFill>
-                        <a:srgbClr val="BFBFBF"/>
-                      </a:solidFill>
-                      <a:prstDash val="solid"/>
-                      <a:round/>
-                      <a:headEnd type="none" w="med" len="med"/>
-                      <a:tailEnd type="none" w="med" len="med"/>
-                    </a:lnB>
-                    <a:solidFill>
-                      <a:srgbClr val="1F3864"/>
-                    </a:solidFill>
-                  </a:tcPr>
-                </a:tc>
-                <a:tc>
-                  <a:txBody>
-                    <a:bodyPr/>
-                    <a:lstStyle/>
-                    <a:p>
-                      <a:pPr algn="ctr" indent="0" marL="0">
-                        <a:buNone/>
-                      </a:pPr>
-                      <a:r>
-                        <a:rPr lang="en-US" sz="950" b="1" dirty="0">
-                          <a:solidFill>
-                            <a:srgbClr val="FFFFFF"/>
-                          </a:solidFill>
-                          <a:latin typeface="Garamond" pitchFamily="34" charset="0"/>
-                          <a:ea typeface="Garamond" pitchFamily="34" charset="-122"/>
-                          <a:cs typeface="Garamond" pitchFamily="34" charset="-120"/>
-                        </a:rPr>
-                        <a:t>Need</a:t>
-                      </a:r>
-                      <a:endParaRPr lang="en-US" sz="950" dirty="0">
-                        <a:latin typeface="Garamond" charset="0"/>
-                        <a:ea typeface="Garamond" charset="0"/>
-                        <a:cs typeface="Garamond" charset="0"/>
-                      </a:endParaRPr>
-                    </a:p>
-                  </a:txBody>
-                  <a:tcPr marL="38100" marR="38100" marT="12700" marB="12700">
-                    <a:lnL w="6350" cap="flat" cmpd="sng" algn="ctr">
-                      <a:solidFill>
-                        <a:srgbClr val="BFBFBF"/>
-                      </a:solidFill>
-                      <a:prstDash val="solid"/>
-                      <a:round/>
-                      <a:headEnd type="none" w="med" len="med"/>
-                      <a:tailEnd type="none" w="med" len="med"/>
-                    </a:lnL>
-                    <a:lnR w="6350" cap="flat" cmpd="sng" algn="ctr">
-                      <a:solidFill>
-                        <a:srgbClr val="BFBFBF"/>
-                      </a:solidFill>
-                      <a:prstDash val="solid"/>
-                      <a:round/>
-                      <a:headEnd type="none" w="med" len="med"/>
-                      <a:tailEnd type="none" w="med" len="med"/>
-                    </a:lnR>
-                    <a:lnT w="6350" cap="flat" cmpd="sng" algn="ctr">
-                      <a:solidFill>
-                        <a:srgbClr val="BFBFBF"/>
-                      </a:solidFill>
-                      <a:prstDash val="solid"/>
-                      <a:round/>
-                      <a:headEnd type="none" w="med" len="med"/>
-                      <a:tailEnd type="none" w="med" len="med"/>
-                    </a:lnT>
-                    <a:lnB w="6350" cap="flat" cmpd="sng" algn="ctr">
-                      <a:solidFill>
-                        <a:srgbClr val="BFBFBF"/>
-                      </a:solidFill>
-                      <a:prstDash val="solid"/>
-                      <a:round/>
-                      <a:headEnd type="none" w="med" len="med"/>
-                      <a:tailEnd type="none" w="med" len="med"/>
-                    </a:lnB>
-                    <a:solidFill>
-                      <a:srgbClr val="1F3864"/>
-                    </a:solidFill>
-                  </a:tcPr>
-                </a:tc>
-                <a:tc>
-                  <a:txBody>
-                    <a:bodyPr/>
-                    <a:lstStyle/>
-                    <a:p>
-                      <a:pPr algn="ctr" indent="0" marL="0">
-                        <a:buNone/>
-                      </a:pPr>
-                      <a:r>
-                        <a:rPr lang="en-US" sz="950" b="1" dirty="0">
-                          <a:solidFill>
-                            <a:srgbClr val="FFFFFF"/>
-                          </a:solidFill>
-                          <a:latin typeface="Garamond" pitchFamily="34" charset="0"/>
-                          <a:ea typeface="Garamond" pitchFamily="34" charset="-122"/>
-                          <a:cs typeface="Garamond" pitchFamily="34" charset="-120"/>
-                        </a:rPr>
-                        <a:t>FTAI win</a:t>
-                      </a:r>
-                      <a:endParaRPr lang="en-US" sz="950" dirty="0">
+                      <a:endParaRPr lang="en-US" sz="900" dirty="0">
                         <a:latin typeface="Garamond" charset="0"/>
                         <a:ea typeface="Garamond" charset="0"/>
                         <a:cs typeface="Garamond" charset="0"/>
@@ -13781,7 +14188,7 @@
                         <a:buNone/>
                       </a:pPr>
                       <a:r>
-                        <a:rPr lang="en-US" sz="950" dirty="0">
+                        <a:rPr lang="en-US" sz="900" dirty="0">
                           <a:solidFill>
                             <a:srgbClr val="1A1A1A"/>
                           </a:solidFill>
@@ -13789,7 +14196,7 @@
                           <a:ea typeface="Garamond" pitchFamily="34" charset="-122"/>
                           <a:cs typeface="Garamond" pitchFamily="34" charset="-120"/>
                         </a:rPr>
-                        <a:t>Amazon “GW Ranch”</a:t>
+                        <a:t>Cipher BYOG sites (TX)</a:t>
                       </a:r>
                       <a:endParaRPr lang="en-US" sz="1200" dirty="0"/>
                     </a:p>
@@ -13841,11 +14248,11 @@
                     <a:bodyPr/>
                     <a:lstStyle/>
                     <a:p>
-                      <a:pPr algn="ctr" indent="0" marL="0">
+                      <a:pPr algn="l" indent="0" marL="0">
                         <a:buNone/>
                       </a:pPr>
                       <a:r>
-                        <a:rPr lang="en-US" sz="950" dirty="0">
+                        <a:rPr lang="en-US" sz="900" dirty="0">
                           <a:solidFill>
                             <a:srgbClr val="1A1A1A"/>
                           </a:solidFill>
@@ -13853,7 +14260,7 @@
                           <a:ea typeface="Garamond" pitchFamily="34" charset="-122"/>
                           <a:cs typeface="Garamond" pitchFamily="34" charset="-120"/>
                         </a:rPr>
-                        <a:t>Pecos Co., TX</a:t>
+                        <a:t>2.5 GW of gas laterals; generator not selected</a:t>
                       </a:r>
                       <a:endParaRPr lang="en-US" sz="1200" dirty="0"/>
                     </a:p>
@@ -13905,11 +14312,11 @@
                     <a:bodyPr/>
                     <a:lstStyle/>
                     <a:p>
-                      <a:pPr algn="ctr" indent="0" marL="0">
+                      <a:pPr algn="l" indent="0" marL="0">
                         <a:buNone/>
                       </a:pPr>
                       <a:r>
-                        <a:rPr lang="en-US" sz="950" dirty="0">
+                        <a:rPr lang="en-US" sz="900" dirty="0">
                           <a:solidFill>
                             <a:srgbClr val="1A1A1A"/>
                           </a:solidFill>
@@ -13917,7 +14324,7 @@
                           <a:ea typeface="Garamond" pitchFamily="34" charset="-122"/>
                           <a:cs typeface="Garamond" pitchFamily="34" charset="-120"/>
                         </a:rPr>
-                        <a:t>≤7.6 GW gen</a:t>
+                        <a:t>15%</a:t>
                       </a:r>
                       <a:endParaRPr lang="en-US" sz="1200" dirty="0"/>
                     </a:p>
@@ -13969,11 +14376,11 @@
                     <a:bodyPr/>
                     <a:lstStyle/>
                     <a:p>
-                      <a:pPr algn="ctr" indent="0" marL="0">
+                      <a:pPr algn="l" indent="0" marL="0">
                         <a:buNone/>
                       </a:pPr>
                       <a:r>
-                        <a:rPr lang="en-US" sz="950" dirty="0">
+                        <a:rPr lang="en-US" sz="900" dirty="0">
                           <a:solidFill>
                             <a:srgbClr val="1A1A1A"/>
                           </a:solidFill>
@@ -13981,199 +14388,7 @@
                           <a:ea typeface="Garamond" pitchFamily="34" charset="-122"/>
                           <a:cs typeface="Garamond" pitchFamily="34" charset="-120"/>
                         </a:rPr>
-                        <a:t>Off-grid; 35-turbine permit, mixed sizes</a:t>
-                      </a:r>
-                      <a:endParaRPr lang="en-US" sz="1200" dirty="0"/>
-                    </a:p>
-                  </a:txBody>
-                  <a:tcPr marL="38100" marR="38100" marT="12700" marB="12700">
-                    <a:lnL w="6350" cap="flat" cmpd="sng" algn="ctr">
-                      <a:solidFill>
-                        <a:srgbClr val="BFBFBF"/>
-                      </a:solidFill>
-                      <a:prstDash val="solid"/>
-                      <a:round/>
-                      <a:headEnd type="none" w="med" len="med"/>
-                      <a:tailEnd type="none" w="med" len="med"/>
-                    </a:lnL>
-                    <a:lnR w="6350" cap="flat" cmpd="sng" algn="ctr">
-                      <a:solidFill>
-                        <a:srgbClr val="BFBFBF"/>
-                      </a:solidFill>
-                      <a:prstDash val="solid"/>
-                      <a:round/>
-                      <a:headEnd type="none" w="med" len="med"/>
-                      <a:tailEnd type="none" w="med" len="med"/>
-                    </a:lnR>
-                    <a:lnT w="6350" cap="flat" cmpd="sng" algn="ctr">
-                      <a:solidFill>
-                        <a:srgbClr val="BFBFBF"/>
-                      </a:solidFill>
-                      <a:prstDash val="solid"/>
-                      <a:round/>
-                      <a:headEnd type="none" w="med" len="med"/>
-                      <a:tailEnd type="none" w="med" len="med"/>
-                    </a:lnT>
-                    <a:lnB w="6350" cap="flat" cmpd="sng" algn="ctr">
-                      <a:solidFill>
-                        <a:srgbClr val="BFBFBF"/>
-                      </a:solidFill>
-                      <a:prstDash val="solid"/>
-                      <a:round/>
-                      <a:headEnd type="none" w="med" len="med"/>
-                      <a:tailEnd type="none" w="med" len="med"/>
-                    </a:lnB>
-                    <a:solidFill>
-                      <a:srgbClr val="FFFFFF"/>
-                    </a:solidFill>
-                  </a:tcPr>
-                </a:tc>
-                <a:tc>
-                  <a:txBody>
-                    <a:bodyPr/>
-                    <a:lstStyle/>
-                    <a:p>
-                      <a:pPr algn="ctr" indent="0" marL="0">
-                        <a:buNone/>
-                      </a:pPr>
-                      <a:r>
-                        <a:rPr lang="en-US" sz="950" dirty="0">
-                          <a:solidFill>
-                            <a:srgbClr val="1A1A1A"/>
-                          </a:solidFill>
-                          <a:latin typeface="Garamond" pitchFamily="34" charset="0"/>
-                          <a:ea typeface="Garamond" pitchFamily="34" charset="-122"/>
-                          <a:cs typeface="Garamond" pitchFamily="34" charset="-120"/>
-                        </a:rPr>
-                        <a:t>Undefined</a:t>
-                      </a:r>
-                      <a:endParaRPr lang="en-US" sz="1200" dirty="0"/>
-                    </a:p>
-                  </a:txBody>
-                  <a:tcPr marL="38100" marR="38100" marT="12700" marB="12700">
-                    <a:lnL w="6350" cap="flat" cmpd="sng" algn="ctr">
-                      <a:solidFill>
-                        <a:srgbClr val="BFBFBF"/>
-                      </a:solidFill>
-                      <a:prstDash val="solid"/>
-                      <a:round/>
-                      <a:headEnd type="none" w="med" len="med"/>
-                      <a:tailEnd type="none" w="med" len="med"/>
-                    </a:lnL>
-                    <a:lnR w="6350" cap="flat" cmpd="sng" algn="ctr">
-                      <a:solidFill>
-                        <a:srgbClr val="BFBFBF"/>
-                      </a:solidFill>
-                      <a:prstDash val="solid"/>
-                      <a:round/>
-                      <a:headEnd type="none" w="med" len="med"/>
-                      <a:tailEnd type="none" w="med" len="med"/>
-                    </a:lnR>
-                    <a:lnT w="6350" cap="flat" cmpd="sng" algn="ctr">
-                      <a:solidFill>
-                        <a:srgbClr val="BFBFBF"/>
-                      </a:solidFill>
-                      <a:prstDash val="solid"/>
-                      <a:round/>
-                      <a:headEnd type="none" w="med" len="med"/>
-                      <a:tailEnd type="none" w="med" len="med"/>
-                    </a:lnT>
-                    <a:lnB w="6350" cap="flat" cmpd="sng" algn="ctr">
-                      <a:solidFill>
-                        <a:srgbClr val="BFBFBF"/>
-                      </a:solidFill>
-                      <a:prstDash val="solid"/>
-                      <a:round/>
-                      <a:headEnd type="none" w="med" len="med"/>
-                      <a:tailEnd type="none" w="med" len="med"/>
-                    </a:lnB>
-                    <a:solidFill>
-                      <a:srgbClr val="FFFFFF"/>
-                    </a:solidFill>
-                  </a:tcPr>
-                </a:tc>
-                <a:tc>
-                  <a:txBody>
-                    <a:bodyPr/>
-                    <a:lstStyle/>
-                    <a:p>
-                      <a:pPr algn="ctr" indent="0" marL="0">
-                        <a:buNone/>
-                      </a:pPr>
-                      <a:r>
-                        <a:rPr lang="en-US" sz="950" dirty="0">
-                          <a:solidFill>
-                            <a:srgbClr val="1A1A1A"/>
-                          </a:solidFill>
-                          <a:latin typeface="Garamond" pitchFamily="34" charset="0"/>
-                          <a:ea typeface="Garamond" pitchFamily="34" charset="-122"/>
-                          <a:cs typeface="Garamond" pitchFamily="34" charset="-120"/>
-                        </a:rPr>
-                        <a:t>High</a:t>
-                      </a:r>
-                      <a:endParaRPr lang="en-US" sz="1200" dirty="0"/>
-                    </a:p>
-                  </a:txBody>
-                  <a:tcPr marL="38100" marR="38100" marT="12700" marB="12700">
-                    <a:lnL w="6350" cap="flat" cmpd="sng" algn="ctr">
-                      <a:solidFill>
-                        <a:srgbClr val="BFBFBF"/>
-                      </a:solidFill>
-                      <a:prstDash val="solid"/>
-                      <a:round/>
-                      <a:headEnd type="none" w="med" len="med"/>
-                      <a:tailEnd type="none" w="med" len="med"/>
-                    </a:lnL>
-                    <a:lnR w="6350" cap="flat" cmpd="sng" algn="ctr">
-                      <a:solidFill>
-                        <a:srgbClr val="BFBFBF"/>
-                      </a:solidFill>
-                      <a:prstDash val="solid"/>
-                      <a:round/>
-                      <a:headEnd type="none" w="med" len="med"/>
-                      <a:tailEnd type="none" w="med" len="med"/>
-                    </a:lnR>
-                    <a:lnT w="6350" cap="flat" cmpd="sng" algn="ctr">
-                      <a:solidFill>
-                        <a:srgbClr val="BFBFBF"/>
-                      </a:solidFill>
-                      <a:prstDash val="solid"/>
-                      <a:round/>
-                      <a:headEnd type="none" w="med" len="med"/>
-                      <a:tailEnd type="none" w="med" len="med"/>
-                    </a:lnT>
-                    <a:lnB w="6350" cap="flat" cmpd="sng" algn="ctr">
-                      <a:solidFill>
-                        <a:srgbClr val="BFBFBF"/>
-                      </a:solidFill>
-                      <a:prstDash val="solid"/>
-                      <a:round/>
-                      <a:headEnd type="none" w="med" len="med"/>
-                      <a:tailEnd type="none" w="med" len="med"/>
-                    </a:lnB>
-                    <a:solidFill>
-                      <a:srgbClr val="FFFFFF"/>
-                    </a:solidFill>
-                  </a:tcPr>
-                </a:tc>
-                <a:tc>
-                  <a:txBody>
-                    <a:bodyPr/>
-                    <a:lstStyle/>
-                    <a:p>
-                      <a:pPr algn="ctr" indent="0" marL="0">
-                        <a:buNone/>
-                      </a:pPr>
-                      <a:r>
-                        <a:rPr lang="en-US" sz="950" b="1" dirty="0">
-                          <a:solidFill>
-                            <a:srgbClr val="1A1A1A"/>
-                          </a:solidFill>
-                          <a:latin typeface="Garamond" pitchFamily="34" charset="0"/>
-                          <a:ea typeface="Garamond" pitchFamily="34" charset="-122"/>
-                          <a:cs typeface="Garamond" pitchFamily="34" charset="-120"/>
-                        </a:rPr>
-                        <a:t>High</a:t>
+                        <a:t>600</a:t>
                       </a:r>
                       <a:endParaRPr lang="en-US" sz="1200" dirty="0"/>
                     </a:p>
@@ -14231,7 +14446,7 @@
                         <a:buNone/>
                       </a:pPr>
                       <a:r>
-                        <a:rPr lang="en-US" sz="950" dirty="0">
+                        <a:rPr lang="en-US" sz="900" dirty="0">
                           <a:solidFill>
                             <a:srgbClr val="1A1A1A"/>
                           </a:solidFill>
@@ -14239,7 +14454,7 @@
                           <a:ea typeface="Garamond" pitchFamily="34" charset="-122"/>
                           <a:cs typeface="Garamond" pitchFamily="34" charset="-120"/>
                         </a:rPr>
-                        <a:t>Poolside / CoreWeave “Horizon”</a:t>
+                        <a:t>xAI Minihard (Memphis)</a:t>
                       </a:r>
                       <a:endParaRPr lang="en-US" sz="1200" dirty="0"/>
                     </a:p>
@@ -14291,11 +14506,11 @@
                     <a:bodyPr/>
                     <a:lstStyle/>
                     <a:p>
-                      <a:pPr algn="ctr" indent="0" marL="0">
+                      <a:pPr algn="l" indent="0" marL="0">
                         <a:buNone/>
                       </a:pPr>
                       <a:r>
-                        <a:rPr lang="en-US" sz="950" dirty="0">
+                        <a:rPr lang="en-US" sz="900" dirty="0">
                           <a:solidFill>
                             <a:srgbClr val="1A1A1A"/>
                           </a:solidFill>
@@ -14303,7 +14518,7 @@
                           <a:ea typeface="Garamond" pitchFamily="34" charset="-122"/>
                           <a:cs typeface="Garamond" pitchFamily="34" charset="-120"/>
                         </a:rPr>
-                        <a:t>Pecos Co., TX</a:t>
+                        <a:t>4th DC, 2027 load; power source undisclosed</a:t>
                       </a:r>
                       <a:endParaRPr lang="en-US" sz="1200" dirty="0"/>
                     </a:p>
@@ -14355,11 +14570,11 @@
                     <a:bodyPr/>
                     <a:lstStyle/>
                     <a:p>
-                      <a:pPr algn="ctr" indent="0" marL="0">
+                      <a:pPr algn="l" indent="0" marL="0">
                         <a:buNone/>
                       </a:pPr>
                       <a:r>
-                        <a:rPr lang="en-US" sz="950" dirty="0">
+                        <a:rPr lang="en-US" sz="900" dirty="0">
                           <a:solidFill>
                             <a:srgbClr val="1A1A1A"/>
                           </a:solidFill>
@@ -14367,7 +14582,7 @@
                           <a:ea typeface="Garamond" pitchFamily="34" charset="-122"/>
                           <a:cs typeface="Garamond" pitchFamily="34" charset="-120"/>
                         </a:rPr>
-                        <a:t>2 GW</a:t>
+                        <a:t>12%</a:t>
                       </a:r>
                       <a:endParaRPr lang="en-US" sz="1200" dirty="0"/>
                     </a:p>
@@ -14419,11 +14634,11 @@
                     <a:bodyPr/>
                     <a:lstStyle/>
                     <a:p>
-                      <a:pPr algn="ctr" indent="0" marL="0">
+                      <a:pPr algn="l" indent="0" marL="0">
                         <a:buNone/>
                       </a:pPr>
                       <a:r>
-                        <a:rPr lang="en-US" sz="950" dirty="0">
+                        <a:rPr lang="en-US" sz="900" dirty="0">
                           <a:solidFill>
                             <a:srgbClr val="1A1A1A"/>
                           </a:solidFill>
@@ -14431,199 +14646,7 @@
                           <a:ea typeface="Garamond" pitchFamily="34" charset="-122"/>
                           <a:cs typeface="Garamond" pitchFamily="34" charset="-120"/>
                         </a:rPr>
-                        <a:t>Behind-the-meter; no supplier named</a:t>
-                      </a:r>
-                      <a:endParaRPr lang="en-US" sz="1200" dirty="0"/>
-                    </a:p>
-                  </a:txBody>
-                  <a:tcPr marL="38100" marR="38100" marT="12700" marB="12700">
-                    <a:lnL w="6350" cap="flat" cmpd="sng" algn="ctr">
-                      <a:solidFill>
-                        <a:srgbClr val="BFBFBF"/>
-                      </a:solidFill>
-                      <a:prstDash val="solid"/>
-                      <a:round/>
-                      <a:headEnd type="none" w="med" len="med"/>
-                      <a:tailEnd type="none" w="med" len="med"/>
-                    </a:lnL>
-                    <a:lnR w="6350" cap="flat" cmpd="sng" algn="ctr">
-                      <a:solidFill>
-                        <a:srgbClr val="BFBFBF"/>
-                      </a:solidFill>
-                      <a:prstDash val="solid"/>
-                      <a:round/>
-                      <a:headEnd type="none" w="med" len="med"/>
-                      <a:tailEnd type="none" w="med" len="med"/>
-                    </a:lnR>
-                    <a:lnT w="6350" cap="flat" cmpd="sng" algn="ctr">
-                      <a:solidFill>
-                        <a:srgbClr val="BFBFBF"/>
-                      </a:solidFill>
-                      <a:prstDash val="solid"/>
-                      <a:round/>
-                      <a:headEnd type="none" w="med" len="med"/>
-                      <a:tailEnd type="none" w="med" len="med"/>
-                    </a:lnT>
-                    <a:lnB w="6350" cap="flat" cmpd="sng" algn="ctr">
-                      <a:solidFill>
-                        <a:srgbClr val="BFBFBF"/>
-                      </a:solidFill>
-                      <a:prstDash val="solid"/>
-                      <a:round/>
-                      <a:headEnd type="none" w="med" len="med"/>
-                      <a:tailEnd type="none" w="med" len="med"/>
-                    </a:lnB>
-                    <a:solidFill>
-                      <a:srgbClr val="F2F2F2"/>
-                    </a:solidFill>
-                  </a:tcPr>
-                </a:tc>
-                <a:tc>
-                  <a:txBody>
-                    <a:bodyPr/>
-                    <a:lstStyle/>
-                    <a:p>
-                      <a:pPr algn="ctr" indent="0" marL="0">
-                        <a:buNone/>
-                      </a:pPr>
-                      <a:r>
-                        <a:rPr lang="en-US" sz="950" dirty="0">
-                          <a:solidFill>
-                            <a:srgbClr val="1A1A1A"/>
-                          </a:solidFill>
-                          <a:latin typeface="Garamond" pitchFamily="34" charset="0"/>
-                          <a:ea typeface="Garamond" pitchFamily="34" charset="-122"/>
-                          <a:cs typeface="Garamond" pitchFamily="34" charset="-120"/>
-                        </a:rPr>
-                        <a:t>None planned</a:t>
-                      </a:r>
-                      <a:endParaRPr lang="en-US" sz="1200" dirty="0"/>
-                    </a:p>
-                  </a:txBody>
-                  <a:tcPr marL="38100" marR="38100" marT="12700" marB="12700">
-                    <a:lnL w="6350" cap="flat" cmpd="sng" algn="ctr">
-                      <a:solidFill>
-                        <a:srgbClr val="BFBFBF"/>
-                      </a:solidFill>
-                      <a:prstDash val="solid"/>
-                      <a:round/>
-                      <a:headEnd type="none" w="med" len="med"/>
-                      <a:tailEnd type="none" w="med" len="med"/>
-                    </a:lnL>
-                    <a:lnR w="6350" cap="flat" cmpd="sng" algn="ctr">
-                      <a:solidFill>
-                        <a:srgbClr val="BFBFBF"/>
-                      </a:solidFill>
-                      <a:prstDash val="solid"/>
-                      <a:round/>
-                      <a:headEnd type="none" w="med" len="med"/>
-                      <a:tailEnd type="none" w="med" len="med"/>
-                    </a:lnR>
-                    <a:lnT w="6350" cap="flat" cmpd="sng" algn="ctr">
-                      <a:solidFill>
-                        <a:srgbClr val="BFBFBF"/>
-                      </a:solidFill>
-                      <a:prstDash val="solid"/>
-                      <a:round/>
-                      <a:headEnd type="none" w="med" len="med"/>
-                      <a:tailEnd type="none" w="med" len="med"/>
-                    </a:lnT>
-                    <a:lnB w="6350" cap="flat" cmpd="sng" algn="ctr">
-                      <a:solidFill>
-                        <a:srgbClr val="BFBFBF"/>
-                      </a:solidFill>
-                      <a:prstDash val="solid"/>
-                      <a:round/>
-                      <a:headEnd type="none" w="med" len="med"/>
-                      <a:tailEnd type="none" w="med" len="med"/>
-                    </a:lnB>
-                    <a:solidFill>
-                      <a:srgbClr val="F2F2F2"/>
-                    </a:solidFill>
-                  </a:tcPr>
-                </a:tc>
-                <a:tc>
-                  <a:txBody>
-                    <a:bodyPr/>
-                    <a:lstStyle/>
-                    <a:p>
-                      <a:pPr algn="ctr" indent="0" marL="0">
-                        <a:buNone/>
-                      </a:pPr>
-                      <a:r>
-                        <a:rPr lang="en-US" sz="950" dirty="0">
-                          <a:solidFill>
-                            <a:srgbClr val="1A1A1A"/>
-                          </a:solidFill>
-                          <a:latin typeface="Garamond" pitchFamily="34" charset="0"/>
-                          <a:ea typeface="Garamond" pitchFamily="34" charset="-122"/>
-                          <a:cs typeface="Garamond" pitchFamily="34" charset="-120"/>
-                        </a:rPr>
-                        <a:t>High</a:t>
-                      </a:r>
-                      <a:endParaRPr lang="en-US" sz="1200" dirty="0"/>
-                    </a:p>
-                  </a:txBody>
-                  <a:tcPr marL="38100" marR="38100" marT="12700" marB="12700">
-                    <a:lnL w="6350" cap="flat" cmpd="sng" algn="ctr">
-                      <a:solidFill>
-                        <a:srgbClr val="BFBFBF"/>
-                      </a:solidFill>
-                      <a:prstDash val="solid"/>
-                      <a:round/>
-                      <a:headEnd type="none" w="med" len="med"/>
-                      <a:tailEnd type="none" w="med" len="med"/>
-                    </a:lnL>
-                    <a:lnR w="6350" cap="flat" cmpd="sng" algn="ctr">
-                      <a:solidFill>
-                        <a:srgbClr val="BFBFBF"/>
-                      </a:solidFill>
-                      <a:prstDash val="solid"/>
-                      <a:round/>
-                      <a:headEnd type="none" w="med" len="med"/>
-                      <a:tailEnd type="none" w="med" len="med"/>
-                    </a:lnR>
-                    <a:lnT w="6350" cap="flat" cmpd="sng" algn="ctr">
-                      <a:solidFill>
-                        <a:srgbClr val="BFBFBF"/>
-                      </a:solidFill>
-                      <a:prstDash val="solid"/>
-                      <a:round/>
-                      <a:headEnd type="none" w="med" len="med"/>
-                      <a:tailEnd type="none" w="med" len="med"/>
-                    </a:lnT>
-                    <a:lnB w="6350" cap="flat" cmpd="sng" algn="ctr">
-                      <a:solidFill>
-                        <a:srgbClr val="BFBFBF"/>
-                      </a:solidFill>
-                      <a:prstDash val="solid"/>
-                      <a:round/>
-                      <a:headEnd type="none" w="med" len="med"/>
-                      <a:tailEnd type="none" w="med" len="med"/>
-                    </a:lnB>
-                    <a:solidFill>
-                      <a:srgbClr val="F2F2F2"/>
-                    </a:solidFill>
-                  </a:tcPr>
-                </a:tc>
-                <a:tc>
-                  <a:txBody>
-                    <a:bodyPr/>
-                    <a:lstStyle/>
-                    <a:p>
-                      <a:pPr algn="ctr" indent="0" marL="0">
-                        <a:buNone/>
-                      </a:pPr>
-                      <a:r>
-                        <a:rPr lang="en-US" sz="950" b="1" dirty="0">
-                          <a:solidFill>
-                            <a:srgbClr val="1A1A1A"/>
-                          </a:solidFill>
-                          <a:latin typeface="Garamond" pitchFamily="34" charset="0"/>
-                          <a:ea typeface="Garamond" pitchFamily="34" charset="-122"/>
-                          <a:cs typeface="Garamond" pitchFamily="34" charset="-120"/>
-                        </a:rPr>
-                        <a:t>High</a:t>
+                        <a:t>350</a:t>
                       </a:r>
                       <a:endParaRPr lang="en-US" sz="1200" dirty="0"/>
                     </a:p>
@@ -14681,7 +14704,7 @@
                         <a:buNone/>
                       </a:pPr>
                       <a:r>
-                        <a:rPr lang="en-US" sz="950" dirty="0">
+                        <a:rPr lang="en-US" sz="900" dirty="0">
                           <a:solidFill>
                             <a:srgbClr val="1A1A1A"/>
                           </a:solidFill>
@@ -14689,7 +14712,7 @@
                           <a:ea typeface="Garamond" pitchFamily="34" charset="-122"/>
                           <a:cs typeface="Garamond" pitchFamily="34" charset="-120"/>
                         </a:rPr>
-                        <a:t>Project Jade (Tallgrass)</a:t>
+                        <a:t>Jereh buyers C / D / E</a:t>
                       </a:r>
                       <a:endParaRPr lang="en-US" sz="1200" dirty="0"/>
                     </a:p>
@@ -14741,11 +14764,11 @@
                     <a:bodyPr/>
                     <a:lstStyle/>
                     <a:p>
-                      <a:pPr algn="ctr" indent="0" marL="0">
+                      <a:pPr algn="l" indent="0" marL="0">
                         <a:buNone/>
                       </a:pPr>
                       <a:r>
-                        <a:rPr lang="en-US" sz="950" dirty="0">
+                        <a:rPr lang="en-US" sz="900" dirty="0">
                           <a:solidFill>
                             <a:srgbClr val="1A1A1A"/>
                           </a:solidFill>
@@ -14753,7 +14776,7 @@
                           <a:ea typeface="Garamond" pitchFamily="34" charset="-122"/>
                           <a:cs typeface="Garamond" pitchFamily="34" charset="-120"/>
                         </a:rPr>
-                        <a:t>Cheyenne, WY</a:t>
+                        <a:t>~$820M of 2027 gensets; repeat via packager</a:t>
                       </a:r>
                       <a:endParaRPr lang="en-US" sz="1200" dirty="0"/>
                     </a:p>
@@ -14805,11 +14828,11 @@
                     <a:bodyPr/>
                     <a:lstStyle/>
                     <a:p>
-                      <a:pPr algn="ctr" indent="0" marL="0">
+                      <a:pPr algn="l" indent="0" marL="0">
                         <a:buNone/>
                       </a:pPr>
                       <a:r>
-                        <a:rPr lang="en-US" sz="950" dirty="0">
+                        <a:rPr lang="en-US" sz="900" dirty="0">
                           <a:solidFill>
                             <a:srgbClr val="1A1A1A"/>
                           </a:solidFill>
@@ -14817,7 +14840,7 @@
                           <a:ea typeface="Garamond" pitchFamily="34" charset="-122"/>
                           <a:cs typeface="Garamond" pitchFamily="34" charset="-120"/>
                         </a:rPr>
-                        <a:t>1.8 GW</a:t>
+                        <a:t>11% ea.</a:t>
                       </a:r>
                       <a:endParaRPr lang="en-US" sz="1200" dirty="0"/>
                     </a:p>
@@ -14869,11 +14892,11 @@
                     <a:bodyPr/>
                     <a:lstStyle/>
                     <a:p>
-                      <a:pPr algn="ctr" indent="0" marL="0">
+                      <a:pPr algn="l" indent="0" marL="0">
                         <a:buNone/>
                       </a:pPr>
                       <a:r>
-                        <a:rPr lang="en-US" sz="950" dirty="0">
+                        <a:rPr lang="en-US" sz="900" dirty="0">
                           <a:solidFill>
                             <a:srgbClr val="1A1A1A"/>
                           </a:solidFill>
@@ -14881,221 +14904,7 @@
                           <a:ea typeface="Garamond" pitchFamily="34" charset="-122"/>
                           <a:cs typeface="Garamond" pitchFamily="34" charset="-120"/>
                         </a:rPr>
-                        <a:t>CCGT + “</a:t>
-                      </a:r>
-                      <a:r>
-                        <a:rPr lang="en-US" sz="950" u="sng" dirty="0">
-                          <a:solidFill>
-                            <a:srgbClr val="1A1A1A"/>
-                          </a:solidFill>
-                          <a:latin typeface="Garamond" pitchFamily="34" charset="0"/>
-                          <a:ea typeface="Garamond" pitchFamily="34" charset="-122"/>
-                          <a:cs typeface="Garamond" pitchFamily="34" charset="-120"/>
-                        </a:rPr>
-                        <a:t>temporary aeroderivatives</a:t>
-                      </a:r>
-                      <a:r>
-                        <a:rPr lang="en-US" sz="950" dirty="0">
-                          <a:solidFill>
-                            <a:srgbClr val="1A1A1A"/>
-                          </a:solidFill>
-                          <a:latin typeface="Garamond" pitchFamily="34" charset="0"/>
-                          <a:ea typeface="Garamond" pitchFamily="34" charset="-122"/>
-                          <a:cs typeface="Garamond" pitchFamily="34" charset="-120"/>
-                        </a:rPr>
-                        <a:t>”</a:t>
-                      </a:r>
-                      <a:endParaRPr lang="en-US" sz="1200" dirty="0"/>
-                    </a:p>
-                  </a:txBody>
-                  <a:tcPr marL="38100" marR="38100" marT="12700" marB="12700">
-                    <a:lnL w="6350" cap="flat" cmpd="sng" algn="ctr">
-                      <a:solidFill>
-                        <a:srgbClr val="BFBFBF"/>
-                      </a:solidFill>
-                      <a:prstDash val="solid"/>
-                      <a:round/>
-                      <a:headEnd type="none" w="med" len="med"/>
-                      <a:tailEnd type="none" w="med" len="med"/>
-                    </a:lnL>
-                    <a:lnR w="6350" cap="flat" cmpd="sng" algn="ctr">
-                      <a:solidFill>
-                        <a:srgbClr val="BFBFBF"/>
-                      </a:solidFill>
-                      <a:prstDash val="solid"/>
-                      <a:round/>
-                      <a:headEnd type="none" w="med" len="med"/>
-                      <a:tailEnd type="none" w="med" len="med"/>
-                    </a:lnR>
-                    <a:lnT w="6350" cap="flat" cmpd="sng" algn="ctr">
-                      <a:solidFill>
-                        <a:srgbClr val="BFBFBF"/>
-                      </a:solidFill>
-                      <a:prstDash val="solid"/>
-                      <a:round/>
-                      <a:headEnd type="none" w="med" len="med"/>
-                      <a:tailEnd type="none" w="med" len="med"/>
-                    </a:lnT>
-                    <a:lnB w="6350" cap="flat" cmpd="sng" algn="ctr">
-                      <a:solidFill>
-                        <a:srgbClr val="BFBFBF"/>
-                      </a:solidFill>
-                      <a:prstDash val="solid"/>
-                      <a:round/>
-                      <a:headEnd type="none" w="med" len="med"/>
-                      <a:tailEnd type="none" w="med" len="med"/>
-                    </a:lnB>
-                    <a:solidFill>
-                      <a:srgbClr val="FFFFFF"/>
-                    </a:solidFill>
-                  </a:tcPr>
-                </a:tc>
-                <a:tc>
-                  <a:txBody>
-                    <a:bodyPr/>
-                    <a:lstStyle/>
-                    <a:p>
-                      <a:pPr algn="ctr" indent="0" marL="0">
-                        <a:buNone/>
-                      </a:pPr>
-                      <a:r>
-                        <a:rPr lang="en-US" sz="950" dirty="0">
-                          <a:solidFill>
-                            <a:srgbClr val="1A1A1A"/>
-                          </a:solidFill>
-                          <a:latin typeface="Garamond" pitchFamily="34" charset="0"/>
-                          <a:ea typeface="Garamond" pitchFamily="34" charset="-122"/>
-                          <a:cs typeface="Garamond" pitchFamily="34" charset="-120"/>
-                        </a:rPr>
-                        <a:t>Off-grid</a:t>
-                      </a:r>
-                      <a:endParaRPr lang="en-US" sz="1200" dirty="0"/>
-                    </a:p>
-                  </a:txBody>
-                  <a:tcPr marL="38100" marR="38100" marT="12700" marB="12700">
-                    <a:lnL w="6350" cap="flat" cmpd="sng" algn="ctr">
-                      <a:solidFill>
-                        <a:srgbClr val="BFBFBF"/>
-                      </a:solidFill>
-                      <a:prstDash val="solid"/>
-                      <a:round/>
-                      <a:headEnd type="none" w="med" len="med"/>
-                      <a:tailEnd type="none" w="med" len="med"/>
-                    </a:lnL>
-                    <a:lnR w="6350" cap="flat" cmpd="sng" algn="ctr">
-                      <a:solidFill>
-                        <a:srgbClr val="BFBFBF"/>
-                      </a:solidFill>
-                      <a:prstDash val="solid"/>
-                      <a:round/>
-                      <a:headEnd type="none" w="med" len="med"/>
-                      <a:tailEnd type="none" w="med" len="med"/>
-                    </a:lnR>
-                    <a:lnT w="6350" cap="flat" cmpd="sng" algn="ctr">
-                      <a:solidFill>
-                        <a:srgbClr val="BFBFBF"/>
-                      </a:solidFill>
-                      <a:prstDash val="solid"/>
-                      <a:round/>
-                      <a:headEnd type="none" w="med" len="med"/>
-                      <a:tailEnd type="none" w="med" len="med"/>
-                    </a:lnT>
-                    <a:lnB w="6350" cap="flat" cmpd="sng" algn="ctr">
-                      <a:solidFill>
-                        <a:srgbClr val="BFBFBF"/>
-                      </a:solidFill>
-                      <a:prstDash val="solid"/>
-                      <a:round/>
-                      <a:headEnd type="none" w="med" len="med"/>
-                      <a:tailEnd type="none" w="med" len="med"/>
-                    </a:lnB>
-                    <a:solidFill>
-                      <a:srgbClr val="FFFFFF"/>
-                    </a:solidFill>
-                  </a:tcPr>
-                </a:tc>
-                <a:tc>
-                  <a:txBody>
-                    <a:bodyPr/>
-                    <a:lstStyle/>
-                    <a:p>
-                      <a:pPr algn="ctr" indent="0" marL="0">
-                        <a:buNone/>
-                      </a:pPr>
-                      <a:r>
-                        <a:rPr lang="en-US" sz="950" dirty="0">
-                          <a:solidFill>
-                            <a:srgbClr val="1A1A1A"/>
-                          </a:solidFill>
-                          <a:latin typeface="Garamond" pitchFamily="34" charset="0"/>
-                          <a:ea typeface="Garamond" pitchFamily="34" charset="-122"/>
-                          <a:cs typeface="Garamond" pitchFamily="34" charset="-120"/>
-                        </a:rPr>
-                        <a:t>High</a:t>
-                      </a:r>
-                      <a:endParaRPr lang="en-US" sz="1200" dirty="0"/>
-                    </a:p>
-                  </a:txBody>
-                  <a:tcPr marL="38100" marR="38100" marT="12700" marB="12700">
-                    <a:lnL w="6350" cap="flat" cmpd="sng" algn="ctr">
-                      <a:solidFill>
-                        <a:srgbClr val="BFBFBF"/>
-                      </a:solidFill>
-                      <a:prstDash val="solid"/>
-                      <a:round/>
-                      <a:headEnd type="none" w="med" len="med"/>
-                      <a:tailEnd type="none" w="med" len="med"/>
-                    </a:lnL>
-                    <a:lnR w="6350" cap="flat" cmpd="sng" algn="ctr">
-                      <a:solidFill>
-                        <a:srgbClr val="BFBFBF"/>
-                      </a:solidFill>
-                      <a:prstDash val="solid"/>
-                      <a:round/>
-                      <a:headEnd type="none" w="med" len="med"/>
-                      <a:tailEnd type="none" w="med" len="med"/>
-                    </a:lnR>
-                    <a:lnT w="6350" cap="flat" cmpd="sng" algn="ctr">
-                      <a:solidFill>
-                        <a:srgbClr val="BFBFBF"/>
-                      </a:solidFill>
-                      <a:prstDash val="solid"/>
-                      <a:round/>
-                      <a:headEnd type="none" w="med" len="med"/>
-                      <a:tailEnd type="none" w="med" len="med"/>
-                    </a:lnT>
-                    <a:lnB w="6350" cap="flat" cmpd="sng" algn="ctr">
-                      <a:solidFill>
-                        <a:srgbClr val="BFBFBF"/>
-                      </a:solidFill>
-                      <a:prstDash val="solid"/>
-                      <a:round/>
-                      <a:headEnd type="none" w="med" len="med"/>
-                      <a:tailEnd type="none" w="med" len="med"/>
-                    </a:lnB>
-                    <a:solidFill>
-                      <a:srgbClr val="FFFFFF"/>
-                    </a:solidFill>
-                  </a:tcPr>
-                </a:tc>
-                <a:tc>
-                  <a:txBody>
-                    <a:bodyPr/>
-                    <a:lstStyle/>
-                    <a:p>
-                      <a:pPr algn="ctr" indent="0" marL="0">
-                        <a:buNone/>
-                      </a:pPr>
-                      <a:r>
-                        <a:rPr lang="en-US" sz="950" b="1" dirty="0">
-                          <a:solidFill>
-                            <a:srgbClr val="1A1A1A"/>
-                          </a:solidFill>
-                          <a:latin typeface="Garamond" pitchFamily="34" charset="0"/>
-                          <a:ea typeface="Garamond" pitchFamily="34" charset="-122"/>
-                          <a:cs typeface="Garamond" pitchFamily="34" charset="-120"/>
-                        </a:rPr>
-                        <a:t>High</a:t>
+                        <a:t>550</a:t>
                       </a:r>
                       <a:endParaRPr lang="en-US" sz="1200" dirty="0"/>
                     </a:p>
@@ -15153,7 +14962,7 @@
                         <a:buNone/>
                       </a:pPr>
                       <a:r>
-                        <a:rPr lang="en-US" sz="950" dirty="0">
+                        <a:rPr lang="en-US" sz="900" dirty="0">
                           <a:solidFill>
                             <a:srgbClr val="1A1A1A"/>
                           </a:solidFill>
@@ -15161,7 +14970,7 @@
                           <a:ea typeface="Garamond" pitchFamily="34" charset="-122"/>
                           <a:cs typeface="Garamond" pitchFamily="34" charset="-120"/>
                         </a:rPr>
-                        <a:t>Google / Crusoe “Goodnight”</a:t>
+                        <a:t>xAI Southaven</a:t>
                       </a:r>
                       <a:endParaRPr lang="en-US" sz="1200" dirty="0"/>
                     </a:p>
@@ -15213,11 +15022,11 @@
                     <a:bodyPr/>
                     <a:lstStyle/>
                     <a:p>
-                      <a:pPr algn="ctr" indent="0" marL="0">
+                      <a:pPr algn="l" indent="0" marL="0">
                         <a:buNone/>
                       </a:pPr>
                       <a:r>
-                        <a:rPr lang="en-US" sz="950" dirty="0">
+                        <a:rPr lang="en-US" sz="900" dirty="0">
                           <a:solidFill>
                             <a:srgbClr val="1A1A1A"/>
                           </a:solidFill>
@@ -15225,7 +15034,7 @@
                           <a:ea typeface="Garamond" pitchFamily="34" charset="-122"/>
                           <a:cs typeface="Garamond" pitchFamily="34" charset="-120"/>
                         </a:rPr>
-                        <a:t>Armstrong Co., TX</a:t>
+                        <a:t>69 temp turbines retire Aug-26 to Jul-27</a:t>
                       </a:r>
                       <a:endParaRPr lang="en-US" sz="1200" dirty="0"/>
                     </a:p>
@@ -15277,11 +15086,11 @@
                     <a:bodyPr/>
                     <a:lstStyle/>
                     <a:p>
-                      <a:pPr algn="ctr" indent="0" marL="0">
+                      <a:pPr algn="l" indent="0" marL="0">
                         <a:buNone/>
                       </a:pPr>
                       <a:r>
-                        <a:rPr lang="en-US" sz="950" dirty="0">
+                        <a:rPr lang="en-US" sz="900" dirty="0">
                           <a:solidFill>
                             <a:srgbClr val="1A1A1A"/>
                           </a:solidFill>
@@ -15289,7 +15098,7 @@
                           <a:ea typeface="Garamond" pitchFamily="34" charset="-122"/>
                           <a:cs typeface="Garamond" pitchFamily="34" charset="-120"/>
                         </a:rPr>
-                        <a:t>Multi-100 MW</a:t>
+                        <a:t>11%</a:t>
                       </a:r>
                       <a:endParaRPr lang="en-US" sz="1200" dirty="0"/>
                     </a:p>
@@ -15341,11 +15150,11 @@
                     <a:bodyPr/>
                     <a:lstStyle/>
                     <a:p>
-                      <a:pPr algn="ctr" indent="0" marL="0">
+                      <a:pPr algn="l" indent="0" marL="0">
                         <a:buNone/>
                       </a:pPr>
                       <a:r>
-                        <a:rPr lang="en-US" sz="950" dirty="0">
+                        <a:rPr lang="en-US" sz="900" dirty="0">
                           <a:solidFill>
                             <a:srgbClr val="1A1A1A"/>
                           </a:solidFill>
@@ -15353,199 +15162,7 @@
                           <a:ea typeface="Garamond" pitchFamily="34" charset="-122"/>
                           <a:cs typeface="Garamond" pitchFamily="34" charset="-120"/>
                         </a:rPr>
-                        <a:t>933 MW aeros, not sourced from GE</a:t>
-                      </a:r>
-                      <a:endParaRPr lang="en-US" sz="1200" dirty="0"/>
-                    </a:p>
-                  </a:txBody>
-                  <a:tcPr marL="38100" marR="38100" marT="12700" marB="12700">
-                    <a:lnL w="6350" cap="flat" cmpd="sng" algn="ctr">
-                      <a:solidFill>
-                        <a:srgbClr val="BFBFBF"/>
-                      </a:solidFill>
-                      <a:prstDash val="solid"/>
-                      <a:round/>
-                      <a:headEnd type="none" w="med" len="med"/>
-                      <a:tailEnd type="none" w="med" len="med"/>
-                    </a:lnL>
-                    <a:lnR w="6350" cap="flat" cmpd="sng" algn="ctr">
-                      <a:solidFill>
-                        <a:srgbClr val="BFBFBF"/>
-                      </a:solidFill>
-                      <a:prstDash val="solid"/>
-                      <a:round/>
-                      <a:headEnd type="none" w="med" len="med"/>
-                      <a:tailEnd type="none" w="med" len="med"/>
-                    </a:lnR>
-                    <a:lnT w="6350" cap="flat" cmpd="sng" algn="ctr">
-                      <a:solidFill>
-                        <a:srgbClr val="BFBFBF"/>
-                      </a:solidFill>
-                      <a:prstDash val="solid"/>
-                      <a:round/>
-                      <a:headEnd type="none" w="med" len="med"/>
-                      <a:tailEnd type="none" w="med" len="med"/>
-                    </a:lnT>
-                    <a:lnB w="6350" cap="flat" cmpd="sng" algn="ctr">
-                      <a:solidFill>
-                        <a:srgbClr val="BFBFBF"/>
-                      </a:solidFill>
-                      <a:prstDash val="solid"/>
-                      <a:round/>
-                      <a:headEnd type="none" w="med" len="med"/>
-                      <a:tailEnd type="none" w="med" len="med"/>
-                    </a:lnB>
-                    <a:solidFill>
-                      <a:srgbClr val="F2F2F2"/>
-                    </a:solidFill>
-                  </a:tcPr>
-                </a:tc>
-                <a:tc>
-                  <a:txBody>
-                    <a:bodyPr/>
-                    <a:lstStyle/>
-                    <a:p>
-                      <a:pPr algn="ctr" indent="0" marL="0">
-                        <a:buNone/>
-                      </a:pPr>
-                      <a:r>
-                        <a:rPr lang="en-US" sz="950" dirty="0">
-                          <a:solidFill>
-                            <a:srgbClr val="1A1A1A"/>
-                          </a:solidFill>
-                          <a:latin typeface="Garamond" pitchFamily="34" charset="0"/>
-                          <a:ea typeface="Garamond" pitchFamily="34" charset="-122"/>
-                          <a:cs typeface="Garamond" pitchFamily="34" charset="-120"/>
-                        </a:rPr>
-                        <a:t>Partial</a:t>
-                      </a:r>
-                      <a:endParaRPr lang="en-US" sz="1200" dirty="0"/>
-                    </a:p>
-                  </a:txBody>
-                  <a:tcPr marL="38100" marR="38100" marT="12700" marB="12700">
-                    <a:lnL w="6350" cap="flat" cmpd="sng" algn="ctr">
-                      <a:solidFill>
-                        <a:srgbClr val="BFBFBF"/>
-                      </a:solidFill>
-                      <a:prstDash val="solid"/>
-                      <a:round/>
-                      <a:headEnd type="none" w="med" len="med"/>
-                      <a:tailEnd type="none" w="med" len="med"/>
-                    </a:lnL>
-                    <a:lnR w="6350" cap="flat" cmpd="sng" algn="ctr">
-                      <a:solidFill>
-                        <a:srgbClr val="BFBFBF"/>
-                      </a:solidFill>
-                      <a:prstDash val="solid"/>
-                      <a:round/>
-                      <a:headEnd type="none" w="med" len="med"/>
-                      <a:tailEnd type="none" w="med" len="med"/>
-                    </a:lnR>
-                    <a:lnT w="6350" cap="flat" cmpd="sng" algn="ctr">
-                      <a:solidFill>
-                        <a:srgbClr val="BFBFBF"/>
-                      </a:solidFill>
-                      <a:prstDash val="solid"/>
-                      <a:round/>
-                      <a:headEnd type="none" w="med" len="med"/>
-                      <a:tailEnd type="none" w="med" len="med"/>
-                    </a:lnT>
-                    <a:lnB w="6350" cap="flat" cmpd="sng" algn="ctr">
-                      <a:solidFill>
-                        <a:srgbClr val="BFBFBF"/>
-                      </a:solidFill>
-                      <a:prstDash val="solid"/>
-                      <a:round/>
-                      <a:headEnd type="none" w="med" len="med"/>
-                      <a:tailEnd type="none" w="med" len="med"/>
-                    </a:lnB>
-                    <a:solidFill>
-                      <a:srgbClr val="F2F2F2"/>
-                    </a:solidFill>
-                  </a:tcPr>
-                </a:tc>
-                <a:tc>
-                  <a:txBody>
-                    <a:bodyPr/>
-                    <a:lstStyle/>
-                    <a:p>
-                      <a:pPr algn="ctr" indent="0" marL="0">
-                        <a:buNone/>
-                      </a:pPr>
-                      <a:r>
-                        <a:rPr lang="en-US" sz="950" dirty="0">
-                          <a:solidFill>
-                            <a:srgbClr val="1A1A1A"/>
-                          </a:solidFill>
-                          <a:latin typeface="Garamond" pitchFamily="34" charset="0"/>
-                          <a:ea typeface="Garamond" pitchFamily="34" charset="-122"/>
-                          <a:cs typeface="Garamond" pitchFamily="34" charset="-120"/>
-                        </a:rPr>
-                        <a:t>High</a:t>
-                      </a:r>
-                      <a:endParaRPr lang="en-US" sz="1200" dirty="0"/>
-                    </a:p>
-                  </a:txBody>
-                  <a:tcPr marL="38100" marR="38100" marT="12700" marB="12700">
-                    <a:lnL w="6350" cap="flat" cmpd="sng" algn="ctr">
-                      <a:solidFill>
-                        <a:srgbClr val="BFBFBF"/>
-                      </a:solidFill>
-                      <a:prstDash val="solid"/>
-                      <a:round/>
-                      <a:headEnd type="none" w="med" len="med"/>
-                      <a:tailEnd type="none" w="med" len="med"/>
-                    </a:lnL>
-                    <a:lnR w="6350" cap="flat" cmpd="sng" algn="ctr">
-                      <a:solidFill>
-                        <a:srgbClr val="BFBFBF"/>
-                      </a:solidFill>
-                      <a:prstDash val="solid"/>
-                      <a:round/>
-                      <a:headEnd type="none" w="med" len="med"/>
-                      <a:tailEnd type="none" w="med" len="med"/>
-                    </a:lnR>
-                    <a:lnT w="6350" cap="flat" cmpd="sng" algn="ctr">
-                      <a:solidFill>
-                        <a:srgbClr val="BFBFBF"/>
-                      </a:solidFill>
-                      <a:prstDash val="solid"/>
-                      <a:round/>
-                      <a:headEnd type="none" w="med" len="med"/>
-                      <a:tailEnd type="none" w="med" len="med"/>
-                    </a:lnT>
-                    <a:lnB w="6350" cap="flat" cmpd="sng" algn="ctr">
-                      <a:solidFill>
-                        <a:srgbClr val="BFBFBF"/>
-                      </a:solidFill>
-                      <a:prstDash val="solid"/>
-                      <a:round/>
-                      <a:headEnd type="none" w="med" len="med"/>
-                      <a:tailEnd type="none" w="med" len="med"/>
-                    </a:lnB>
-                    <a:solidFill>
-                      <a:srgbClr val="F2F2F2"/>
-                    </a:solidFill>
-                  </a:tcPr>
-                </a:tc>
-                <a:tc>
-                  <a:txBody>
-                    <a:bodyPr/>
-                    <a:lstStyle/>
-                    <a:p>
-                      <a:pPr algn="ctr" indent="0" marL="0">
-                        <a:buNone/>
-                      </a:pPr>
-                      <a:r>
-                        <a:rPr lang="en-US" sz="950" dirty="0">
-                          <a:solidFill>
-                            <a:srgbClr val="1A1A1A"/>
-                          </a:solidFill>
-                          <a:latin typeface="Garamond" pitchFamily="34" charset="0"/>
-                          <a:ea typeface="Garamond" pitchFamily="34" charset="-122"/>
-                          <a:cs typeface="Garamond" pitchFamily="34" charset="-120"/>
-                        </a:rPr>
-                        <a:t>Med</a:t>
+                        <a:t>575</a:t>
                       </a:r>
                       <a:endParaRPr lang="en-US" sz="1200" dirty="0"/>
                     </a:p>
@@ -15603,7 +15220,7 @@
                         <a:buNone/>
                       </a:pPr>
                       <a:r>
-                        <a:rPr lang="en-US" sz="950" dirty="0">
+                        <a:rPr lang="en-US" sz="900" dirty="0">
                           <a:solidFill>
                             <a:srgbClr val="1A1A1A"/>
                           </a:solidFill>
@@ -15611,7 +15228,7 @@
                           <a:ea typeface="Garamond" pitchFamily="34" charset="-122"/>
                           <a:cs typeface="Garamond" pitchFamily="34" charset="-120"/>
                         </a:rPr>
-                        <a:t>Meta El Paso</a:t>
+                        <a:t>xAI Doosan frame sites</a:t>
                       </a:r>
                       <a:endParaRPr lang="en-US" sz="1200" dirty="0"/>
                     </a:p>
@@ -15663,11 +15280,11 @@
                     <a:bodyPr/>
                     <a:lstStyle/>
                     <a:p>
-                      <a:pPr algn="ctr" indent="0" marL="0">
+                      <a:pPr algn="l" indent="0" marL="0">
                         <a:buNone/>
                       </a:pPr>
                       <a:r>
-                        <a:rPr lang="en-US" sz="950" dirty="0">
+                        <a:rPr lang="en-US" sz="900" dirty="0">
                           <a:solidFill>
                             <a:srgbClr val="1A1A1A"/>
                           </a:solidFill>
@@ -15675,7 +15292,7 @@
                           <a:ea typeface="Garamond" pitchFamily="34" charset="-122"/>
                           <a:cs typeface="Garamond" pitchFamily="34" charset="-120"/>
                         </a:rPr>
-                        <a:t>El Paso, TX</a:t>
+                        <a:t>Bridge power until 2027–28 combined cycle</a:t>
                       </a:r>
                       <a:endParaRPr lang="en-US" sz="1200" dirty="0"/>
                     </a:p>
@@ -15727,11 +15344,11 @@
                     <a:bodyPr/>
                     <a:lstStyle/>
                     <a:p>
-                      <a:pPr algn="ctr" indent="0" marL="0">
+                      <a:pPr algn="l" indent="0" marL="0">
                         <a:buNone/>
                       </a:pPr>
                       <a:r>
-                        <a:rPr lang="en-US" sz="950" dirty="0">
+                        <a:rPr lang="en-US" sz="900" dirty="0">
                           <a:solidFill>
                             <a:srgbClr val="1A1A1A"/>
                           </a:solidFill>
@@ -15739,7 +15356,7 @@
                           <a:ea typeface="Garamond" pitchFamily="34" charset="-122"/>
                           <a:cs typeface="Garamond" pitchFamily="34" charset="-120"/>
                         </a:rPr>
-                        <a:t>1 GW</a:t>
+                        <a:t>9%</a:t>
                       </a:r>
                       <a:endParaRPr lang="en-US" sz="1200" dirty="0"/>
                     </a:p>
@@ -15791,11 +15408,11 @@
                     <a:bodyPr/>
                     <a:lstStyle/>
                     <a:p>
-                      <a:pPr algn="ctr" indent="0" marL="0">
+                      <a:pPr algn="l" indent="0" marL="0">
                         <a:buNone/>
                       </a:pPr>
                       <a:r>
-                        <a:rPr lang="en-US" sz="950" dirty="0">
+                        <a:rPr lang="en-US" sz="900" dirty="0">
                           <a:solidFill>
                             <a:srgbClr val="1A1A1A"/>
                           </a:solidFill>
@@ -15803,199 +15420,7 @@
                           <a:ea typeface="Garamond" pitchFamily="34" charset="-122"/>
                           <a:cs typeface="Garamond" pitchFamily="34" charset="-120"/>
                         </a:rPr>
-                        <a:t>366 MW utility plant stalled at PUC</a:t>
-                      </a:r>
-                      <a:endParaRPr lang="en-US" sz="1200" dirty="0"/>
-                    </a:p>
-                  </a:txBody>
-                  <a:tcPr marL="38100" marR="38100" marT="12700" marB="12700">
-                    <a:lnL w="6350" cap="flat" cmpd="sng" algn="ctr">
-                      <a:solidFill>
-                        <a:srgbClr val="BFBFBF"/>
-                      </a:solidFill>
-                      <a:prstDash val="solid"/>
-                      <a:round/>
-                      <a:headEnd type="none" w="med" len="med"/>
-                      <a:tailEnd type="none" w="med" len="med"/>
-                    </a:lnL>
-                    <a:lnR w="6350" cap="flat" cmpd="sng" algn="ctr">
-                      <a:solidFill>
-                        <a:srgbClr val="BFBFBF"/>
-                      </a:solidFill>
-                      <a:prstDash val="solid"/>
-                      <a:round/>
-                      <a:headEnd type="none" w="med" len="med"/>
-                      <a:tailEnd type="none" w="med" len="med"/>
-                    </a:lnR>
-                    <a:lnT w="6350" cap="flat" cmpd="sng" algn="ctr">
-                      <a:solidFill>
-                        <a:srgbClr val="BFBFBF"/>
-                      </a:solidFill>
-                      <a:prstDash val="solid"/>
-                      <a:round/>
-                      <a:headEnd type="none" w="med" len="med"/>
-                      <a:tailEnd type="none" w="med" len="med"/>
-                    </a:lnT>
-                    <a:lnB w="6350" cap="flat" cmpd="sng" algn="ctr">
-                      <a:solidFill>
-                        <a:srgbClr val="BFBFBF"/>
-                      </a:solidFill>
-                      <a:prstDash val="solid"/>
-                      <a:round/>
-                      <a:headEnd type="none" w="med" len="med"/>
-                      <a:tailEnd type="none" w="med" len="med"/>
-                    </a:lnB>
-                    <a:solidFill>
-                      <a:srgbClr val="FFFFFF"/>
-                    </a:solidFill>
-                  </a:tcPr>
-                </a:tc>
-                <a:tc>
-                  <a:txBody>
-                    <a:bodyPr/>
-                    <a:lstStyle/>
-                    <a:p>
-                      <a:pPr algn="ctr" indent="0" marL="0">
-                        <a:buNone/>
-                      </a:pPr>
-                      <a:r>
-                        <a:rPr lang="en-US" sz="950" dirty="0">
-                          <a:solidFill>
-                            <a:srgbClr val="1A1A1A"/>
-                          </a:solidFill>
-                          <a:latin typeface="Garamond" pitchFamily="34" charset="0"/>
-                          <a:ea typeface="Garamond" pitchFamily="34" charset="-122"/>
-                          <a:cs typeface="Garamond" pitchFamily="34" charset="-120"/>
-                        </a:rPr>
-                        <a:t>2027 if approved</a:t>
-                      </a:r>
-                      <a:endParaRPr lang="en-US" sz="1200" dirty="0"/>
-                    </a:p>
-                  </a:txBody>
-                  <a:tcPr marL="38100" marR="38100" marT="12700" marB="12700">
-                    <a:lnL w="6350" cap="flat" cmpd="sng" algn="ctr">
-                      <a:solidFill>
-                        <a:srgbClr val="BFBFBF"/>
-                      </a:solidFill>
-                      <a:prstDash val="solid"/>
-                      <a:round/>
-                      <a:headEnd type="none" w="med" len="med"/>
-                      <a:tailEnd type="none" w="med" len="med"/>
-                    </a:lnL>
-                    <a:lnR w="6350" cap="flat" cmpd="sng" algn="ctr">
-                      <a:solidFill>
-                        <a:srgbClr val="BFBFBF"/>
-                      </a:solidFill>
-                      <a:prstDash val="solid"/>
-                      <a:round/>
-                      <a:headEnd type="none" w="med" len="med"/>
-                      <a:tailEnd type="none" w="med" len="med"/>
-                    </a:lnR>
-                    <a:lnT w="6350" cap="flat" cmpd="sng" algn="ctr">
-                      <a:solidFill>
-                        <a:srgbClr val="BFBFBF"/>
-                      </a:solidFill>
-                      <a:prstDash val="solid"/>
-                      <a:round/>
-                      <a:headEnd type="none" w="med" len="med"/>
-                      <a:tailEnd type="none" w="med" len="med"/>
-                    </a:lnT>
-                    <a:lnB w="6350" cap="flat" cmpd="sng" algn="ctr">
-                      <a:solidFill>
-                        <a:srgbClr val="BFBFBF"/>
-                      </a:solidFill>
-                      <a:prstDash val="solid"/>
-                      <a:round/>
-                      <a:headEnd type="none" w="med" len="med"/>
-                      <a:tailEnd type="none" w="med" len="med"/>
-                    </a:lnB>
-                    <a:solidFill>
-                      <a:srgbClr val="FFFFFF"/>
-                    </a:solidFill>
-                  </a:tcPr>
-                </a:tc>
-                <a:tc>
-                  <a:txBody>
-                    <a:bodyPr/>
-                    <a:lstStyle/>
-                    <a:p>
-                      <a:pPr algn="ctr" indent="0" marL="0">
-                        <a:buNone/>
-                      </a:pPr>
-                      <a:r>
-                        <a:rPr lang="en-US" sz="950" dirty="0">
-                          <a:solidFill>
-                            <a:srgbClr val="1A1A1A"/>
-                          </a:solidFill>
-                          <a:latin typeface="Garamond" pitchFamily="34" charset="0"/>
-                          <a:ea typeface="Garamond" pitchFamily="34" charset="-122"/>
-                          <a:cs typeface="Garamond" pitchFamily="34" charset="-120"/>
-                        </a:rPr>
-                        <a:t>High</a:t>
-                      </a:r>
-                      <a:endParaRPr lang="en-US" sz="1200" dirty="0"/>
-                    </a:p>
-                  </a:txBody>
-                  <a:tcPr marL="38100" marR="38100" marT="12700" marB="12700">
-                    <a:lnL w="6350" cap="flat" cmpd="sng" algn="ctr">
-                      <a:solidFill>
-                        <a:srgbClr val="BFBFBF"/>
-                      </a:solidFill>
-                      <a:prstDash val="solid"/>
-                      <a:round/>
-                      <a:headEnd type="none" w="med" len="med"/>
-                      <a:tailEnd type="none" w="med" len="med"/>
-                    </a:lnL>
-                    <a:lnR w="6350" cap="flat" cmpd="sng" algn="ctr">
-                      <a:solidFill>
-                        <a:srgbClr val="BFBFBF"/>
-                      </a:solidFill>
-                      <a:prstDash val="solid"/>
-                      <a:round/>
-                      <a:headEnd type="none" w="med" len="med"/>
-                      <a:tailEnd type="none" w="med" len="med"/>
-                    </a:lnR>
-                    <a:lnT w="6350" cap="flat" cmpd="sng" algn="ctr">
-                      <a:solidFill>
-                        <a:srgbClr val="BFBFBF"/>
-                      </a:solidFill>
-                      <a:prstDash val="solid"/>
-                      <a:round/>
-                      <a:headEnd type="none" w="med" len="med"/>
-                      <a:tailEnd type="none" w="med" len="med"/>
-                    </a:lnT>
-                    <a:lnB w="6350" cap="flat" cmpd="sng" algn="ctr">
-                      <a:solidFill>
-                        <a:srgbClr val="BFBFBF"/>
-                      </a:solidFill>
-                      <a:prstDash val="solid"/>
-                      <a:round/>
-                      <a:headEnd type="none" w="med" len="med"/>
-                      <a:tailEnd type="none" w="med" len="med"/>
-                    </a:lnB>
-                    <a:solidFill>
-                      <a:srgbClr val="FFFFFF"/>
-                    </a:solidFill>
-                  </a:tcPr>
-                </a:tc>
-                <a:tc>
-                  <a:txBody>
-                    <a:bodyPr/>
-                    <a:lstStyle/>
-                    <a:p>
-                      <a:pPr algn="ctr" indent="0" marL="0">
-                        <a:buNone/>
-                      </a:pPr>
-                      <a:r>
-                        <a:rPr lang="en-US" sz="950" dirty="0">
-                          <a:solidFill>
-                            <a:srgbClr val="1A1A1A"/>
-                          </a:solidFill>
-                          <a:latin typeface="Garamond" pitchFamily="34" charset="0"/>
-                          <a:ea typeface="Garamond" pitchFamily="34" charset="-122"/>
-                          <a:cs typeface="Garamond" pitchFamily="34" charset="-120"/>
-                        </a:rPr>
-                        <a:t>Med</a:t>
+                        <a:t>500</a:t>
                       </a:r>
                       <a:endParaRPr lang="en-US" sz="1200" dirty="0"/>
                     </a:p>
@@ -16053,7 +15478,7 @@
                         <a:buNone/>
                       </a:pPr>
                       <a:r>
-                        <a:rPr lang="en-US" sz="950" dirty="0">
+                        <a:rPr lang="en-US" sz="900" dirty="0">
                           <a:solidFill>
                             <a:srgbClr val="1A1A1A"/>
                           </a:solidFill>
@@ -16061,7 +15486,7 @@
                           <a:ea typeface="Garamond" pitchFamily="34" charset="-122"/>
                           <a:cs typeface="Garamond" pitchFamily="34" charset="-120"/>
                         </a:rPr>
-                        <a:t>Microsoft / Chevron “Kilby”</a:t>
+                        <a:t>Crusoe Abilene (Microsoft)</a:t>
                       </a:r>
                       <a:endParaRPr lang="en-US" sz="1200" dirty="0"/>
                     </a:p>
@@ -16113,11 +15538,11 @@
                     <a:bodyPr/>
                     <a:lstStyle/>
                     <a:p>
-                      <a:pPr algn="ctr" indent="0" marL="0">
+                      <a:pPr algn="l" indent="0" marL="0">
                         <a:buNone/>
                       </a:pPr>
                       <a:r>
-                        <a:rPr lang="en-US" sz="950" dirty="0">
+                        <a:rPr lang="en-US" sz="900" dirty="0">
                           <a:solidFill>
                             <a:srgbClr val="1A1A1A"/>
                           </a:solidFill>
@@ -16125,7 +15550,7 @@
                           <a:ea typeface="Garamond" pitchFamily="34" charset="-122"/>
                           <a:cs typeface="Garamond" pitchFamily="34" charset="-120"/>
                         </a:rPr>
-                        <a:t>Pecos area, TX</a:t>
+                        <a:t>Cancelled 1.2 GW Boom order 25-Sep-26</a:t>
                       </a:r>
                       <a:endParaRPr lang="en-US" sz="1200" dirty="0"/>
                     </a:p>
@@ -16177,11 +15602,11 @@
                     <a:bodyPr/>
                     <a:lstStyle/>
                     <a:p>
-                      <a:pPr algn="ctr" indent="0" marL="0">
+                      <a:pPr algn="l" indent="0" marL="0">
                         <a:buNone/>
                       </a:pPr>
                       <a:r>
-                        <a:rPr lang="en-US" sz="950" dirty="0">
+                        <a:rPr lang="en-US" sz="900" dirty="0">
                           <a:solidFill>
                             <a:srgbClr val="1A1A1A"/>
                           </a:solidFill>
@@ -16189,7 +15614,7 @@
                           <a:ea typeface="Garamond" pitchFamily="34" charset="-122"/>
                           <a:cs typeface="Garamond" pitchFamily="34" charset="-120"/>
                         </a:rPr>
-                        <a:t>2–2.5 GW</a:t>
+                        <a:t>8%</a:t>
                       </a:r>
                       <a:endParaRPr lang="en-US" sz="1200" dirty="0"/>
                     </a:p>
@@ -16241,11 +15666,11 @@
                     <a:bodyPr/>
                     <a:lstStyle/>
                     <a:p>
-                      <a:pPr algn="ctr" indent="0" marL="0">
+                      <a:pPr algn="l" indent="0" marL="0">
                         <a:buNone/>
                       </a:pPr>
                       <a:r>
-                        <a:rPr lang="en-US" sz="950" dirty="0">
+                        <a:rPr lang="en-US" sz="900" dirty="0">
                           <a:solidFill>
                             <a:srgbClr val="1A1A1A"/>
                           </a:solidFill>
@@ -16253,199 +15678,7 @@
                           <a:ea typeface="Garamond" pitchFamily="34" charset="-122"/>
                           <a:cs typeface="Garamond" pitchFamily="34" charset="-120"/>
                         </a:rPr>
-                        <a:t>Chevron BTM; first power 2028</a:t>
-                      </a:r>
-                      <a:endParaRPr lang="en-US" sz="1200" dirty="0"/>
-                    </a:p>
-                  </a:txBody>
-                  <a:tcPr marL="38100" marR="38100" marT="12700" marB="12700">
-                    <a:lnL w="6350" cap="flat" cmpd="sng" algn="ctr">
-                      <a:solidFill>
-                        <a:srgbClr val="BFBFBF"/>
-                      </a:solidFill>
-                      <a:prstDash val="solid"/>
-                      <a:round/>
-                      <a:headEnd type="none" w="med" len="med"/>
-                      <a:tailEnd type="none" w="med" len="med"/>
-                    </a:lnL>
-                    <a:lnR w="6350" cap="flat" cmpd="sng" algn="ctr">
-                      <a:solidFill>
-                        <a:srgbClr val="BFBFBF"/>
-                      </a:solidFill>
-                      <a:prstDash val="solid"/>
-                      <a:round/>
-                      <a:headEnd type="none" w="med" len="med"/>
-                      <a:tailEnd type="none" w="med" len="med"/>
-                    </a:lnR>
-                    <a:lnT w="6350" cap="flat" cmpd="sng" algn="ctr">
-                      <a:solidFill>
-                        <a:srgbClr val="BFBFBF"/>
-                      </a:solidFill>
-                      <a:prstDash val="solid"/>
-                      <a:round/>
-                      <a:headEnd type="none" w="med" len="med"/>
-                      <a:tailEnd type="none" w="med" len="med"/>
-                    </a:lnT>
-                    <a:lnB w="6350" cap="flat" cmpd="sng" algn="ctr">
-                      <a:solidFill>
-                        <a:srgbClr val="BFBFBF"/>
-                      </a:solidFill>
-                      <a:prstDash val="solid"/>
-                      <a:round/>
-                      <a:headEnd type="none" w="med" len="med"/>
-                      <a:tailEnd type="none" w="med" len="med"/>
-                    </a:lnB>
-                    <a:solidFill>
-                      <a:srgbClr val="F2F2F2"/>
-                    </a:solidFill>
-                  </a:tcPr>
-                </a:tc>
-                <a:tc>
-                  <a:txBody>
-                    <a:bodyPr/>
-                    <a:lstStyle/>
-                    <a:p>
-                      <a:pPr algn="ctr" indent="0" marL="0">
-                        <a:buNone/>
-                      </a:pPr>
-                      <a:r>
-                        <a:rPr lang="en-US" sz="950" dirty="0">
-                          <a:solidFill>
-                            <a:srgbClr val="1A1A1A"/>
-                          </a:solidFill>
-                          <a:latin typeface="Garamond" pitchFamily="34" charset="0"/>
-                          <a:ea typeface="Garamond" pitchFamily="34" charset="-122"/>
-                          <a:cs typeface="Garamond" pitchFamily="34" charset="-120"/>
-                        </a:rPr>
-                        <a:t>n/a</a:t>
-                      </a:r>
-                      <a:endParaRPr lang="en-US" sz="1200" dirty="0"/>
-                    </a:p>
-                  </a:txBody>
-                  <a:tcPr marL="38100" marR="38100" marT="12700" marB="12700">
-                    <a:lnL w="6350" cap="flat" cmpd="sng" algn="ctr">
-                      <a:solidFill>
-                        <a:srgbClr val="BFBFBF"/>
-                      </a:solidFill>
-                      <a:prstDash val="solid"/>
-                      <a:round/>
-                      <a:headEnd type="none" w="med" len="med"/>
-                      <a:tailEnd type="none" w="med" len="med"/>
-                    </a:lnL>
-                    <a:lnR w="6350" cap="flat" cmpd="sng" algn="ctr">
-                      <a:solidFill>
-                        <a:srgbClr val="BFBFBF"/>
-                      </a:solidFill>
-                      <a:prstDash val="solid"/>
-                      <a:round/>
-                      <a:headEnd type="none" w="med" len="med"/>
-                      <a:tailEnd type="none" w="med" len="med"/>
-                    </a:lnR>
-                    <a:lnT w="6350" cap="flat" cmpd="sng" algn="ctr">
-                      <a:solidFill>
-                        <a:srgbClr val="BFBFBF"/>
-                      </a:solidFill>
-                      <a:prstDash val="solid"/>
-                      <a:round/>
-                      <a:headEnd type="none" w="med" len="med"/>
-                      <a:tailEnd type="none" w="med" len="med"/>
-                    </a:lnT>
-                    <a:lnB w="6350" cap="flat" cmpd="sng" algn="ctr">
-                      <a:solidFill>
-                        <a:srgbClr val="BFBFBF"/>
-                      </a:solidFill>
-                      <a:prstDash val="solid"/>
-                      <a:round/>
-                      <a:headEnd type="none" w="med" len="med"/>
-                      <a:tailEnd type="none" w="med" len="med"/>
-                    </a:lnB>
-                    <a:solidFill>
-                      <a:srgbClr val="F2F2F2"/>
-                    </a:solidFill>
-                  </a:tcPr>
-                </a:tc>
-                <a:tc>
-                  <a:txBody>
-                    <a:bodyPr/>
-                    <a:lstStyle/>
-                    <a:p>
-                      <a:pPr algn="ctr" indent="0" marL="0">
-                        <a:buNone/>
-                      </a:pPr>
-                      <a:r>
-                        <a:rPr lang="en-US" sz="950" dirty="0">
-                          <a:solidFill>
-                            <a:srgbClr val="1A1A1A"/>
-                          </a:solidFill>
-                          <a:latin typeface="Garamond" pitchFamily="34" charset="0"/>
-                          <a:ea typeface="Garamond" pitchFamily="34" charset="-122"/>
-                          <a:cs typeface="Garamond" pitchFamily="34" charset="-120"/>
-                        </a:rPr>
-                        <a:t>Med-High</a:t>
-                      </a:r>
-                      <a:endParaRPr lang="en-US" sz="1200" dirty="0"/>
-                    </a:p>
-                  </a:txBody>
-                  <a:tcPr marL="38100" marR="38100" marT="12700" marB="12700">
-                    <a:lnL w="6350" cap="flat" cmpd="sng" algn="ctr">
-                      <a:solidFill>
-                        <a:srgbClr val="BFBFBF"/>
-                      </a:solidFill>
-                      <a:prstDash val="solid"/>
-                      <a:round/>
-                      <a:headEnd type="none" w="med" len="med"/>
-                      <a:tailEnd type="none" w="med" len="med"/>
-                    </a:lnL>
-                    <a:lnR w="6350" cap="flat" cmpd="sng" algn="ctr">
-                      <a:solidFill>
-                        <a:srgbClr val="BFBFBF"/>
-                      </a:solidFill>
-                      <a:prstDash val="solid"/>
-                      <a:round/>
-                      <a:headEnd type="none" w="med" len="med"/>
-                      <a:tailEnd type="none" w="med" len="med"/>
-                    </a:lnR>
-                    <a:lnT w="6350" cap="flat" cmpd="sng" algn="ctr">
-                      <a:solidFill>
-                        <a:srgbClr val="BFBFBF"/>
-                      </a:solidFill>
-                      <a:prstDash val="solid"/>
-                      <a:round/>
-                      <a:headEnd type="none" w="med" len="med"/>
-                      <a:tailEnd type="none" w="med" len="med"/>
-                    </a:lnT>
-                    <a:lnB w="6350" cap="flat" cmpd="sng" algn="ctr">
-                      <a:solidFill>
-                        <a:srgbClr val="BFBFBF"/>
-                      </a:solidFill>
-                      <a:prstDash val="solid"/>
-                      <a:round/>
-                      <a:headEnd type="none" w="med" len="med"/>
-                      <a:tailEnd type="none" w="med" len="med"/>
-                    </a:lnB>
-                    <a:solidFill>
-                      <a:srgbClr val="F2F2F2"/>
-                    </a:solidFill>
-                  </a:tcPr>
-                </a:tc>
-                <a:tc>
-                  <a:txBody>
-                    <a:bodyPr/>
-                    <a:lstStyle/>
-                    <a:p>
-                      <a:pPr algn="ctr" indent="0" marL="0">
-                        <a:buNone/>
-                      </a:pPr>
-                      <a:r>
-                        <a:rPr lang="en-US" sz="950" dirty="0">
-                          <a:solidFill>
-                            <a:srgbClr val="1A1A1A"/>
-                          </a:solidFill>
-                          <a:latin typeface="Garamond" pitchFamily="34" charset="0"/>
-                          <a:ea typeface="Garamond" pitchFamily="34" charset="-122"/>
-                          <a:cs typeface="Garamond" pitchFamily="34" charset="-120"/>
-                        </a:rPr>
-                        <a:t>Med</a:t>
+                        <a:t>250</a:t>
                       </a:r>
                       <a:endParaRPr lang="en-US" sz="1200" dirty="0"/>
                     </a:p>
@@ -16503,7 +15736,7 @@
                         <a:buNone/>
                       </a:pPr>
                       <a:r>
-                        <a:rPr lang="en-US" sz="950" dirty="0">
+                        <a:rPr lang="en-US" sz="900" dirty="0">
                           <a:solidFill>
                             <a:srgbClr val="1A1A1A"/>
                           </a:solidFill>
@@ -16511,7 +15744,7 @@
                           <a:ea typeface="Garamond" pitchFamily="34" charset="-122"/>
                           <a:cs typeface="Garamond" pitchFamily="34" charset="-120"/>
                         </a:rPr>
-                        <a:t>Cipher “Colchis” / Stargate Milam / Nebius</a:t>
+                        <a:t>Fermi Matador (TensorWave)</a:t>
                       </a:r>
                       <a:endParaRPr lang="en-US" sz="1200" dirty="0"/>
                     </a:p>
@@ -16563,11 +15796,11 @@
                     <a:bodyPr/>
                     <a:lstStyle/>
                     <a:p>
-                      <a:pPr algn="ctr" indent="0" marL="0">
+                      <a:pPr algn="l" indent="0" marL="0">
                         <a:buNone/>
                       </a:pPr>
                       <a:r>
-                        <a:rPr lang="en-US" sz="950" dirty="0">
+                        <a:rPr lang="en-US" sz="900" dirty="0">
                           <a:solidFill>
                             <a:srgbClr val="1A1A1A"/>
                           </a:solidFill>
@@ -16575,7 +15808,7 @@
                           <a:ea typeface="Garamond" pitchFamily="34" charset="-122"/>
                           <a:cs typeface="Garamond" pitchFamily="34" charset="-120"/>
                         </a:rPr>
-                        <a:t>TX, MO</a:t>
+                        <a:t>222 MW lease from H2-27; leased TM2500s</a:t>
                       </a:r>
                       <a:endParaRPr lang="en-US" sz="1200" dirty="0"/>
                     </a:p>
@@ -16627,11 +15860,11 @@
                     <a:bodyPr/>
                     <a:lstStyle/>
                     <a:p>
-                      <a:pPr algn="ctr" indent="0" marL="0">
+                      <a:pPr algn="l" indent="0" marL="0">
                         <a:buNone/>
                       </a:pPr>
                       <a:r>
-                        <a:rPr lang="en-US" sz="950" dirty="0">
+                        <a:rPr lang="en-US" sz="900" dirty="0">
                           <a:solidFill>
                             <a:srgbClr val="1A1A1A"/>
                           </a:solidFill>
@@ -16639,7 +15872,7 @@
                           <a:ea typeface="Garamond" pitchFamily="34" charset="-122"/>
                           <a:cs typeface="Garamond" pitchFamily="34" charset="-120"/>
                         </a:rPr>
-                        <a:t>~3.3 GW</a:t>
+                        <a:t>7%</a:t>
                       </a:r>
                       <a:endParaRPr lang="en-US" sz="1200" dirty="0"/>
                     </a:p>
@@ -16691,11 +15924,11 @@
                     <a:bodyPr/>
                     <a:lstStyle/>
                     <a:p>
-                      <a:pPr algn="ctr" indent="0" marL="0">
+                      <a:pPr algn="l" indent="0" marL="0">
                         <a:buNone/>
                       </a:pPr>
                       <a:r>
-                        <a:rPr lang="en-US" sz="950" dirty="0">
+                        <a:rPr lang="en-US" sz="900" dirty="0">
                           <a:solidFill>
                             <a:srgbClr val="1A1A1A"/>
                           </a:solidFill>
@@ -16703,199 +15936,7 @@
                           <a:ea typeface="Garamond" pitchFamily="34" charset="-122"/>
                           <a:cs typeface="Garamond" pitchFamily="34" charset="-120"/>
                         </a:rPr>
-                        <a:t>AEP 2028; solar + storage; new plant Oct-27</a:t>
-                      </a:r>
-                      <a:endParaRPr lang="en-US" sz="1200" dirty="0"/>
-                    </a:p>
-                  </a:txBody>
-                  <a:tcPr marL="38100" marR="38100" marT="12700" marB="12700">
-                    <a:lnL w="6350" cap="flat" cmpd="sng" algn="ctr">
-                      <a:solidFill>
-                        <a:srgbClr val="BFBFBF"/>
-                      </a:solidFill>
-                      <a:prstDash val="solid"/>
-                      <a:round/>
-                      <a:headEnd type="none" w="med" len="med"/>
-                      <a:tailEnd type="none" w="med" len="med"/>
-                    </a:lnL>
-                    <a:lnR w="6350" cap="flat" cmpd="sng" algn="ctr">
-                      <a:solidFill>
-                        <a:srgbClr val="BFBFBF"/>
-                      </a:solidFill>
-                      <a:prstDash val="solid"/>
-                      <a:round/>
-                      <a:headEnd type="none" w="med" len="med"/>
-                      <a:tailEnd type="none" w="med" len="med"/>
-                    </a:lnR>
-                    <a:lnT w="6350" cap="flat" cmpd="sng" algn="ctr">
-                      <a:solidFill>
-                        <a:srgbClr val="BFBFBF"/>
-                      </a:solidFill>
-                      <a:prstDash val="solid"/>
-                      <a:round/>
-                      <a:headEnd type="none" w="med" len="med"/>
-                      <a:tailEnd type="none" w="med" len="med"/>
-                    </a:lnT>
-                    <a:lnB w="6350" cap="flat" cmpd="sng" algn="ctr">
-                      <a:solidFill>
-                        <a:srgbClr val="BFBFBF"/>
-                      </a:solidFill>
-                      <a:prstDash val="solid"/>
-                      <a:round/>
-                      <a:headEnd type="none" w="med" len="med"/>
-                      <a:tailEnd type="none" w="med" len="med"/>
-                    </a:lnB>
-                    <a:solidFill>
-                      <a:srgbClr val="FFFFFF"/>
-                    </a:solidFill>
-                  </a:tcPr>
-                </a:tc>
-                <a:tc>
-                  <a:txBody>
-                    <a:bodyPr/>
-                    <a:lstStyle/>
-                    <a:p>
-                      <a:pPr algn="ctr" indent="0" marL="0">
-                        <a:buNone/>
-                      </a:pPr>
-                      <a:r>
-                        <a:rPr lang="en-US" sz="950" dirty="0">
-                          <a:solidFill>
-                            <a:srgbClr val="1A1A1A"/>
-                          </a:solidFill>
-                          <a:latin typeface="Garamond" pitchFamily="34" charset="0"/>
-                          <a:ea typeface="Garamond" pitchFamily="34" charset="-122"/>
-                          <a:cs typeface="Garamond" pitchFamily="34" charset="-120"/>
-                        </a:rPr>
-                        <a:t>2027–28</a:t>
-                      </a:r>
-                      <a:endParaRPr lang="en-US" sz="1200" dirty="0"/>
-                    </a:p>
-                  </a:txBody>
-                  <a:tcPr marL="38100" marR="38100" marT="12700" marB="12700">
-                    <a:lnL w="6350" cap="flat" cmpd="sng" algn="ctr">
-                      <a:solidFill>
-                        <a:srgbClr val="BFBFBF"/>
-                      </a:solidFill>
-                      <a:prstDash val="solid"/>
-                      <a:round/>
-                      <a:headEnd type="none" w="med" len="med"/>
-                      <a:tailEnd type="none" w="med" len="med"/>
-                    </a:lnL>
-                    <a:lnR w="6350" cap="flat" cmpd="sng" algn="ctr">
-                      <a:solidFill>
-                        <a:srgbClr val="BFBFBF"/>
-                      </a:solidFill>
-                      <a:prstDash val="solid"/>
-                      <a:round/>
-                      <a:headEnd type="none" w="med" len="med"/>
-                      <a:tailEnd type="none" w="med" len="med"/>
-                    </a:lnR>
-                    <a:lnT w="6350" cap="flat" cmpd="sng" algn="ctr">
-                      <a:solidFill>
-                        <a:srgbClr val="BFBFBF"/>
-                      </a:solidFill>
-                      <a:prstDash val="solid"/>
-                      <a:round/>
-                      <a:headEnd type="none" w="med" len="med"/>
-                      <a:tailEnd type="none" w="med" len="med"/>
-                    </a:lnT>
-                    <a:lnB w="6350" cap="flat" cmpd="sng" algn="ctr">
-                      <a:solidFill>
-                        <a:srgbClr val="BFBFBF"/>
-                      </a:solidFill>
-                      <a:prstDash val="solid"/>
-                      <a:round/>
-                      <a:headEnd type="none" w="med" len="med"/>
-                      <a:tailEnd type="none" w="med" len="med"/>
-                    </a:lnB>
-                    <a:solidFill>
-                      <a:srgbClr val="FFFFFF"/>
-                    </a:solidFill>
-                  </a:tcPr>
-                </a:tc>
-                <a:tc>
-                  <a:txBody>
-                    <a:bodyPr/>
-                    <a:lstStyle/>
-                    <a:p>
-                      <a:pPr algn="ctr" indent="0" marL="0">
-                        <a:buNone/>
-                      </a:pPr>
-                      <a:r>
-                        <a:rPr lang="en-US" sz="950" dirty="0">
-                          <a:solidFill>
-                            <a:srgbClr val="1A1A1A"/>
-                          </a:solidFill>
-                          <a:latin typeface="Garamond" pitchFamily="34" charset="0"/>
-                          <a:ea typeface="Garamond" pitchFamily="34" charset="-122"/>
-                          <a:cs typeface="Garamond" pitchFamily="34" charset="-120"/>
-                        </a:rPr>
-                        <a:t>Med</a:t>
-                      </a:r>
-                      <a:endParaRPr lang="en-US" sz="1200" dirty="0"/>
-                    </a:p>
-                  </a:txBody>
-                  <a:tcPr marL="38100" marR="38100" marT="12700" marB="12700">
-                    <a:lnL w="6350" cap="flat" cmpd="sng" algn="ctr">
-                      <a:solidFill>
-                        <a:srgbClr val="BFBFBF"/>
-                      </a:solidFill>
-                      <a:prstDash val="solid"/>
-                      <a:round/>
-                      <a:headEnd type="none" w="med" len="med"/>
-                      <a:tailEnd type="none" w="med" len="med"/>
-                    </a:lnL>
-                    <a:lnR w="6350" cap="flat" cmpd="sng" algn="ctr">
-                      <a:solidFill>
-                        <a:srgbClr val="BFBFBF"/>
-                      </a:solidFill>
-                      <a:prstDash val="solid"/>
-                      <a:round/>
-                      <a:headEnd type="none" w="med" len="med"/>
-                      <a:tailEnd type="none" w="med" len="med"/>
-                    </a:lnR>
-                    <a:lnT w="6350" cap="flat" cmpd="sng" algn="ctr">
-                      <a:solidFill>
-                        <a:srgbClr val="BFBFBF"/>
-                      </a:solidFill>
-                      <a:prstDash val="solid"/>
-                      <a:round/>
-                      <a:headEnd type="none" w="med" len="med"/>
-                      <a:tailEnd type="none" w="med" len="med"/>
-                    </a:lnT>
-                    <a:lnB w="6350" cap="flat" cmpd="sng" algn="ctr">
-                      <a:solidFill>
-                        <a:srgbClr val="BFBFBF"/>
-                      </a:solidFill>
-                      <a:prstDash val="solid"/>
-                      <a:round/>
-                      <a:headEnd type="none" w="med" len="med"/>
-                      <a:tailEnd type="none" w="med" len="med"/>
-                    </a:lnB>
-                    <a:solidFill>
-                      <a:srgbClr val="FFFFFF"/>
-                    </a:solidFill>
-                  </a:tcPr>
-                </a:tc>
-                <a:tc>
-                  <a:txBody>
-                    <a:bodyPr/>
-                    <a:lstStyle/>
-                    <a:p>
-                      <a:pPr algn="ctr" indent="0" marL="0">
-                        <a:buNone/>
-                      </a:pPr>
-                      <a:r>
-                        <a:rPr lang="en-US" sz="950" dirty="0">
-                          <a:solidFill>
-                            <a:srgbClr val="1A1A1A"/>
-                          </a:solidFill>
-                          <a:latin typeface="Garamond" pitchFamily="34" charset="0"/>
-                          <a:ea typeface="Garamond" pitchFamily="34" charset="-122"/>
-                          <a:cs typeface="Garamond" pitchFamily="34" charset="-120"/>
-                        </a:rPr>
-                        <a:t>Med</a:t>
+                        <a:t>214</a:t>
                       </a:r>
                       <a:endParaRPr lang="en-US" sz="1200" dirty="0"/>
                     </a:p>
@@ -16949,14 +15990,14 @@
       </p:graphicFrame>
       <p:sp>
         <p:nvSpPr>
-          <p:cNvPr id="6" name="Text 3"/>
+          <p:cNvPr id="15" name="Text 11"/>
           <p:cNvSpPr txBox="1"/>
           <p:nvPr/>
         </p:nvSpPr>
         <p:spPr>
           <a:xfrm>
-            <a:off x="621792" y="2999232"/>
-            <a:ext cx="11201400" cy="438912"/>
+            <a:off x="6611112" y="2935224"/>
+            <a:ext cx="5212080" cy="457200"/>
           </a:xfrm>
           <a:prstGeom prst="rect">
             <a:avLst/>
@@ -16975,62 +16016,40 @@
               <a:buNone/>
             </a:pPr>
             <a:r>
-              <a:rPr lang="en-US" sz="1050" b="1" dirty="0">
-                <a:solidFill>
-                  <a:srgbClr val="1A1A1A"/>
-                </a:solidFill>
-                <a:latin typeface="Garamond" pitchFamily="34" charset="0"/>
-                <a:ea typeface="Garamond" pitchFamily="34" charset="-122"/>
-                <a:cs typeface="Garamond" pitchFamily="34" charset="-120"/>
-              </a:rPr>
-              <a:t>Screened out:</a:t>
-            </a:r>
-            <a:r>
-              <a:rPr lang="en-US" sz="1050" dirty="0">
-                <a:solidFill>
-                  <a:srgbClr val="1A1A1A"/>
-                </a:solidFill>
-                <a:latin typeface="Garamond" pitchFamily="34" charset="0"/>
-                <a:ea typeface="Garamond" pitchFamily="34" charset="-122"/>
-                <a:cs typeface="Garamond" pitchFamily="34" charset="-120"/>
-              </a:rPr>
-              <a:t> Stargate Jupiter → Bloom; Frontier → VoltaGrid; Prometheus → Williams; Homer City → GE 7HA. </a:t>
-            </a:r>
-            <a:r>
-              <a:rPr lang="en-US" sz="1050" b="1" dirty="0">
-                <a:solidFill>
-                  <a:srgbClr val="1A1A1A"/>
-                </a:solidFill>
-                <a:latin typeface="Garamond" pitchFamily="34" charset="0"/>
-                <a:ea typeface="Garamond" pitchFamily="34" charset="-122"/>
-                <a:cs typeface="Garamond" pitchFamily="34" charset="-120"/>
-              </a:rPr>
-              <a:t>Grid-led:</a:t>
-            </a:r>
-            <a:r>
-              <a:rPr lang="en-US" sz="1050" dirty="0">
-                <a:solidFill>
-                  <a:srgbClr val="1A1A1A"/>
-                </a:solidFill>
-                <a:latin typeface="Garamond" pitchFamily="34" charset="0"/>
-                <a:ea typeface="Garamond" pitchFamily="34" charset="-122"/>
-                <a:cs typeface="Garamond" pitchFamily="34" charset="-120"/>
-              </a:rPr>
-              <a:t> Saline, Lighthouse, Fairwater, Helios, Sweetwater. </a:t>
-            </a:r>
-            <a:r>
-              <a:rPr lang="en-US" sz="1050" u="sng" dirty="0">
-                <a:solidFill>
-                  <a:srgbClr val="1A1A1A"/>
-                </a:solidFill>
-                <a:latin typeface="Garamond" pitchFamily="34" charset="0"/>
-                <a:ea typeface="Garamond" pitchFamily="34" charset="-122"/>
-                <a:cs typeface="Garamond" pitchFamily="34" charset="-120"/>
-              </a:rPr>
-              <a:t>One High site ≈ another first order</a:t>
-            </a:r>
-            <a:r>
-              <a:rPr lang="en-US" sz="1050" dirty="0">
+              <a:rPr lang="en-US" sz="950" b="1" dirty="0">
+                <a:solidFill>
+                  <a:srgbClr val="1A1A1A"/>
+                </a:solidFill>
+                <a:latin typeface="Garamond" pitchFamily="34" charset="0"/>
+                <a:ea typeface="Garamond" pitchFamily="34" charset="-122"/>
+                <a:cs typeface="Garamond" pitchFamily="34" charset="-120"/>
+              </a:rPr>
+              <a:t>Locked out:</a:t>
+            </a:r>
+            <a:r>
+              <a:rPr lang="en-US" sz="950" dirty="0">
+                <a:solidFill>
+                  <a:srgbClr val="1A1A1A"/>
+                </a:solidFill>
+                <a:latin typeface="Garamond" pitchFamily="34" charset="0"/>
+                <a:ea typeface="Garamond" pitchFamily="34" charset="-122"/>
+                <a:cs typeface="Garamond" pitchFamily="34" charset="-120"/>
+              </a:rPr>
+              <a:t> Jupiter → Bloom; Frontier → VoltaGrid; Prometheus → Williams; Kilby, Homer City → GE 7HA. Typical non-xAI Jereh order: </a:t>
+            </a:r>
+            <a:r>
+              <a:rPr lang="en-US" sz="950" u="sng" dirty="0">
+                <a:solidFill>
+                  <a:srgbClr val="1A1A1A"/>
+                </a:solidFill>
+                <a:latin typeface="Garamond" pitchFamily="34" charset="0"/>
+                <a:ea typeface="Garamond" pitchFamily="34" charset="-122"/>
+                <a:cs typeface="Garamond" pitchFamily="34" charset="-120"/>
+              </a:rPr>
+              <a:t>$100–341M (3–11 units)</a:t>
+            </a:r>
+            <a:r>
+              <a:rPr lang="en-US" sz="950" dirty="0">
                 <a:solidFill>
                   <a:srgbClr val="1A1A1A"/>
                 </a:solidFill>
@@ -17040,13 +16059,13 @@
               </a:rPr>
               <a:t>.</a:t>
             </a:r>
-            <a:endParaRPr lang="en-US" sz="1050" dirty="0"/>
+            <a:endParaRPr lang="en-US" sz="950" dirty="0"/>
           </a:p>
         </p:txBody>
       </p:sp>
       <p:sp>
         <p:nvSpPr>
-          <p:cNvPr id="7" name="Text 4"/>
+          <p:cNvPr id="16" name="Text 12"/>
           <p:cNvSpPr txBox="1"/>
           <p:nvPr/>
         </p:nvSpPr>
@@ -17085,7 +16104,7 @@
       </p:sp>
       <p:sp>
         <p:nvSpPr>
-          <p:cNvPr id="8" name="Shape 5"/>
+          <p:cNvPr id="17" name="Shape 13"/>
           <p:cNvSpPr/>
           <p:nvPr/>
         </p:nvSpPr>
@@ -17108,7 +16127,7 @@
       </p:sp>
       <p:graphicFrame>
         <p:nvGraphicFramePr>
-          <p:cNvPr id="9" name="Chart 0" descr=""/>
+          <p:cNvPr id="18" name="Chart 1" descr=""/>
           <p:cNvGraphicFramePr/>
           <p:nvPr/>
         </p:nvGraphicFramePr>
@@ -17118,13 +16137,13 @@
         </p:xfrm>
         <a:graphic xmlns:a="http://schemas.openxmlformats.org/drawingml/2006/main">
           <a:graphicData uri="http://schemas.openxmlformats.org/drawingml/2006/chart">
-            <c:chart xmlns:c="http://schemas.openxmlformats.org/drawingml/2006/chart" r:id="rId1"/>
+            <c:chart xmlns:c="http://schemas.openxmlformats.org/drawingml/2006/chart" r:id="rId2"/>
           </a:graphicData>
         </a:graphic>
       </p:graphicFrame>
       <p:sp>
         <p:nvSpPr>
-          <p:cNvPr id="10" name="Text 6"/>
+          <p:cNvPr id="19" name="Text 14"/>
           <p:cNvSpPr txBox="1"/>
           <p:nvPr/>
         </p:nvSpPr>
@@ -17306,7 +16325,7 @@
       </p:sp>
       <p:sp>
         <p:nvSpPr>
-          <p:cNvPr id="11" name="Shape 7"/>
+          <p:cNvPr id="20" name="Shape 15"/>
           <p:cNvSpPr/>
           <p:nvPr/>
         </p:nvSpPr>
@@ -18342,7 +17361,7 @@
       </p:graphicFrame>
       <p:sp>
         <p:nvSpPr>
-          <p:cNvPr id="13" name="Text 8"/>
+          <p:cNvPr id="22" name="Text 16"/>
           <p:cNvSpPr txBox="1"/>
           <p:nvPr/>
         </p:nvSpPr>
@@ -19573,7 +18592,7 @@
       </p:graphicFrame>
       <p:sp>
         <p:nvSpPr>
-          <p:cNvPr id="15" name="Shape 9"/>
+          <p:cNvPr id="24" name="Shape 17"/>
           <p:cNvSpPr/>
           <p:nvPr/>
         </p:nvSpPr>
@@ -19598,7 +18617,7 @@
       </p:sp>
       <p:sp>
         <p:nvSpPr>
-          <p:cNvPr id="16" name="Text 10"/>
+          <p:cNvPr id="25" name="Text 18"/>
           <p:cNvSpPr txBox="1"/>
           <p:nvPr/>
         </p:nvSpPr>
@@ -19629,7 +18648,7 @@
                 <a:ea typeface="Garamond" pitchFamily="34" charset="-122"/>
                 <a:cs typeface="Garamond" pitchFamily="34" charset="-120"/>
               </a:rPr>
-              <a:t>Power is a free call option: ~10 GW sits at the first buyer's stage, and each ~1 GW contract FTAI wins adds ~$35 / share.</a:t>
+              <a:t>Power is a free call option: we see ~75% odds of another order within 12 months, and each ~1 GW contract adds ~$35 / share.</a:t>
             </a:r>
             <a:endParaRPr lang="en-US" sz="1400" dirty="0"/>
           </a:p>
@@ -19637,7 +18656,7 @@
       </p:sp>
       <p:sp>
         <p:nvSpPr>
-          <p:cNvPr id="17" name="Text 11"/>
+          <p:cNvPr id="26" name="Text 19"/>
           <p:cNvSpPr txBox="1"/>
           <p:nvPr/>
         </p:nvSpPr>
@@ -19668,7 +18687,7 @@
                 <a:ea typeface="Garamond" pitchFamily="34" charset="-122"/>
                 <a:cs typeface="Garamond" pitchFamily="34" charset="-120"/>
               </a:rPr>
-              <a:t>Source: Company releases, TCEQ / MDEQ filings, Cleanview, Epoch AI, DCD, GE Vernova / Siemens Energy / MHI Q2'26, GridLab, JLL, FTAI calls, GPS Model</a:t>
+              <a:t>Source: GPS Power Next-Contract Model, Jereh filings / order ledger, Company releases, TCEQ / MDEQ filings, Cleanview, Epoch AI, DCD, GE Vernova / Siemens Energy / MHI Q2'26, GridLab, JLL, FTAI calls, GPS Model</a:t>
             </a:r>
             <a:endParaRPr lang="en-US" sz="1100" dirty="0"/>
           </a:p>
@@ -19676,7 +18695,7 @@
       </p:sp>
       <p:sp>
         <p:nvSpPr>
-          <p:cNvPr id="18" name="Text 12"/>
+          <p:cNvPr id="27" name="Text 20"/>
           <p:cNvSpPr txBox="1"/>
           <p:nvPr/>
         </p:nvSpPr>
@@ -19707,7 +18726,7 @@
                 <a:ea typeface="Garamond" pitchFamily="34" charset="-122"/>
                 <a:cs typeface="Garamond" pitchFamily="34" charset="-120"/>
               </a:rPr>
-              <a:t>1.  Win-ability = gas access + BTM permitting + no locked supplier + 2026–28 load date. Value per share at 12x Power EBITDA, 104.0M shares.</a:t>
+              <a:t>1.  Site-level P = S × [1 – Π(1 – p_i)] + (1 – S) × P(E | shock), S = 0.855, 37 sites + residual; Chinese-supplier risk excluded. $ / share at 12x, 104.0M shares.</a:t>
             </a:r>
             <a:endParaRPr lang="en-US" sz="700" dirty="0"/>
           </a:p>
@@ -29513,7 +28532,7 @@
                 <a:ea typeface="Garamond" pitchFamily="34" charset="-122"/>
                 <a:cs typeface="Garamond" pitchFamily="34" charset="-120"/>
               </a:rPr>
-              <a:t>First revenue from the $1.465bn order; a second order adds ~$35 / share</a:t>
+              <a:t>First revenue from the $1.465bn order; a second order (~75% odds in 12M) adds ~$35 / share</a:t>
             </a:r>
             <a:endParaRPr lang="en-US" sz="1050" dirty="0"/>
           </a:p>
@@ -36524,7 +35543,7 @@
                 <a:ea typeface="Garamond" pitchFamily="34" charset="-122"/>
                 <a:cs typeface="Garamond" pitchFamily="34" charset="-120"/>
               </a:rPr>
-              <a:t>screened 24 US AI campuses</a:t>
+              <a:t>a site-level next-order model</a:t>
             </a:r>
             <a:r>
               <a:rPr lang="en-US" sz="1300" dirty="0">
@@ -36535,7 +35554,7 @@
                 <a:ea typeface="Garamond" pitchFamily="34" charset="-122"/>
                 <a:cs typeface="Garamond" pitchFamily="34" charset="-120"/>
               </a:rPr>
-              <a:t> for sites at the first buyer's stage.</a:t>
+              <a:t> across 37 AI campuses.</a:t>
             </a:r>
             <a:endParaRPr lang="en-US" sz="1300" dirty="0"/>
           </a:p>
@@ -37091,7 +36110,7 @@
                 <a:ea typeface="Garamond" pitchFamily="34" charset="-122"/>
                 <a:cs typeface="Garamond" pitchFamily="34" charset="-120"/>
               </a:rPr>
-              <a:t>Power is a call option: </a:t>
+              <a:t>Power is a call option: we see </a:t>
             </a:r>
             <a:r>
               <a:rPr lang="en-US" sz="1300" u="sng" dirty="0">
@@ -37102,7 +36121,7 @@
                 <a:ea typeface="Garamond" pitchFamily="34" charset="-122"/>
                 <a:cs typeface="Garamond" pitchFamily="34" charset="-120"/>
               </a:rPr>
-              <a:t>~10 GW of load</a:t>
+              <a:t>~75% odds of another order</a:t>
             </a:r>
             <a:r>
               <a:rPr lang="en-US" sz="1300" dirty="0">
@@ -37113,7 +36132,7 @@
                 <a:ea typeface="Garamond" pitchFamily="34" charset="-122"/>
                 <a:cs typeface="Garamond" pitchFamily="34" charset="-120"/>
               </a:rPr>
-              <a:t> sits at the first buyer's stage without a locked supplier; one more contract is worth </a:t>
+              <a:t> in 12 months (61% ex-xAI); one more contract is worth </a:t>
             </a:r>
             <a:r>
               <a:rPr lang="en-US" sz="1300" u="sng" dirty="0">

</xml_diff>

<commit_message>
Fix chart XML so Thesis II and other charts open cleanly in PowerPoint
pptxgenjs wrote per-bar colours after data labels, an extra axis id and
line charts without a grouping element, which break the OOXML chart
schema. Add a post-build pass (fix_charts.py) that reorders chart XML;
all 22 charts now validate. Nudge the Thesis II legend caption off the
divider.

Co-Authored-By: Claude Opus 5.5 <noreply@anthropic.com>
Claude-Session: https://claude.ai/code/session_01UfcjrwVkNc9oEPnjB82u2w
</commit_message>
<xml_diff>
--- a/ftai_pitch/FTAI_Long_Pitch.pptx
+++ b/ftai_pitch/FTAI_Long_Pitch.pptx
@@ -394,7 +394,6 @@
         <c:overlap val="100"/>
         <c:axId val="2094734554"/>
         <c:axId val="2094734552"/>
-        <c:axId val="2094734556"/>
       </c:barChart>
       <c:catAx>
         <c:axId val="2094734554"/>
@@ -776,7 +775,6 @@
         <c:overlap val="100"/>
         <c:axId val="2094734554"/>
         <c:axId val="2094734552"/>
-        <c:axId val="2094734556"/>
       </c:barChart>
       <c:catAx>
         <c:axId val="2094734554"/>
@@ -1146,7 +1144,6 @@
         <c:overlap val="100"/>
         <c:axId val="2094734554"/>
         <c:axId val="2094734552"/>
-        <c:axId val="2094734556"/>
       </c:barChart>
       <c:catAx>
         <c:axId val="2094734554"/>
@@ -1292,6 +1289,7 @@
     <c:plotArea>
       <c:layout/>
       <c:lineChart>
+        <c:grouping val="standard"/>
         <c:varyColors val="0"/>
         <c:ser>
           <c:idx val="0"/>
@@ -1320,7 +1318,23 @@
             </a:ln>
             <a:effectLst/>
           </c:spPr>
-          <c:invertIfNegative val="0"/>
+          <c:marker>
+            <c:symbol val="circle"/>
+            <c:size val="6"/>
+            <c:spPr>
+              <a:solidFill>
+                <a:srgbClr val="E8702A"/>
+              </a:solidFill>
+              <a:ln w="9525" cap="flat">
+                <a:solidFill>
+                  <a:srgbClr val="E8702A"/>
+                </a:solidFill>
+                <a:prstDash val="solid"/>
+                <a:round/>
+              </a:ln>
+              <a:effectLst/>
+            </c:spPr>
+          </c:marker>
           <c:dLbls>
             <c:numFmt formatCode="$0" sourceLinked="0"/>
             <c:txPr>
@@ -1346,23 +1360,6 @@
             <c:showBubbleSize val="0"/>
             <c:showLeaderLines val="0"/>
           </c:dLbls>
-          <c:marker>
-            <c:symbol val="circle"/>
-            <c:size val="6"/>
-            <c:spPr>
-              <a:solidFill>
-                <a:srgbClr val="E8702A"/>
-              </a:solidFill>
-              <a:ln w="9525" cap="flat">
-                <a:solidFill>
-                  <a:srgbClr val="E8702A"/>
-                </a:solidFill>
-                <a:prstDash val="solid"/>
-                <a:round/>
-              </a:ln>
-              <a:effectLst/>
-            </c:spPr>
-          </c:marker>
           <c:cat>
             <c:multiLvlStrRef>
               <c:f>Sheet1!$A$2:$A$6</c:f>
@@ -1442,7 +1439,6 @@
         <c:marker val="1"/>
         <c:axId val="2094734554"/>
         <c:axId val="2094734552"/>
-        <c:axId val="2094734556"/>
       </c:lineChart>
       <c:catAx>
         <c:axId val="2094734554"/>
@@ -1612,30 +1608,6 @@
             <a:effectLst/>
           </c:spPr>
           <c:invertIfNegative val="0"/>
-          <c:dLbls>
-            <c:numFmt formatCode="0.0%" sourceLinked="0"/>
-            <c:txPr>
-              <a:bodyPr/>
-              <a:lstStyle/>
-              <a:p>
-                <a:pPr>
-                  <a:defRPr b="0" i="0" strike="noStrike" sz="900" u="none">
-                    <a:solidFill>
-                      <a:srgbClr val="262626"/>
-                    </a:solidFill>
-                    <a:latin typeface="Garamond"/>
-                  </a:defRPr>
-                </a:pPr>
-              </a:p>
-            </c:txPr>
-            <c:showLegendKey val="0"/>
-            <c:showVal val="1"/>
-            <c:showCatName val="0"/>
-            <c:showSerName val="0"/>
-            <c:showPercent val="0"/>
-            <c:showBubbleSize val="0"/>
-            <c:showLeaderLines val="0"/>
-          </c:dLbls>
           <c:dPt>
             <c:idx val="0"/>
             <c:invertIfNegative val="0"/>
@@ -1680,6 +1652,30 @@
               <a:effectLst/>
             </c:spPr>
           </c:dPt>
+          <c:dLbls>
+            <c:numFmt formatCode="0.0%" sourceLinked="0"/>
+            <c:txPr>
+              <a:bodyPr/>
+              <a:lstStyle/>
+              <a:p>
+                <a:pPr>
+                  <a:defRPr b="0" i="0" strike="noStrike" sz="900" u="none">
+                    <a:solidFill>
+                      <a:srgbClr val="262626"/>
+                    </a:solidFill>
+                    <a:latin typeface="Garamond"/>
+                  </a:defRPr>
+                </a:pPr>
+              </a:p>
+            </c:txPr>
+            <c:showLegendKey val="0"/>
+            <c:showVal val="1"/>
+            <c:showCatName val="0"/>
+            <c:showSerName val="0"/>
+            <c:showPercent val="0"/>
+            <c:showBubbleSize val="0"/>
+            <c:showLeaderLines val="0"/>
+          </c:dLbls>
           <c:cat>
             <c:multiLvlStrRef>
               <c:f>Sheet1!$A$2:$A$5</c:f>
@@ -1752,7 +1748,6 @@
         <c:overlap val="0"/>
         <c:axId val="2094734554"/>
         <c:axId val="2094734552"/>
-        <c:axId val="2094734556"/>
       </c:barChart>
       <c:catAx>
         <c:axId val="2094734554"/>
@@ -1922,6 +1917,28 @@
             <a:effectLst/>
           </c:spPr>
           <c:invertIfNegative val="0"/>
+          <c:dPt>
+            <c:idx val="0"/>
+            <c:invertIfNegative val="0"/>
+            <c:bubble3D val="0"/>
+            <c:spPr>
+              <a:solidFill>
+                <a:srgbClr val="A6A6A6"/>
+              </a:solidFill>
+              <a:effectLst/>
+            </c:spPr>
+          </c:dPt>
+          <c:dPt>
+            <c:idx val="1"/>
+            <c:invertIfNegative val="0"/>
+            <c:bubble3D val="0"/>
+            <c:spPr>
+              <a:solidFill>
+                <a:srgbClr val="E8702A"/>
+              </a:solidFill>
+              <a:effectLst/>
+            </c:spPr>
+          </c:dPt>
           <c:dLbls>
             <c:numFmt formatCode="0" sourceLinked="0"/>
             <c:txPr>
@@ -1946,28 +1963,6 @@
             <c:showBubbleSize val="0"/>
             <c:showLeaderLines val="0"/>
           </c:dLbls>
-          <c:dPt>
-            <c:idx val="0"/>
-            <c:invertIfNegative val="0"/>
-            <c:bubble3D val="0"/>
-            <c:spPr>
-              <a:solidFill>
-                <a:srgbClr val="A6A6A6"/>
-              </a:solidFill>
-              <a:effectLst/>
-            </c:spPr>
-          </c:dPt>
-          <c:dPt>
-            <c:idx val="1"/>
-            <c:invertIfNegative val="0"/>
-            <c:bubble3D val="0"/>
-            <c:spPr>
-              <a:solidFill>
-                <a:srgbClr val="E8702A"/>
-              </a:solidFill>
-              <a:effectLst/>
-            </c:spPr>
-          </c:dPt>
           <c:cat>
             <c:multiLvlStrRef>
               <c:f>Sheet1!$A$2:$A$3</c:f>
@@ -2028,7 +2023,6 @@
         <c:overlap val="0"/>
         <c:axId val="2094734554"/>
         <c:axId val="2094734552"/>
-        <c:axId val="2094734556"/>
       </c:barChart>
       <c:catAx>
         <c:axId val="2094734554"/>
@@ -2145,6 +2139,7 @@
     <c:plotArea>
       <c:layout/>
       <c:lineChart>
+        <c:grouping val="standard"/>
         <c:varyColors val="0"/>
         <c:ser>
           <c:idx val="0"/>
@@ -2173,7 +2168,23 @@
             </a:ln>
             <a:effectLst/>
           </c:spPr>
-          <c:invertIfNegative val="0"/>
+          <c:marker>
+            <c:symbol val="circle"/>
+            <c:size val="6"/>
+            <c:spPr>
+              <a:solidFill>
+                <a:srgbClr val="E8702A"/>
+              </a:solidFill>
+              <a:ln w="9525" cap="flat">
+                <a:solidFill>
+                  <a:srgbClr val="E8702A"/>
+                </a:solidFill>
+                <a:prstDash val="solid"/>
+                <a:round/>
+              </a:ln>
+              <a:effectLst/>
+            </c:spPr>
+          </c:marker>
           <c:dLbls>
             <c:numFmt formatCode="0%" sourceLinked="0"/>
             <c:txPr>
@@ -2199,23 +2210,6 @@
             <c:showBubbleSize val="0"/>
             <c:showLeaderLines val="0"/>
           </c:dLbls>
-          <c:marker>
-            <c:symbol val="circle"/>
-            <c:size val="6"/>
-            <c:spPr>
-              <a:solidFill>
-                <a:srgbClr val="E8702A"/>
-              </a:solidFill>
-              <a:ln w="9525" cap="flat">
-                <a:solidFill>
-                  <a:srgbClr val="E8702A"/>
-                </a:solidFill>
-                <a:prstDash val="solid"/>
-                <a:round/>
-              </a:ln>
-              <a:effectLst/>
-            </c:spPr>
-          </c:marker>
           <c:cat>
             <c:multiLvlStrRef>
               <c:f>Sheet1!$A$2:$A$6</c:f>
@@ -2294,7 +2288,23 @@
             </a:ln>
             <a:effectLst/>
           </c:spPr>
-          <c:invertIfNegative val="0"/>
+          <c:marker>
+            <c:symbol val="circle"/>
+            <c:size val="6"/>
+            <c:spPr>
+              <a:solidFill>
+                <a:srgbClr val="1F3864"/>
+              </a:solidFill>
+              <a:ln w="9525" cap="flat">
+                <a:solidFill>
+                  <a:srgbClr val="1F3864"/>
+                </a:solidFill>
+                <a:prstDash val="solid"/>
+                <a:round/>
+              </a:ln>
+              <a:effectLst/>
+            </c:spPr>
+          </c:marker>
           <c:dLbls>
             <c:numFmt formatCode="0%" sourceLinked="0"/>
             <c:txPr>
@@ -2320,23 +2330,6 @@
             <c:showBubbleSize val="0"/>
             <c:showLeaderLines val="0"/>
           </c:dLbls>
-          <c:marker>
-            <c:symbol val="circle"/>
-            <c:size val="6"/>
-            <c:spPr>
-              <a:solidFill>
-                <a:srgbClr val="1F3864"/>
-              </a:solidFill>
-              <a:ln w="9525" cap="flat">
-                <a:solidFill>
-                  <a:srgbClr val="1F3864"/>
-                </a:solidFill>
-                <a:prstDash val="solid"/>
-                <a:round/>
-              </a:ln>
-              <a:effectLst/>
-            </c:spPr>
-          </c:marker>
           <c:cat>
             <c:multiLvlStrRef>
               <c:f>Sheet1!$A$2:$A$6</c:f>
@@ -2416,7 +2409,6 @@
         <c:marker val="1"/>
         <c:axId val="2094734554"/>
         <c:axId val="2094734552"/>
-        <c:axId val="2094734556"/>
       </c:lineChart>
       <c:catAx>
         <c:axId val="2094734554"/>
@@ -2782,7 +2774,6 @@
         <c:overlap val="100"/>
         <c:axId val="2094734554"/>
         <c:axId val="2094734552"/>
-        <c:axId val="2094734556"/>
       </c:barChart>
       <c:catAx>
         <c:axId val="2094734554"/>
@@ -3087,7 +3078,6 @@
         <c:overlap val="0"/>
         <c:axId val="2094734554"/>
         <c:axId val="2094734552"/>
-        <c:axId val="2094734556"/>
       </c:barChart>
       <c:catAx>
         <c:axId val="2094734554"/>
@@ -3371,7 +3361,6 @@
         <c:overlap val="0"/>
         <c:axId val="2094734554"/>
         <c:axId val="2094734552"/>
-        <c:axId val="2094734556"/>
       </c:barChart>
       <c:catAx>
         <c:axId val="2094734554"/>
@@ -3851,7 +3840,6 @@
         <c:overlap val="100"/>
         <c:axId val="2094734554"/>
         <c:axId val="2094734552"/>
-        <c:axId val="2094734556"/>
       </c:barChart>
       <c:catAx>
         <c:axId val="2094734554"/>
@@ -4121,7 +4109,6 @@
         <c:overlap val="0"/>
         <c:axId val="2094734554"/>
         <c:axId val="2094734552"/>
-        <c:axId val="2094734556"/>
       </c:barChart>
       <c:catAx>
         <c:axId val="2094734554"/>
@@ -4411,7 +4398,6 @@
         <c:overlap val="0"/>
         <c:axId val="2094734554"/>
         <c:axId val="2094734552"/>
-        <c:axId val="2094734556"/>
       </c:barChart>
       <c:catAx>
         <c:axId val="2094734554"/>
@@ -4873,7 +4859,6 @@
         <c:overlap val="0"/>
         <c:axId val="2094734554"/>
         <c:axId val="2094734552"/>
-        <c:axId val="2094734556"/>
       </c:barChart>
       <c:catAx>
         <c:axId val="2094734554"/>
@@ -5236,7 +5221,6 @@
         <c:overlap val="100"/>
         <c:axId val="2094734554"/>
         <c:axId val="2094734552"/>
-        <c:axId val="2094734556"/>
       </c:barChart>
       <c:catAx>
         <c:axId val="2094734554"/>
@@ -5499,7 +5483,6 @@
         <c:overlap val="0"/>
         <c:axId val="2094734554"/>
         <c:axId val="2094734552"/>
-        <c:axId val="2094734556"/>
       </c:barChart>
       <c:catAx>
         <c:axId val="2094734554"/>
@@ -5669,30 +5652,6 @@
             <a:effectLst/>
           </c:spPr>
           <c:invertIfNegative val="0"/>
-          <c:dLbls>
-            <c:numFmt formatCode="#,##0" sourceLinked="0"/>
-            <c:txPr>
-              <a:bodyPr/>
-              <a:lstStyle/>
-              <a:p>
-                <a:pPr>
-                  <a:defRPr b="0" i="0" strike="noStrike" sz="900" u="none">
-                    <a:solidFill>
-                      <a:srgbClr val="262626"/>
-                    </a:solidFill>
-                    <a:latin typeface="Garamond"/>
-                  </a:defRPr>
-                </a:pPr>
-              </a:p>
-            </c:txPr>
-            <c:showLegendKey val="0"/>
-            <c:showVal val="1"/>
-            <c:showCatName val="0"/>
-            <c:showSerName val="0"/>
-            <c:showPercent val="0"/>
-            <c:showBubbleSize val="0"/>
-            <c:showLeaderLines val="0"/>
-          </c:dLbls>
           <c:dPt>
             <c:idx val="0"/>
             <c:invertIfNegative val="0"/>
@@ -5759,6 +5718,30 @@
               <a:effectLst/>
             </c:spPr>
           </c:dPt>
+          <c:dLbls>
+            <c:numFmt formatCode="#,##0" sourceLinked="0"/>
+            <c:txPr>
+              <a:bodyPr/>
+              <a:lstStyle/>
+              <a:p>
+                <a:pPr>
+                  <a:defRPr b="0" i="0" strike="noStrike" sz="900" u="none">
+                    <a:solidFill>
+                      <a:srgbClr val="262626"/>
+                    </a:solidFill>
+                    <a:latin typeface="Garamond"/>
+                  </a:defRPr>
+                </a:pPr>
+              </a:p>
+            </c:txPr>
+            <c:showLegendKey val="0"/>
+            <c:showVal val="1"/>
+            <c:showCatName val="0"/>
+            <c:showSerName val="0"/>
+            <c:showPercent val="0"/>
+            <c:showBubbleSize val="0"/>
+            <c:showLeaderLines val="0"/>
+          </c:dLbls>
           <c:cat>
             <c:multiLvlStrRef>
               <c:f>Sheet1!$A$2:$A$7</c:f>
@@ -5843,7 +5826,6 @@
         <c:overlap val="0"/>
         <c:axId val="2094734554"/>
         <c:axId val="2094734552"/>
-        <c:axId val="2094734556"/>
       </c:barChart>
       <c:catAx>
         <c:axId val="2094734554"/>
@@ -5989,6 +5971,7 @@
     <c:plotArea>
       <c:layout/>
       <c:lineChart>
+        <c:grouping val="standard"/>
         <c:varyColors val="0"/>
         <c:ser>
           <c:idx val="0"/>
@@ -6017,7 +6000,23 @@
             </a:ln>
             <a:effectLst/>
           </c:spPr>
-          <c:invertIfNegative val="0"/>
+          <c:marker>
+            <c:symbol val="circle"/>
+            <c:size val="6"/>
+            <c:spPr>
+              <a:solidFill>
+                <a:srgbClr val="E8702A"/>
+              </a:solidFill>
+              <a:ln w="9525" cap="flat">
+                <a:solidFill>
+                  <a:srgbClr val="E8702A"/>
+                </a:solidFill>
+                <a:prstDash val="solid"/>
+                <a:round/>
+              </a:ln>
+              <a:effectLst/>
+            </c:spPr>
+          </c:marker>
           <c:dLbls>
             <c:numFmt formatCode="0.0%" sourceLinked="0"/>
             <c:txPr>
@@ -6043,23 +6042,6 @@
             <c:showBubbleSize val="0"/>
             <c:showLeaderLines val="0"/>
           </c:dLbls>
-          <c:marker>
-            <c:symbol val="circle"/>
-            <c:size val="6"/>
-            <c:spPr>
-              <a:solidFill>
-                <a:srgbClr val="E8702A"/>
-              </a:solidFill>
-              <a:ln w="9525" cap="flat">
-                <a:solidFill>
-                  <a:srgbClr val="E8702A"/>
-                </a:solidFill>
-                <a:prstDash val="solid"/>
-                <a:round/>
-              </a:ln>
-              <a:effectLst/>
-            </c:spPr>
-          </c:marker>
           <c:cat>
             <c:multiLvlStrRef>
               <c:f>Sheet1!$A$2:$A$7</c:f>
@@ -6145,7 +6127,6 @@
         <c:marker val="1"/>
         <c:axId val="2094734554"/>
         <c:axId val="2094734552"/>
-        <c:axId val="2094734556"/>
       </c:lineChart>
       <c:catAx>
         <c:axId val="2094734554"/>
@@ -6476,7 +6457,6 @@
         <c:overlap val="100"/>
         <c:axId val="2094734554"/>
         <c:axId val="2094734552"/>
-        <c:axId val="2094734556"/>
       </c:barChart>
       <c:catAx>
         <c:axId val="2094734554"/>
@@ -6824,7 +6804,6 @@
         <c:overlap val="0"/>
         <c:axId val="2094734554"/>
         <c:axId val="2094734552"/>
-        <c:axId val="2094734556"/>
       </c:barChart>
       <c:catAx>
         <c:axId val="2094734554"/>
@@ -7011,30 +6990,6 @@
             <a:effectLst/>
           </c:spPr>
           <c:invertIfNegative val="0"/>
-          <c:dLbls>
-            <c:numFmt formatCode="0%" sourceLinked="0"/>
-            <c:txPr>
-              <a:bodyPr/>
-              <a:lstStyle/>
-              <a:p>
-                <a:pPr>
-                  <a:defRPr b="0" i="0" strike="noStrike" sz="900" u="none">
-                    <a:solidFill>
-                      <a:srgbClr val="262626"/>
-                    </a:solidFill>
-                    <a:latin typeface="Garamond"/>
-                  </a:defRPr>
-                </a:pPr>
-              </a:p>
-            </c:txPr>
-            <c:showLegendKey val="0"/>
-            <c:showVal val="1"/>
-            <c:showCatName val="0"/>
-            <c:showSerName val="0"/>
-            <c:showPercent val="0"/>
-            <c:showBubbleSize val="0"/>
-            <c:showLeaderLines val="0"/>
-          </c:dLbls>
           <c:dPt>
             <c:idx val="0"/>
             <c:invertIfNegative val="0"/>
@@ -7068,6 +7023,30 @@
               <a:effectLst/>
             </c:spPr>
           </c:dPt>
+          <c:dLbls>
+            <c:numFmt formatCode="0%" sourceLinked="0"/>
+            <c:txPr>
+              <a:bodyPr/>
+              <a:lstStyle/>
+              <a:p>
+                <a:pPr>
+                  <a:defRPr b="0" i="0" strike="noStrike" sz="900" u="none">
+                    <a:solidFill>
+                      <a:srgbClr val="262626"/>
+                    </a:solidFill>
+                    <a:latin typeface="Garamond"/>
+                  </a:defRPr>
+                </a:pPr>
+              </a:p>
+            </c:txPr>
+            <c:showLegendKey val="0"/>
+            <c:showVal val="1"/>
+            <c:showCatName val="0"/>
+            <c:showSerName val="0"/>
+            <c:showPercent val="0"/>
+            <c:showBubbleSize val="0"/>
+            <c:showLeaderLines val="0"/>
+          </c:dLbls>
           <c:cat>
             <c:multiLvlStrRef>
               <c:f>Sheet1!$A$2:$A$4</c:f>
@@ -7137,7 +7116,6 @@
         <c:overlap val="0"/>
         <c:axId val="2094734554"/>
         <c:axId val="2094734552"/>
-        <c:axId val="2094734556"/>
       </c:barChart>
       <c:catAx>
         <c:axId val="2094734554"/>
@@ -7504,7 +7482,6 @@
         <c:overlap val="0"/>
         <c:axId val="2094734554"/>
         <c:axId val="2094734552"/>
-        <c:axId val="2094734556"/>
       </c:barChart>
       <c:catAx>
         <c:axId val="2094734554"/>
@@ -43151,7 +43128,7 @@
         </p:nvSpPr>
         <p:spPr>
           <a:xfrm>
-            <a:off x="4233672" y="3218688"/>
+            <a:off x="4142232" y="3218688"/>
             <a:ext cx="2194560" cy="182880"/>
           </a:xfrm>
           <a:prstGeom prst="rect">

</xml_diff>

<commit_message>
Rebuild Thesis II slide 1 with native table and column charts
Replace the shape-drawn positioning map with a flip-tracker table
(counts plus pulling back / holding / adding columns) and the jet-fuel
line chart with a column chart.

Co-Authored-By: Claude Opus 5.5 <noreply@anthropic.com>
Claude-Session: https://claude.ai/code/session_01UfcjrwVkNc9oEPnjB82u2w
</commit_message>
<xml_diff>
--- a/ftai_pitch/FTAI_Long_Pitch.pptx
+++ b/ftai_pitch/FTAI_Long_Pitch.pptx
@@ -1288,8 +1288,9 @@
     <c:autoTitleDeleted val="0"/>
     <c:plotArea>
       <c:layout/>
-      <c:lineChart>
-        <c:grouping val="standard"/>
+      <c:barChart>
+        <c:barDir val="col"/>
+        <c:grouping val="clustered"/>
         <c:varyColors val="0"/>
         <c:ser>
           <c:idx val="0"/>
@@ -1309,32 +1310,9 @@
             <a:solidFill>
               <a:srgbClr val="E8702A"/>
             </a:solidFill>
-            <a:ln w="28575" cap="flat">
-              <a:solidFill>
-                <a:srgbClr val="E8702A"/>
-              </a:solidFill>
-              <a:prstDash val="solid"/>
-              <a:round/>
-            </a:ln>
             <a:effectLst/>
           </c:spPr>
-          <c:marker>
-            <c:symbol val="circle"/>
-            <c:size val="6"/>
-            <c:spPr>
-              <a:solidFill>
-                <a:srgbClr val="E8702A"/>
-              </a:solidFill>
-              <a:ln w="9525" cap="flat">
-                <a:solidFill>
-                  <a:srgbClr val="E8702A"/>
-                </a:solidFill>
-                <a:prstDash val="solid"/>
-                <a:round/>
-              </a:ln>
-              <a:effectLst/>
-            </c:spPr>
-          </c:marker>
+          <c:invertIfNegative val="0"/>
           <c:dLbls>
             <c:numFmt formatCode="$0" sourceLinked="0"/>
             <c:txPr>
@@ -1351,7 +1329,6 @@
                 </a:pPr>
               </a:p>
             </c:txPr>
-            <c:dLblPos val="t"/>
             <c:showLegendKey val="0"/>
             <c:showVal val="1"/>
             <c:showCatName val="0"/>
@@ -1409,7 +1386,6 @@
               </c:numCache>
             </c:numRef>
           </c:val>
-          <c:smooth val="0"/>
         </c:ser>
         <c:dLbls>
           <c:numFmt formatCode="$0" sourceLinked="0"/>
@@ -1427,7 +1403,6 @@
               </a:pPr>
             </a:p>
           </c:txPr>
-          <c:dLblPos val="t"/>
           <c:showLegendKey val="0"/>
           <c:showVal val="1"/>
           <c:showCatName val="0"/>
@@ -1436,10 +1411,11 @@
           <c:showBubbleSize val="0"/>
           <c:showLeaderLines val="0"/>
         </c:dLbls>
-        <c:marker val="1"/>
+        <c:gapWidth val="40"/>
+        <c:overlap val="0"/>
         <c:axId val="2094734554"/>
         <c:axId val="2094734552"/>
-      </c:lineChart>
+      </c:barChart>
       <c:catAx>
         <c:axId val="2094734554"/>
         <c:scaling>
@@ -1486,7 +1462,7 @@
         <c:scaling>
           <c:orientation val="minMax"/>
           <c:max val="240"/>
-          <c:min val="40"/>
+          <c:min val="0"/>
         </c:scaling>
         <c:delete val="1"/>
         <c:axPos val="l"/>
@@ -1572,7 +1548,7 @@
                 </a:solidFill>
                 <a:latin typeface="Garamond"/>
               </a:rPr>
-              <a:t>GE's 2026 CFM56 Retirement View (Q1 actual &lt;1%)</a:t>
+              <a:t>GE CFM56 Retirement View, 2026</a:t>
             </a:r>
           </a:p>
         </c:rich>
@@ -41735,1453 +41711,6 @@
           </a:ln>
         </p:spPr>
       </p:sp>
-      <p:sp>
-        <p:nvSpPr>
-          <p:cNvPr id="5" name="Shape 3"/>
-          <p:cNvSpPr/>
-          <p:nvPr/>
-        </p:nvSpPr>
-        <p:spPr>
-          <a:xfrm>
-            <a:off x="621792" y="1170432"/>
-            <a:ext cx="5806440" cy="2011680"/>
-          </a:xfrm>
-          <a:prstGeom prst="rect">
-            <a:avLst/>
-          </a:prstGeom>
-          <a:ln w="9525">
-            <a:solidFill>
-              <a:srgbClr val="BFBFBF"/>
-            </a:solidFill>
-            <a:prstDash val="solid"/>
-          </a:ln>
-        </p:spPr>
-      </p:sp>
-      <p:sp>
-        <p:nvSpPr>
-          <p:cNvPr id="6" name="Shape 4"/>
-          <p:cNvSpPr/>
-          <p:nvPr/>
-        </p:nvSpPr>
-        <p:spPr>
-          <a:xfrm>
-            <a:off x="2557272" y="1170432"/>
-            <a:ext cx="0" cy="2011680"/>
-          </a:xfrm>
-          <a:prstGeom prst="line">
-            <a:avLst/>
-          </a:prstGeom>
-          <a:noFill/>
-          <a:ln w="9525">
-            <a:solidFill>
-              <a:srgbClr val="BFBFBF"/>
-            </a:solidFill>
-            <a:prstDash val="dash"/>
-          </a:ln>
-        </p:spPr>
-      </p:sp>
-      <p:sp>
-        <p:nvSpPr>
-          <p:cNvPr id="7" name="Shape 5"/>
-          <p:cNvSpPr/>
-          <p:nvPr/>
-        </p:nvSpPr>
-        <p:spPr>
-          <a:xfrm>
-            <a:off x="4492752" y="1170432"/>
-            <a:ext cx="0" cy="2011680"/>
-          </a:xfrm>
-          <a:prstGeom prst="line">
-            <a:avLst/>
-          </a:prstGeom>
-          <a:noFill/>
-          <a:ln w="9525">
-            <a:solidFill>
-              <a:srgbClr val="BFBFBF"/>
-            </a:solidFill>
-            <a:prstDash val="dash"/>
-          </a:ln>
-        </p:spPr>
-      </p:sp>
-      <p:sp>
-        <p:nvSpPr>
-          <p:cNvPr id="8" name="Text 6"/>
-          <p:cNvSpPr txBox="1"/>
-          <p:nvPr/>
-        </p:nvSpPr>
-        <p:spPr>
-          <a:xfrm>
-            <a:off x="621792" y="2962656"/>
-            <a:ext cx="1935480" cy="201168"/>
-          </a:xfrm>
-          <a:prstGeom prst="rect">
-            <a:avLst/>
-          </a:prstGeom>
-          <a:noFill/>
-          <a:ln/>
-        </p:spPr>
-        <p:txBody>
-          <a:bodyPr wrap="square" lIns="0" tIns="0" rIns="0" bIns="0" rtlCol="0" anchor="ctr"/>
-          <a:lstStyle/>
-          <a:p>
-            <a:pPr algn="ctr" indent="0" marL="0">
-              <a:buNone/>
-            </a:pPr>
-            <a:r>
-              <a:rPr lang="en-US" sz="950" b="1" dirty="0">
-                <a:solidFill>
-                  <a:srgbClr val="595959"/>
-                </a:solidFill>
-                <a:latin typeface="Garamond" pitchFamily="34" charset="0"/>
-                <a:ea typeface="Garamond" pitchFamily="34" charset="-122"/>
-                <a:cs typeface="Garamond" pitchFamily="34" charset="-120"/>
-              </a:rPr>
-              <a:t>Pulling back on CFM56</a:t>
-            </a:r>
-            <a:endParaRPr lang="en-US" sz="950" dirty="0"/>
-          </a:p>
-        </p:txBody>
-      </p:sp>
-      <p:sp>
-        <p:nvSpPr>
-          <p:cNvPr id="9" name="Text 7"/>
-          <p:cNvSpPr txBox="1"/>
-          <p:nvPr/>
-        </p:nvSpPr>
-        <p:spPr>
-          <a:xfrm>
-            <a:off x="2557272" y="2962656"/>
-            <a:ext cx="1935480" cy="201168"/>
-          </a:xfrm>
-          <a:prstGeom prst="rect">
-            <a:avLst/>
-          </a:prstGeom>
-          <a:noFill/>
-          <a:ln/>
-        </p:spPr>
-        <p:txBody>
-          <a:bodyPr wrap="square" lIns="0" tIns="0" rIns="0" bIns="0" rtlCol="0" anchor="ctr"/>
-          <a:lstStyle/>
-          <a:p>
-            <a:pPr algn="ctr" indent="0" marL="0">
-              <a:buNone/>
-            </a:pPr>
-            <a:r>
-              <a:rPr lang="en-US" sz="950" b="1" dirty="0">
-                <a:solidFill>
-                  <a:srgbClr val="595959"/>
-                </a:solidFill>
-                <a:latin typeface="Garamond" pitchFamily="34" charset="0"/>
-                <a:ea typeface="Garamond" pitchFamily="34" charset="-122"/>
-                <a:cs typeface="Garamond" pitchFamily="34" charset="-120"/>
-              </a:rPr>
-              <a:t>Holding CFM56</a:t>
-            </a:r>
-            <a:endParaRPr lang="en-US" sz="950" dirty="0"/>
-          </a:p>
-        </p:txBody>
-      </p:sp>
-      <p:sp>
-        <p:nvSpPr>
-          <p:cNvPr id="10" name="Text 8"/>
-          <p:cNvSpPr txBox="1"/>
-          <p:nvPr/>
-        </p:nvSpPr>
-        <p:spPr>
-          <a:xfrm>
-            <a:off x="4492752" y="2962656"/>
-            <a:ext cx="1935480" cy="201168"/>
-          </a:xfrm>
-          <a:prstGeom prst="rect">
-            <a:avLst/>
-          </a:prstGeom>
-          <a:noFill/>
-          <a:ln/>
-        </p:spPr>
-        <p:txBody>
-          <a:bodyPr wrap="square" lIns="0" tIns="0" rIns="0" bIns="0" rtlCol="0" anchor="ctr"/>
-          <a:lstStyle/>
-          <a:p>
-            <a:pPr algn="ctr" indent="0" marL="0">
-              <a:buNone/>
-            </a:pPr>
-            <a:r>
-              <a:rPr lang="en-US" sz="950" b="1" dirty="0">
-                <a:solidFill>
-                  <a:srgbClr val="595959"/>
-                </a:solidFill>
-                <a:latin typeface="Garamond" pitchFamily="34" charset="0"/>
-                <a:ea typeface="Garamond" pitchFamily="34" charset="-122"/>
-                <a:cs typeface="Garamond" pitchFamily="34" charset="-120"/>
-              </a:rPr>
-              <a:t>Adding CFM56</a:t>
-            </a:r>
-            <a:endParaRPr lang="en-US" sz="950" dirty="0"/>
-          </a:p>
-        </p:txBody>
-      </p:sp>
-      <p:sp>
-        <p:nvSpPr>
-          <p:cNvPr id="11" name="Text 9"/>
-          <p:cNvSpPr txBox="1"/>
-          <p:nvPr/>
-        </p:nvSpPr>
-        <p:spPr>
-          <a:xfrm>
-            <a:off x="667512" y="1188720"/>
-            <a:ext cx="914400" cy="164592"/>
-          </a:xfrm>
-          <a:prstGeom prst="rect">
-            <a:avLst/>
-          </a:prstGeom>
-          <a:noFill/>
-          <a:ln/>
-        </p:spPr>
-        <p:txBody>
-          <a:bodyPr wrap="square" lIns="0" tIns="0" rIns="0" bIns="0" rtlCol="0" anchor="ctr"/>
-          <a:lstStyle/>
-          <a:p>
-            <a:pPr indent="0" marL="0">
-              <a:buNone/>
-            </a:pPr>
-            <a:r>
-              <a:rPr lang="en-US" sz="850" i="1" dirty="0">
-                <a:solidFill>
-                  <a:srgbClr val="7F7F7F"/>
-                </a:solidFill>
-                <a:latin typeface="Garamond" pitchFamily="34" charset="0"/>
-                <a:ea typeface="Garamond" pitchFamily="34" charset="-122"/>
-                <a:cs typeface="Garamond" pitchFamily="34" charset="-120"/>
-              </a:rPr>
-              <a:t>More LEAP</a:t>
-            </a:r>
-            <a:endParaRPr lang="en-US" sz="850" dirty="0"/>
-          </a:p>
-        </p:txBody>
-      </p:sp>
-      <p:sp>
-        <p:nvSpPr>
-          <p:cNvPr id="12" name="Text 10"/>
-          <p:cNvSpPr txBox="1"/>
-          <p:nvPr/>
-        </p:nvSpPr>
-        <p:spPr>
-          <a:xfrm>
-            <a:off x="667512" y="2779776"/>
-            <a:ext cx="914400" cy="164592"/>
-          </a:xfrm>
-          <a:prstGeom prst="rect">
-            <a:avLst/>
-          </a:prstGeom>
-          <a:noFill/>
-          <a:ln/>
-        </p:spPr>
-        <p:txBody>
-          <a:bodyPr wrap="square" lIns="0" tIns="0" rIns="0" bIns="0" rtlCol="0" anchor="ctr"/>
-          <a:lstStyle/>
-          <a:p>
-            <a:pPr indent="0" marL="0">
-              <a:buNone/>
-            </a:pPr>
-            <a:r>
-              <a:rPr lang="en-US" sz="850" i="1" dirty="0">
-                <a:solidFill>
-                  <a:srgbClr val="7F7F7F"/>
-                </a:solidFill>
-                <a:latin typeface="Garamond" pitchFamily="34" charset="0"/>
-                <a:ea typeface="Garamond" pitchFamily="34" charset="-122"/>
-                <a:cs typeface="Garamond" pitchFamily="34" charset="-120"/>
-              </a:rPr>
-              <a:t>Less LEAP</a:t>
-            </a:r>
-            <a:endParaRPr lang="en-US" sz="850" dirty="0"/>
-          </a:p>
-        </p:txBody>
-      </p:sp>
-      <p:sp>
-        <p:nvSpPr>
-          <p:cNvPr id="13" name="Shape 11"/>
-          <p:cNvSpPr/>
-          <p:nvPr/>
-        </p:nvSpPr>
-        <p:spPr>
-          <a:xfrm>
-            <a:off x="1260866" y="1389459"/>
-            <a:ext cx="146304" cy="146304"/>
-          </a:xfrm>
-          <a:prstGeom prst="roundRect">
-            <a:avLst>
-              <a:gd name="adj" fmla="val 18750"/>
-            </a:avLst>
-          </a:prstGeom>
-          <a:solidFill>
-            <a:srgbClr val="FBE5D6"/>
-          </a:solidFill>
-          <a:ln w="12700">
-            <a:solidFill>
-              <a:srgbClr val="A0522D"/>
-            </a:solidFill>
-            <a:prstDash val="solid"/>
-          </a:ln>
-        </p:spPr>
-      </p:sp>
-      <p:sp>
-        <p:nvSpPr>
-          <p:cNvPr id="14" name="Text 12"/>
-          <p:cNvSpPr txBox="1"/>
-          <p:nvPr/>
-        </p:nvSpPr>
-        <p:spPr>
-          <a:xfrm>
-            <a:off x="1443746" y="1362027"/>
-            <a:ext cx="1463040" cy="201168"/>
-          </a:xfrm>
-          <a:prstGeom prst="rect">
-            <a:avLst/>
-          </a:prstGeom>
-          <a:noFill/>
-          <a:ln/>
-        </p:spPr>
-        <p:txBody>
-          <a:bodyPr wrap="square" lIns="0" tIns="0" rIns="0" bIns="0" rtlCol="0" anchor="ctr"/>
-          <a:lstStyle/>
-          <a:p>
-            <a:pPr indent="0" marL="0">
-              <a:buNone/>
-            </a:pPr>
-            <a:r>
-              <a:rPr lang="en-US" sz="950" dirty="0">
-                <a:solidFill>
-                  <a:srgbClr val="1A1A1A"/>
-                </a:solidFill>
-                <a:latin typeface="Garamond" pitchFamily="34" charset="0"/>
-                <a:ea typeface="Garamond" pitchFamily="34" charset="-122"/>
-                <a:cs typeface="Garamond" pitchFamily="34" charset="-120"/>
-              </a:rPr>
-              <a:t>GE / CFM</a:t>
-            </a:r>
-            <a:endParaRPr lang="en-US" sz="950" dirty="0"/>
-          </a:p>
-        </p:txBody>
-      </p:sp>
-      <p:sp>
-        <p:nvSpPr>
-          <p:cNvPr id="15" name="Shape 13"/>
-          <p:cNvSpPr/>
-          <p:nvPr/>
-        </p:nvSpPr>
-        <p:spPr>
-          <a:xfrm>
-            <a:off x="1753865" y="1559481"/>
-            <a:ext cx="146304" cy="146304"/>
-          </a:xfrm>
-          <a:prstGeom prst="roundRect">
-            <a:avLst>
-              <a:gd name="adj" fmla="val 18750"/>
-            </a:avLst>
-          </a:prstGeom>
-          <a:solidFill>
-            <a:srgbClr val="FBE5D6"/>
-          </a:solidFill>
-          <a:ln w="12700">
-            <a:solidFill>
-              <a:srgbClr val="A0522D"/>
-            </a:solidFill>
-            <a:prstDash val="solid"/>
-          </a:ln>
-        </p:spPr>
-      </p:sp>
-      <p:sp>
-        <p:nvSpPr>
-          <p:cNvPr id="16" name="Text 14"/>
-          <p:cNvSpPr txBox="1"/>
-          <p:nvPr/>
-        </p:nvSpPr>
-        <p:spPr>
-          <a:xfrm>
-            <a:off x="1936745" y="1532049"/>
-            <a:ext cx="1463040" cy="201168"/>
-          </a:xfrm>
-          <a:prstGeom prst="rect">
-            <a:avLst/>
-          </a:prstGeom>
-          <a:noFill/>
-          <a:ln/>
-        </p:spPr>
-        <p:txBody>
-          <a:bodyPr wrap="square" lIns="0" tIns="0" rIns="0" bIns="0" rtlCol="0" anchor="ctr"/>
-          <a:lstStyle/>
-          <a:p>
-            <a:pPr indent="0" marL="0">
-              <a:buNone/>
-            </a:pPr>
-            <a:r>
-              <a:rPr lang="en-US" sz="950" dirty="0">
-                <a:solidFill>
-                  <a:srgbClr val="1A1A1A"/>
-                </a:solidFill>
-                <a:latin typeface="Garamond" pitchFamily="34" charset="0"/>
-                <a:ea typeface="Garamond" pitchFamily="34" charset="-122"/>
-                <a:cs typeface="Garamond" pitchFamily="34" charset="-120"/>
-              </a:rPr>
-              <a:t>Safran</a:t>
-            </a:r>
-            <a:endParaRPr lang="en-US" sz="950" dirty="0"/>
-          </a:p>
-        </p:txBody>
-      </p:sp>
-      <p:sp>
-        <p:nvSpPr>
-          <p:cNvPr id="17" name="Shape 15"/>
-          <p:cNvSpPr/>
-          <p:nvPr/>
-        </p:nvSpPr>
-        <p:spPr>
-          <a:xfrm>
-            <a:off x="1589532" y="1838801"/>
-            <a:ext cx="146304" cy="146304"/>
-          </a:xfrm>
-          <a:prstGeom prst="ellipse">
-            <a:avLst>
-              <a:gd name="adj" fmla="val 18750"/>
-            </a:avLst>
-          </a:prstGeom>
-          <a:solidFill>
-            <a:srgbClr val="E6E4FA"/>
-          </a:solidFill>
-          <a:ln w="12700">
-            <a:solidFill>
-              <a:srgbClr val="5B4FC4"/>
-            </a:solidFill>
-            <a:prstDash val="solid"/>
-          </a:ln>
-        </p:spPr>
-      </p:sp>
-      <p:sp>
-        <p:nvSpPr>
-          <p:cNvPr id="18" name="Text 16"/>
-          <p:cNvSpPr txBox="1"/>
-          <p:nvPr/>
-        </p:nvSpPr>
-        <p:spPr>
-          <a:xfrm>
-            <a:off x="1772412" y="1811369"/>
-            <a:ext cx="1463040" cy="201168"/>
-          </a:xfrm>
-          <a:prstGeom prst="rect">
-            <a:avLst/>
-          </a:prstGeom>
-          <a:noFill/>
-          <a:ln/>
-        </p:spPr>
-        <p:txBody>
-          <a:bodyPr wrap="square" lIns="0" tIns="0" rIns="0" bIns="0" rtlCol="0" anchor="ctr"/>
-          <a:lstStyle/>
-          <a:p>
-            <a:pPr indent="0" marL="0">
-              <a:buNone/>
-            </a:pPr>
-            <a:r>
-              <a:rPr lang="en-US" sz="950" dirty="0">
-                <a:solidFill>
-                  <a:srgbClr val="1A1A1A"/>
-                </a:solidFill>
-                <a:latin typeface="Garamond" pitchFamily="34" charset="0"/>
-                <a:ea typeface="Garamond" pitchFamily="34" charset="-122"/>
-                <a:cs typeface="Garamond" pitchFamily="34" charset="-120"/>
-              </a:rPr>
-              <a:t>Lufthansa</a:t>
-            </a:r>
-            <a:endParaRPr lang="en-US" sz="950" dirty="0"/>
-          </a:p>
-        </p:txBody>
-      </p:sp>
-      <p:sp>
-        <p:nvSpPr>
-          <p:cNvPr id="19" name="Shape 17"/>
-          <p:cNvSpPr/>
-          <p:nvPr/>
-        </p:nvSpPr>
-        <p:spPr>
-          <a:xfrm>
-            <a:off x="3725864" y="1474470"/>
-            <a:ext cx="146304" cy="146304"/>
-          </a:xfrm>
-          <a:prstGeom prst="ellipse">
-            <a:avLst>
-              <a:gd name="adj" fmla="val 18750"/>
-            </a:avLst>
-          </a:prstGeom>
-          <a:solidFill>
-            <a:srgbClr val="E6E4FA"/>
-          </a:solidFill>
-          <a:ln w="12700">
-            <a:solidFill>
-              <a:srgbClr val="5B4FC4"/>
-            </a:solidFill>
-            <a:prstDash val="solid"/>
-          </a:ln>
-        </p:spPr>
-      </p:sp>
-      <p:sp>
-        <p:nvSpPr>
-          <p:cNvPr id="20" name="Text 18"/>
-          <p:cNvSpPr txBox="1"/>
-          <p:nvPr/>
-        </p:nvSpPr>
-        <p:spPr>
-          <a:xfrm>
-            <a:off x="3908744" y="1447038"/>
-            <a:ext cx="1463040" cy="201168"/>
-          </a:xfrm>
-          <a:prstGeom prst="rect">
-            <a:avLst/>
-          </a:prstGeom>
-          <a:noFill/>
-          <a:ln/>
-        </p:spPr>
-        <p:txBody>
-          <a:bodyPr wrap="square" lIns="0" tIns="0" rIns="0" bIns="0" rtlCol="0" anchor="ctr"/>
-          <a:lstStyle/>
-          <a:p>
-            <a:pPr indent="0" marL="0">
-              <a:buNone/>
-            </a:pPr>
-            <a:r>
-              <a:rPr lang="en-US" sz="950" dirty="0">
-                <a:solidFill>
-                  <a:srgbClr val="1A1A1A"/>
-                </a:solidFill>
-                <a:latin typeface="Garamond" pitchFamily="34" charset="0"/>
-                <a:ea typeface="Garamond" pitchFamily="34" charset="-122"/>
-                <a:cs typeface="Garamond" pitchFamily="34" charset="-120"/>
-              </a:rPr>
-              <a:t>AFI KLM</a:t>
-            </a:r>
-            <a:endParaRPr lang="en-US" sz="950" dirty="0"/>
-          </a:p>
-        </p:txBody>
-      </p:sp>
-      <p:sp>
-        <p:nvSpPr>
-          <p:cNvPr id="21" name="Shape 19"/>
-          <p:cNvSpPr/>
-          <p:nvPr/>
-        </p:nvSpPr>
-        <p:spPr>
-          <a:xfrm>
-            <a:off x="3196346" y="1717357"/>
-            <a:ext cx="146304" cy="146304"/>
-          </a:xfrm>
-          <a:prstGeom prst="ellipse">
-            <a:avLst>
-              <a:gd name="adj" fmla="val 18750"/>
-            </a:avLst>
-          </a:prstGeom>
-          <a:solidFill>
-            <a:srgbClr val="E6E4FA"/>
-          </a:solidFill>
-          <a:ln w="12700">
-            <a:solidFill>
-              <a:srgbClr val="5B4FC4"/>
-            </a:solidFill>
-            <a:prstDash val="solid"/>
-          </a:ln>
-        </p:spPr>
-      </p:sp>
-      <p:sp>
-        <p:nvSpPr>
-          <p:cNvPr id="22" name="Text 20"/>
-          <p:cNvSpPr txBox="1"/>
-          <p:nvPr/>
-        </p:nvSpPr>
-        <p:spPr>
-          <a:xfrm>
-            <a:off x="3379226" y="1689925"/>
-            <a:ext cx="1463040" cy="201168"/>
-          </a:xfrm>
-          <a:prstGeom prst="rect">
-            <a:avLst/>
-          </a:prstGeom>
-          <a:noFill/>
-          <a:ln/>
-        </p:spPr>
-        <p:txBody>
-          <a:bodyPr wrap="square" lIns="0" tIns="0" rIns="0" bIns="0" rtlCol="0" anchor="ctr"/>
-          <a:lstStyle/>
-          <a:p>
-            <a:pPr indent="0" marL="0">
-              <a:buNone/>
-            </a:pPr>
-            <a:r>
-              <a:rPr lang="en-US" sz="950" dirty="0">
-                <a:solidFill>
-                  <a:srgbClr val="1A1A1A"/>
-                </a:solidFill>
-                <a:latin typeface="Garamond" pitchFamily="34" charset="0"/>
-                <a:ea typeface="Garamond" pitchFamily="34" charset="-122"/>
-                <a:cs typeface="Garamond" pitchFamily="34" charset="-120"/>
-              </a:rPr>
-              <a:t>Delta</a:t>
-            </a:r>
-            <a:endParaRPr lang="en-US" sz="950" dirty="0"/>
-          </a:p>
-        </p:txBody>
-      </p:sp>
-      <p:sp>
-        <p:nvSpPr>
-          <p:cNvPr id="23" name="Shape 21"/>
-          <p:cNvSpPr/>
-          <p:nvPr/>
-        </p:nvSpPr>
-        <p:spPr>
-          <a:xfrm>
-            <a:off x="3196346" y="2105978"/>
-            <a:ext cx="146304" cy="146304"/>
-          </a:xfrm>
-          <a:prstGeom prst="ellipse">
-            <a:avLst>
-              <a:gd name="adj" fmla="val 18750"/>
-            </a:avLst>
-          </a:prstGeom>
-          <a:solidFill>
-            <a:srgbClr val="E6E4FA"/>
-          </a:solidFill>
-          <a:ln w="12700">
-            <a:solidFill>
-              <a:srgbClr val="5B4FC4"/>
-            </a:solidFill>
-            <a:prstDash val="solid"/>
-          </a:ln>
-        </p:spPr>
-      </p:sp>
-      <p:sp>
-        <p:nvSpPr>
-          <p:cNvPr id="24" name="Text 22"/>
-          <p:cNvSpPr txBox="1"/>
-          <p:nvPr/>
-        </p:nvSpPr>
-        <p:spPr>
-          <a:xfrm>
-            <a:off x="3379226" y="2078546"/>
-            <a:ext cx="1463040" cy="201168"/>
-          </a:xfrm>
-          <a:prstGeom prst="rect">
-            <a:avLst/>
-          </a:prstGeom>
-          <a:noFill/>
-          <a:ln/>
-        </p:spPr>
-        <p:txBody>
-          <a:bodyPr wrap="square" lIns="0" tIns="0" rIns="0" bIns="0" rtlCol="0" anchor="ctr"/>
-          <a:lstStyle/>
-          <a:p>
-            <a:pPr indent="0" marL="0">
-              <a:buNone/>
-            </a:pPr>
-            <a:r>
-              <a:rPr lang="en-US" sz="950" dirty="0">
-                <a:solidFill>
-                  <a:srgbClr val="1A1A1A"/>
-                </a:solidFill>
-                <a:latin typeface="Garamond" pitchFamily="34" charset="0"/>
-                <a:ea typeface="Garamond" pitchFamily="34" charset="-122"/>
-                <a:cs typeface="Garamond" pitchFamily="34" charset="-120"/>
-              </a:rPr>
-              <a:t>Iberia (planned)</a:t>
-            </a:r>
-            <a:endParaRPr lang="en-US" sz="950" dirty="0"/>
-          </a:p>
-        </p:txBody>
-      </p:sp>
-      <p:sp>
-        <p:nvSpPr>
-          <p:cNvPr id="25" name="Shape 23"/>
-          <p:cNvSpPr/>
-          <p:nvPr/>
-        </p:nvSpPr>
-        <p:spPr>
-          <a:xfrm>
-            <a:off x="2977235" y="2421731"/>
-            <a:ext cx="146304" cy="146304"/>
-          </a:xfrm>
-          <a:prstGeom prst="ellipse">
-            <a:avLst>
-              <a:gd name="adj" fmla="val 18750"/>
-            </a:avLst>
-          </a:prstGeom>
-          <a:solidFill>
-            <a:srgbClr val="E6E4FA"/>
-          </a:solidFill>
-          <a:ln w="12700">
-            <a:solidFill>
-              <a:srgbClr val="5B4FC4"/>
-            </a:solidFill>
-            <a:prstDash val="solid"/>
-          </a:ln>
-        </p:spPr>
-      </p:sp>
-      <p:sp>
-        <p:nvSpPr>
-          <p:cNvPr id="26" name="Text 24"/>
-          <p:cNvSpPr txBox="1"/>
-          <p:nvPr/>
-        </p:nvSpPr>
-        <p:spPr>
-          <a:xfrm>
-            <a:off x="3160115" y="2394299"/>
-            <a:ext cx="1463040" cy="201168"/>
-          </a:xfrm>
-          <a:prstGeom prst="rect">
-            <a:avLst/>
-          </a:prstGeom>
-          <a:noFill/>
-          <a:ln/>
-        </p:spPr>
-        <p:txBody>
-          <a:bodyPr wrap="square" lIns="0" tIns="0" rIns="0" bIns="0" rtlCol="0" anchor="ctr"/>
-          <a:lstStyle/>
-          <a:p>
-            <a:pPr indent="0" marL="0">
-              <a:buNone/>
-            </a:pPr>
-            <a:r>
-              <a:rPr lang="en-US" sz="950" dirty="0">
-                <a:solidFill>
-                  <a:srgbClr val="1A1A1A"/>
-                </a:solidFill>
-                <a:latin typeface="Garamond" pitchFamily="34" charset="0"/>
-                <a:ea typeface="Garamond" pitchFamily="34" charset="-122"/>
-                <a:cs typeface="Garamond" pitchFamily="34" charset="-120"/>
-              </a:rPr>
-              <a:t>Turkish (exploring)</a:t>
-            </a:r>
-            <a:endParaRPr lang="en-US" sz="950" dirty="0"/>
-          </a:p>
-        </p:txBody>
-      </p:sp>
-      <p:sp>
-        <p:nvSpPr>
-          <p:cNvPr id="27" name="Shape 25"/>
-          <p:cNvSpPr/>
-          <p:nvPr/>
-        </p:nvSpPr>
-        <p:spPr>
-          <a:xfrm>
-            <a:off x="2977235" y="2664619"/>
-            <a:ext cx="146304" cy="146304"/>
-          </a:xfrm>
-          <a:prstGeom prst="ellipse">
-            <a:avLst>
-              <a:gd name="adj" fmla="val 18750"/>
-            </a:avLst>
-          </a:prstGeom>
-          <a:solidFill>
-            <a:srgbClr val="E6E4FA"/>
-          </a:solidFill>
-          <a:ln w="12700">
-            <a:solidFill>
-              <a:srgbClr val="5B4FC4"/>
-            </a:solidFill>
-            <a:prstDash val="solid"/>
-          </a:ln>
-        </p:spPr>
-      </p:sp>
-      <p:sp>
-        <p:nvSpPr>
-          <p:cNvPr id="28" name="Text 26"/>
-          <p:cNvSpPr txBox="1"/>
-          <p:nvPr/>
-        </p:nvSpPr>
-        <p:spPr>
-          <a:xfrm>
-            <a:off x="3160115" y="2637187"/>
-            <a:ext cx="1463040" cy="201168"/>
-          </a:xfrm>
-          <a:prstGeom prst="rect">
-            <a:avLst/>
-          </a:prstGeom>
-          <a:noFill/>
-          <a:ln/>
-        </p:spPr>
-        <p:txBody>
-          <a:bodyPr wrap="square" lIns="0" tIns="0" rIns="0" bIns="0" rtlCol="0" anchor="ctr"/>
-          <a:lstStyle/>
-          <a:p>
-            <a:pPr indent="0" marL="0">
-              <a:buNone/>
-            </a:pPr>
-            <a:r>
-              <a:rPr lang="en-US" sz="950" dirty="0">
-                <a:solidFill>
-                  <a:srgbClr val="1A1A1A"/>
-                </a:solidFill>
-                <a:latin typeface="Garamond" pitchFamily="34" charset="0"/>
-                <a:ea typeface="Garamond" pitchFamily="34" charset="-122"/>
-                <a:cs typeface="Garamond" pitchFamily="34" charset="-120"/>
-              </a:rPr>
-              <a:t>Korean Air</a:t>
-            </a:r>
-            <a:endParaRPr lang="en-US" sz="950" dirty="0"/>
-          </a:p>
-        </p:txBody>
-      </p:sp>
-      <p:sp>
-        <p:nvSpPr>
-          <p:cNvPr id="29" name="Shape 27"/>
-          <p:cNvSpPr/>
-          <p:nvPr/>
-        </p:nvSpPr>
-        <p:spPr>
-          <a:xfrm>
-            <a:off x="4748381" y="1401604"/>
-            <a:ext cx="201168" cy="146304"/>
-          </a:xfrm>
-          <a:prstGeom prst="ellipse">
-            <a:avLst>
-              <a:gd name="adj" fmla="val 18750"/>
-            </a:avLst>
-          </a:prstGeom>
-          <a:solidFill>
-            <a:srgbClr val="D5EFE6"/>
-          </a:solidFill>
-          <a:ln w="12700">
-            <a:solidFill>
-              <a:srgbClr val="2E8B57"/>
-            </a:solidFill>
-            <a:prstDash val="solid"/>
-          </a:ln>
-        </p:spPr>
-      </p:sp>
-      <p:sp>
-        <p:nvSpPr>
-          <p:cNvPr id="30" name="Text 28"/>
-          <p:cNvSpPr txBox="1"/>
-          <p:nvPr/>
-        </p:nvSpPr>
-        <p:spPr>
-          <a:xfrm>
-            <a:off x="4986125" y="1374172"/>
-            <a:ext cx="1463040" cy="201168"/>
-          </a:xfrm>
-          <a:prstGeom prst="rect">
-            <a:avLst/>
-          </a:prstGeom>
-          <a:noFill/>
-          <a:ln/>
-        </p:spPr>
-        <p:txBody>
-          <a:bodyPr wrap="square" lIns="0" tIns="0" rIns="0" bIns="0" rtlCol="0" anchor="ctr"/>
-          <a:lstStyle/>
-          <a:p>
-            <a:pPr indent="0" marL="0">
-              <a:buNone/>
-            </a:pPr>
-            <a:r>
-              <a:rPr lang="en-US" sz="950" dirty="0">
-                <a:solidFill>
-                  <a:srgbClr val="1A1A1A"/>
-                </a:solidFill>
-                <a:latin typeface="Garamond" pitchFamily="34" charset="0"/>
-                <a:ea typeface="Garamond" pitchFamily="34" charset="-122"/>
-                <a:cs typeface="Garamond" pitchFamily="34" charset="-120"/>
-              </a:rPr>
-              <a:t>MTU</a:t>
-            </a:r>
-            <a:endParaRPr lang="en-US" sz="950" dirty="0"/>
-          </a:p>
-        </p:txBody>
-      </p:sp>
-      <p:sp>
-        <p:nvSpPr>
-          <p:cNvPr id="31" name="Shape 29"/>
-          <p:cNvSpPr/>
-          <p:nvPr/>
-        </p:nvSpPr>
-        <p:spPr>
-          <a:xfrm>
-            <a:off x="5350937" y="1632347"/>
-            <a:ext cx="201168" cy="146304"/>
-          </a:xfrm>
-          <a:prstGeom prst="ellipse">
-            <a:avLst>
-              <a:gd name="adj" fmla="val 18750"/>
-            </a:avLst>
-          </a:prstGeom>
-          <a:solidFill>
-            <a:srgbClr val="D5EFE6"/>
-          </a:solidFill>
-          <a:ln w="12700">
-            <a:solidFill>
-              <a:srgbClr val="2E8B57"/>
-            </a:solidFill>
-            <a:prstDash val="solid"/>
-          </a:ln>
-        </p:spPr>
-      </p:sp>
-      <p:sp>
-        <p:nvSpPr>
-          <p:cNvPr id="32" name="Text 30"/>
-          <p:cNvSpPr txBox="1"/>
-          <p:nvPr/>
-        </p:nvSpPr>
-        <p:spPr>
-          <a:xfrm>
-            <a:off x="5588681" y="1604915"/>
-            <a:ext cx="1463040" cy="201168"/>
-          </a:xfrm>
-          <a:prstGeom prst="rect">
-            <a:avLst/>
-          </a:prstGeom>
-          <a:noFill/>
-          <a:ln/>
-        </p:spPr>
-        <p:txBody>
-          <a:bodyPr wrap="square" lIns="0" tIns="0" rIns="0" bIns="0" rtlCol="0" anchor="ctr"/>
-          <a:lstStyle/>
-          <a:p>
-            <a:pPr indent="0" marL="0">
-              <a:buNone/>
-            </a:pPr>
-            <a:r>
-              <a:rPr lang="en-US" sz="950" dirty="0">
-                <a:solidFill>
-                  <a:srgbClr val="1A1A1A"/>
-                </a:solidFill>
-                <a:latin typeface="Garamond" pitchFamily="34" charset="0"/>
-                <a:ea typeface="Garamond" pitchFamily="34" charset="-122"/>
-                <a:cs typeface="Garamond" pitchFamily="34" charset="-120"/>
-              </a:rPr>
-              <a:t>StandardAero</a:t>
-            </a:r>
-            <a:endParaRPr lang="en-US" sz="950" dirty="0"/>
-          </a:p>
-        </p:txBody>
-      </p:sp>
-      <p:sp>
-        <p:nvSpPr>
-          <p:cNvPr id="33" name="Shape 31"/>
-          <p:cNvSpPr/>
-          <p:nvPr/>
-        </p:nvSpPr>
-        <p:spPr>
-          <a:xfrm>
-            <a:off x="5022270" y="1863090"/>
-            <a:ext cx="201168" cy="146304"/>
-          </a:xfrm>
-          <a:prstGeom prst="ellipse">
-            <a:avLst>
-              <a:gd name="adj" fmla="val 18750"/>
-            </a:avLst>
-          </a:prstGeom>
-          <a:solidFill>
-            <a:srgbClr val="D5EFE6"/>
-          </a:solidFill>
-          <a:ln w="12700">
-            <a:solidFill>
-              <a:srgbClr val="2E8B57"/>
-            </a:solidFill>
-            <a:prstDash val="solid"/>
-          </a:ln>
-        </p:spPr>
-      </p:sp>
-      <p:sp>
-        <p:nvSpPr>
-          <p:cNvPr id="34" name="Text 32"/>
-          <p:cNvSpPr txBox="1"/>
-          <p:nvPr/>
-        </p:nvSpPr>
-        <p:spPr>
-          <a:xfrm>
-            <a:off x="5260014" y="1835658"/>
-            <a:ext cx="1463040" cy="201168"/>
-          </a:xfrm>
-          <a:prstGeom prst="rect">
-            <a:avLst/>
-          </a:prstGeom>
-          <a:noFill/>
-          <a:ln/>
-        </p:spPr>
-        <p:txBody>
-          <a:bodyPr wrap="square" lIns="0" tIns="0" rIns="0" bIns="0" rtlCol="0" anchor="ctr"/>
-          <a:lstStyle/>
-          <a:p>
-            <a:pPr indent="0" marL="0">
-              <a:buNone/>
-            </a:pPr>
-            <a:r>
-              <a:rPr lang="en-US" sz="950" dirty="0">
-                <a:solidFill>
-                  <a:srgbClr val="1A1A1A"/>
-                </a:solidFill>
-                <a:latin typeface="Garamond" pitchFamily="34" charset="0"/>
-                <a:ea typeface="Garamond" pitchFamily="34" charset="-122"/>
-                <a:cs typeface="Garamond" pitchFamily="34" charset="-120"/>
-              </a:rPr>
-              <a:t>ST Engineering</a:t>
-            </a:r>
-            <a:endParaRPr lang="en-US" sz="950" dirty="0"/>
-          </a:p>
-        </p:txBody>
-      </p:sp>
-      <p:sp>
-        <p:nvSpPr>
-          <p:cNvPr id="35" name="Shape 33"/>
-          <p:cNvSpPr/>
-          <p:nvPr/>
-        </p:nvSpPr>
-        <p:spPr>
-          <a:xfrm>
-            <a:off x="5241381" y="2105978"/>
-            <a:ext cx="201168" cy="146304"/>
-          </a:xfrm>
-          <a:prstGeom prst="ellipse">
-            <a:avLst>
-              <a:gd name="adj" fmla="val 18750"/>
-            </a:avLst>
-          </a:prstGeom>
-          <a:solidFill>
-            <a:srgbClr val="D5EFE6"/>
-          </a:solidFill>
-          <a:ln w="12700">
-            <a:solidFill>
-              <a:srgbClr val="2E8B57"/>
-            </a:solidFill>
-            <a:prstDash val="solid"/>
-          </a:ln>
-        </p:spPr>
-      </p:sp>
-      <p:sp>
-        <p:nvSpPr>
-          <p:cNvPr id="36" name="Text 34"/>
-          <p:cNvSpPr txBox="1"/>
-          <p:nvPr/>
-        </p:nvSpPr>
-        <p:spPr>
-          <a:xfrm>
-            <a:off x="5479125" y="2078546"/>
-            <a:ext cx="1463040" cy="201168"/>
-          </a:xfrm>
-          <a:prstGeom prst="rect">
-            <a:avLst/>
-          </a:prstGeom>
-          <a:noFill/>
-          <a:ln/>
-        </p:spPr>
-        <p:txBody>
-          <a:bodyPr wrap="square" lIns="0" tIns="0" rIns="0" bIns="0" rtlCol="0" anchor="ctr"/>
-          <a:lstStyle/>
-          <a:p>
-            <a:pPr indent="0" marL="0">
-              <a:buNone/>
-            </a:pPr>
-            <a:r>
-              <a:rPr lang="en-US" sz="950" dirty="0">
-                <a:solidFill>
-                  <a:srgbClr val="1A1A1A"/>
-                </a:solidFill>
-                <a:latin typeface="Garamond" pitchFamily="34" charset="0"/>
-                <a:ea typeface="Garamond" pitchFamily="34" charset="-122"/>
-                <a:cs typeface="Garamond" pitchFamily="34" charset="-120"/>
-              </a:rPr>
-              <a:t>SR Technics</a:t>
-            </a:r>
-            <a:endParaRPr lang="en-US" sz="950" dirty="0"/>
-          </a:p>
-        </p:txBody>
-      </p:sp>
-      <p:sp>
-        <p:nvSpPr>
-          <p:cNvPr id="37" name="Shape 35"/>
-          <p:cNvSpPr/>
-          <p:nvPr/>
-        </p:nvSpPr>
-        <p:spPr>
-          <a:xfrm>
-            <a:off x="5570047" y="2567464"/>
-            <a:ext cx="146304" cy="146304"/>
-          </a:xfrm>
-          <a:prstGeom prst="ellipse">
-            <a:avLst>
-              <a:gd name="adj" fmla="val 18750"/>
-            </a:avLst>
-          </a:prstGeom>
-          <a:solidFill>
-            <a:srgbClr val="E8702A"/>
-          </a:solidFill>
-          <a:ln w="12700">
-            <a:solidFill>
-              <a:srgbClr val="E8702A"/>
-            </a:solidFill>
-            <a:prstDash val="solid"/>
-          </a:ln>
-        </p:spPr>
-      </p:sp>
-      <p:sp>
-        <p:nvSpPr>
-          <p:cNvPr id="38" name="Text 36"/>
-          <p:cNvSpPr txBox="1"/>
-          <p:nvPr/>
-        </p:nvSpPr>
-        <p:spPr>
-          <a:xfrm>
-            <a:off x="5752927" y="2540032"/>
-            <a:ext cx="1463040" cy="201168"/>
-          </a:xfrm>
-          <a:prstGeom prst="rect">
-            <a:avLst/>
-          </a:prstGeom>
-          <a:noFill/>
-          <a:ln/>
-        </p:spPr>
-        <p:txBody>
-          <a:bodyPr wrap="square" lIns="0" tIns="0" rIns="0" bIns="0" rtlCol="0" anchor="ctr"/>
-          <a:lstStyle/>
-          <a:p>
-            <a:pPr indent="0" marL="0">
-              <a:buNone/>
-            </a:pPr>
-            <a:r>
-              <a:rPr lang="en-US" sz="950" b="1" dirty="0">
-                <a:solidFill>
-                  <a:srgbClr val="E8702A"/>
-                </a:solidFill>
-                <a:latin typeface="Garamond" pitchFamily="34" charset="0"/>
-                <a:ea typeface="Garamond" pitchFamily="34" charset="-122"/>
-                <a:cs typeface="Garamond" pitchFamily="34" charset="-120"/>
-              </a:rPr>
-              <a:t>FTAI</a:t>
-            </a:r>
-            <a:endParaRPr lang="en-US" sz="950" dirty="0"/>
-          </a:p>
-        </p:txBody>
-      </p:sp>
-      <p:sp>
-        <p:nvSpPr>
-          <p:cNvPr id="39" name="Shape 37"/>
-          <p:cNvSpPr/>
-          <p:nvPr/>
-        </p:nvSpPr>
-        <p:spPr>
-          <a:xfrm>
-            <a:off x="621792" y="3255264"/>
-            <a:ext cx="128016" cy="128016"/>
-          </a:xfrm>
-          <a:prstGeom prst="roundRect">
-            <a:avLst>
-              <a:gd name="adj" fmla="val 21429"/>
-            </a:avLst>
-          </a:prstGeom>
-          <a:solidFill>
-            <a:srgbClr val="FBE5D6"/>
-          </a:solidFill>
-          <a:ln w="12700">
-            <a:solidFill>
-              <a:srgbClr val="A0522D"/>
-            </a:solidFill>
-            <a:prstDash val="solid"/>
-          </a:ln>
-        </p:spPr>
-      </p:sp>
-      <p:sp>
-        <p:nvSpPr>
-          <p:cNvPr id="40" name="Text 38"/>
-          <p:cNvSpPr txBox="1"/>
-          <p:nvPr/>
-        </p:nvSpPr>
-        <p:spPr>
-          <a:xfrm>
-            <a:off x="786384" y="3218688"/>
-            <a:ext cx="777240" cy="182880"/>
-          </a:xfrm>
-          <a:prstGeom prst="rect">
-            <a:avLst/>
-          </a:prstGeom>
-          <a:noFill/>
-          <a:ln/>
-        </p:spPr>
-        <p:txBody>
-          <a:bodyPr wrap="square" lIns="0" tIns="0" rIns="0" bIns="0" rtlCol="0" anchor="ctr"/>
-          <a:lstStyle/>
-          <a:p>
-            <a:pPr indent="0" marL="0">
-              <a:buNone/>
-            </a:pPr>
-            <a:r>
-              <a:rPr lang="en-US" sz="850" dirty="0">
-                <a:solidFill>
-                  <a:srgbClr val="1A1A1A"/>
-                </a:solidFill>
-                <a:latin typeface="Garamond" pitchFamily="34" charset="0"/>
-                <a:ea typeface="Garamond" pitchFamily="34" charset="-122"/>
-                <a:cs typeface="Garamond" pitchFamily="34" charset="-120"/>
-              </a:rPr>
-              <a:t>OEM</a:t>
-            </a:r>
-            <a:endParaRPr lang="en-US" sz="850" dirty="0"/>
-          </a:p>
-        </p:txBody>
-      </p:sp>
-      <p:sp>
-        <p:nvSpPr>
-          <p:cNvPr id="41" name="Shape 39"/>
-          <p:cNvSpPr/>
-          <p:nvPr/>
-        </p:nvSpPr>
-        <p:spPr>
-          <a:xfrm>
-            <a:off x="1554480" y="3255264"/>
-            <a:ext cx="128016" cy="128016"/>
-          </a:xfrm>
-          <a:prstGeom prst="ellipse">
-            <a:avLst>
-              <a:gd name="adj" fmla="val 21429"/>
-            </a:avLst>
-          </a:prstGeom>
-          <a:solidFill>
-            <a:srgbClr val="E6E4FA"/>
-          </a:solidFill>
-          <a:ln w="12700">
-            <a:solidFill>
-              <a:srgbClr val="5B4FC4"/>
-            </a:solidFill>
-            <a:prstDash val="solid"/>
-          </a:ln>
-        </p:spPr>
-      </p:sp>
-      <p:sp>
-        <p:nvSpPr>
-          <p:cNvPr id="42" name="Text 40"/>
-          <p:cNvSpPr txBox="1"/>
-          <p:nvPr/>
-        </p:nvSpPr>
-        <p:spPr>
-          <a:xfrm>
-            <a:off x="1719072" y="3218688"/>
-            <a:ext cx="777240" cy="182880"/>
-          </a:xfrm>
-          <a:prstGeom prst="rect">
-            <a:avLst/>
-          </a:prstGeom>
-          <a:noFill/>
-          <a:ln/>
-        </p:spPr>
-        <p:txBody>
-          <a:bodyPr wrap="square" lIns="0" tIns="0" rIns="0" bIns="0" rtlCol="0" anchor="ctr"/>
-          <a:lstStyle/>
-          <a:p>
-            <a:pPr indent="0" marL="0">
-              <a:buNone/>
-            </a:pPr>
-            <a:r>
-              <a:rPr lang="en-US" sz="850" dirty="0">
-                <a:solidFill>
-                  <a:srgbClr val="1A1A1A"/>
-                </a:solidFill>
-                <a:latin typeface="Garamond" pitchFamily="34" charset="0"/>
-                <a:ea typeface="Garamond" pitchFamily="34" charset="-122"/>
-                <a:cs typeface="Garamond" pitchFamily="34" charset="-120"/>
-              </a:rPr>
-              <a:t>Airline-owned</a:t>
-            </a:r>
-            <a:endParaRPr lang="en-US" sz="850" dirty="0"/>
-          </a:p>
-        </p:txBody>
-      </p:sp>
-      <p:sp>
-        <p:nvSpPr>
-          <p:cNvPr id="43" name="Shape 41"/>
-          <p:cNvSpPr/>
-          <p:nvPr/>
-        </p:nvSpPr>
-        <p:spPr>
-          <a:xfrm>
-            <a:off x="2487168" y="3255264"/>
-            <a:ext cx="128016" cy="128016"/>
-          </a:xfrm>
-          <a:prstGeom prst="ellipse">
-            <a:avLst>
-              <a:gd name="adj" fmla="val 21429"/>
-            </a:avLst>
-          </a:prstGeom>
-          <a:solidFill>
-            <a:srgbClr val="D5EFE6"/>
-          </a:solidFill>
-          <a:ln w="12700">
-            <a:solidFill>
-              <a:srgbClr val="2E8B57"/>
-            </a:solidFill>
-            <a:prstDash val="solid"/>
-          </a:ln>
-        </p:spPr>
-      </p:sp>
-      <p:sp>
-        <p:nvSpPr>
-          <p:cNvPr id="44" name="Text 42"/>
-          <p:cNvSpPr txBox="1"/>
-          <p:nvPr/>
-        </p:nvSpPr>
-        <p:spPr>
-          <a:xfrm>
-            <a:off x="2651760" y="3218688"/>
-            <a:ext cx="777240" cy="182880"/>
-          </a:xfrm>
-          <a:prstGeom prst="rect">
-            <a:avLst/>
-          </a:prstGeom>
-          <a:noFill/>
-          <a:ln/>
-        </p:spPr>
-        <p:txBody>
-          <a:bodyPr wrap="square" lIns="0" tIns="0" rIns="0" bIns="0" rtlCol="0" anchor="ctr"/>
-          <a:lstStyle/>
-          <a:p>
-            <a:pPr indent="0" marL="0">
-              <a:buNone/>
-            </a:pPr>
-            <a:r>
-              <a:rPr lang="en-US" sz="850" dirty="0">
-                <a:solidFill>
-                  <a:srgbClr val="1A1A1A"/>
-                </a:solidFill>
-                <a:latin typeface="Garamond" pitchFamily="34" charset="0"/>
-                <a:ea typeface="Garamond" pitchFamily="34" charset="-122"/>
-                <a:cs typeface="Garamond" pitchFamily="34" charset="-120"/>
-              </a:rPr>
-              <a:t>Independent</a:t>
-            </a:r>
-            <a:endParaRPr lang="en-US" sz="850" dirty="0"/>
-          </a:p>
-        </p:txBody>
-      </p:sp>
-      <p:sp>
-        <p:nvSpPr>
-          <p:cNvPr id="45" name="Shape 43"/>
-          <p:cNvSpPr/>
-          <p:nvPr/>
-        </p:nvSpPr>
-        <p:spPr>
-          <a:xfrm>
-            <a:off x="3419856" y="3255264"/>
-            <a:ext cx="128016" cy="128016"/>
-          </a:xfrm>
-          <a:prstGeom prst="ellipse">
-            <a:avLst>
-              <a:gd name="adj" fmla="val 21429"/>
-            </a:avLst>
-          </a:prstGeom>
-          <a:solidFill>
-            <a:srgbClr val="E8702A"/>
-          </a:solidFill>
-          <a:ln w="12700">
-            <a:solidFill>
-              <a:srgbClr val="E8702A"/>
-            </a:solidFill>
-            <a:prstDash val="solid"/>
-          </a:ln>
-        </p:spPr>
-      </p:sp>
-      <p:sp>
-        <p:nvSpPr>
-          <p:cNvPr id="46" name="Text 44"/>
-          <p:cNvSpPr txBox="1"/>
-          <p:nvPr/>
-        </p:nvSpPr>
-        <p:spPr>
-          <a:xfrm>
-            <a:off x="3584448" y="3218688"/>
-            <a:ext cx="777240" cy="182880"/>
-          </a:xfrm>
-          <a:prstGeom prst="rect">
-            <a:avLst/>
-          </a:prstGeom>
-          <a:noFill/>
-          <a:ln/>
-        </p:spPr>
-        <p:txBody>
-          <a:bodyPr wrap="square" lIns="0" tIns="0" rIns="0" bIns="0" rtlCol="0" anchor="ctr"/>
-          <a:lstStyle/>
-          <a:p>
-            <a:pPr indent="0" marL="0">
-              <a:buNone/>
-            </a:pPr>
-            <a:r>
-              <a:rPr lang="en-US" sz="850" dirty="0">
-                <a:solidFill>
-                  <a:srgbClr val="1A1A1A"/>
-                </a:solidFill>
-                <a:latin typeface="Garamond" pitchFamily="34" charset="0"/>
-                <a:ea typeface="Garamond" pitchFamily="34" charset="-122"/>
-                <a:cs typeface="Garamond" pitchFamily="34" charset="-120"/>
-              </a:rPr>
-              <a:t>FTAI</a:t>
-            </a:r>
-            <a:endParaRPr lang="en-US" sz="850" dirty="0"/>
-          </a:p>
-        </p:txBody>
-      </p:sp>
-      <p:sp>
-        <p:nvSpPr>
-          <p:cNvPr id="47" name="Text 45"/>
-          <p:cNvSpPr txBox="1"/>
-          <p:nvPr/>
-        </p:nvSpPr>
-        <p:spPr>
-          <a:xfrm>
-            <a:off x="4142232" y="3218688"/>
-            <a:ext cx="2194560" cy="182880"/>
-          </a:xfrm>
-          <a:prstGeom prst="rect">
-            <a:avLst/>
-          </a:prstGeom>
-          <a:noFill/>
-          <a:ln/>
-        </p:spPr>
-        <p:txBody>
-          <a:bodyPr wrap="square" lIns="0" tIns="0" rIns="0" bIns="0" rtlCol="0" anchor="ctr"/>
-          <a:lstStyle/>
-          <a:p>
-            <a:pPr algn="r" indent="0" marL="0">
-              <a:buNone/>
-            </a:pPr>
-            <a:r>
-              <a:rPr lang="en-US" sz="900" b="1" dirty="0">
-                <a:solidFill>
-                  <a:srgbClr val="E8702A"/>
-                </a:solidFill>
-                <a:latin typeface="Garamond" pitchFamily="34" charset="0"/>
-                <a:ea typeface="Garamond" pitchFamily="34" charset="-122"/>
-                <a:cs typeface="Garamond" pitchFamily="34" charset="-120"/>
-              </a:rPr>
-              <a:t>CFM56 work flows OEM → independents</a:t>
-            </a:r>
-            <a:endParaRPr lang="en-US" sz="900" dirty="0"/>
-          </a:p>
-        </p:txBody>
-      </p:sp>
-      <p:sp>
-        <p:nvSpPr>
-          <p:cNvPr id="48" name="Shape 46"/>
-          <p:cNvSpPr/>
-          <p:nvPr/>
-        </p:nvSpPr>
-        <p:spPr>
-          <a:xfrm>
-            <a:off x="6455664" y="1188720"/>
-            <a:ext cx="0" cy="2240280"/>
-          </a:xfrm>
-          <a:prstGeom prst="line">
-            <a:avLst/>
-          </a:prstGeom>
-          <a:noFill/>
-          <a:ln w="12700">
-            <a:solidFill>
-              <a:srgbClr val="1A1A1A"/>
-            </a:solidFill>
-            <a:prstDash val="sysDot"/>
-          </a:ln>
-        </p:spPr>
-      </p:sp>
       <p:graphicFrame>
         <p:nvGraphicFramePr>
           <p:cNvPr id="9" name="Table 0"/>
@@ -43197,21 +41726,24 @@
           </p:nvPr>
         </p:nvGraphicFramePr>
         <p:xfrm>
-          <a:off x="6565392" y="1170432"/>
-          <a:ext cx="5257800" cy="914400"/>
+          <a:off x="621792" y="1152144"/>
+          <a:ext cx="11201400" cy="914400"/>
         </p:xfrm>
         <a:graphic>
           <a:graphicData uri="http://schemas.openxmlformats.org/drawingml/2006/table">
             <a:tbl>
               <a:tblPr/>
               <a:tblGrid>
-                <a:gridCol w="1325880"/>
-                <a:gridCol w="777240"/>
-                <a:gridCol w="914400"/>
-                <a:gridCol w="1188720"/>
-                <a:gridCol w="1051560"/>
+                <a:gridCol w="1234440"/>
+                <a:gridCol w="685800"/>
+                <a:gridCol w="685800"/>
+                <a:gridCol w="685800"/>
+                <a:gridCol w="731520"/>
+                <a:gridCol w="1874520"/>
+                <a:gridCol w="2743200"/>
+                <a:gridCol w="2560320"/>
               </a:tblGrid>
-              <a:tr h="201168">
+              <a:tr h="274320">
                 <a:tc>
                   <a:txBody>
                     <a:bodyPr/>
@@ -43433,7 +41965,7 @@
                           <a:ea typeface="Garamond" pitchFamily="34" charset="-122"/>
                           <a:cs typeface="Garamond" pitchFamily="34" charset="-120"/>
                         </a:rPr>
-                        <a:t>Pull back CFM56</a:t>
+                        <a:t>Pull back</a:t>
                       </a:r>
                       <a:endParaRPr lang="en-US" sz="950" dirty="0">
                         <a:latin typeface="Garamond" charset="0"/>
@@ -43501,7 +42033,7 @@
                           <a:ea typeface="Garamond" pitchFamily="34" charset="-122"/>
                           <a:cs typeface="Garamond" pitchFamily="34" charset="-120"/>
                         </a:rPr>
-                        <a:t>Win CFM56 work</a:t>
+                        <a:t>Win CFM56</a:t>
                       </a:r>
                       <a:endParaRPr lang="en-US" sz="950" dirty="0">
                         <a:latin typeface="Garamond" charset="0"/>
@@ -43552,8 +42084,212 @@
                     </a:solidFill>
                   </a:tcPr>
                 </a:tc>
+                <a:tc>
+                  <a:txBody>
+                    <a:bodyPr/>
+                    <a:lstStyle/>
+                    <a:p>
+                      <a:pPr algn="ctr" indent="0" marL="0">
+                        <a:buNone/>
+                      </a:pPr>
+                      <a:r>
+                        <a:rPr lang="en-US" sz="950" b="1" dirty="0">
+                          <a:solidFill>
+                            <a:srgbClr val="FFFFFF"/>
+                          </a:solidFill>
+                          <a:latin typeface="Garamond" pitchFamily="34" charset="0"/>
+                          <a:ea typeface="Garamond" pitchFamily="34" charset="-122"/>
+                          <a:cs typeface="Garamond" pitchFamily="34" charset="-120"/>
+                        </a:rPr>
+                        <a:t>Pulling back on CFM56</a:t>
+                      </a:r>
+                      <a:endParaRPr lang="en-US" sz="950" dirty="0">
+                        <a:latin typeface="Garamond" charset="0"/>
+                        <a:ea typeface="Garamond" charset="0"/>
+                        <a:cs typeface="Garamond" charset="0"/>
+                      </a:endParaRPr>
+                    </a:p>
+                  </a:txBody>
+                  <a:tcPr marL="38100" marR="38100" marT="12700" marB="12700">
+                    <a:lnL w="6350" cap="flat" cmpd="sng" algn="ctr">
+                      <a:solidFill>
+                        <a:srgbClr val="BFBFBF"/>
+                      </a:solidFill>
+                      <a:prstDash val="solid"/>
+                      <a:round/>
+                      <a:headEnd type="none" w="med" len="med"/>
+                      <a:tailEnd type="none" w="med" len="med"/>
+                    </a:lnL>
+                    <a:lnR w="6350" cap="flat" cmpd="sng" algn="ctr">
+                      <a:solidFill>
+                        <a:srgbClr val="BFBFBF"/>
+                      </a:solidFill>
+                      <a:prstDash val="solid"/>
+                      <a:round/>
+                      <a:headEnd type="none" w="med" len="med"/>
+                      <a:tailEnd type="none" w="med" len="med"/>
+                    </a:lnR>
+                    <a:lnT w="6350" cap="flat" cmpd="sng" algn="ctr">
+                      <a:solidFill>
+                        <a:srgbClr val="BFBFBF"/>
+                      </a:solidFill>
+                      <a:prstDash val="solid"/>
+                      <a:round/>
+                      <a:headEnd type="none" w="med" len="med"/>
+                      <a:tailEnd type="none" w="med" len="med"/>
+                    </a:lnT>
+                    <a:lnB w="6350" cap="flat" cmpd="sng" algn="ctr">
+                      <a:solidFill>
+                        <a:srgbClr val="BFBFBF"/>
+                      </a:solidFill>
+                      <a:prstDash val="solid"/>
+                      <a:round/>
+                      <a:headEnd type="none" w="med" len="med"/>
+                      <a:tailEnd type="none" w="med" len="med"/>
+                    </a:lnB>
+                    <a:solidFill>
+                      <a:srgbClr val="1F3864"/>
+                    </a:solidFill>
+                  </a:tcPr>
+                </a:tc>
+                <a:tc>
+                  <a:txBody>
+                    <a:bodyPr/>
+                    <a:lstStyle/>
+                    <a:p>
+                      <a:pPr algn="ctr" indent="0" marL="0">
+                        <a:buNone/>
+                      </a:pPr>
+                      <a:r>
+                        <a:rPr lang="en-US" sz="950" b="1" dirty="0">
+                          <a:solidFill>
+                            <a:srgbClr val="FFFFFF"/>
+                          </a:solidFill>
+                          <a:latin typeface="Garamond" pitchFamily="34" charset="0"/>
+                          <a:ea typeface="Garamond" pitchFamily="34" charset="-122"/>
+                          <a:cs typeface="Garamond" pitchFamily="34" charset="-120"/>
+                        </a:rPr>
+                        <a:t>Holding CFM56</a:t>
+                      </a:r>
+                      <a:endParaRPr lang="en-US" sz="950" dirty="0">
+                        <a:latin typeface="Garamond" charset="0"/>
+                        <a:ea typeface="Garamond" charset="0"/>
+                        <a:cs typeface="Garamond" charset="0"/>
+                      </a:endParaRPr>
+                    </a:p>
+                  </a:txBody>
+                  <a:tcPr marL="38100" marR="38100" marT="12700" marB="12700">
+                    <a:lnL w="6350" cap="flat" cmpd="sng" algn="ctr">
+                      <a:solidFill>
+                        <a:srgbClr val="BFBFBF"/>
+                      </a:solidFill>
+                      <a:prstDash val="solid"/>
+                      <a:round/>
+                      <a:headEnd type="none" w="med" len="med"/>
+                      <a:tailEnd type="none" w="med" len="med"/>
+                    </a:lnL>
+                    <a:lnR w="6350" cap="flat" cmpd="sng" algn="ctr">
+                      <a:solidFill>
+                        <a:srgbClr val="BFBFBF"/>
+                      </a:solidFill>
+                      <a:prstDash val="solid"/>
+                      <a:round/>
+                      <a:headEnd type="none" w="med" len="med"/>
+                      <a:tailEnd type="none" w="med" len="med"/>
+                    </a:lnR>
+                    <a:lnT w="6350" cap="flat" cmpd="sng" algn="ctr">
+                      <a:solidFill>
+                        <a:srgbClr val="BFBFBF"/>
+                      </a:solidFill>
+                      <a:prstDash val="solid"/>
+                      <a:round/>
+                      <a:headEnd type="none" w="med" len="med"/>
+                      <a:tailEnd type="none" w="med" len="med"/>
+                    </a:lnT>
+                    <a:lnB w="6350" cap="flat" cmpd="sng" algn="ctr">
+                      <a:solidFill>
+                        <a:srgbClr val="BFBFBF"/>
+                      </a:solidFill>
+                      <a:prstDash val="solid"/>
+                      <a:round/>
+                      <a:headEnd type="none" w="med" len="med"/>
+                      <a:tailEnd type="none" w="med" len="med"/>
+                    </a:lnB>
+                    <a:solidFill>
+                      <a:srgbClr val="1F3864"/>
+                    </a:solidFill>
+                  </a:tcPr>
+                </a:tc>
+                <a:tc>
+                  <a:txBody>
+                    <a:bodyPr/>
+                    <a:lstStyle/>
+                    <a:p>
+                      <a:pPr algn="ctr" indent="0" marL="0">
+                        <a:buNone/>
+                      </a:pPr>
+                      <a:r>
+                        <a:rPr lang="en-US" sz="950" b="1" dirty="0">
+                          <a:solidFill>
+                            <a:srgbClr val="FFFFFF"/>
+                          </a:solidFill>
+                          <a:latin typeface="Garamond" pitchFamily="34" charset="0"/>
+                          <a:ea typeface="Garamond" pitchFamily="34" charset="-122"/>
+                          <a:cs typeface="Garamond" pitchFamily="34" charset="-120"/>
+                        </a:rPr>
+                        <a:t>Adding CFM56</a:t>
+                      </a:r>
+                      <a:endParaRPr lang="en-US" sz="950" dirty="0">
+                        <a:latin typeface="Garamond" charset="0"/>
+                        <a:ea typeface="Garamond" charset="0"/>
+                        <a:cs typeface="Garamond" charset="0"/>
+                      </a:endParaRPr>
+                    </a:p>
+                  </a:txBody>
+                  <a:tcPr marL="38100" marR="38100" marT="12700" marB="12700">
+                    <a:lnL w="6350" cap="flat" cmpd="sng" algn="ctr">
+                      <a:solidFill>
+                        <a:srgbClr val="BFBFBF"/>
+                      </a:solidFill>
+                      <a:prstDash val="solid"/>
+                      <a:round/>
+                      <a:headEnd type="none" w="med" len="med"/>
+                      <a:tailEnd type="none" w="med" len="med"/>
+                    </a:lnL>
+                    <a:lnR w="6350" cap="flat" cmpd="sng" algn="ctr">
+                      <a:solidFill>
+                        <a:srgbClr val="BFBFBF"/>
+                      </a:solidFill>
+                      <a:prstDash val="solid"/>
+                      <a:round/>
+                      <a:headEnd type="none" w="med" len="med"/>
+                      <a:tailEnd type="none" w="med" len="med"/>
+                    </a:lnR>
+                    <a:lnT w="6350" cap="flat" cmpd="sng" algn="ctr">
+                      <a:solidFill>
+                        <a:srgbClr val="BFBFBF"/>
+                      </a:solidFill>
+                      <a:prstDash val="solid"/>
+                      <a:round/>
+                      <a:headEnd type="none" w="med" len="med"/>
+                      <a:tailEnd type="none" w="med" len="med"/>
+                    </a:lnT>
+                    <a:lnB w="6350" cap="flat" cmpd="sng" algn="ctr">
+                      <a:solidFill>
+                        <a:srgbClr val="BFBFBF"/>
+                      </a:solidFill>
+                      <a:prstDash val="solid"/>
+                      <a:round/>
+                      <a:headEnd type="none" w="med" len="med"/>
+                      <a:tailEnd type="none" w="med" len="med"/>
+                    </a:lnB>
+                    <a:solidFill>
+                      <a:srgbClr val="1F3864"/>
+                    </a:solidFill>
+                  </a:tcPr>
+                </a:tc>
               </a:tr>
-              <a:tr h="201168">
+              <a:tr h="274320">
                 <a:tc>
                   <a:txBody>
                     <a:bodyPr/>
@@ -43563,7 +42299,7 @@
                         <a:buNone/>
                       </a:pPr>
                       <a:r>
-                        <a:rPr lang="en-US" sz="950" dirty="0">
+                        <a:rPr lang="en-US" sz="950" b="1" dirty="0">
                           <a:solidFill>
                             <a:srgbClr val="1A1A1A"/>
                           </a:solidFill>
@@ -43571,7 +42307,7 @@
                           <a:ea typeface="Garamond" pitchFamily="34" charset="-122"/>
                           <a:cs typeface="Garamond" pitchFamily="34" charset="-120"/>
                         </a:rPr>
-                        <a:t>Airline-owned</a:t>
+                        <a:t>OEM network</a:t>
                       </a:r>
                       <a:endParaRPr lang="en-US" sz="1200" dirty="0"/>
                     </a:p>
@@ -43635,7 +42371,7 @@
                           <a:ea typeface="Garamond" pitchFamily="34" charset="-122"/>
                           <a:cs typeface="Garamond" pitchFamily="34" charset="-120"/>
                         </a:rPr>
-                        <a:t>8</a:t>
+                        <a:t>2</a:t>
                       </a:r>
                       <a:endParaRPr lang="en-US" sz="1200" dirty="0"/>
                     </a:p>
@@ -43699,7 +42435,7 @@
                           <a:ea typeface="Garamond" pitchFamily="34" charset="-122"/>
                           <a:cs typeface="Garamond" pitchFamily="34" charset="-120"/>
                         </a:rPr>
-                        <a:t>8</a:t>
+                        <a:t>2</a:t>
                       </a:r>
                       <a:endParaRPr lang="en-US" sz="1200" dirty="0"/>
                     </a:p>
@@ -43827,7 +42563,7 @@
                           <a:ea typeface="Garamond" pitchFamily="34" charset="-122"/>
                           <a:cs typeface="Garamond" pitchFamily="34" charset="-120"/>
                         </a:rPr>
-                        <a:t>3</a:t>
+                        <a:t>2</a:t>
                       </a:r>
                       <a:endParaRPr lang="en-US" sz="1200" dirty="0"/>
                     </a:p>
@@ -43874,14 +42610,12 @@
                     </a:solidFill>
                   </a:tcPr>
                 </a:tc>
-              </a:tr>
-              <a:tr h="201168">
                 <a:tc>
                   <a:txBody>
                     <a:bodyPr/>
                     <a:lstStyle/>
                     <a:p>
-                      <a:pPr algn="l" indent="0" marL="0">
+                      <a:pPr algn="ctr" indent="0" marL="0">
                         <a:buNone/>
                       </a:pPr>
                       <a:r>
@@ -43893,7 +42627,201 @@
                           <a:ea typeface="Garamond" pitchFamily="34" charset="-122"/>
                           <a:cs typeface="Garamond" pitchFamily="34" charset="-120"/>
                         </a:rPr>
-                        <a:t>OEM network</a:t>
+                        <a:t>GE / CFM, Safran</a:t>
+                      </a:r>
+                      <a:endParaRPr lang="en-US" sz="1200" dirty="0"/>
+                    </a:p>
+                  </a:txBody>
+                  <a:tcPr marL="38100" marR="38100" marT="12700" marB="12700">
+                    <a:lnL w="6350" cap="flat" cmpd="sng" algn="ctr">
+                      <a:solidFill>
+                        <a:srgbClr val="BFBFBF"/>
+                      </a:solidFill>
+                      <a:prstDash val="solid"/>
+                      <a:round/>
+                      <a:headEnd type="none" w="med" len="med"/>
+                      <a:tailEnd type="none" w="med" len="med"/>
+                    </a:lnL>
+                    <a:lnR w="6350" cap="flat" cmpd="sng" algn="ctr">
+                      <a:solidFill>
+                        <a:srgbClr val="BFBFBF"/>
+                      </a:solidFill>
+                      <a:prstDash val="solid"/>
+                      <a:round/>
+                      <a:headEnd type="none" w="med" len="med"/>
+                      <a:tailEnd type="none" w="med" len="med"/>
+                    </a:lnR>
+                    <a:lnT w="6350" cap="flat" cmpd="sng" algn="ctr">
+                      <a:solidFill>
+                        <a:srgbClr val="BFBFBF"/>
+                      </a:solidFill>
+                      <a:prstDash val="solid"/>
+                      <a:round/>
+                      <a:headEnd type="none" w="med" len="med"/>
+                      <a:tailEnd type="none" w="med" len="med"/>
+                    </a:lnT>
+                    <a:lnB w="6350" cap="flat" cmpd="sng" algn="ctr">
+                      <a:solidFill>
+                        <a:srgbClr val="BFBFBF"/>
+                      </a:solidFill>
+                      <a:prstDash val="solid"/>
+                      <a:round/>
+                      <a:headEnd type="none" w="med" len="med"/>
+                      <a:tailEnd type="none" w="med" len="med"/>
+                    </a:lnB>
+                    <a:solidFill>
+                      <a:srgbClr val="FFFFFF"/>
+                    </a:solidFill>
+                  </a:tcPr>
+                </a:tc>
+                <a:tc>
+                  <a:txBody>
+                    <a:bodyPr/>
+                    <a:lstStyle/>
+                    <a:p>
+                      <a:pPr algn="ctr" indent="0" marL="0">
+                        <a:buNone/>
+                      </a:pPr>
+                      <a:r>
+                        <a:rPr lang="en-US" sz="950" dirty="0">
+                          <a:solidFill>
+                            <a:srgbClr val="1A1A1A"/>
+                          </a:solidFill>
+                          <a:latin typeface="Garamond" pitchFamily="34" charset="0"/>
+                          <a:ea typeface="Garamond" pitchFamily="34" charset="-122"/>
+                          <a:cs typeface="Garamond" pitchFamily="34" charset="-120"/>
+                        </a:rPr>
+                        <a:t>–</a:t>
+                      </a:r>
+                      <a:endParaRPr lang="en-US" sz="1200" dirty="0"/>
+                    </a:p>
+                  </a:txBody>
+                  <a:tcPr marL="38100" marR="38100" marT="12700" marB="12700">
+                    <a:lnL w="6350" cap="flat" cmpd="sng" algn="ctr">
+                      <a:solidFill>
+                        <a:srgbClr val="BFBFBF"/>
+                      </a:solidFill>
+                      <a:prstDash val="solid"/>
+                      <a:round/>
+                      <a:headEnd type="none" w="med" len="med"/>
+                      <a:tailEnd type="none" w="med" len="med"/>
+                    </a:lnL>
+                    <a:lnR w="6350" cap="flat" cmpd="sng" algn="ctr">
+                      <a:solidFill>
+                        <a:srgbClr val="BFBFBF"/>
+                      </a:solidFill>
+                      <a:prstDash val="solid"/>
+                      <a:round/>
+                      <a:headEnd type="none" w="med" len="med"/>
+                      <a:tailEnd type="none" w="med" len="med"/>
+                    </a:lnR>
+                    <a:lnT w="6350" cap="flat" cmpd="sng" algn="ctr">
+                      <a:solidFill>
+                        <a:srgbClr val="BFBFBF"/>
+                      </a:solidFill>
+                      <a:prstDash val="solid"/>
+                      <a:round/>
+                      <a:headEnd type="none" w="med" len="med"/>
+                      <a:tailEnd type="none" w="med" len="med"/>
+                    </a:lnT>
+                    <a:lnB w="6350" cap="flat" cmpd="sng" algn="ctr">
+                      <a:solidFill>
+                        <a:srgbClr val="BFBFBF"/>
+                      </a:solidFill>
+                      <a:prstDash val="solid"/>
+                      <a:round/>
+                      <a:headEnd type="none" w="med" len="med"/>
+                      <a:tailEnd type="none" w="med" len="med"/>
+                    </a:lnB>
+                    <a:solidFill>
+                      <a:srgbClr val="FFFFFF"/>
+                    </a:solidFill>
+                  </a:tcPr>
+                </a:tc>
+                <a:tc>
+                  <a:txBody>
+                    <a:bodyPr/>
+                    <a:lstStyle/>
+                    <a:p>
+                      <a:pPr algn="ctr" indent="0" marL="0">
+                        <a:buNone/>
+                      </a:pPr>
+                      <a:r>
+                        <a:rPr lang="en-US" sz="950" dirty="0">
+                          <a:solidFill>
+                            <a:srgbClr val="1A1A1A"/>
+                          </a:solidFill>
+                          <a:latin typeface="Garamond" pitchFamily="34" charset="0"/>
+                          <a:ea typeface="Garamond" pitchFamily="34" charset="-122"/>
+                          <a:cs typeface="Garamond" pitchFamily="34" charset="-120"/>
+                        </a:rPr>
+                        <a:t>–</a:t>
+                      </a:r>
+                      <a:endParaRPr lang="en-US" sz="1200" dirty="0"/>
+                    </a:p>
+                  </a:txBody>
+                  <a:tcPr marL="38100" marR="38100" marT="12700" marB="12700">
+                    <a:lnL w="6350" cap="flat" cmpd="sng" algn="ctr">
+                      <a:solidFill>
+                        <a:srgbClr val="BFBFBF"/>
+                      </a:solidFill>
+                      <a:prstDash val="solid"/>
+                      <a:round/>
+                      <a:headEnd type="none" w="med" len="med"/>
+                      <a:tailEnd type="none" w="med" len="med"/>
+                    </a:lnL>
+                    <a:lnR w="6350" cap="flat" cmpd="sng" algn="ctr">
+                      <a:solidFill>
+                        <a:srgbClr val="BFBFBF"/>
+                      </a:solidFill>
+                      <a:prstDash val="solid"/>
+                      <a:round/>
+                      <a:headEnd type="none" w="med" len="med"/>
+                      <a:tailEnd type="none" w="med" len="med"/>
+                    </a:lnR>
+                    <a:lnT w="6350" cap="flat" cmpd="sng" algn="ctr">
+                      <a:solidFill>
+                        <a:srgbClr val="BFBFBF"/>
+                      </a:solidFill>
+                      <a:prstDash val="solid"/>
+                      <a:round/>
+                      <a:headEnd type="none" w="med" len="med"/>
+                      <a:tailEnd type="none" w="med" len="med"/>
+                    </a:lnT>
+                    <a:lnB w="6350" cap="flat" cmpd="sng" algn="ctr">
+                      <a:solidFill>
+                        <a:srgbClr val="BFBFBF"/>
+                      </a:solidFill>
+                      <a:prstDash val="solid"/>
+                      <a:round/>
+                      <a:headEnd type="none" w="med" len="med"/>
+                      <a:tailEnd type="none" w="med" len="med"/>
+                    </a:lnB>
+                    <a:solidFill>
+                      <a:srgbClr val="FFFFFF"/>
+                    </a:solidFill>
+                  </a:tcPr>
+                </a:tc>
+              </a:tr>
+              <a:tr h="274320">
+                <a:tc>
+                  <a:txBody>
+                    <a:bodyPr/>
+                    <a:lstStyle/>
+                    <a:p>
+                      <a:pPr algn="l" indent="0" marL="0">
+                        <a:buNone/>
+                      </a:pPr>
+                      <a:r>
+                        <a:rPr lang="en-US" sz="950" b="1" dirty="0">
+                          <a:solidFill>
+                            <a:srgbClr val="1A1A1A"/>
+                          </a:solidFill>
+                          <a:latin typeface="Garamond" pitchFamily="34" charset="0"/>
+                          <a:ea typeface="Garamond" pitchFamily="34" charset="-122"/>
+                          <a:cs typeface="Garamond" pitchFamily="34" charset="-120"/>
+                        </a:rPr>
+                        <a:t>Airline-owned</a:t>
                       </a:r>
                       <a:endParaRPr lang="en-US" sz="1200" dirty="0"/>
                     </a:p>
@@ -43957,7 +42885,7 @@
                           <a:ea typeface="Garamond" pitchFamily="34" charset="-122"/>
                           <a:cs typeface="Garamond" pitchFamily="34" charset="-120"/>
                         </a:rPr>
-                        <a:t>2</a:t>
+                        <a:t>8</a:t>
                       </a:r>
                       <a:endParaRPr lang="en-US" sz="1200" dirty="0"/>
                     </a:p>
@@ -44021,7 +42949,7 @@
                           <a:ea typeface="Garamond" pitchFamily="34" charset="-122"/>
                           <a:cs typeface="Garamond" pitchFamily="34" charset="-120"/>
                         </a:rPr>
-                        <a:t>2</a:t>
+                        <a:t>8</a:t>
                       </a:r>
                       <a:endParaRPr lang="en-US" sz="1200" dirty="0"/>
                     </a:p>
@@ -44149,7 +43077,199 @@
                           <a:ea typeface="Garamond" pitchFamily="34" charset="-122"/>
                           <a:cs typeface="Garamond" pitchFamily="34" charset="-120"/>
                         </a:rPr>
-                        <a:t>2</a:t>
+                        <a:t>3</a:t>
+                      </a:r>
+                      <a:endParaRPr lang="en-US" sz="1200" dirty="0"/>
+                    </a:p>
+                  </a:txBody>
+                  <a:tcPr marL="38100" marR="38100" marT="12700" marB="12700">
+                    <a:lnL w="6350" cap="flat" cmpd="sng" algn="ctr">
+                      <a:solidFill>
+                        <a:srgbClr val="BFBFBF"/>
+                      </a:solidFill>
+                      <a:prstDash val="solid"/>
+                      <a:round/>
+                      <a:headEnd type="none" w="med" len="med"/>
+                      <a:tailEnd type="none" w="med" len="med"/>
+                    </a:lnL>
+                    <a:lnR w="6350" cap="flat" cmpd="sng" algn="ctr">
+                      <a:solidFill>
+                        <a:srgbClr val="BFBFBF"/>
+                      </a:solidFill>
+                      <a:prstDash val="solid"/>
+                      <a:round/>
+                      <a:headEnd type="none" w="med" len="med"/>
+                      <a:tailEnd type="none" w="med" len="med"/>
+                    </a:lnR>
+                    <a:lnT w="6350" cap="flat" cmpd="sng" algn="ctr">
+                      <a:solidFill>
+                        <a:srgbClr val="BFBFBF"/>
+                      </a:solidFill>
+                      <a:prstDash val="solid"/>
+                      <a:round/>
+                      <a:headEnd type="none" w="med" len="med"/>
+                      <a:tailEnd type="none" w="med" len="med"/>
+                    </a:lnT>
+                    <a:lnB w="6350" cap="flat" cmpd="sng" algn="ctr">
+                      <a:solidFill>
+                        <a:srgbClr val="BFBFBF"/>
+                      </a:solidFill>
+                      <a:prstDash val="solid"/>
+                      <a:round/>
+                      <a:headEnd type="none" w="med" len="med"/>
+                      <a:tailEnd type="none" w="med" len="med"/>
+                    </a:lnB>
+                    <a:solidFill>
+                      <a:srgbClr val="F2F2F2"/>
+                    </a:solidFill>
+                  </a:tcPr>
+                </a:tc>
+                <a:tc>
+                  <a:txBody>
+                    <a:bodyPr/>
+                    <a:lstStyle/>
+                    <a:p>
+                      <a:pPr algn="ctr" indent="0" marL="0">
+                        <a:buNone/>
+                      </a:pPr>
+                      <a:r>
+                        <a:rPr lang="en-US" sz="950" dirty="0">
+                          <a:solidFill>
+                            <a:srgbClr val="1A1A1A"/>
+                          </a:solidFill>
+                          <a:latin typeface="Garamond" pitchFamily="34" charset="0"/>
+                          <a:ea typeface="Garamond" pitchFamily="34" charset="-122"/>
+                          <a:cs typeface="Garamond" pitchFamily="34" charset="-120"/>
+                        </a:rPr>
+                        <a:t>Lufthansa</a:t>
+                      </a:r>
+                      <a:endParaRPr lang="en-US" sz="1200" dirty="0"/>
+                    </a:p>
+                  </a:txBody>
+                  <a:tcPr marL="38100" marR="38100" marT="12700" marB="12700">
+                    <a:lnL w="6350" cap="flat" cmpd="sng" algn="ctr">
+                      <a:solidFill>
+                        <a:srgbClr val="BFBFBF"/>
+                      </a:solidFill>
+                      <a:prstDash val="solid"/>
+                      <a:round/>
+                      <a:headEnd type="none" w="med" len="med"/>
+                      <a:tailEnd type="none" w="med" len="med"/>
+                    </a:lnL>
+                    <a:lnR w="6350" cap="flat" cmpd="sng" algn="ctr">
+                      <a:solidFill>
+                        <a:srgbClr val="BFBFBF"/>
+                      </a:solidFill>
+                      <a:prstDash val="solid"/>
+                      <a:round/>
+                      <a:headEnd type="none" w="med" len="med"/>
+                      <a:tailEnd type="none" w="med" len="med"/>
+                    </a:lnR>
+                    <a:lnT w="6350" cap="flat" cmpd="sng" algn="ctr">
+                      <a:solidFill>
+                        <a:srgbClr val="BFBFBF"/>
+                      </a:solidFill>
+                      <a:prstDash val="solid"/>
+                      <a:round/>
+                      <a:headEnd type="none" w="med" len="med"/>
+                      <a:tailEnd type="none" w="med" len="med"/>
+                    </a:lnT>
+                    <a:lnB w="6350" cap="flat" cmpd="sng" algn="ctr">
+                      <a:solidFill>
+                        <a:srgbClr val="BFBFBF"/>
+                      </a:solidFill>
+                      <a:prstDash val="solid"/>
+                      <a:round/>
+                      <a:headEnd type="none" w="med" len="med"/>
+                      <a:tailEnd type="none" w="med" len="med"/>
+                    </a:lnB>
+                    <a:solidFill>
+                      <a:srgbClr val="F2F2F2"/>
+                    </a:solidFill>
+                  </a:tcPr>
+                </a:tc>
+                <a:tc>
+                  <a:txBody>
+                    <a:bodyPr/>
+                    <a:lstStyle/>
+                    <a:p>
+                      <a:pPr algn="ctr" indent="0" marL="0">
+                        <a:buNone/>
+                      </a:pPr>
+                      <a:r>
+                        <a:rPr lang="en-US" sz="950" dirty="0">
+                          <a:solidFill>
+                            <a:srgbClr val="1A1A1A"/>
+                          </a:solidFill>
+                          <a:latin typeface="Garamond" pitchFamily="34" charset="0"/>
+                          <a:ea typeface="Garamond" pitchFamily="34" charset="-122"/>
+                          <a:cs typeface="Garamond" pitchFamily="34" charset="-120"/>
+                        </a:rPr>
+                        <a:t>AFI KLM, Delta, Iberia (planned), Turkish (exploring), Korean Air</a:t>
+                      </a:r>
+                      <a:endParaRPr lang="en-US" sz="1200" dirty="0"/>
+                    </a:p>
+                  </a:txBody>
+                  <a:tcPr marL="38100" marR="38100" marT="12700" marB="12700">
+                    <a:lnL w="6350" cap="flat" cmpd="sng" algn="ctr">
+                      <a:solidFill>
+                        <a:srgbClr val="BFBFBF"/>
+                      </a:solidFill>
+                      <a:prstDash val="solid"/>
+                      <a:round/>
+                      <a:headEnd type="none" w="med" len="med"/>
+                      <a:tailEnd type="none" w="med" len="med"/>
+                    </a:lnL>
+                    <a:lnR w="6350" cap="flat" cmpd="sng" algn="ctr">
+                      <a:solidFill>
+                        <a:srgbClr val="BFBFBF"/>
+                      </a:solidFill>
+                      <a:prstDash val="solid"/>
+                      <a:round/>
+                      <a:headEnd type="none" w="med" len="med"/>
+                      <a:tailEnd type="none" w="med" len="med"/>
+                    </a:lnR>
+                    <a:lnT w="6350" cap="flat" cmpd="sng" algn="ctr">
+                      <a:solidFill>
+                        <a:srgbClr val="BFBFBF"/>
+                      </a:solidFill>
+                      <a:prstDash val="solid"/>
+                      <a:round/>
+                      <a:headEnd type="none" w="med" len="med"/>
+                      <a:tailEnd type="none" w="med" len="med"/>
+                    </a:lnT>
+                    <a:lnB w="6350" cap="flat" cmpd="sng" algn="ctr">
+                      <a:solidFill>
+                        <a:srgbClr val="BFBFBF"/>
+                      </a:solidFill>
+                      <a:prstDash val="solid"/>
+                      <a:round/>
+                      <a:headEnd type="none" w="med" len="med"/>
+                      <a:tailEnd type="none" w="med" len="med"/>
+                    </a:lnB>
+                    <a:solidFill>
+                      <a:srgbClr val="F2F2F2"/>
+                    </a:solidFill>
+                  </a:tcPr>
+                </a:tc>
+                <a:tc>
+                  <a:txBody>
+                    <a:bodyPr/>
+                    <a:lstStyle/>
+                    <a:p>
+                      <a:pPr algn="ctr" indent="0" marL="0">
+                        <a:buNone/>
+                      </a:pPr>
+                      <a:r>
+                        <a:rPr lang="en-US" sz="950" dirty="0">
+                          <a:solidFill>
+                            <a:srgbClr val="1A1A1A"/>
+                          </a:solidFill>
+                          <a:latin typeface="Garamond" pitchFamily="34" charset="0"/>
+                          <a:ea typeface="Garamond" pitchFamily="34" charset="-122"/>
+                          <a:cs typeface="Garamond" pitchFamily="34" charset="-120"/>
+                        </a:rPr>
+                        <a:t>–</a:t>
                       </a:r>
                       <a:endParaRPr lang="en-US" sz="1200" dirty="0"/>
                     </a:p>
@@ -44197,7 +43317,7 @@
                   </a:tcPr>
                 </a:tc>
               </a:tr>
-              <a:tr h="201168">
+              <a:tr h="274320">
                 <a:tc>
                   <a:txBody>
                     <a:bodyPr/>
@@ -44207,7 +43327,7 @@
                         <a:buNone/>
                       </a:pPr>
                       <a:r>
-                        <a:rPr lang="en-US" sz="950" dirty="0">
+                        <a:rPr lang="en-US" sz="950" b="1" dirty="0">
                           <a:solidFill>
                             <a:srgbClr val="1A1A1A"/>
                           </a:solidFill>
@@ -44518,6 +43638,209 @@
                     </a:solidFill>
                   </a:tcPr>
                 </a:tc>
+                <a:tc>
+                  <a:txBody>
+                    <a:bodyPr/>
+                    <a:lstStyle/>
+                    <a:p>
+                      <a:pPr algn="ctr" indent="0" marL="0">
+                        <a:buNone/>
+                      </a:pPr>
+                      <a:r>
+                        <a:rPr lang="en-US" sz="950" dirty="0">
+                          <a:solidFill>
+                            <a:srgbClr val="1A1A1A"/>
+                          </a:solidFill>
+                          <a:latin typeface="Garamond" pitchFamily="34" charset="0"/>
+                          <a:ea typeface="Garamond" pitchFamily="34" charset="-122"/>
+                          <a:cs typeface="Garamond" pitchFamily="34" charset="-120"/>
+                        </a:rPr>
+                        <a:t>–</a:t>
+                      </a:r>
+                      <a:endParaRPr lang="en-US" sz="1200" dirty="0"/>
+                    </a:p>
+                  </a:txBody>
+                  <a:tcPr marL="38100" marR="38100" marT="12700" marB="12700">
+                    <a:lnL w="6350" cap="flat" cmpd="sng" algn="ctr">
+                      <a:solidFill>
+                        <a:srgbClr val="BFBFBF"/>
+                      </a:solidFill>
+                      <a:prstDash val="solid"/>
+                      <a:round/>
+                      <a:headEnd type="none" w="med" len="med"/>
+                      <a:tailEnd type="none" w="med" len="med"/>
+                    </a:lnL>
+                    <a:lnR w="6350" cap="flat" cmpd="sng" algn="ctr">
+                      <a:solidFill>
+                        <a:srgbClr val="BFBFBF"/>
+                      </a:solidFill>
+                      <a:prstDash val="solid"/>
+                      <a:round/>
+                      <a:headEnd type="none" w="med" len="med"/>
+                      <a:tailEnd type="none" w="med" len="med"/>
+                    </a:lnR>
+                    <a:lnT w="6350" cap="flat" cmpd="sng" algn="ctr">
+                      <a:solidFill>
+                        <a:srgbClr val="BFBFBF"/>
+                      </a:solidFill>
+                      <a:prstDash val="solid"/>
+                      <a:round/>
+                      <a:headEnd type="none" w="med" len="med"/>
+                      <a:tailEnd type="none" w="med" len="med"/>
+                    </a:lnT>
+                    <a:lnB w="6350" cap="flat" cmpd="sng" algn="ctr">
+                      <a:solidFill>
+                        <a:srgbClr val="BFBFBF"/>
+                      </a:solidFill>
+                      <a:prstDash val="solid"/>
+                      <a:round/>
+                      <a:headEnd type="none" w="med" len="med"/>
+                      <a:tailEnd type="none" w="med" len="med"/>
+                    </a:lnB>
+                    <a:solidFill>
+                      <a:srgbClr val="FFFFFF"/>
+                    </a:solidFill>
+                  </a:tcPr>
+                </a:tc>
+                <a:tc>
+                  <a:txBody>
+                    <a:bodyPr/>
+                    <a:lstStyle/>
+                    <a:p>
+                      <a:pPr algn="ctr" indent="0" marL="0">
+                        <a:buNone/>
+                      </a:pPr>
+                      <a:r>
+                        <a:rPr lang="en-US" sz="950" dirty="0">
+                          <a:solidFill>
+                            <a:srgbClr val="1A1A1A"/>
+                          </a:solidFill>
+                          <a:latin typeface="Garamond" pitchFamily="34" charset="0"/>
+                          <a:ea typeface="Garamond" pitchFamily="34" charset="-122"/>
+                          <a:cs typeface="Garamond" pitchFamily="34" charset="-120"/>
+                        </a:rPr>
+                        <a:t>–</a:t>
+                      </a:r>
+                      <a:endParaRPr lang="en-US" sz="1200" dirty="0"/>
+                    </a:p>
+                  </a:txBody>
+                  <a:tcPr marL="38100" marR="38100" marT="12700" marB="12700">
+                    <a:lnL w="6350" cap="flat" cmpd="sng" algn="ctr">
+                      <a:solidFill>
+                        <a:srgbClr val="BFBFBF"/>
+                      </a:solidFill>
+                      <a:prstDash val="solid"/>
+                      <a:round/>
+                      <a:headEnd type="none" w="med" len="med"/>
+                      <a:tailEnd type="none" w="med" len="med"/>
+                    </a:lnL>
+                    <a:lnR w="6350" cap="flat" cmpd="sng" algn="ctr">
+                      <a:solidFill>
+                        <a:srgbClr val="BFBFBF"/>
+                      </a:solidFill>
+                      <a:prstDash val="solid"/>
+                      <a:round/>
+                      <a:headEnd type="none" w="med" len="med"/>
+                      <a:tailEnd type="none" w="med" len="med"/>
+                    </a:lnR>
+                    <a:lnT w="6350" cap="flat" cmpd="sng" algn="ctr">
+                      <a:solidFill>
+                        <a:srgbClr val="BFBFBF"/>
+                      </a:solidFill>
+                      <a:prstDash val="solid"/>
+                      <a:round/>
+                      <a:headEnd type="none" w="med" len="med"/>
+                      <a:tailEnd type="none" w="med" len="med"/>
+                    </a:lnT>
+                    <a:lnB w="6350" cap="flat" cmpd="sng" algn="ctr">
+                      <a:solidFill>
+                        <a:srgbClr val="BFBFBF"/>
+                      </a:solidFill>
+                      <a:prstDash val="solid"/>
+                      <a:round/>
+                      <a:headEnd type="none" w="med" len="med"/>
+                      <a:tailEnd type="none" w="med" len="med"/>
+                    </a:lnB>
+                    <a:solidFill>
+                      <a:srgbClr val="FFFFFF"/>
+                    </a:solidFill>
+                  </a:tcPr>
+                </a:tc>
+                <a:tc>
+                  <a:txBody>
+                    <a:bodyPr/>
+                    <a:lstStyle/>
+                    <a:p>
+                      <a:pPr algn="ctr" indent="0" marL="0">
+                        <a:buNone/>
+                      </a:pPr>
+                      <a:r>
+                        <a:rPr lang="en-US" sz="950" dirty="0">
+                          <a:solidFill>
+                            <a:srgbClr val="1A1A1A"/>
+                          </a:solidFill>
+                          <a:latin typeface="Garamond" pitchFamily="34" charset="0"/>
+                          <a:ea typeface="Garamond" pitchFamily="34" charset="-122"/>
+                          <a:cs typeface="Garamond" pitchFamily="34" charset="-120"/>
+                        </a:rPr>
+                        <a:t>MTU, StandardAero, ST Engineering, SR Technics, </a:t>
+                      </a:r>
+                      <a:r>
+                        <a:rPr lang="en-US" sz="950" b="1" dirty="0">
+                          <a:solidFill>
+                            <a:srgbClr val="1A1A1A"/>
+                          </a:solidFill>
+                          <a:latin typeface="Garamond" pitchFamily="34" charset="0"/>
+                          <a:ea typeface="Garamond" pitchFamily="34" charset="-122"/>
+                          <a:cs typeface="Garamond" pitchFamily="34" charset="-120"/>
+                        </a:rPr>
+                        <a:t>FTAI</a:t>
+                      </a:r>
+                      <a:endParaRPr lang="en-US" sz="1200" dirty="0"/>
+                    </a:p>
+                  </a:txBody>
+                  <a:tcPr marL="38100" marR="38100" marT="12700" marB="12700">
+                    <a:lnL w="6350" cap="flat" cmpd="sng" algn="ctr">
+                      <a:solidFill>
+                        <a:srgbClr val="BFBFBF"/>
+                      </a:solidFill>
+                      <a:prstDash val="solid"/>
+                      <a:round/>
+                      <a:headEnd type="none" w="med" len="med"/>
+                      <a:tailEnd type="none" w="med" len="med"/>
+                    </a:lnL>
+                    <a:lnR w="6350" cap="flat" cmpd="sng" algn="ctr">
+                      <a:solidFill>
+                        <a:srgbClr val="BFBFBF"/>
+                      </a:solidFill>
+                      <a:prstDash val="solid"/>
+                      <a:round/>
+                      <a:headEnd type="none" w="med" len="med"/>
+                      <a:tailEnd type="none" w="med" len="med"/>
+                    </a:lnR>
+                    <a:lnT w="6350" cap="flat" cmpd="sng" algn="ctr">
+                      <a:solidFill>
+                        <a:srgbClr val="BFBFBF"/>
+                      </a:solidFill>
+                      <a:prstDash val="solid"/>
+                      <a:round/>
+                      <a:headEnd type="none" w="med" len="med"/>
+                      <a:tailEnd type="none" w="med" len="med"/>
+                    </a:lnT>
+                    <a:lnB w="6350" cap="flat" cmpd="sng" algn="ctr">
+                      <a:solidFill>
+                        <a:srgbClr val="BFBFBF"/>
+                      </a:solidFill>
+                      <a:prstDash val="solid"/>
+                      <a:round/>
+                      <a:headEnd type="none" w="med" len="med"/>
+                      <a:tailEnd type="none" w="med" len="med"/>
+                    </a:lnB>
+                    <a:solidFill>
+                      <a:srgbClr val="FFFFFF"/>
+                    </a:solidFill>
+                  </a:tcPr>
+                </a:tc>
               </a:tr>
             </a:tbl>
           </a:graphicData>
@@ -44525,14 +43848,67 @@
       </p:graphicFrame>
       <p:sp>
         <p:nvSpPr>
-          <p:cNvPr id="50" name="Text 47"/>
+          <p:cNvPr id="6" name="Text 3"/>
           <p:cNvSpPr txBox="1"/>
           <p:nvPr/>
         </p:nvSpPr>
         <p:spPr>
           <a:xfrm>
-            <a:off x="6565392" y="2029968"/>
-            <a:ext cx="5257800" cy="1463040"/>
+            <a:off x="621792" y="2286000"/>
+            <a:ext cx="11201400" cy="219456"/>
+          </a:xfrm>
+          <a:prstGeom prst="rect">
+            <a:avLst/>
+          </a:prstGeom>
+          <a:noFill/>
+          <a:ln/>
+        </p:spPr>
+        <p:txBody>
+          <a:bodyPr wrap="square" lIns="25400" tIns="25400" rIns="25400" bIns="25400" rtlCol="0" anchor="t"/>
+          <a:lstStyle/>
+          <a:p>
+            <a:pPr algn="ctr" indent="0" marL="0">
+              <a:lnSpc>
+                <a:spcPct val="100000"/>
+              </a:lnSpc>
+              <a:buNone/>
+            </a:pPr>
+            <a:r>
+              <a:rPr lang="en-US" sz="1050" b="1" u="sng" dirty="0">
+                <a:solidFill>
+                  <a:srgbClr val="E8702A"/>
+                </a:solidFill>
+                <a:latin typeface="Garamond" pitchFamily="34" charset="0"/>
+                <a:ea typeface="Garamond" pitchFamily="34" charset="-122"/>
+                <a:cs typeface="Garamond" pitchFamily="34" charset="-120"/>
+              </a:rPr>
+              <a:t>CFM56 work flows from OEMs and airline shops to independents</a:t>
+            </a:r>
+            <a:r>
+              <a:rPr lang="en-US" sz="1050" baseline="30000" dirty="0">
+                <a:solidFill>
+                  <a:srgbClr val="E8702A"/>
+                </a:solidFill>
+                <a:latin typeface="Garamond" pitchFamily="34" charset="0"/>
+                <a:ea typeface="Garamond" pitchFamily="34" charset="-122"/>
+                <a:cs typeface="Garamond" pitchFamily="34" charset="-120"/>
+              </a:rPr>
+              <a:t>1</a:t>
+            </a:r>
+            <a:endParaRPr lang="en-US" sz="1050" dirty="0"/>
+          </a:p>
+        </p:txBody>
+      </p:sp>
+      <p:sp>
+        <p:nvSpPr>
+          <p:cNvPr id="7" name="Text 4"/>
+          <p:cNvSpPr txBox="1"/>
+          <p:nvPr/>
+        </p:nvSpPr>
+        <p:spPr>
+          <a:xfrm>
+            <a:off x="621792" y="2542032"/>
+            <a:ext cx="5486400" cy="896112"/>
           </a:xfrm>
           <a:prstGeom prst="rect">
             <a:avLst/>
@@ -44546,13 +43922,13 @@
           <a:p>
             <a:pPr marL="177800" indent="-177800">
               <a:spcAft>
-                <a:spcPts val="100"/>
+                <a:spcPts val="200"/>
               </a:spcAft>
               <a:buSzPct val="100000"/>
               <a:buChar char="•"/>
             </a:pPr>
             <a:r>
-              <a:rPr lang="en-US" sz="1000" b="1" dirty="0">
+              <a:rPr lang="en-US" sz="1050" b="1" dirty="0">
                 <a:solidFill>
                   <a:srgbClr val="1A1A1A"/>
                 </a:solidFill>
@@ -44563,7 +43939,7 @@
               <a:t>OEMs:</a:t>
             </a:r>
             <a:r>
-              <a:rPr lang="en-US" sz="1000" dirty="0">
+              <a:rPr lang="en-US" sz="1050" dirty="0">
                 <a:solidFill>
                   <a:srgbClr val="1A1A1A"/>
                 </a:solidFill>
@@ -44574,7 +43950,7 @@
               <a:t> all new sites </a:t>
             </a:r>
             <a:r>
-              <a:rPr lang="en-US" sz="1000" u="sng" dirty="0">
+              <a:rPr lang="en-US" sz="1050" u="sng" dirty="0">
                 <a:solidFill>
                   <a:srgbClr val="1A1A1A"/>
                 </a:solidFill>
@@ -44585,7 +43961,7 @@
               <a:t>LEAP-only</a:t>
             </a:r>
             <a:r>
-              <a:rPr lang="en-US" sz="1000" dirty="0">
+              <a:rPr lang="en-US" sz="1050" dirty="0">
                 <a:solidFill>
                   <a:srgbClr val="1A1A1A"/>
                 </a:solidFill>
@@ -44596,7 +43972,7 @@
               <a:t> (Brazil, India, Mexico, Belgium); CFM </a:t>
             </a:r>
             <a:r>
-              <a:rPr lang="en-US" sz="1000" u="sng" dirty="0">
+              <a:rPr lang="en-US" sz="1050" u="sng" dirty="0">
                 <a:solidFill>
                   <a:srgbClr val="1A1A1A"/>
                 </a:solidFill>
@@ -44607,7 +43983,7 @@
               <a:t>gives up Ryanair CFM56 labor from 2029</a:t>
             </a:r>
             <a:r>
-              <a:rPr lang="en-US" sz="1000" dirty="0">
+              <a:rPr lang="en-US" sz="1050" dirty="0">
                 <a:solidFill>
                   <a:srgbClr val="1A1A1A"/>
                 </a:solidFill>
@@ -44617,18 +43993,18 @@
               </a:rPr>
               <a:t> – its largest CFM56 account – keeping only parts</a:t>
             </a:r>
-            <a:endParaRPr lang="en-US" sz="1000" dirty="0"/>
+            <a:endParaRPr lang="en-US" sz="1050" dirty="0"/>
           </a:p>
           <a:p>
             <a:pPr marL="177800" indent="-177800">
               <a:spcAft>
-                <a:spcPts val="100"/>
+                <a:spcPts val="200"/>
               </a:spcAft>
               <a:buSzPct val="100000"/>
               <a:buChar char="•"/>
             </a:pPr>
             <a:r>
-              <a:rPr lang="en-US" sz="1000" b="1" dirty="0">
+              <a:rPr lang="en-US" sz="1050" b="1" dirty="0">
                 <a:solidFill>
                   <a:srgbClr val="1A1A1A"/>
                 </a:solidFill>
@@ -44639,7 +44015,7 @@
               <a:t>First airline flip:</a:t>
             </a:r>
             <a:r>
-              <a:rPr lang="en-US" sz="1000" dirty="0">
+              <a:rPr lang="en-US" sz="1050" dirty="0">
                 <a:solidFill>
                   <a:srgbClr val="1A1A1A"/>
                 </a:solidFill>
@@ -44650,7 +44026,7 @@
               <a:t> Lufthansa Group sends its </a:t>
             </a:r>
             <a:r>
-              <a:rPr lang="en-US" sz="1000" u="sng" dirty="0">
+              <a:rPr lang="en-US" sz="1050" u="sng" dirty="0">
                 <a:solidFill>
                   <a:srgbClr val="1A1A1A"/>
                 </a:solidFill>
@@ -44661,7 +44037,7 @@
               <a:t>own CFM56 to FL Technics</a:t>
             </a:r>
             <a:r>
-              <a:rPr lang="en-US" sz="1000" dirty="0">
+              <a:rPr lang="en-US" sz="1050" dirty="0">
                 <a:solidFill>
                   <a:srgbClr val="1A1A1A"/>
                 </a:solidFill>
@@ -44671,72 +44047,94 @@
               </a:rPr>
               <a:t> (Oct-26) as Hamburg turns LEAP</a:t>
             </a:r>
-            <a:endParaRPr lang="en-US" sz="1000" dirty="0"/>
+            <a:endParaRPr lang="en-US" sz="1050" dirty="0"/>
+          </a:p>
+        </p:txBody>
+      </p:sp>
+      <p:sp>
+        <p:nvSpPr>
+          <p:cNvPr id="8" name="Text 5"/>
+          <p:cNvSpPr txBox="1"/>
+          <p:nvPr/>
+        </p:nvSpPr>
+        <p:spPr>
+          <a:xfrm>
+            <a:off x="6336792" y="2542032"/>
+            <a:ext cx="5486400" cy="896112"/>
+          </a:xfrm>
+          <a:prstGeom prst="rect">
+            <a:avLst/>
+          </a:prstGeom>
+          <a:noFill/>
+          <a:ln/>
+        </p:spPr>
+        <p:txBody>
+          <a:bodyPr wrap="square" lIns="25400" tIns="25400" rIns="25400" bIns="25400" rtlCol="0" anchor="t"/>
+          <a:lstStyle/>
+          <a:p>
+            <a:pPr marL="177800" indent="-177800">
+              <a:spcAft>
+                <a:spcPts val="200"/>
+              </a:spcAft>
+              <a:buSzPct val="100000"/>
+              <a:buChar char="•"/>
+            </a:pPr>
+            <a:r>
+              <a:rPr lang="en-US" sz="1050" b="1" dirty="0">
+                <a:solidFill>
+                  <a:srgbClr val="1A1A1A"/>
+                </a:solidFill>
+                <a:latin typeface="Garamond" pitchFamily="34" charset="0"/>
+                <a:ea typeface="Garamond" pitchFamily="34" charset="-122"/>
+                <a:cs typeface="Garamond" pitchFamily="34" charset="-120"/>
+              </a:rPr>
+              <a:t>Moving to independents:</a:t>
+            </a:r>
+            <a:r>
+              <a:rPr lang="en-US" sz="1050" dirty="0">
+                <a:solidFill>
+                  <a:srgbClr val="1A1A1A"/>
+                </a:solidFill>
+                <a:latin typeface="Garamond" pitchFamily="34" charset="0"/>
+                <a:ea typeface="Garamond" pitchFamily="34" charset="-122"/>
+                <a:cs typeface="Garamond" pitchFamily="34" charset="-120"/>
+              </a:rPr>
+              <a:t> EVA Air → MTU (first non-OEM, May-26); </a:t>
+            </a:r>
+            <a:r>
+              <a:rPr lang="en-US" sz="1050" u="sng" dirty="0">
+                <a:solidFill>
+                  <a:srgbClr val="1A1A1A"/>
+                </a:solidFill>
+                <a:latin typeface="Garamond" pitchFamily="34" charset="0"/>
+                <a:ea typeface="Garamond" pitchFamily="34" charset="-122"/>
+                <a:cs typeface="Garamond" pitchFamily="34" charset="-120"/>
+              </a:rPr>
+              <a:t>United → FTAI</a:t>
+            </a:r>
+            <a:r>
+              <a:rPr lang="en-US" sz="1050" dirty="0">
+                <a:solidFill>
+                  <a:srgbClr val="1A1A1A"/>
+                </a:solidFill>
+                <a:latin typeface="Garamond" pitchFamily="34" charset="0"/>
+                <a:ea typeface="Garamond" pitchFamily="34" charset="-122"/>
+                <a:cs typeface="Garamond" pitchFamily="34" charset="-120"/>
+              </a:rPr>
+              <a:t> CFM56-7B MRE (Oct-26)</a:t>
+            </a:r>
+            <a:endParaRPr lang="en-US" sz="1050" dirty="0"/>
           </a:p>
           <a:p>
             <a:pPr marL="177800" indent="-177800">
               <a:spcAft>
-                <a:spcPts val="100"/>
+                <a:spcPts val="200"/>
               </a:spcAft>
               <a:buSzPct val="100000"/>
               <a:buChar char="•"/>
             </a:pPr>
             <a:r>
-              <a:rPr lang="en-US" sz="1000" b="1" dirty="0">
-                <a:solidFill>
-                  <a:srgbClr val="1A1A1A"/>
-                </a:solidFill>
-                <a:latin typeface="Garamond" pitchFamily="34" charset="0"/>
-                <a:ea typeface="Garamond" pitchFamily="34" charset="-122"/>
-                <a:cs typeface="Garamond" pitchFamily="34" charset="-120"/>
-              </a:rPr>
-              <a:t>Moving to independents:</a:t>
-            </a:r>
-            <a:r>
-              <a:rPr lang="en-US" sz="1000" dirty="0">
-                <a:solidFill>
-                  <a:srgbClr val="1A1A1A"/>
-                </a:solidFill>
-                <a:latin typeface="Garamond" pitchFamily="34" charset="0"/>
-                <a:ea typeface="Garamond" pitchFamily="34" charset="-122"/>
-                <a:cs typeface="Garamond" pitchFamily="34" charset="-120"/>
-              </a:rPr>
-              <a:t> EVA Air → MTU (first non-OEM, May-26); </a:t>
-            </a:r>
-            <a:r>
-              <a:rPr lang="en-US" sz="1000" u="sng" dirty="0">
-                <a:solidFill>
-                  <a:srgbClr val="1A1A1A"/>
-                </a:solidFill>
-                <a:latin typeface="Garamond" pitchFamily="34" charset="0"/>
-                <a:ea typeface="Garamond" pitchFamily="34" charset="-122"/>
-                <a:cs typeface="Garamond" pitchFamily="34" charset="-120"/>
-              </a:rPr>
-              <a:t>United → FTAI</a:t>
-            </a:r>
-            <a:r>
-              <a:rPr lang="en-US" sz="1000" dirty="0">
-                <a:solidFill>
-                  <a:srgbClr val="1A1A1A"/>
-                </a:solidFill>
-                <a:latin typeface="Garamond" pitchFamily="34" charset="0"/>
-                <a:ea typeface="Garamond" pitchFamily="34" charset="-122"/>
-                <a:cs typeface="Garamond" pitchFamily="34" charset="-120"/>
-              </a:rPr>
-              <a:t> CFM56-7B MRE (Oct-26)</a:t>
-            </a:r>
-            <a:endParaRPr lang="en-US" sz="1000" dirty="0"/>
-          </a:p>
-          <a:p>
-            <a:pPr marL="177800" indent="-177800">
-              <a:spcAft>
-                <a:spcPts val="100"/>
-              </a:spcAft>
-              <a:buSzPct val="100000"/>
-              <a:buChar char="•"/>
-            </a:pPr>
-            <a:r>
-              <a:rPr lang="en-US" sz="1000" b="1" dirty="0">
+              <a:rPr lang="en-US" sz="1050" b="1" dirty="0">
                 <a:solidFill>
                   <a:srgbClr val="1A1A1A"/>
                 </a:solidFill>
@@ -44747,7 +44145,7 @@
               <a:t>Counter:</a:t>
             </a:r>
             <a:r>
-              <a:rPr lang="en-US" sz="1000" dirty="0">
+              <a:rPr lang="en-US" sz="1050" dirty="0">
                 <a:solidFill>
                   <a:srgbClr val="1A1A1A"/>
                 </a:solidFill>
@@ -44758,7 +44156,7 @@
               <a:t> Korean Air keeps CFM56, outsources LEAP; independents add CFM56 too – </a:t>
             </a:r>
             <a:r>
-              <a:rPr lang="en-US" sz="1000" u="sng" dirty="0">
+              <a:rPr lang="en-US" sz="1050" u="sng" dirty="0">
                 <a:solidFill>
                   <a:srgbClr val="1A1A1A"/>
                 </a:solidFill>
@@ -44768,13 +44166,13 @@
               </a:rPr>
               <a:t>overflow is real, but contested</a:t>
             </a:r>
-            <a:endParaRPr lang="en-US" sz="1000" dirty="0"/>
+            <a:endParaRPr lang="en-US" sz="1050" dirty="0"/>
           </a:p>
         </p:txBody>
       </p:sp>
       <p:sp>
         <p:nvSpPr>
-          <p:cNvPr id="51" name="Text 48"/>
+          <p:cNvPr id="9" name="Text 6"/>
           <p:cNvSpPr txBox="1"/>
           <p:nvPr/>
         </p:nvSpPr>
@@ -44813,7 +44211,7 @@
       </p:sp>
       <p:sp>
         <p:nvSpPr>
-          <p:cNvPr id="52" name="Shape 49"/>
+          <p:cNvPr id="10" name="Shape 7"/>
           <p:cNvSpPr/>
           <p:nvPr/>
         </p:nvSpPr>
@@ -44836,7 +44234,7 @@
       </p:sp>
       <p:graphicFrame>
         <p:nvGraphicFramePr>
-          <p:cNvPr id="53" name="Chart 0" descr=""/>
+          <p:cNvPr id="11" name="Chart 0" descr=""/>
           <p:cNvGraphicFramePr/>
           <p:nvPr/>
         </p:nvGraphicFramePr>
@@ -44852,7 +44250,7 @@
       </p:graphicFrame>
       <p:graphicFrame>
         <p:nvGraphicFramePr>
-          <p:cNvPr id="54" name="Chart 1" descr=""/>
+          <p:cNvPr id="12" name="Chart 1" descr=""/>
           <p:cNvGraphicFramePr/>
           <p:nvPr/>
         </p:nvGraphicFramePr>
@@ -44868,7 +44266,7 @@
       </p:graphicFrame>
       <p:sp>
         <p:nvSpPr>
-          <p:cNvPr id="55" name="Shape 50"/>
+          <p:cNvPr id="13" name="Shape 8"/>
           <p:cNvSpPr/>
           <p:nvPr/>
         </p:nvSpPr>
@@ -44891,7 +44289,7 @@
       </p:sp>
       <p:sp>
         <p:nvSpPr>
-          <p:cNvPr id="56" name="Text 51"/>
+          <p:cNvPr id="14" name="Text 9"/>
           <p:cNvSpPr txBox="1"/>
           <p:nvPr/>
         </p:nvSpPr>
@@ -44959,7 +44357,7 @@
                 <a:ea typeface="Garamond" pitchFamily="34" charset="-122"/>
                 <a:cs typeface="Garamond" pitchFamily="34" charset="-120"/>
               </a:rPr>
-              <a:t> on CFM56</a:t>
+              <a:t> on CFM56; Q1 retirements &lt;1%</a:t>
             </a:r>
             <a:endParaRPr lang="en-US" sz="1050" dirty="0"/>
           </a:p>
@@ -45118,7 +44516,7 @@
       </p:sp>
       <p:sp>
         <p:nvSpPr>
-          <p:cNvPr id="57" name="Shape 52"/>
+          <p:cNvPr id="15" name="Shape 10"/>
           <p:cNvSpPr/>
           <p:nvPr/>
         </p:nvSpPr>
@@ -45143,7 +44541,7 @@
       </p:sp>
       <p:sp>
         <p:nvSpPr>
-          <p:cNvPr id="58" name="Text 53"/>
+          <p:cNvPr id="16" name="Text 11"/>
           <p:cNvSpPr txBox="1"/>
           <p:nvPr/>
         </p:nvSpPr>
@@ -45207,7 +44605,7 @@
       </p:sp>
       <p:sp>
         <p:nvSpPr>
-          <p:cNvPr id="59" name="Shape 54"/>
+          <p:cNvPr id="17" name="Shape 12"/>
           <p:cNvSpPr/>
           <p:nvPr/>
         </p:nvSpPr>
@@ -45232,7 +44630,7 @@
       </p:sp>
       <p:sp>
         <p:nvSpPr>
-          <p:cNvPr id="60" name="Text 55"/>
+          <p:cNvPr id="18" name="Text 13"/>
           <p:cNvSpPr txBox="1"/>
           <p:nvPr/>
         </p:nvSpPr>
@@ -45271,7 +44669,7 @@
       </p:sp>
       <p:sp>
         <p:nvSpPr>
-          <p:cNvPr id="61" name="Text 56"/>
+          <p:cNvPr id="19" name="Text 14"/>
           <p:cNvSpPr txBox="1"/>
           <p:nvPr/>
         </p:nvSpPr>
@@ -45310,7 +44708,7 @@
       </p:sp>
       <p:sp>
         <p:nvSpPr>
-          <p:cNvPr id="62" name="Text 57"/>
+          <p:cNvPr id="20" name="Text 15"/>
           <p:cNvSpPr txBox="1"/>
           <p:nvPr/>
         </p:nvSpPr>

</xml_diff>

<commit_message>
Restore CFM56 positioning map on Thesis II slide 1 as an embedded image
Map (OEM / airline / independent / overflow receiver by CFM56 stance)
is drawn from SVG and placed as one PNG so it renders identically in
any viewer; counts table and flip bullets back on the right.

Co-Authored-By: Claude Opus 5.5 <noreply@anthropic.com>
Claude-Session: https://claude.ai/code/session_01UfcjrwVkNc9oEPnjB82u2w
</commit_message>
<xml_diff>
--- a/ftai_pitch/FTAI_Long_Pitch.pptx
+++ b/ftai_pitch/FTAI_Long_Pitch.pptx
@@ -41711,6 +41711,53 @@
           </a:ln>
         </p:spPr>
       </p:sp>
+      <p:pic>
+        <p:nvPicPr>
+          <p:cNvPr id="5" name="Image 0" descr="/tmp/claude-0/-home-user-SPOT/35e892d7-e78e-5f3a-b423-61b3cc9e48e5/scratchpad/build/cfm56_map.png">    </p:cNvPr>
+          <p:cNvPicPr>
+            <a:picLocks noChangeAspect="1"/>
+          </p:cNvPicPr>
+          <p:nvPr/>
+        </p:nvPicPr>
+        <p:blipFill>
+          <a:blip r:embed="rId1"/>
+          <a:stretch>
+            <a:fillRect/>
+          </a:stretch>
+        </p:blipFill>
+        <p:spPr>
+          <a:xfrm>
+            <a:off x="621792" y="1143000"/>
+            <a:ext cx="5806440" cy="2286000"/>
+          </a:xfrm>
+          <a:prstGeom prst="rect">
+            <a:avLst/>
+          </a:prstGeom>
+        </p:spPr>
+      </p:pic>
+      <p:sp>
+        <p:nvSpPr>
+          <p:cNvPr id="6" name="Shape 3"/>
+          <p:cNvSpPr/>
+          <p:nvPr/>
+        </p:nvSpPr>
+        <p:spPr>
+          <a:xfrm>
+            <a:off x="6455664" y="1188720"/>
+            <a:ext cx="0" cy="2240280"/>
+          </a:xfrm>
+          <a:prstGeom prst="line">
+            <a:avLst/>
+          </a:prstGeom>
+          <a:noFill/>
+          <a:ln w="12700">
+            <a:solidFill>
+              <a:srgbClr val="1A1A1A"/>
+            </a:solidFill>
+            <a:prstDash val="sysDot"/>
+          </a:ln>
+        </p:spPr>
+      </p:sp>
       <p:graphicFrame>
         <p:nvGraphicFramePr>
           <p:cNvPr id="9" name="Table 0"/>
@@ -41726,24 +41773,21 @@
           </p:nvPr>
         </p:nvGraphicFramePr>
         <p:xfrm>
-          <a:off x="621792" y="1152144"/>
-          <a:ext cx="11201400" cy="914400"/>
+          <a:off x="6565392" y="1170432"/>
+          <a:ext cx="5257800" cy="914400"/>
         </p:xfrm>
         <a:graphic>
           <a:graphicData uri="http://schemas.openxmlformats.org/drawingml/2006/table">
             <a:tbl>
               <a:tblPr/>
               <a:tblGrid>
-                <a:gridCol w="1234440"/>
-                <a:gridCol w="685800"/>
-                <a:gridCol w="685800"/>
-                <a:gridCol w="685800"/>
-                <a:gridCol w="731520"/>
-                <a:gridCol w="1874520"/>
-                <a:gridCol w="2743200"/>
-                <a:gridCol w="2560320"/>
+                <a:gridCol w="1325880"/>
+                <a:gridCol w="777240"/>
+                <a:gridCol w="914400"/>
+                <a:gridCol w="1188720"/>
+                <a:gridCol w="1051560"/>
               </a:tblGrid>
-              <a:tr h="274320">
+              <a:tr h="201168">
                 <a:tc>
                   <a:txBody>
                     <a:bodyPr/>
@@ -41965,7 +42009,7 @@
                           <a:ea typeface="Garamond" pitchFamily="34" charset="-122"/>
                           <a:cs typeface="Garamond" pitchFamily="34" charset="-120"/>
                         </a:rPr>
-                        <a:t>Pull back</a:t>
+                        <a:t>Pull back CFM56</a:t>
                       </a:r>
                       <a:endParaRPr lang="en-US" sz="950" dirty="0">
                         <a:latin typeface="Garamond" charset="0"/>
@@ -42033,7 +42077,7 @@
                           <a:ea typeface="Garamond" pitchFamily="34" charset="-122"/>
                           <a:cs typeface="Garamond" pitchFamily="34" charset="-120"/>
                         </a:rPr>
-                        <a:t>Win CFM56</a:t>
+                        <a:t>Win CFM56 work</a:t>
                       </a:r>
                       <a:endParaRPr lang="en-US" sz="950" dirty="0">
                         <a:latin typeface="Garamond" charset="0"/>
@@ -42084,212 +42128,8 @@
                     </a:solidFill>
                   </a:tcPr>
                 </a:tc>
-                <a:tc>
-                  <a:txBody>
-                    <a:bodyPr/>
-                    <a:lstStyle/>
-                    <a:p>
-                      <a:pPr algn="ctr" indent="0" marL="0">
-                        <a:buNone/>
-                      </a:pPr>
-                      <a:r>
-                        <a:rPr lang="en-US" sz="950" b="1" dirty="0">
-                          <a:solidFill>
-                            <a:srgbClr val="FFFFFF"/>
-                          </a:solidFill>
-                          <a:latin typeface="Garamond" pitchFamily="34" charset="0"/>
-                          <a:ea typeface="Garamond" pitchFamily="34" charset="-122"/>
-                          <a:cs typeface="Garamond" pitchFamily="34" charset="-120"/>
-                        </a:rPr>
-                        <a:t>Pulling back on CFM56</a:t>
-                      </a:r>
-                      <a:endParaRPr lang="en-US" sz="950" dirty="0">
-                        <a:latin typeface="Garamond" charset="0"/>
-                        <a:ea typeface="Garamond" charset="0"/>
-                        <a:cs typeface="Garamond" charset="0"/>
-                      </a:endParaRPr>
-                    </a:p>
-                  </a:txBody>
-                  <a:tcPr marL="38100" marR="38100" marT="12700" marB="12700">
-                    <a:lnL w="6350" cap="flat" cmpd="sng" algn="ctr">
-                      <a:solidFill>
-                        <a:srgbClr val="BFBFBF"/>
-                      </a:solidFill>
-                      <a:prstDash val="solid"/>
-                      <a:round/>
-                      <a:headEnd type="none" w="med" len="med"/>
-                      <a:tailEnd type="none" w="med" len="med"/>
-                    </a:lnL>
-                    <a:lnR w="6350" cap="flat" cmpd="sng" algn="ctr">
-                      <a:solidFill>
-                        <a:srgbClr val="BFBFBF"/>
-                      </a:solidFill>
-                      <a:prstDash val="solid"/>
-                      <a:round/>
-                      <a:headEnd type="none" w="med" len="med"/>
-                      <a:tailEnd type="none" w="med" len="med"/>
-                    </a:lnR>
-                    <a:lnT w="6350" cap="flat" cmpd="sng" algn="ctr">
-                      <a:solidFill>
-                        <a:srgbClr val="BFBFBF"/>
-                      </a:solidFill>
-                      <a:prstDash val="solid"/>
-                      <a:round/>
-                      <a:headEnd type="none" w="med" len="med"/>
-                      <a:tailEnd type="none" w="med" len="med"/>
-                    </a:lnT>
-                    <a:lnB w="6350" cap="flat" cmpd="sng" algn="ctr">
-                      <a:solidFill>
-                        <a:srgbClr val="BFBFBF"/>
-                      </a:solidFill>
-                      <a:prstDash val="solid"/>
-                      <a:round/>
-                      <a:headEnd type="none" w="med" len="med"/>
-                      <a:tailEnd type="none" w="med" len="med"/>
-                    </a:lnB>
-                    <a:solidFill>
-                      <a:srgbClr val="1F3864"/>
-                    </a:solidFill>
-                  </a:tcPr>
-                </a:tc>
-                <a:tc>
-                  <a:txBody>
-                    <a:bodyPr/>
-                    <a:lstStyle/>
-                    <a:p>
-                      <a:pPr algn="ctr" indent="0" marL="0">
-                        <a:buNone/>
-                      </a:pPr>
-                      <a:r>
-                        <a:rPr lang="en-US" sz="950" b="1" dirty="0">
-                          <a:solidFill>
-                            <a:srgbClr val="FFFFFF"/>
-                          </a:solidFill>
-                          <a:latin typeface="Garamond" pitchFamily="34" charset="0"/>
-                          <a:ea typeface="Garamond" pitchFamily="34" charset="-122"/>
-                          <a:cs typeface="Garamond" pitchFamily="34" charset="-120"/>
-                        </a:rPr>
-                        <a:t>Holding CFM56</a:t>
-                      </a:r>
-                      <a:endParaRPr lang="en-US" sz="950" dirty="0">
-                        <a:latin typeface="Garamond" charset="0"/>
-                        <a:ea typeface="Garamond" charset="0"/>
-                        <a:cs typeface="Garamond" charset="0"/>
-                      </a:endParaRPr>
-                    </a:p>
-                  </a:txBody>
-                  <a:tcPr marL="38100" marR="38100" marT="12700" marB="12700">
-                    <a:lnL w="6350" cap="flat" cmpd="sng" algn="ctr">
-                      <a:solidFill>
-                        <a:srgbClr val="BFBFBF"/>
-                      </a:solidFill>
-                      <a:prstDash val="solid"/>
-                      <a:round/>
-                      <a:headEnd type="none" w="med" len="med"/>
-                      <a:tailEnd type="none" w="med" len="med"/>
-                    </a:lnL>
-                    <a:lnR w="6350" cap="flat" cmpd="sng" algn="ctr">
-                      <a:solidFill>
-                        <a:srgbClr val="BFBFBF"/>
-                      </a:solidFill>
-                      <a:prstDash val="solid"/>
-                      <a:round/>
-                      <a:headEnd type="none" w="med" len="med"/>
-                      <a:tailEnd type="none" w="med" len="med"/>
-                    </a:lnR>
-                    <a:lnT w="6350" cap="flat" cmpd="sng" algn="ctr">
-                      <a:solidFill>
-                        <a:srgbClr val="BFBFBF"/>
-                      </a:solidFill>
-                      <a:prstDash val="solid"/>
-                      <a:round/>
-                      <a:headEnd type="none" w="med" len="med"/>
-                      <a:tailEnd type="none" w="med" len="med"/>
-                    </a:lnT>
-                    <a:lnB w="6350" cap="flat" cmpd="sng" algn="ctr">
-                      <a:solidFill>
-                        <a:srgbClr val="BFBFBF"/>
-                      </a:solidFill>
-                      <a:prstDash val="solid"/>
-                      <a:round/>
-                      <a:headEnd type="none" w="med" len="med"/>
-                      <a:tailEnd type="none" w="med" len="med"/>
-                    </a:lnB>
-                    <a:solidFill>
-                      <a:srgbClr val="1F3864"/>
-                    </a:solidFill>
-                  </a:tcPr>
-                </a:tc>
-                <a:tc>
-                  <a:txBody>
-                    <a:bodyPr/>
-                    <a:lstStyle/>
-                    <a:p>
-                      <a:pPr algn="ctr" indent="0" marL="0">
-                        <a:buNone/>
-                      </a:pPr>
-                      <a:r>
-                        <a:rPr lang="en-US" sz="950" b="1" dirty="0">
-                          <a:solidFill>
-                            <a:srgbClr val="FFFFFF"/>
-                          </a:solidFill>
-                          <a:latin typeface="Garamond" pitchFamily="34" charset="0"/>
-                          <a:ea typeface="Garamond" pitchFamily="34" charset="-122"/>
-                          <a:cs typeface="Garamond" pitchFamily="34" charset="-120"/>
-                        </a:rPr>
-                        <a:t>Adding CFM56</a:t>
-                      </a:r>
-                      <a:endParaRPr lang="en-US" sz="950" dirty="0">
-                        <a:latin typeface="Garamond" charset="0"/>
-                        <a:ea typeface="Garamond" charset="0"/>
-                        <a:cs typeface="Garamond" charset="0"/>
-                      </a:endParaRPr>
-                    </a:p>
-                  </a:txBody>
-                  <a:tcPr marL="38100" marR="38100" marT="12700" marB="12700">
-                    <a:lnL w="6350" cap="flat" cmpd="sng" algn="ctr">
-                      <a:solidFill>
-                        <a:srgbClr val="BFBFBF"/>
-                      </a:solidFill>
-                      <a:prstDash val="solid"/>
-                      <a:round/>
-                      <a:headEnd type="none" w="med" len="med"/>
-                      <a:tailEnd type="none" w="med" len="med"/>
-                    </a:lnL>
-                    <a:lnR w="6350" cap="flat" cmpd="sng" algn="ctr">
-                      <a:solidFill>
-                        <a:srgbClr val="BFBFBF"/>
-                      </a:solidFill>
-                      <a:prstDash val="solid"/>
-                      <a:round/>
-                      <a:headEnd type="none" w="med" len="med"/>
-                      <a:tailEnd type="none" w="med" len="med"/>
-                    </a:lnR>
-                    <a:lnT w="6350" cap="flat" cmpd="sng" algn="ctr">
-                      <a:solidFill>
-                        <a:srgbClr val="BFBFBF"/>
-                      </a:solidFill>
-                      <a:prstDash val="solid"/>
-                      <a:round/>
-                      <a:headEnd type="none" w="med" len="med"/>
-                      <a:tailEnd type="none" w="med" len="med"/>
-                    </a:lnT>
-                    <a:lnB w="6350" cap="flat" cmpd="sng" algn="ctr">
-                      <a:solidFill>
-                        <a:srgbClr val="BFBFBF"/>
-                      </a:solidFill>
-                      <a:prstDash val="solid"/>
-                      <a:round/>
-                      <a:headEnd type="none" w="med" len="med"/>
-                      <a:tailEnd type="none" w="med" len="med"/>
-                    </a:lnB>
-                    <a:solidFill>
-                      <a:srgbClr val="1F3864"/>
-                    </a:solidFill>
-                  </a:tcPr>
-                </a:tc>
               </a:tr>
-              <a:tr h="274320">
+              <a:tr h="201168">
                 <a:tc>
                   <a:txBody>
                     <a:bodyPr/>
@@ -42299,7 +42139,7 @@
                         <a:buNone/>
                       </a:pPr>
                       <a:r>
-                        <a:rPr lang="en-US" sz="950" b="1" dirty="0">
+                        <a:rPr lang="en-US" sz="950" dirty="0">
                           <a:solidFill>
                             <a:srgbClr val="1A1A1A"/>
                           </a:solidFill>
@@ -42307,7 +42147,7 @@
                           <a:ea typeface="Garamond" pitchFamily="34" charset="-122"/>
                           <a:cs typeface="Garamond" pitchFamily="34" charset="-120"/>
                         </a:rPr>
-                        <a:t>OEM network</a:t>
+                        <a:t>Airline-owned</a:t>
                       </a:r>
                       <a:endParaRPr lang="en-US" sz="1200" dirty="0"/>
                     </a:p>
@@ -42371,7 +42211,7 @@
                           <a:ea typeface="Garamond" pitchFamily="34" charset="-122"/>
                           <a:cs typeface="Garamond" pitchFamily="34" charset="-120"/>
                         </a:rPr>
-                        <a:t>2</a:t>
+                        <a:t>8</a:t>
                       </a:r>
                       <a:endParaRPr lang="en-US" sz="1200" dirty="0"/>
                     </a:p>
@@ -42435,7 +42275,7 @@
                           <a:ea typeface="Garamond" pitchFamily="34" charset="-122"/>
                           <a:cs typeface="Garamond" pitchFamily="34" charset="-120"/>
                         </a:rPr>
-                        <a:t>2</a:t>
+                        <a:t>8</a:t>
                       </a:r>
                       <a:endParaRPr lang="en-US" sz="1200" dirty="0"/>
                     </a:p>
@@ -42563,7 +42403,395 @@
                           <a:ea typeface="Garamond" pitchFamily="34" charset="-122"/>
                           <a:cs typeface="Garamond" pitchFamily="34" charset="-120"/>
                         </a:rPr>
+                        <a:t>3</a:t>
+                      </a:r>
+                      <a:endParaRPr lang="en-US" sz="1200" dirty="0"/>
+                    </a:p>
+                  </a:txBody>
+                  <a:tcPr marL="38100" marR="38100" marT="12700" marB="12700">
+                    <a:lnL w="6350" cap="flat" cmpd="sng" algn="ctr">
+                      <a:solidFill>
+                        <a:srgbClr val="BFBFBF"/>
+                      </a:solidFill>
+                      <a:prstDash val="solid"/>
+                      <a:round/>
+                      <a:headEnd type="none" w="med" len="med"/>
+                      <a:tailEnd type="none" w="med" len="med"/>
+                    </a:lnL>
+                    <a:lnR w="6350" cap="flat" cmpd="sng" algn="ctr">
+                      <a:solidFill>
+                        <a:srgbClr val="BFBFBF"/>
+                      </a:solidFill>
+                      <a:prstDash val="solid"/>
+                      <a:round/>
+                      <a:headEnd type="none" w="med" len="med"/>
+                      <a:tailEnd type="none" w="med" len="med"/>
+                    </a:lnR>
+                    <a:lnT w="6350" cap="flat" cmpd="sng" algn="ctr">
+                      <a:solidFill>
+                        <a:srgbClr val="BFBFBF"/>
+                      </a:solidFill>
+                      <a:prstDash val="solid"/>
+                      <a:round/>
+                      <a:headEnd type="none" w="med" len="med"/>
+                      <a:tailEnd type="none" w="med" len="med"/>
+                    </a:lnT>
+                    <a:lnB w="6350" cap="flat" cmpd="sng" algn="ctr">
+                      <a:solidFill>
+                        <a:srgbClr val="BFBFBF"/>
+                      </a:solidFill>
+                      <a:prstDash val="solid"/>
+                      <a:round/>
+                      <a:headEnd type="none" w="med" len="med"/>
+                      <a:tailEnd type="none" w="med" len="med"/>
+                    </a:lnB>
+                    <a:solidFill>
+                      <a:srgbClr val="FFFFFF"/>
+                    </a:solidFill>
+                  </a:tcPr>
+                </a:tc>
+              </a:tr>
+              <a:tr h="201168">
+                <a:tc>
+                  <a:txBody>
+                    <a:bodyPr/>
+                    <a:lstStyle/>
+                    <a:p>
+                      <a:pPr algn="l" indent="0" marL="0">
+                        <a:buNone/>
+                      </a:pPr>
+                      <a:r>
+                        <a:rPr lang="en-US" sz="950" dirty="0">
+                          <a:solidFill>
+                            <a:srgbClr val="1A1A1A"/>
+                          </a:solidFill>
+                          <a:latin typeface="Garamond" pitchFamily="34" charset="0"/>
+                          <a:ea typeface="Garamond" pitchFamily="34" charset="-122"/>
+                          <a:cs typeface="Garamond" pitchFamily="34" charset="-120"/>
+                        </a:rPr>
+                        <a:t>OEM network</a:t>
+                      </a:r>
+                      <a:endParaRPr lang="en-US" sz="1200" dirty="0"/>
+                    </a:p>
+                  </a:txBody>
+                  <a:tcPr marL="38100" marR="38100" marT="12700" marB="12700">
+                    <a:lnL w="6350" cap="flat" cmpd="sng" algn="ctr">
+                      <a:solidFill>
+                        <a:srgbClr val="BFBFBF"/>
+                      </a:solidFill>
+                      <a:prstDash val="solid"/>
+                      <a:round/>
+                      <a:headEnd type="none" w="med" len="med"/>
+                      <a:tailEnd type="none" w="med" len="med"/>
+                    </a:lnL>
+                    <a:lnR w="6350" cap="flat" cmpd="sng" algn="ctr">
+                      <a:solidFill>
+                        <a:srgbClr val="BFBFBF"/>
+                      </a:solidFill>
+                      <a:prstDash val="solid"/>
+                      <a:round/>
+                      <a:headEnd type="none" w="med" len="med"/>
+                      <a:tailEnd type="none" w="med" len="med"/>
+                    </a:lnR>
+                    <a:lnT w="6350" cap="flat" cmpd="sng" algn="ctr">
+                      <a:solidFill>
+                        <a:srgbClr val="BFBFBF"/>
+                      </a:solidFill>
+                      <a:prstDash val="solid"/>
+                      <a:round/>
+                      <a:headEnd type="none" w="med" len="med"/>
+                      <a:tailEnd type="none" w="med" len="med"/>
+                    </a:lnT>
+                    <a:lnB w="6350" cap="flat" cmpd="sng" algn="ctr">
+                      <a:solidFill>
+                        <a:srgbClr val="BFBFBF"/>
+                      </a:solidFill>
+                      <a:prstDash val="solid"/>
+                      <a:round/>
+                      <a:headEnd type="none" w="med" len="med"/>
+                      <a:tailEnd type="none" w="med" len="med"/>
+                    </a:lnB>
+                    <a:solidFill>
+                      <a:srgbClr val="F2F2F2"/>
+                    </a:solidFill>
+                  </a:tcPr>
+                </a:tc>
+                <a:tc>
+                  <a:txBody>
+                    <a:bodyPr/>
+                    <a:lstStyle/>
+                    <a:p>
+                      <a:pPr algn="ctr" indent="0" marL="0">
+                        <a:buNone/>
+                      </a:pPr>
+                      <a:r>
+                        <a:rPr lang="en-US" sz="950" dirty="0">
+                          <a:solidFill>
+                            <a:srgbClr val="1A1A1A"/>
+                          </a:solidFill>
+                          <a:latin typeface="Garamond" pitchFamily="34" charset="0"/>
+                          <a:ea typeface="Garamond" pitchFamily="34" charset="-122"/>
+                          <a:cs typeface="Garamond" pitchFamily="34" charset="-120"/>
+                        </a:rPr>
                         <a:t>2</a:t>
+                      </a:r>
+                      <a:endParaRPr lang="en-US" sz="1200" dirty="0"/>
+                    </a:p>
+                  </a:txBody>
+                  <a:tcPr marL="38100" marR="38100" marT="12700" marB="12700">
+                    <a:lnL w="6350" cap="flat" cmpd="sng" algn="ctr">
+                      <a:solidFill>
+                        <a:srgbClr val="BFBFBF"/>
+                      </a:solidFill>
+                      <a:prstDash val="solid"/>
+                      <a:round/>
+                      <a:headEnd type="none" w="med" len="med"/>
+                      <a:tailEnd type="none" w="med" len="med"/>
+                    </a:lnL>
+                    <a:lnR w="6350" cap="flat" cmpd="sng" algn="ctr">
+                      <a:solidFill>
+                        <a:srgbClr val="BFBFBF"/>
+                      </a:solidFill>
+                      <a:prstDash val="solid"/>
+                      <a:round/>
+                      <a:headEnd type="none" w="med" len="med"/>
+                      <a:tailEnd type="none" w="med" len="med"/>
+                    </a:lnR>
+                    <a:lnT w="6350" cap="flat" cmpd="sng" algn="ctr">
+                      <a:solidFill>
+                        <a:srgbClr val="BFBFBF"/>
+                      </a:solidFill>
+                      <a:prstDash val="solid"/>
+                      <a:round/>
+                      <a:headEnd type="none" w="med" len="med"/>
+                      <a:tailEnd type="none" w="med" len="med"/>
+                    </a:lnT>
+                    <a:lnB w="6350" cap="flat" cmpd="sng" algn="ctr">
+                      <a:solidFill>
+                        <a:srgbClr val="BFBFBF"/>
+                      </a:solidFill>
+                      <a:prstDash val="solid"/>
+                      <a:round/>
+                      <a:headEnd type="none" w="med" len="med"/>
+                      <a:tailEnd type="none" w="med" len="med"/>
+                    </a:lnB>
+                    <a:solidFill>
+                      <a:srgbClr val="F2F2F2"/>
+                    </a:solidFill>
+                  </a:tcPr>
+                </a:tc>
+                <a:tc>
+                  <a:txBody>
+                    <a:bodyPr/>
+                    <a:lstStyle/>
+                    <a:p>
+                      <a:pPr algn="ctr" indent="0" marL="0">
+                        <a:buNone/>
+                      </a:pPr>
+                      <a:r>
+                        <a:rPr lang="en-US" sz="950" dirty="0">
+                          <a:solidFill>
+                            <a:srgbClr val="1A1A1A"/>
+                          </a:solidFill>
+                          <a:latin typeface="Garamond" pitchFamily="34" charset="0"/>
+                          <a:ea typeface="Garamond" pitchFamily="34" charset="-122"/>
+                          <a:cs typeface="Garamond" pitchFamily="34" charset="-120"/>
+                        </a:rPr>
+                        <a:t>2</a:t>
+                      </a:r>
+                      <a:endParaRPr lang="en-US" sz="1200" dirty="0"/>
+                    </a:p>
+                  </a:txBody>
+                  <a:tcPr marL="38100" marR="38100" marT="12700" marB="12700">
+                    <a:lnL w="6350" cap="flat" cmpd="sng" algn="ctr">
+                      <a:solidFill>
+                        <a:srgbClr val="BFBFBF"/>
+                      </a:solidFill>
+                      <a:prstDash val="solid"/>
+                      <a:round/>
+                      <a:headEnd type="none" w="med" len="med"/>
+                      <a:tailEnd type="none" w="med" len="med"/>
+                    </a:lnL>
+                    <a:lnR w="6350" cap="flat" cmpd="sng" algn="ctr">
+                      <a:solidFill>
+                        <a:srgbClr val="BFBFBF"/>
+                      </a:solidFill>
+                      <a:prstDash val="solid"/>
+                      <a:round/>
+                      <a:headEnd type="none" w="med" len="med"/>
+                      <a:tailEnd type="none" w="med" len="med"/>
+                    </a:lnR>
+                    <a:lnT w="6350" cap="flat" cmpd="sng" algn="ctr">
+                      <a:solidFill>
+                        <a:srgbClr val="BFBFBF"/>
+                      </a:solidFill>
+                      <a:prstDash val="solid"/>
+                      <a:round/>
+                      <a:headEnd type="none" w="med" len="med"/>
+                      <a:tailEnd type="none" w="med" len="med"/>
+                    </a:lnT>
+                    <a:lnB w="6350" cap="flat" cmpd="sng" algn="ctr">
+                      <a:solidFill>
+                        <a:srgbClr val="BFBFBF"/>
+                      </a:solidFill>
+                      <a:prstDash val="solid"/>
+                      <a:round/>
+                      <a:headEnd type="none" w="med" len="med"/>
+                      <a:tailEnd type="none" w="med" len="med"/>
+                    </a:lnB>
+                    <a:solidFill>
+                      <a:srgbClr val="F2F2F2"/>
+                    </a:solidFill>
+                  </a:tcPr>
+                </a:tc>
+                <a:tc>
+                  <a:txBody>
+                    <a:bodyPr/>
+                    <a:lstStyle/>
+                    <a:p>
+                      <a:pPr algn="ctr" indent="0" marL="0">
+                        <a:buNone/>
+                      </a:pPr>
+                      <a:r>
+                        <a:rPr lang="en-US" sz="950" dirty="0">
+                          <a:solidFill>
+                            <a:srgbClr val="1A1A1A"/>
+                          </a:solidFill>
+                          <a:latin typeface="Garamond" pitchFamily="34" charset="0"/>
+                          <a:ea typeface="Garamond" pitchFamily="34" charset="-122"/>
+                          <a:cs typeface="Garamond" pitchFamily="34" charset="-120"/>
+                        </a:rPr>
+                        <a:t>1</a:t>
+                      </a:r>
+                      <a:endParaRPr lang="en-US" sz="1200" dirty="0"/>
+                    </a:p>
+                  </a:txBody>
+                  <a:tcPr marL="38100" marR="38100" marT="12700" marB="12700">
+                    <a:lnL w="6350" cap="flat" cmpd="sng" algn="ctr">
+                      <a:solidFill>
+                        <a:srgbClr val="BFBFBF"/>
+                      </a:solidFill>
+                      <a:prstDash val="solid"/>
+                      <a:round/>
+                      <a:headEnd type="none" w="med" len="med"/>
+                      <a:tailEnd type="none" w="med" len="med"/>
+                    </a:lnL>
+                    <a:lnR w="6350" cap="flat" cmpd="sng" algn="ctr">
+                      <a:solidFill>
+                        <a:srgbClr val="BFBFBF"/>
+                      </a:solidFill>
+                      <a:prstDash val="solid"/>
+                      <a:round/>
+                      <a:headEnd type="none" w="med" len="med"/>
+                      <a:tailEnd type="none" w="med" len="med"/>
+                    </a:lnR>
+                    <a:lnT w="6350" cap="flat" cmpd="sng" algn="ctr">
+                      <a:solidFill>
+                        <a:srgbClr val="BFBFBF"/>
+                      </a:solidFill>
+                      <a:prstDash val="solid"/>
+                      <a:round/>
+                      <a:headEnd type="none" w="med" len="med"/>
+                      <a:tailEnd type="none" w="med" len="med"/>
+                    </a:lnT>
+                    <a:lnB w="6350" cap="flat" cmpd="sng" algn="ctr">
+                      <a:solidFill>
+                        <a:srgbClr val="BFBFBF"/>
+                      </a:solidFill>
+                      <a:prstDash val="solid"/>
+                      <a:round/>
+                      <a:headEnd type="none" w="med" len="med"/>
+                      <a:tailEnd type="none" w="med" len="med"/>
+                    </a:lnB>
+                    <a:solidFill>
+                      <a:srgbClr val="F2F2F2"/>
+                    </a:solidFill>
+                  </a:tcPr>
+                </a:tc>
+                <a:tc>
+                  <a:txBody>
+                    <a:bodyPr/>
+                    <a:lstStyle/>
+                    <a:p>
+                      <a:pPr algn="ctr" indent="0" marL="0">
+                        <a:buNone/>
+                      </a:pPr>
+                      <a:r>
+                        <a:rPr lang="en-US" sz="950" dirty="0">
+                          <a:solidFill>
+                            <a:srgbClr val="1A1A1A"/>
+                          </a:solidFill>
+                          <a:latin typeface="Garamond" pitchFamily="34" charset="0"/>
+                          <a:ea typeface="Garamond" pitchFamily="34" charset="-122"/>
+                          <a:cs typeface="Garamond" pitchFamily="34" charset="-120"/>
+                        </a:rPr>
+                        <a:t>2</a:t>
+                      </a:r>
+                      <a:endParaRPr lang="en-US" sz="1200" dirty="0"/>
+                    </a:p>
+                  </a:txBody>
+                  <a:tcPr marL="38100" marR="38100" marT="12700" marB="12700">
+                    <a:lnL w="6350" cap="flat" cmpd="sng" algn="ctr">
+                      <a:solidFill>
+                        <a:srgbClr val="BFBFBF"/>
+                      </a:solidFill>
+                      <a:prstDash val="solid"/>
+                      <a:round/>
+                      <a:headEnd type="none" w="med" len="med"/>
+                      <a:tailEnd type="none" w="med" len="med"/>
+                    </a:lnL>
+                    <a:lnR w="6350" cap="flat" cmpd="sng" algn="ctr">
+                      <a:solidFill>
+                        <a:srgbClr val="BFBFBF"/>
+                      </a:solidFill>
+                      <a:prstDash val="solid"/>
+                      <a:round/>
+                      <a:headEnd type="none" w="med" len="med"/>
+                      <a:tailEnd type="none" w="med" len="med"/>
+                    </a:lnR>
+                    <a:lnT w="6350" cap="flat" cmpd="sng" algn="ctr">
+                      <a:solidFill>
+                        <a:srgbClr val="BFBFBF"/>
+                      </a:solidFill>
+                      <a:prstDash val="solid"/>
+                      <a:round/>
+                      <a:headEnd type="none" w="med" len="med"/>
+                      <a:tailEnd type="none" w="med" len="med"/>
+                    </a:lnT>
+                    <a:lnB w="6350" cap="flat" cmpd="sng" algn="ctr">
+                      <a:solidFill>
+                        <a:srgbClr val="BFBFBF"/>
+                      </a:solidFill>
+                      <a:prstDash val="solid"/>
+                      <a:round/>
+                      <a:headEnd type="none" w="med" len="med"/>
+                      <a:tailEnd type="none" w="med" len="med"/>
+                    </a:lnB>
+                    <a:solidFill>
+                      <a:srgbClr val="F2F2F2"/>
+                    </a:solidFill>
+                  </a:tcPr>
+                </a:tc>
+              </a:tr>
+              <a:tr h="201168">
+                <a:tc>
+                  <a:txBody>
+                    <a:bodyPr/>
+                    <a:lstStyle/>
+                    <a:p>
+                      <a:pPr algn="l" indent="0" marL="0">
+                        <a:buNone/>
+                      </a:pPr>
+                      <a:r>
+                        <a:rPr lang="en-US" sz="950" dirty="0">
+                          <a:solidFill>
+                            <a:srgbClr val="1A1A1A"/>
+                          </a:solidFill>
+                          <a:latin typeface="Garamond" pitchFamily="34" charset="0"/>
+                          <a:ea typeface="Garamond" pitchFamily="34" charset="-122"/>
+                          <a:cs typeface="Garamond" pitchFamily="34" charset="-120"/>
+                        </a:rPr>
+                        <a:t>Independent</a:t>
                       </a:r>
                       <a:endParaRPr lang="en-US" sz="1200" dirty="0"/>
                     </a:p>
@@ -42627,7 +42855,71 @@
                           <a:ea typeface="Garamond" pitchFamily="34" charset="-122"/>
                           <a:cs typeface="Garamond" pitchFamily="34" charset="-120"/>
                         </a:rPr>
-                        <a:t>GE / CFM, Safran</a:t>
+                        <a:t>4</a:t>
+                      </a:r>
+                      <a:endParaRPr lang="en-US" sz="1200" dirty="0"/>
+                    </a:p>
+                  </a:txBody>
+                  <a:tcPr marL="38100" marR="38100" marT="12700" marB="12700">
+                    <a:lnL w="6350" cap="flat" cmpd="sng" algn="ctr">
+                      <a:solidFill>
+                        <a:srgbClr val="BFBFBF"/>
+                      </a:solidFill>
+                      <a:prstDash val="solid"/>
+                      <a:round/>
+                      <a:headEnd type="none" w="med" len="med"/>
+                      <a:tailEnd type="none" w="med" len="med"/>
+                    </a:lnL>
+                    <a:lnR w="6350" cap="flat" cmpd="sng" algn="ctr">
+                      <a:solidFill>
+                        <a:srgbClr val="BFBFBF"/>
+                      </a:solidFill>
+                      <a:prstDash val="solid"/>
+                      <a:round/>
+                      <a:headEnd type="none" w="med" len="med"/>
+                      <a:tailEnd type="none" w="med" len="med"/>
+                    </a:lnR>
+                    <a:lnT w="6350" cap="flat" cmpd="sng" algn="ctr">
+                      <a:solidFill>
+                        <a:srgbClr val="BFBFBF"/>
+                      </a:solidFill>
+                      <a:prstDash val="solid"/>
+                      <a:round/>
+                      <a:headEnd type="none" w="med" len="med"/>
+                      <a:tailEnd type="none" w="med" len="med"/>
+                    </a:lnT>
+                    <a:lnB w="6350" cap="flat" cmpd="sng" algn="ctr">
+                      <a:solidFill>
+                        <a:srgbClr val="BFBFBF"/>
+                      </a:solidFill>
+                      <a:prstDash val="solid"/>
+                      <a:round/>
+                      <a:headEnd type="none" w="med" len="med"/>
+                      <a:tailEnd type="none" w="med" len="med"/>
+                    </a:lnB>
+                    <a:solidFill>
+                      <a:srgbClr val="FFFFFF"/>
+                    </a:solidFill>
+                  </a:tcPr>
+                </a:tc>
+                <a:tc>
+                  <a:txBody>
+                    <a:bodyPr/>
+                    <a:lstStyle/>
+                    <a:p>
+                      <a:pPr algn="ctr" indent="0" marL="0">
+                        <a:buNone/>
+                      </a:pPr>
+                      <a:r>
+                        <a:rPr lang="en-US" sz="950" dirty="0">
+                          <a:solidFill>
+                            <a:srgbClr val="1A1A1A"/>
+                          </a:solidFill>
+                          <a:latin typeface="Garamond" pitchFamily="34" charset="0"/>
+                          <a:ea typeface="Garamond" pitchFamily="34" charset="-122"/>
+                          <a:cs typeface="Garamond" pitchFamily="34" charset="-120"/>
+                        </a:rPr>
+                        <a:t>4</a:t>
                       </a:r>
                       <a:endParaRPr lang="en-US" sz="1200" dirty="0"/>
                     </a:p>
@@ -42755,1046 +43047,7 @@
                           <a:ea typeface="Garamond" pitchFamily="34" charset="-122"/>
                           <a:cs typeface="Garamond" pitchFamily="34" charset="-120"/>
                         </a:rPr>
-                        <a:t>–</a:t>
-                      </a:r>
-                      <a:endParaRPr lang="en-US" sz="1200" dirty="0"/>
-                    </a:p>
-                  </a:txBody>
-                  <a:tcPr marL="38100" marR="38100" marT="12700" marB="12700">
-                    <a:lnL w="6350" cap="flat" cmpd="sng" algn="ctr">
-                      <a:solidFill>
-                        <a:srgbClr val="BFBFBF"/>
-                      </a:solidFill>
-                      <a:prstDash val="solid"/>
-                      <a:round/>
-                      <a:headEnd type="none" w="med" len="med"/>
-                      <a:tailEnd type="none" w="med" len="med"/>
-                    </a:lnL>
-                    <a:lnR w="6350" cap="flat" cmpd="sng" algn="ctr">
-                      <a:solidFill>
-                        <a:srgbClr val="BFBFBF"/>
-                      </a:solidFill>
-                      <a:prstDash val="solid"/>
-                      <a:round/>
-                      <a:headEnd type="none" w="med" len="med"/>
-                      <a:tailEnd type="none" w="med" len="med"/>
-                    </a:lnR>
-                    <a:lnT w="6350" cap="flat" cmpd="sng" algn="ctr">
-                      <a:solidFill>
-                        <a:srgbClr val="BFBFBF"/>
-                      </a:solidFill>
-                      <a:prstDash val="solid"/>
-                      <a:round/>
-                      <a:headEnd type="none" w="med" len="med"/>
-                      <a:tailEnd type="none" w="med" len="med"/>
-                    </a:lnT>
-                    <a:lnB w="6350" cap="flat" cmpd="sng" algn="ctr">
-                      <a:solidFill>
-                        <a:srgbClr val="BFBFBF"/>
-                      </a:solidFill>
-                      <a:prstDash val="solid"/>
-                      <a:round/>
-                      <a:headEnd type="none" w="med" len="med"/>
-                      <a:tailEnd type="none" w="med" len="med"/>
-                    </a:lnB>
-                    <a:solidFill>
-                      <a:srgbClr val="FFFFFF"/>
-                    </a:solidFill>
-                  </a:tcPr>
-                </a:tc>
-              </a:tr>
-              <a:tr h="274320">
-                <a:tc>
-                  <a:txBody>
-                    <a:bodyPr/>
-                    <a:lstStyle/>
-                    <a:p>
-                      <a:pPr algn="l" indent="0" marL="0">
-                        <a:buNone/>
-                      </a:pPr>
-                      <a:r>
-                        <a:rPr lang="en-US" sz="950" b="1" dirty="0">
-                          <a:solidFill>
-                            <a:srgbClr val="1A1A1A"/>
-                          </a:solidFill>
-                          <a:latin typeface="Garamond" pitchFamily="34" charset="0"/>
-                          <a:ea typeface="Garamond" pitchFamily="34" charset="-122"/>
-                          <a:cs typeface="Garamond" pitchFamily="34" charset="-120"/>
-                        </a:rPr>
-                        <a:t>Airline-owned</a:t>
-                      </a:r>
-                      <a:endParaRPr lang="en-US" sz="1200" dirty="0"/>
-                    </a:p>
-                  </a:txBody>
-                  <a:tcPr marL="38100" marR="38100" marT="12700" marB="12700">
-                    <a:lnL w="6350" cap="flat" cmpd="sng" algn="ctr">
-                      <a:solidFill>
-                        <a:srgbClr val="BFBFBF"/>
-                      </a:solidFill>
-                      <a:prstDash val="solid"/>
-                      <a:round/>
-                      <a:headEnd type="none" w="med" len="med"/>
-                      <a:tailEnd type="none" w="med" len="med"/>
-                    </a:lnL>
-                    <a:lnR w="6350" cap="flat" cmpd="sng" algn="ctr">
-                      <a:solidFill>
-                        <a:srgbClr val="BFBFBF"/>
-                      </a:solidFill>
-                      <a:prstDash val="solid"/>
-                      <a:round/>
-                      <a:headEnd type="none" w="med" len="med"/>
-                      <a:tailEnd type="none" w="med" len="med"/>
-                    </a:lnR>
-                    <a:lnT w="6350" cap="flat" cmpd="sng" algn="ctr">
-                      <a:solidFill>
-                        <a:srgbClr val="BFBFBF"/>
-                      </a:solidFill>
-                      <a:prstDash val="solid"/>
-                      <a:round/>
-                      <a:headEnd type="none" w="med" len="med"/>
-                      <a:tailEnd type="none" w="med" len="med"/>
-                    </a:lnT>
-                    <a:lnB w="6350" cap="flat" cmpd="sng" algn="ctr">
-                      <a:solidFill>
-                        <a:srgbClr val="BFBFBF"/>
-                      </a:solidFill>
-                      <a:prstDash val="solid"/>
-                      <a:round/>
-                      <a:headEnd type="none" w="med" len="med"/>
-                      <a:tailEnd type="none" w="med" len="med"/>
-                    </a:lnB>
-                    <a:solidFill>
-                      <a:srgbClr val="F2F2F2"/>
-                    </a:solidFill>
-                  </a:tcPr>
-                </a:tc>
-                <a:tc>
-                  <a:txBody>
-                    <a:bodyPr/>
-                    <a:lstStyle/>
-                    <a:p>
-                      <a:pPr algn="ctr" indent="0" marL="0">
-                        <a:buNone/>
-                      </a:pPr>
-                      <a:r>
-                        <a:rPr lang="en-US" sz="950" dirty="0">
-                          <a:solidFill>
-                            <a:srgbClr val="1A1A1A"/>
-                          </a:solidFill>
-                          <a:latin typeface="Garamond" pitchFamily="34" charset="0"/>
-                          <a:ea typeface="Garamond" pitchFamily="34" charset="-122"/>
-                          <a:cs typeface="Garamond" pitchFamily="34" charset="-120"/>
-                        </a:rPr>
-                        <a:t>8</a:t>
-                      </a:r>
-                      <a:endParaRPr lang="en-US" sz="1200" dirty="0"/>
-                    </a:p>
-                  </a:txBody>
-                  <a:tcPr marL="38100" marR="38100" marT="12700" marB="12700">
-                    <a:lnL w="6350" cap="flat" cmpd="sng" algn="ctr">
-                      <a:solidFill>
-                        <a:srgbClr val="BFBFBF"/>
-                      </a:solidFill>
-                      <a:prstDash val="solid"/>
-                      <a:round/>
-                      <a:headEnd type="none" w="med" len="med"/>
-                      <a:tailEnd type="none" w="med" len="med"/>
-                    </a:lnL>
-                    <a:lnR w="6350" cap="flat" cmpd="sng" algn="ctr">
-                      <a:solidFill>
-                        <a:srgbClr val="BFBFBF"/>
-                      </a:solidFill>
-                      <a:prstDash val="solid"/>
-                      <a:round/>
-                      <a:headEnd type="none" w="med" len="med"/>
-                      <a:tailEnd type="none" w="med" len="med"/>
-                    </a:lnR>
-                    <a:lnT w="6350" cap="flat" cmpd="sng" algn="ctr">
-                      <a:solidFill>
-                        <a:srgbClr val="BFBFBF"/>
-                      </a:solidFill>
-                      <a:prstDash val="solid"/>
-                      <a:round/>
-                      <a:headEnd type="none" w="med" len="med"/>
-                      <a:tailEnd type="none" w="med" len="med"/>
-                    </a:lnT>
-                    <a:lnB w="6350" cap="flat" cmpd="sng" algn="ctr">
-                      <a:solidFill>
-                        <a:srgbClr val="BFBFBF"/>
-                      </a:solidFill>
-                      <a:prstDash val="solid"/>
-                      <a:round/>
-                      <a:headEnd type="none" w="med" len="med"/>
-                      <a:tailEnd type="none" w="med" len="med"/>
-                    </a:lnB>
-                    <a:solidFill>
-                      <a:srgbClr val="F2F2F2"/>
-                    </a:solidFill>
-                  </a:tcPr>
-                </a:tc>
-                <a:tc>
-                  <a:txBody>
-                    <a:bodyPr/>
-                    <a:lstStyle/>
-                    <a:p>
-                      <a:pPr algn="ctr" indent="0" marL="0">
-                        <a:buNone/>
-                      </a:pPr>
-                      <a:r>
-                        <a:rPr lang="en-US" sz="950" dirty="0">
-                          <a:solidFill>
-                            <a:srgbClr val="1A1A1A"/>
-                          </a:solidFill>
-                          <a:latin typeface="Garamond" pitchFamily="34" charset="0"/>
-                          <a:ea typeface="Garamond" pitchFamily="34" charset="-122"/>
-                          <a:cs typeface="Garamond" pitchFamily="34" charset="-120"/>
-                        </a:rPr>
-                        <a:t>8</a:t>
-                      </a:r>
-                      <a:endParaRPr lang="en-US" sz="1200" dirty="0"/>
-                    </a:p>
-                  </a:txBody>
-                  <a:tcPr marL="38100" marR="38100" marT="12700" marB="12700">
-                    <a:lnL w="6350" cap="flat" cmpd="sng" algn="ctr">
-                      <a:solidFill>
-                        <a:srgbClr val="BFBFBF"/>
-                      </a:solidFill>
-                      <a:prstDash val="solid"/>
-                      <a:round/>
-                      <a:headEnd type="none" w="med" len="med"/>
-                      <a:tailEnd type="none" w="med" len="med"/>
-                    </a:lnL>
-                    <a:lnR w="6350" cap="flat" cmpd="sng" algn="ctr">
-                      <a:solidFill>
-                        <a:srgbClr val="BFBFBF"/>
-                      </a:solidFill>
-                      <a:prstDash val="solid"/>
-                      <a:round/>
-                      <a:headEnd type="none" w="med" len="med"/>
-                      <a:tailEnd type="none" w="med" len="med"/>
-                    </a:lnR>
-                    <a:lnT w="6350" cap="flat" cmpd="sng" algn="ctr">
-                      <a:solidFill>
-                        <a:srgbClr val="BFBFBF"/>
-                      </a:solidFill>
-                      <a:prstDash val="solid"/>
-                      <a:round/>
-                      <a:headEnd type="none" w="med" len="med"/>
-                      <a:tailEnd type="none" w="med" len="med"/>
-                    </a:lnT>
-                    <a:lnB w="6350" cap="flat" cmpd="sng" algn="ctr">
-                      <a:solidFill>
-                        <a:srgbClr val="BFBFBF"/>
-                      </a:solidFill>
-                      <a:prstDash val="solid"/>
-                      <a:round/>
-                      <a:headEnd type="none" w="med" len="med"/>
-                      <a:tailEnd type="none" w="med" len="med"/>
-                    </a:lnB>
-                    <a:solidFill>
-                      <a:srgbClr val="F2F2F2"/>
-                    </a:solidFill>
-                  </a:tcPr>
-                </a:tc>
-                <a:tc>
-                  <a:txBody>
-                    <a:bodyPr/>
-                    <a:lstStyle/>
-                    <a:p>
-                      <a:pPr algn="ctr" indent="0" marL="0">
-                        <a:buNone/>
-                      </a:pPr>
-                      <a:r>
-                        <a:rPr lang="en-US" sz="950" dirty="0">
-                          <a:solidFill>
-                            <a:srgbClr val="1A1A1A"/>
-                          </a:solidFill>
-                          <a:latin typeface="Garamond" pitchFamily="34" charset="0"/>
-                          <a:ea typeface="Garamond" pitchFamily="34" charset="-122"/>
-                          <a:cs typeface="Garamond" pitchFamily="34" charset="-120"/>
-                        </a:rPr>
-                        <a:t>1</a:t>
-                      </a:r>
-                      <a:endParaRPr lang="en-US" sz="1200" dirty="0"/>
-                    </a:p>
-                  </a:txBody>
-                  <a:tcPr marL="38100" marR="38100" marT="12700" marB="12700">
-                    <a:lnL w="6350" cap="flat" cmpd="sng" algn="ctr">
-                      <a:solidFill>
-                        <a:srgbClr val="BFBFBF"/>
-                      </a:solidFill>
-                      <a:prstDash val="solid"/>
-                      <a:round/>
-                      <a:headEnd type="none" w="med" len="med"/>
-                      <a:tailEnd type="none" w="med" len="med"/>
-                    </a:lnL>
-                    <a:lnR w="6350" cap="flat" cmpd="sng" algn="ctr">
-                      <a:solidFill>
-                        <a:srgbClr val="BFBFBF"/>
-                      </a:solidFill>
-                      <a:prstDash val="solid"/>
-                      <a:round/>
-                      <a:headEnd type="none" w="med" len="med"/>
-                      <a:tailEnd type="none" w="med" len="med"/>
-                    </a:lnR>
-                    <a:lnT w="6350" cap="flat" cmpd="sng" algn="ctr">
-                      <a:solidFill>
-                        <a:srgbClr val="BFBFBF"/>
-                      </a:solidFill>
-                      <a:prstDash val="solid"/>
-                      <a:round/>
-                      <a:headEnd type="none" w="med" len="med"/>
-                      <a:tailEnd type="none" w="med" len="med"/>
-                    </a:lnT>
-                    <a:lnB w="6350" cap="flat" cmpd="sng" algn="ctr">
-                      <a:solidFill>
-                        <a:srgbClr val="BFBFBF"/>
-                      </a:solidFill>
-                      <a:prstDash val="solid"/>
-                      <a:round/>
-                      <a:headEnd type="none" w="med" len="med"/>
-                      <a:tailEnd type="none" w="med" len="med"/>
-                    </a:lnB>
-                    <a:solidFill>
-                      <a:srgbClr val="F2F2F2"/>
-                    </a:solidFill>
-                  </a:tcPr>
-                </a:tc>
-                <a:tc>
-                  <a:txBody>
-                    <a:bodyPr/>
-                    <a:lstStyle/>
-                    <a:p>
-                      <a:pPr algn="ctr" indent="0" marL="0">
-                        <a:buNone/>
-                      </a:pPr>
-                      <a:r>
-                        <a:rPr lang="en-US" sz="950" dirty="0">
-                          <a:solidFill>
-                            <a:srgbClr val="1A1A1A"/>
-                          </a:solidFill>
-                          <a:latin typeface="Garamond" pitchFamily="34" charset="0"/>
-                          <a:ea typeface="Garamond" pitchFamily="34" charset="-122"/>
-                          <a:cs typeface="Garamond" pitchFamily="34" charset="-120"/>
-                        </a:rPr>
-                        <a:t>3</a:t>
-                      </a:r>
-                      <a:endParaRPr lang="en-US" sz="1200" dirty="0"/>
-                    </a:p>
-                  </a:txBody>
-                  <a:tcPr marL="38100" marR="38100" marT="12700" marB="12700">
-                    <a:lnL w="6350" cap="flat" cmpd="sng" algn="ctr">
-                      <a:solidFill>
-                        <a:srgbClr val="BFBFBF"/>
-                      </a:solidFill>
-                      <a:prstDash val="solid"/>
-                      <a:round/>
-                      <a:headEnd type="none" w="med" len="med"/>
-                      <a:tailEnd type="none" w="med" len="med"/>
-                    </a:lnL>
-                    <a:lnR w="6350" cap="flat" cmpd="sng" algn="ctr">
-                      <a:solidFill>
-                        <a:srgbClr val="BFBFBF"/>
-                      </a:solidFill>
-                      <a:prstDash val="solid"/>
-                      <a:round/>
-                      <a:headEnd type="none" w="med" len="med"/>
-                      <a:tailEnd type="none" w="med" len="med"/>
-                    </a:lnR>
-                    <a:lnT w="6350" cap="flat" cmpd="sng" algn="ctr">
-                      <a:solidFill>
-                        <a:srgbClr val="BFBFBF"/>
-                      </a:solidFill>
-                      <a:prstDash val="solid"/>
-                      <a:round/>
-                      <a:headEnd type="none" w="med" len="med"/>
-                      <a:tailEnd type="none" w="med" len="med"/>
-                    </a:lnT>
-                    <a:lnB w="6350" cap="flat" cmpd="sng" algn="ctr">
-                      <a:solidFill>
-                        <a:srgbClr val="BFBFBF"/>
-                      </a:solidFill>
-                      <a:prstDash val="solid"/>
-                      <a:round/>
-                      <a:headEnd type="none" w="med" len="med"/>
-                      <a:tailEnd type="none" w="med" len="med"/>
-                    </a:lnB>
-                    <a:solidFill>
-                      <a:srgbClr val="F2F2F2"/>
-                    </a:solidFill>
-                  </a:tcPr>
-                </a:tc>
-                <a:tc>
-                  <a:txBody>
-                    <a:bodyPr/>
-                    <a:lstStyle/>
-                    <a:p>
-                      <a:pPr algn="ctr" indent="0" marL="0">
-                        <a:buNone/>
-                      </a:pPr>
-                      <a:r>
-                        <a:rPr lang="en-US" sz="950" dirty="0">
-                          <a:solidFill>
-                            <a:srgbClr val="1A1A1A"/>
-                          </a:solidFill>
-                          <a:latin typeface="Garamond" pitchFamily="34" charset="0"/>
-                          <a:ea typeface="Garamond" pitchFamily="34" charset="-122"/>
-                          <a:cs typeface="Garamond" pitchFamily="34" charset="-120"/>
-                        </a:rPr>
-                        <a:t>Lufthansa</a:t>
-                      </a:r>
-                      <a:endParaRPr lang="en-US" sz="1200" dirty="0"/>
-                    </a:p>
-                  </a:txBody>
-                  <a:tcPr marL="38100" marR="38100" marT="12700" marB="12700">
-                    <a:lnL w="6350" cap="flat" cmpd="sng" algn="ctr">
-                      <a:solidFill>
-                        <a:srgbClr val="BFBFBF"/>
-                      </a:solidFill>
-                      <a:prstDash val="solid"/>
-                      <a:round/>
-                      <a:headEnd type="none" w="med" len="med"/>
-                      <a:tailEnd type="none" w="med" len="med"/>
-                    </a:lnL>
-                    <a:lnR w="6350" cap="flat" cmpd="sng" algn="ctr">
-                      <a:solidFill>
-                        <a:srgbClr val="BFBFBF"/>
-                      </a:solidFill>
-                      <a:prstDash val="solid"/>
-                      <a:round/>
-                      <a:headEnd type="none" w="med" len="med"/>
-                      <a:tailEnd type="none" w="med" len="med"/>
-                    </a:lnR>
-                    <a:lnT w="6350" cap="flat" cmpd="sng" algn="ctr">
-                      <a:solidFill>
-                        <a:srgbClr val="BFBFBF"/>
-                      </a:solidFill>
-                      <a:prstDash val="solid"/>
-                      <a:round/>
-                      <a:headEnd type="none" w="med" len="med"/>
-                      <a:tailEnd type="none" w="med" len="med"/>
-                    </a:lnT>
-                    <a:lnB w="6350" cap="flat" cmpd="sng" algn="ctr">
-                      <a:solidFill>
-                        <a:srgbClr val="BFBFBF"/>
-                      </a:solidFill>
-                      <a:prstDash val="solid"/>
-                      <a:round/>
-                      <a:headEnd type="none" w="med" len="med"/>
-                      <a:tailEnd type="none" w="med" len="med"/>
-                    </a:lnB>
-                    <a:solidFill>
-                      <a:srgbClr val="F2F2F2"/>
-                    </a:solidFill>
-                  </a:tcPr>
-                </a:tc>
-                <a:tc>
-                  <a:txBody>
-                    <a:bodyPr/>
-                    <a:lstStyle/>
-                    <a:p>
-                      <a:pPr algn="ctr" indent="0" marL="0">
-                        <a:buNone/>
-                      </a:pPr>
-                      <a:r>
-                        <a:rPr lang="en-US" sz="950" dirty="0">
-                          <a:solidFill>
-                            <a:srgbClr val="1A1A1A"/>
-                          </a:solidFill>
-                          <a:latin typeface="Garamond" pitchFamily="34" charset="0"/>
-                          <a:ea typeface="Garamond" pitchFamily="34" charset="-122"/>
-                          <a:cs typeface="Garamond" pitchFamily="34" charset="-120"/>
-                        </a:rPr>
-                        <a:t>AFI KLM, Delta, Iberia (planned), Turkish (exploring), Korean Air</a:t>
-                      </a:r>
-                      <a:endParaRPr lang="en-US" sz="1200" dirty="0"/>
-                    </a:p>
-                  </a:txBody>
-                  <a:tcPr marL="38100" marR="38100" marT="12700" marB="12700">
-                    <a:lnL w="6350" cap="flat" cmpd="sng" algn="ctr">
-                      <a:solidFill>
-                        <a:srgbClr val="BFBFBF"/>
-                      </a:solidFill>
-                      <a:prstDash val="solid"/>
-                      <a:round/>
-                      <a:headEnd type="none" w="med" len="med"/>
-                      <a:tailEnd type="none" w="med" len="med"/>
-                    </a:lnL>
-                    <a:lnR w="6350" cap="flat" cmpd="sng" algn="ctr">
-                      <a:solidFill>
-                        <a:srgbClr val="BFBFBF"/>
-                      </a:solidFill>
-                      <a:prstDash val="solid"/>
-                      <a:round/>
-                      <a:headEnd type="none" w="med" len="med"/>
-                      <a:tailEnd type="none" w="med" len="med"/>
-                    </a:lnR>
-                    <a:lnT w="6350" cap="flat" cmpd="sng" algn="ctr">
-                      <a:solidFill>
-                        <a:srgbClr val="BFBFBF"/>
-                      </a:solidFill>
-                      <a:prstDash val="solid"/>
-                      <a:round/>
-                      <a:headEnd type="none" w="med" len="med"/>
-                      <a:tailEnd type="none" w="med" len="med"/>
-                    </a:lnT>
-                    <a:lnB w="6350" cap="flat" cmpd="sng" algn="ctr">
-                      <a:solidFill>
-                        <a:srgbClr val="BFBFBF"/>
-                      </a:solidFill>
-                      <a:prstDash val="solid"/>
-                      <a:round/>
-                      <a:headEnd type="none" w="med" len="med"/>
-                      <a:tailEnd type="none" w="med" len="med"/>
-                    </a:lnB>
-                    <a:solidFill>
-                      <a:srgbClr val="F2F2F2"/>
-                    </a:solidFill>
-                  </a:tcPr>
-                </a:tc>
-                <a:tc>
-                  <a:txBody>
-                    <a:bodyPr/>
-                    <a:lstStyle/>
-                    <a:p>
-                      <a:pPr algn="ctr" indent="0" marL="0">
-                        <a:buNone/>
-                      </a:pPr>
-                      <a:r>
-                        <a:rPr lang="en-US" sz="950" dirty="0">
-                          <a:solidFill>
-                            <a:srgbClr val="1A1A1A"/>
-                          </a:solidFill>
-                          <a:latin typeface="Garamond" pitchFamily="34" charset="0"/>
-                          <a:ea typeface="Garamond" pitchFamily="34" charset="-122"/>
-                          <a:cs typeface="Garamond" pitchFamily="34" charset="-120"/>
-                        </a:rPr>
-                        <a:t>–</a:t>
-                      </a:r>
-                      <a:endParaRPr lang="en-US" sz="1200" dirty="0"/>
-                    </a:p>
-                  </a:txBody>
-                  <a:tcPr marL="38100" marR="38100" marT="12700" marB="12700">
-                    <a:lnL w="6350" cap="flat" cmpd="sng" algn="ctr">
-                      <a:solidFill>
-                        <a:srgbClr val="BFBFBF"/>
-                      </a:solidFill>
-                      <a:prstDash val="solid"/>
-                      <a:round/>
-                      <a:headEnd type="none" w="med" len="med"/>
-                      <a:tailEnd type="none" w="med" len="med"/>
-                    </a:lnL>
-                    <a:lnR w="6350" cap="flat" cmpd="sng" algn="ctr">
-                      <a:solidFill>
-                        <a:srgbClr val="BFBFBF"/>
-                      </a:solidFill>
-                      <a:prstDash val="solid"/>
-                      <a:round/>
-                      <a:headEnd type="none" w="med" len="med"/>
-                      <a:tailEnd type="none" w="med" len="med"/>
-                    </a:lnR>
-                    <a:lnT w="6350" cap="flat" cmpd="sng" algn="ctr">
-                      <a:solidFill>
-                        <a:srgbClr val="BFBFBF"/>
-                      </a:solidFill>
-                      <a:prstDash val="solid"/>
-                      <a:round/>
-                      <a:headEnd type="none" w="med" len="med"/>
-                      <a:tailEnd type="none" w="med" len="med"/>
-                    </a:lnT>
-                    <a:lnB w="6350" cap="flat" cmpd="sng" algn="ctr">
-                      <a:solidFill>
-                        <a:srgbClr val="BFBFBF"/>
-                      </a:solidFill>
-                      <a:prstDash val="solid"/>
-                      <a:round/>
-                      <a:headEnd type="none" w="med" len="med"/>
-                      <a:tailEnd type="none" w="med" len="med"/>
-                    </a:lnB>
-                    <a:solidFill>
-                      <a:srgbClr val="F2F2F2"/>
-                    </a:solidFill>
-                  </a:tcPr>
-                </a:tc>
-              </a:tr>
-              <a:tr h="274320">
-                <a:tc>
-                  <a:txBody>
-                    <a:bodyPr/>
-                    <a:lstStyle/>
-                    <a:p>
-                      <a:pPr algn="l" indent="0" marL="0">
-                        <a:buNone/>
-                      </a:pPr>
-                      <a:r>
-                        <a:rPr lang="en-US" sz="950" b="1" dirty="0">
-                          <a:solidFill>
-                            <a:srgbClr val="1A1A1A"/>
-                          </a:solidFill>
-                          <a:latin typeface="Garamond" pitchFamily="34" charset="0"/>
-                          <a:ea typeface="Garamond" pitchFamily="34" charset="-122"/>
-                          <a:cs typeface="Garamond" pitchFamily="34" charset="-120"/>
-                        </a:rPr>
-                        <a:t>Independent</a:t>
-                      </a:r>
-                      <a:endParaRPr lang="en-US" sz="1200" dirty="0"/>
-                    </a:p>
-                  </a:txBody>
-                  <a:tcPr marL="38100" marR="38100" marT="12700" marB="12700">
-                    <a:lnL w="6350" cap="flat" cmpd="sng" algn="ctr">
-                      <a:solidFill>
-                        <a:srgbClr val="BFBFBF"/>
-                      </a:solidFill>
-                      <a:prstDash val="solid"/>
-                      <a:round/>
-                      <a:headEnd type="none" w="med" len="med"/>
-                      <a:tailEnd type="none" w="med" len="med"/>
-                    </a:lnL>
-                    <a:lnR w="6350" cap="flat" cmpd="sng" algn="ctr">
-                      <a:solidFill>
-                        <a:srgbClr val="BFBFBF"/>
-                      </a:solidFill>
-                      <a:prstDash val="solid"/>
-                      <a:round/>
-                      <a:headEnd type="none" w="med" len="med"/>
-                      <a:tailEnd type="none" w="med" len="med"/>
-                    </a:lnR>
-                    <a:lnT w="6350" cap="flat" cmpd="sng" algn="ctr">
-                      <a:solidFill>
-                        <a:srgbClr val="BFBFBF"/>
-                      </a:solidFill>
-                      <a:prstDash val="solid"/>
-                      <a:round/>
-                      <a:headEnd type="none" w="med" len="med"/>
-                      <a:tailEnd type="none" w="med" len="med"/>
-                    </a:lnT>
-                    <a:lnB w="6350" cap="flat" cmpd="sng" algn="ctr">
-                      <a:solidFill>
-                        <a:srgbClr val="BFBFBF"/>
-                      </a:solidFill>
-                      <a:prstDash val="solid"/>
-                      <a:round/>
-                      <a:headEnd type="none" w="med" len="med"/>
-                      <a:tailEnd type="none" w="med" len="med"/>
-                    </a:lnB>
-                    <a:solidFill>
-                      <a:srgbClr val="FFFFFF"/>
-                    </a:solidFill>
-                  </a:tcPr>
-                </a:tc>
-                <a:tc>
-                  <a:txBody>
-                    <a:bodyPr/>
-                    <a:lstStyle/>
-                    <a:p>
-                      <a:pPr algn="ctr" indent="0" marL="0">
-                        <a:buNone/>
-                      </a:pPr>
-                      <a:r>
-                        <a:rPr lang="en-US" sz="950" dirty="0">
-                          <a:solidFill>
-                            <a:srgbClr val="1A1A1A"/>
-                          </a:solidFill>
-                          <a:latin typeface="Garamond" pitchFamily="34" charset="0"/>
-                          <a:ea typeface="Garamond" pitchFamily="34" charset="-122"/>
-                          <a:cs typeface="Garamond" pitchFamily="34" charset="-120"/>
-                        </a:rPr>
                         <a:t>4</a:t>
-                      </a:r>
-                      <a:endParaRPr lang="en-US" sz="1200" dirty="0"/>
-                    </a:p>
-                  </a:txBody>
-                  <a:tcPr marL="38100" marR="38100" marT="12700" marB="12700">
-                    <a:lnL w="6350" cap="flat" cmpd="sng" algn="ctr">
-                      <a:solidFill>
-                        <a:srgbClr val="BFBFBF"/>
-                      </a:solidFill>
-                      <a:prstDash val="solid"/>
-                      <a:round/>
-                      <a:headEnd type="none" w="med" len="med"/>
-                      <a:tailEnd type="none" w="med" len="med"/>
-                    </a:lnL>
-                    <a:lnR w="6350" cap="flat" cmpd="sng" algn="ctr">
-                      <a:solidFill>
-                        <a:srgbClr val="BFBFBF"/>
-                      </a:solidFill>
-                      <a:prstDash val="solid"/>
-                      <a:round/>
-                      <a:headEnd type="none" w="med" len="med"/>
-                      <a:tailEnd type="none" w="med" len="med"/>
-                    </a:lnR>
-                    <a:lnT w="6350" cap="flat" cmpd="sng" algn="ctr">
-                      <a:solidFill>
-                        <a:srgbClr val="BFBFBF"/>
-                      </a:solidFill>
-                      <a:prstDash val="solid"/>
-                      <a:round/>
-                      <a:headEnd type="none" w="med" len="med"/>
-                      <a:tailEnd type="none" w="med" len="med"/>
-                    </a:lnT>
-                    <a:lnB w="6350" cap="flat" cmpd="sng" algn="ctr">
-                      <a:solidFill>
-                        <a:srgbClr val="BFBFBF"/>
-                      </a:solidFill>
-                      <a:prstDash val="solid"/>
-                      <a:round/>
-                      <a:headEnd type="none" w="med" len="med"/>
-                      <a:tailEnd type="none" w="med" len="med"/>
-                    </a:lnB>
-                    <a:solidFill>
-                      <a:srgbClr val="FFFFFF"/>
-                    </a:solidFill>
-                  </a:tcPr>
-                </a:tc>
-                <a:tc>
-                  <a:txBody>
-                    <a:bodyPr/>
-                    <a:lstStyle/>
-                    <a:p>
-                      <a:pPr algn="ctr" indent="0" marL="0">
-                        <a:buNone/>
-                      </a:pPr>
-                      <a:r>
-                        <a:rPr lang="en-US" sz="950" dirty="0">
-                          <a:solidFill>
-                            <a:srgbClr val="1A1A1A"/>
-                          </a:solidFill>
-                          <a:latin typeface="Garamond" pitchFamily="34" charset="0"/>
-                          <a:ea typeface="Garamond" pitchFamily="34" charset="-122"/>
-                          <a:cs typeface="Garamond" pitchFamily="34" charset="-120"/>
-                        </a:rPr>
-                        <a:t>4</a:t>
-                      </a:r>
-                      <a:endParaRPr lang="en-US" sz="1200" dirty="0"/>
-                    </a:p>
-                  </a:txBody>
-                  <a:tcPr marL="38100" marR="38100" marT="12700" marB="12700">
-                    <a:lnL w="6350" cap="flat" cmpd="sng" algn="ctr">
-                      <a:solidFill>
-                        <a:srgbClr val="BFBFBF"/>
-                      </a:solidFill>
-                      <a:prstDash val="solid"/>
-                      <a:round/>
-                      <a:headEnd type="none" w="med" len="med"/>
-                      <a:tailEnd type="none" w="med" len="med"/>
-                    </a:lnL>
-                    <a:lnR w="6350" cap="flat" cmpd="sng" algn="ctr">
-                      <a:solidFill>
-                        <a:srgbClr val="BFBFBF"/>
-                      </a:solidFill>
-                      <a:prstDash val="solid"/>
-                      <a:round/>
-                      <a:headEnd type="none" w="med" len="med"/>
-                      <a:tailEnd type="none" w="med" len="med"/>
-                    </a:lnR>
-                    <a:lnT w="6350" cap="flat" cmpd="sng" algn="ctr">
-                      <a:solidFill>
-                        <a:srgbClr val="BFBFBF"/>
-                      </a:solidFill>
-                      <a:prstDash val="solid"/>
-                      <a:round/>
-                      <a:headEnd type="none" w="med" len="med"/>
-                      <a:tailEnd type="none" w="med" len="med"/>
-                    </a:lnT>
-                    <a:lnB w="6350" cap="flat" cmpd="sng" algn="ctr">
-                      <a:solidFill>
-                        <a:srgbClr val="BFBFBF"/>
-                      </a:solidFill>
-                      <a:prstDash val="solid"/>
-                      <a:round/>
-                      <a:headEnd type="none" w="med" len="med"/>
-                      <a:tailEnd type="none" w="med" len="med"/>
-                    </a:lnB>
-                    <a:solidFill>
-                      <a:srgbClr val="FFFFFF"/>
-                    </a:solidFill>
-                  </a:tcPr>
-                </a:tc>
-                <a:tc>
-                  <a:txBody>
-                    <a:bodyPr/>
-                    <a:lstStyle/>
-                    <a:p>
-                      <a:pPr algn="ctr" indent="0" marL="0">
-                        <a:buNone/>
-                      </a:pPr>
-                      <a:r>
-                        <a:rPr lang="en-US" sz="950" dirty="0">
-                          <a:solidFill>
-                            <a:srgbClr val="1A1A1A"/>
-                          </a:solidFill>
-                          <a:latin typeface="Garamond" pitchFamily="34" charset="0"/>
-                          <a:ea typeface="Garamond" pitchFamily="34" charset="-122"/>
-                          <a:cs typeface="Garamond" pitchFamily="34" charset="-120"/>
-                        </a:rPr>
-                        <a:t>–</a:t>
-                      </a:r>
-                      <a:endParaRPr lang="en-US" sz="1200" dirty="0"/>
-                    </a:p>
-                  </a:txBody>
-                  <a:tcPr marL="38100" marR="38100" marT="12700" marB="12700">
-                    <a:lnL w="6350" cap="flat" cmpd="sng" algn="ctr">
-                      <a:solidFill>
-                        <a:srgbClr val="BFBFBF"/>
-                      </a:solidFill>
-                      <a:prstDash val="solid"/>
-                      <a:round/>
-                      <a:headEnd type="none" w="med" len="med"/>
-                      <a:tailEnd type="none" w="med" len="med"/>
-                    </a:lnL>
-                    <a:lnR w="6350" cap="flat" cmpd="sng" algn="ctr">
-                      <a:solidFill>
-                        <a:srgbClr val="BFBFBF"/>
-                      </a:solidFill>
-                      <a:prstDash val="solid"/>
-                      <a:round/>
-                      <a:headEnd type="none" w="med" len="med"/>
-                      <a:tailEnd type="none" w="med" len="med"/>
-                    </a:lnR>
-                    <a:lnT w="6350" cap="flat" cmpd="sng" algn="ctr">
-                      <a:solidFill>
-                        <a:srgbClr val="BFBFBF"/>
-                      </a:solidFill>
-                      <a:prstDash val="solid"/>
-                      <a:round/>
-                      <a:headEnd type="none" w="med" len="med"/>
-                      <a:tailEnd type="none" w="med" len="med"/>
-                    </a:lnT>
-                    <a:lnB w="6350" cap="flat" cmpd="sng" algn="ctr">
-                      <a:solidFill>
-                        <a:srgbClr val="BFBFBF"/>
-                      </a:solidFill>
-                      <a:prstDash val="solid"/>
-                      <a:round/>
-                      <a:headEnd type="none" w="med" len="med"/>
-                      <a:tailEnd type="none" w="med" len="med"/>
-                    </a:lnB>
-                    <a:solidFill>
-                      <a:srgbClr val="FFFFFF"/>
-                    </a:solidFill>
-                  </a:tcPr>
-                </a:tc>
-                <a:tc>
-                  <a:txBody>
-                    <a:bodyPr/>
-                    <a:lstStyle/>
-                    <a:p>
-                      <a:pPr algn="ctr" indent="0" marL="0">
-                        <a:buNone/>
-                      </a:pPr>
-                      <a:r>
-                        <a:rPr lang="en-US" sz="950" dirty="0">
-                          <a:solidFill>
-                            <a:srgbClr val="1A1A1A"/>
-                          </a:solidFill>
-                          <a:latin typeface="Garamond" pitchFamily="34" charset="0"/>
-                          <a:ea typeface="Garamond" pitchFamily="34" charset="-122"/>
-                          <a:cs typeface="Garamond" pitchFamily="34" charset="-120"/>
-                        </a:rPr>
-                        <a:t>4</a:t>
-                      </a:r>
-                      <a:endParaRPr lang="en-US" sz="1200" dirty="0"/>
-                    </a:p>
-                  </a:txBody>
-                  <a:tcPr marL="38100" marR="38100" marT="12700" marB="12700">
-                    <a:lnL w="6350" cap="flat" cmpd="sng" algn="ctr">
-                      <a:solidFill>
-                        <a:srgbClr val="BFBFBF"/>
-                      </a:solidFill>
-                      <a:prstDash val="solid"/>
-                      <a:round/>
-                      <a:headEnd type="none" w="med" len="med"/>
-                      <a:tailEnd type="none" w="med" len="med"/>
-                    </a:lnL>
-                    <a:lnR w="6350" cap="flat" cmpd="sng" algn="ctr">
-                      <a:solidFill>
-                        <a:srgbClr val="BFBFBF"/>
-                      </a:solidFill>
-                      <a:prstDash val="solid"/>
-                      <a:round/>
-                      <a:headEnd type="none" w="med" len="med"/>
-                      <a:tailEnd type="none" w="med" len="med"/>
-                    </a:lnR>
-                    <a:lnT w="6350" cap="flat" cmpd="sng" algn="ctr">
-                      <a:solidFill>
-                        <a:srgbClr val="BFBFBF"/>
-                      </a:solidFill>
-                      <a:prstDash val="solid"/>
-                      <a:round/>
-                      <a:headEnd type="none" w="med" len="med"/>
-                      <a:tailEnd type="none" w="med" len="med"/>
-                    </a:lnT>
-                    <a:lnB w="6350" cap="flat" cmpd="sng" algn="ctr">
-                      <a:solidFill>
-                        <a:srgbClr val="BFBFBF"/>
-                      </a:solidFill>
-                      <a:prstDash val="solid"/>
-                      <a:round/>
-                      <a:headEnd type="none" w="med" len="med"/>
-                      <a:tailEnd type="none" w="med" len="med"/>
-                    </a:lnB>
-                    <a:solidFill>
-                      <a:srgbClr val="FFFFFF"/>
-                    </a:solidFill>
-                  </a:tcPr>
-                </a:tc>
-                <a:tc>
-                  <a:txBody>
-                    <a:bodyPr/>
-                    <a:lstStyle/>
-                    <a:p>
-                      <a:pPr algn="ctr" indent="0" marL="0">
-                        <a:buNone/>
-                      </a:pPr>
-                      <a:r>
-                        <a:rPr lang="en-US" sz="950" dirty="0">
-                          <a:solidFill>
-                            <a:srgbClr val="1A1A1A"/>
-                          </a:solidFill>
-                          <a:latin typeface="Garamond" pitchFamily="34" charset="0"/>
-                          <a:ea typeface="Garamond" pitchFamily="34" charset="-122"/>
-                          <a:cs typeface="Garamond" pitchFamily="34" charset="-120"/>
-                        </a:rPr>
-                        <a:t>–</a:t>
-                      </a:r>
-                      <a:endParaRPr lang="en-US" sz="1200" dirty="0"/>
-                    </a:p>
-                  </a:txBody>
-                  <a:tcPr marL="38100" marR="38100" marT="12700" marB="12700">
-                    <a:lnL w="6350" cap="flat" cmpd="sng" algn="ctr">
-                      <a:solidFill>
-                        <a:srgbClr val="BFBFBF"/>
-                      </a:solidFill>
-                      <a:prstDash val="solid"/>
-                      <a:round/>
-                      <a:headEnd type="none" w="med" len="med"/>
-                      <a:tailEnd type="none" w="med" len="med"/>
-                    </a:lnL>
-                    <a:lnR w="6350" cap="flat" cmpd="sng" algn="ctr">
-                      <a:solidFill>
-                        <a:srgbClr val="BFBFBF"/>
-                      </a:solidFill>
-                      <a:prstDash val="solid"/>
-                      <a:round/>
-                      <a:headEnd type="none" w="med" len="med"/>
-                      <a:tailEnd type="none" w="med" len="med"/>
-                    </a:lnR>
-                    <a:lnT w="6350" cap="flat" cmpd="sng" algn="ctr">
-                      <a:solidFill>
-                        <a:srgbClr val="BFBFBF"/>
-                      </a:solidFill>
-                      <a:prstDash val="solid"/>
-                      <a:round/>
-                      <a:headEnd type="none" w="med" len="med"/>
-                      <a:tailEnd type="none" w="med" len="med"/>
-                    </a:lnT>
-                    <a:lnB w="6350" cap="flat" cmpd="sng" algn="ctr">
-                      <a:solidFill>
-                        <a:srgbClr val="BFBFBF"/>
-                      </a:solidFill>
-                      <a:prstDash val="solid"/>
-                      <a:round/>
-                      <a:headEnd type="none" w="med" len="med"/>
-                      <a:tailEnd type="none" w="med" len="med"/>
-                    </a:lnB>
-                    <a:solidFill>
-                      <a:srgbClr val="FFFFFF"/>
-                    </a:solidFill>
-                  </a:tcPr>
-                </a:tc>
-                <a:tc>
-                  <a:txBody>
-                    <a:bodyPr/>
-                    <a:lstStyle/>
-                    <a:p>
-                      <a:pPr algn="ctr" indent="0" marL="0">
-                        <a:buNone/>
-                      </a:pPr>
-                      <a:r>
-                        <a:rPr lang="en-US" sz="950" dirty="0">
-                          <a:solidFill>
-                            <a:srgbClr val="1A1A1A"/>
-                          </a:solidFill>
-                          <a:latin typeface="Garamond" pitchFamily="34" charset="0"/>
-                          <a:ea typeface="Garamond" pitchFamily="34" charset="-122"/>
-                          <a:cs typeface="Garamond" pitchFamily="34" charset="-120"/>
-                        </a:rPr>
-                        <a:t>–</a:t>
-                      </a:r>
-                      <a:endParaRPr lang="en-US" sz="1200" dirty="0"/>
-                    </a:p>
-                  </a:txBody>
-                  <a:tcPr marL="38100" marR="38100" marT="12700" marB="12700">
-                    <a:lnL w="6350" cap="flat" cmpd="sng" algn="ctr">
-                      <a:solidFill>
-                        <a:srgbClr val="BFBFBF"/>
-                      </a:solidFill>
-                      <a:prstDash val="solid"/>
-                      <a:round/>
-                      <a:headEnd type="none" w="med" len="med"/>
-                      <a:tailEnd type="none" w="med" len="med"/>
-                    </a:lnL>
-                    <a:lnR w="6350" cap="flat" cmpd="sng" algn="ctr">
-                      <a:solidFill>
-                        <a:srgbClr val="BFBFBF"/>
-                      </a:solidFill>
-                      <a:prstDash val="solid"/>
-                      <a:round/>
-                      <a:headEnd type="none" w="med" len="med"/>
-                      <a:tailEnd type="none" w="med" len="med"/>
-                    </a:lnR>
-                    <a:lnT w="6350" cap="flat" cmpd="sng" algn="ctr">
-                      <a:solidFill>
-                        <a:srgbClr val="BFBFBF"/>
-                      </a:solidFill>
-                      <a:prstDash val="solid"/>
-                      <a:round/>
-                      <a:headEnd type="none" w="med" len="med"/>
-                      <a:tailEnd type="none" w="med" len="med"/>
-                    </a:lnT>
-                    <a:lnB w="6350" cap="flat" cmpd="sng" algn="ctr">
-                      <a:solidFill>
-                        <a:srgbClr val="BFBFBF"/>
-                      </a:solidFill>
-                      <a:prstDash val="solid"/>
-                      <a:round/>
-                      <a:headEnd type="none" w="med" len="med"/>
-                      <a:tailEnd type="none" w="med" len="med"/>
-                    </a:lnB>
-                    <a:solidFill>
-                      <a:srgbClr val="FFFFFF"/>
-                    </a:solidFill>
-                  </a:tcPr>
-                </a:tc>
-                <a:tc>
-                  <a:txBody>
-                    <a:bodyPr/>
-                    <a:lstStyle/>
-                    <a:p>
-                      <a:pPr algn="ctr" indent="0" marL="0">
-                        <a:buNone/>
-                      </a:pPr>
-                      <a:r>
-                        <a:rPr lang="en-US" sz="950" dirty="0">
-                          <a:solidFill>
-                            <a:srgbClr val="1A1A1A"/>
-                          </a:solidFill>
-                          <a:latin typeface="Garamond" pitchFamily="34" charset="0"/>
-                          <a:ea typeface="Garamond" pitchFamily="34" charset="-122"/>
-                          <a:cs typeface="Garamond" pitchFamily="34" charset="-120"/>
-                        </a:rPr>
-                        <a:t>MTU, StandardAero, ST Engineering, SR Technics, </a:t>
-                      </a:r>
-                      <a:r>
-                        <a:rPr lang="en-US" sz="950" b="1" dirty="0">
-                          <a:solidFill>
-                            <a:srgbClr val="1A1A1A"/>
-                          </a:solidFill>
-                          <a:latin typeface="Garamond" pitchFamily="34" charset="0"/>
-                          <a:ea typeface="Garamond" pitchFamily="34" charset="-122"/>
-                          <a:cs typeface="Garamond" pitchFamily="34" charset="-120"/>
-                        </a:rPr>
-                        <a:t>FTAI</a:t>
                       </a:r>
                       <a:endParaRPr lang="en-US" sz="1200" dirty="0"/>
                     </a:p>
@@ -43848,67 +43101,14 @@
       </p:graphicFrame>
       <p:sp>
         <p:nvSpPr>
-          <p:cNvPr id="6" name="Text 3"/>
+          <p:cNvPr id="8" name="Text 4"/>
           <p:cNvSpPr txBox="1"/>
           <p:nvPr/>
         </p:nvSpPr>
         <p:spPr>
           <a:xfrm>
-            <a:off x="621792" y="2286000"/>
-            <a:ext cx="11201400" cy="219456"/>
-          </a:xfrm>
-          <a:prstGeom prst="rect">
-            <a:avLst/>
-          </a:prstGeom>
-          <a:noFill/>
-          <a:ln/>
-        </p:spPr>
-        <p:txBody>
-          <a:bodyPr wrap="square" lIns="25400" tIns="25400" rIns="25400" bIns="25400" rtlCol="0" anchor="t"/>
-          <a:lstStyle/>
-          <a:p>
-            <a:pPr algn="ctr" indent="0" marL="0">
-              <a:lnSpc>
-                <a:spcPct val="100000"/>
-              </a:lnSpc>
-              <a:buNone/>
-            </a:pPr>
-            <a:r>
-              <a:rPr lang="en-US" sz="1050" b="1" u="sng" dirty="0">
-                <a:solidFill>
-                  <a:srgbClr val="E8702A"/>
-                </a:solidFill>
-                <a:latin typeface="Garamond" pitchFamily="34" charset="0"/>
-                <a:ea typeface="Garamond" pitchFamily="34" charset="-122"/>
-                <a:cs typeface="Garamond" pitchFamily="34" charset="-120"/>
-              </a:rPr>
-              <a:t>CFM56 work flows from OEMs and airline shops to independents</a:t>
-            </a:r>
-            <a:r>
-              <a:rPr lang="en-US" sz="1050" baseline="30000" dirty="0">
-                <a:solidFill>
-                  <a:srgbClr val="E8702A"/>
-                </a:solidFill>
-                <a:latin typeface="Garamond" pitchFamily="34" charset="0"/>
-                <a:ea typeface="Garamond" pitchFamily="34" charset="-122"/>
-                <a:cs typeface="Garamond" pitchFamily="34" charset="-120"/>
-              </a:rPr>
-              <a:t>1</a:t>
-            </a:r>
-            <a:endParaRPr lang="en-US" sz="1050" dirty="0"/>
-          </a:p>
-        </p:txBody>
-      </p:sp>
-      <p:sp>
-        <p:nvSpPr>
-          <p:cNvPr id="7" name="Text 4"/>
-          <p:cNvSpPr txBox="1"/>
-          <p:nvPr/>
-        </p:nvSpPr>
-        <p:spPr>
-          <a:xfrm>
-            <a:off x="621792" y="2542032"/>
-            <a:ext cx="5486400" cy="896112"/>
+            <a:off x="6565392" y="2029968"/>
+            <a:ext cx="5257800" cy="1463040"/>
           </a:xfrm>
           <a:prstGeom prst="rect">
             <a:avLst/>
@@ -43922,13 +43122,13 @@
           <a:p>
             <a:pPr marL="177800" indent="-177800">
               <a:spcAft>
-                <a:spcPts val="200"/>
+                <a:spcPts val="100"/>
               </a:spcAft>
               <a:buSzPct val="100000"/>
               <a:buChar char="•"/>
             </a:pPr>
             <a:r>
-              <a:rPr lang="en-US" sz="1050" b="1" dirty="0">
+              <a:rPr lang="en-US" sz="1000" b="1" dirty="0">
                 <a:solidFill>
                   <a:srgbClr val="1A1A1A"/>
                 </a:solidFill>
@@ -43939,7 +43139,7 @@
               <a:t>OEMs:</a:t>
             </a:r>
             <a:r>
-              <a:rPr lang="en-US" sz="1050" dirty="0">
+              <a:rPr lang="en-US" sz="1000" dirty="0">
                 <a:solidFill>
                   <a:srgbClr val="1A1A1A"/>
                 </a:solidFill>
@@ -43950,7 +43150,7 @@
               <a:t> all new sites </a:t>
             </a:r>
             <a:r>
-              <a:rPr lang="en-US" sz="1050" u="sng" dirty="0">
+              <a:rPr lang="en-US" sz="1000" u="sng" dirty="0">
                 <a:solidFill>
                   <a:srgbClr val="1A1A1A"/>
                 </a:solidFill>
@@ -43961,7 +43161,7 @@
               <a:t>LEAP-only</a:t>
             </a:r>
             <a:r>
-              <a:rPr lang="en-US" sz="1050" dirty="0">
+              <a:rPr lang="en-US" sz="1000" dirty="0">
                 <a:solidFill>
                   <a:srgbClr val="1A1A1A"/>
                 </a:solidFill>
@@ -43972,7 +43172,7 @@
               <a:t> (Brazil, India, Mexico, Belgium); CFM </a:t>
             </a:r>
             <a:r>
-              <a:rPr lang="en-US" sz="1050" u="sng" dirty="0">
+              <a:rPr lang="en-US" sz="1000" u="sng" dirty="0">
                 <a:solidFill>
                   <a:srgbClr val="1A1A1A"/>
                 </a:solidFill>
@@ -43983,7 +43183,7 @@
               <a:t>gives up Ryanair CFM56 labor from 2029</a:t>
             </a:r>
             <a:r>
-              <a:rPr lang="en-US" sz="1050" dirty="0">
+              <a:rPr lang="en-US" sz="1000" dirty="0">
                 <a:solidFill>
                   <a:srgbClr val="1A1A1A"/>
                 </a:solidFill>
@@ -43993,18 +43193,18 @@
               </a:rPr>
               <a:t> – its largest CFM56 account – keeping only parts</a:t>
             </a:r>
-            <a:endParaRPr lang="en-US" sz="1050" dirty="0"/>
+            <a:endParaRPr lang="en-US" sz="1000" dirty="0"/>
           </a:p>
           <a:p>
             <a:pPr marL="177800" indent="-177800">
               <a:spcAft>
-                <a:spcPts val="200"/>
+                <a:spcPts val="100"/>
               </a:spcAft>
               <a:buSzPct val="100000"/>
               <a:buChar char="•"/>
             </a:pPr>
             <a:r>
-              <a:rPr lang="en-US" sz="1050" b="1" dirty="0">
+              <a:rPr lang="en-US" sz="1000" b="1" dirty="0">
                 <a:solidFill>
                   <a:srgbClr val="1A1A1A"/>
                 </a:solidFill>
@@ -44015,7 +43215,7 @@
               <a:t>First airline flip:</a:t>
             </a:r>
             <a:r>
-              <a:rPr lang="en-US" sz="1050" dirty="0">
+              <a:rPr lang="en-US" sz="1000" dirty="0">
                 <a:solidFill>
                   <a:srgbClr val="1A1A1A"/>
                 </a:solidFill>
@@ -44026,7 +43226,7 @@
               <a:t> Lufthansa Group sends its </a:t>
             </a:r>
             <a:r>
-              <a:rPr lang="en-US" sz="1050" u="sng" dirty="0">
+              <a:rPr lang="en-US" sz="1000" u="sng" dirty="0">
                 <a:solidFill>
                   <a:srgbClr val="1A1A1A"/>
                 </a:solidFill>
@@ -44037,7 +43237,7 @@
               <a:t>own CFM56 to FL Technics</a:t>
             </a:r>
             <a:r>
-              <a:rPr lang="en-US" sz="1050" dirty="0">
+              <a:rPr lang="en-US" sz="1000" dirty="0">
                 <a:solidFill>
                   <a:srgbClr val="1A1A1A"/>
                 </a:solidFill>
@@ -44047,40 +43247,18 @@
               </a:rPr>
               <a:t> (Oct-26) as Hamburg turns LEAP</a:t>
             </a:r>
-            <a:endParaRPr lang="en-US" sz="1050" dirty="0"/>
+            <a:endParaRPr lang="en-US" sz="1000" dirty="0"/>
           </a:p>
-        </p:txBody>
-      </p:sp>
-      <p:sp>
-        <p:nvSpPr>
-          <p:cNvPr id="8" name="Text 5"/>
-          <p:cNvSpPr txBox="1"/>
-          <p:nvPr/>
-        </p:nvSpPr>
-        <p:spPr>
-          <a:xfrm>
-            <a:off x="6336792" y="2542032"/>
-            <a:ext cx="5486400" cy="896112"/>
-          </a:xfrm>
-          <a:prstGeom prst="rect">
-            <a:avLst/>
-          </a:prstGeom>
-          <a:noFill/>
-          <a:ln/>
-        </p:spPr>
-        <p:txBody>
-          <a:bodyPr wrap="square" lIns="25400" tIns="25400" rIns="25400" bIns="25400" rtlCol="0" anchor="t"/>
-          <a:lstStyle/>
           <a:p>
             <a:pPr marL="177800" indent="-177800">
               <a:spcAft>
-                <a:spcPts val="200"/>
+                <a:spcPts val="100"/>
               </a:spcAft>
               <a:buSzPct val="100000"/>
               <a:buChar char="•"/>
             </a:pPr>
             <a:r>
-              <a:rPr lang="en-US" sz="1050" b="1" dirty="0">
+              <a:rPr lang="en-US" sz="1000" b="1" dirty="0">
                 <a:solidFill>
                   <a:srgbClr val="1A1A1A"/>
                 </a:solidFill>
@@ -44091,7 +43269,7 @@
               <a:t>Moving to independents:</a:t>
             </a:r>
             <a:r>
-              <a:rPr lang="en-US" sz="1050" dirty="0">
+              <a:rPr lang="en-US" sz="1000" dirty="0">
                 <a:solidFill>
                   <a:srgbClr val="1A1A1A"/>
                 </a:solidFill>
@@ -44102,7 +43280,7 @@
               <a:t> EVA Air → MTU (first non-OEM, May-26); </a:t>
             </a:r>
             <a:r>
-              <a:rPr lang="en-US" sz="1050" u="sng" dirty="0">
+              <a:rPr lang="en-US" sz="1000" u="sng" dirty="0">
                 <a:solidFill>
                   <a:srgbClr val="1A1A1A"/>
                 </a:solidFill>
@@ -44113,7 +43291,7 @@
               <a:t>United → FTAI</a:t>
             </a:r>
             <a:r>
-              <a:rPr lang="en-US" sz="1050" dirty="0">
+              <a:rPr lang="en-US" sz="1000" dirty="0">
                 <a:solidFill>
                   <a:srgbClr val="1A1A1A"/>
                 </a:solidFill>
@@ -44123,18 +43301,18 @@
               </a:rPr>
               <a:t> CFM56-7B MRE (Oct-26)</a:t>
             </a:r>
-            <a:endParaRPr lang="en-US" sz="1050" dirty="0"/>
+            <a:endParaRPr lang="en-US" sz="1000" dirty="0"/>
           </a:p>
           <a:p>
             <a:pPr marL="177800" indent="-177800">
               <a:spcAft>
-                <a:spcPts val="200"/>
+                <a:spcPts val="100"/>
               </a:spcAft>
               <a:buSzPct val="100000"/>
               <a:buChar char="•"/>
             </a:pPr>
             <a:r>
-              <a:rPr lang="en-US" sz="1050" b="1" dirty="0">
+              <a:rPr lang="en-US" sz="1000" b="1" dirty="0">
                 <a:solidFill>
                   <a:srgbClr val="1A1A1A"/>
                 </a:solidFill>
@@ -44145,7 +43323,7 @@
               <a:t>Counter:</a:t>
             </a:r>
             <a:r>
-              <a:rPr lang="en-US" sz="1050" dirty="0">
+              <a:rPr lang="en-US" sz="1000" dirty="0">
                 <a:solidFill>
                   <a:srgbClr val="1A1A1A"/>
                 </a:solidFill>
@@ -44156,7 +43334,7 @@
               <a:t> Korean Air keeps CFM56, outsources LEAP; independents add CFM56 too – </a:t>
             </a:r>
             <a:r>
-              <a:rPr lang="en-US" sz="1050" u="sng" dirty="0">
+              <a:rPr lang="en-US" sz="1000" u="sng" dirty="0">
                 <a:solidFill>
                   <a:srgbClr val="1A1A1A"/>
                 </a:solidFill>
@@ -44166,13 +43344,24 @@
               </a:rPr>
               <a:t>overflow is real, but contested</a:t>
             </a:r>
-            <a:endParaRPr lang="en-US" sz="1050" dirty="0"/>
+            <a:r>
+              <a:rPr lang="en-US" sz="1000" baseline="30000" dirty="0">
+                <a:solidFill>
+                  <a:srgbClr val="1A1A1A"/>
+                </a:solidFill>
+                <a:latin typeface="Garamond" pitchFamily="34" charset="0"/>
+                <a:ea typeface="Garamond" pitchFamily="34" charset="-122"/>
+                <a:cs typeface="Garamond" pitchFamily="34" charset="-120"/>
+              </a:rPr>
+              <a:t>1</a:t>
+            </a:r>
+            <a:endParaRPr lang="en-US" sz="1000" dirty="0"/>
           </a:p>
         </p:txBody>
       </p:sp>
       <p:sp>
         <p:nvSpPr>
-          <p:cNvPr id="9" name="Text 6"/>
+          <p:cNvPr id="9" name="Text 5"/>
           <p:cNvSpPr txBox="1"/>
           <p:nvPr/>
         </p:nvSpPr>
@@ -44211,7 +43400,7 @@
       </p:sp>
       <p:sp>
         <p:nvSpPr>
-          <p:cNvPr id="10" name="Shape 7"/>
+          <p:cNvPr id="10" name="Shape 6"/>
           <p:cNvSpPr/>
           <p:nvPr/>
         </p:nvSpPr>
@@ -44244,7 +43433,7 @@
         </p:xfrm>
         <a:graphic xmlns:a="http://schemas.openxmlformats.org/drawingml/2006/main">
           <a:graphicData uri="http://schemas.openxmlformats.org/drawingml/2006/chart">
-            <c:chart xmlns:c="http://schemas.openxmlformats.org/drawingml/2006/chart" r:id="rId1"/>
+            <c:chart xmlns:c="http://schemas.openxmlformats.org/drawingml/2006/chart" r:id="rId2"/>
           </a:graphicData>
         </a:graphic>
       </p:graphicFrame>
@@ -44260,13 +43449,13 @@
         </p:xfrm>
         <a:graphic xmlns:a="http://schemas.openxmlformats.org/drawingml/2006/main">
           <a:graphicData uri="http://schemas.openxmlformats.org/drawingml/2006/chart">
-            <c:chart xmlns:c="http://schemas.openxmlformats.org/drawingml/2006/chart" r:id="rId2"/>
+            <c:chart xmlns:c="http://schemas.openxmlformats.org/drawingml/2006/chart" r:id="rId3"/>
           </a:graphicData>
         </a:graphic>
       </p:graphicFrame>
       <p:sp>
         <p:nvSpPr>
-          <p:cNvPr id="13" name="Shape 8"/>
+          <p:cNvPr id="13" name="Shape 7"/>
           <p:cNvSpPr/>
           <p:nvPr/>
         </p:nvSpPr>
@@ -44289,7 +43478,7 @@
       </p:sp>
       <p:sp>
         <p:nvSpPr>
-          <p:cNvPr id="14" name="Text 9"/>
+          <p:cNvPr id="14" name="Text 8"/>
           <p:cNvSpPr txBox="1"/>
           <p:nvPr/>
         </p:nvSpPr>
@@ -44516,7 +43705,7 @@
       </p:sp>
       <p:sp>
         <p:nvSpPr>
-          <p:cNvPr id="15" name="Shape 10"/>
+          <p:cNvPr id="15" name="Shape 9"/>
           <p:cNvSpPr/>
           <p:nvPr/>
         </p:nvSpPr>
@@ -44541,7 +43730,7 @@
       </p:sp>
       <p:sp>
         <p:nvSpPr>
-          <p:cNvPr id="16" name="Text 11"/>
+          <p:cNvPr id="16" name="Text 10"/>
           <p:cNvSpPr txBox="1"/>
           <p:nvPr/>
         </p:nvSpPr>
@@ -44605,7 +43794,7 @@
       </p:sp>
       <p:sp>
         <p:nvSpPr>
-          <p:cNvPr id="17" name="Shape 12"/>
+          <p:cNvPr id="17" name="Shape 11"/>
           <p:cNvSpPr/>
           <p:nvPr/>
         </p:nvSpPr>
@@ -44630,7 +43819,7 @@
       </p:sp>
       <p:sp>
         <p:nvSpPr>
-          <p:cNvPr id="18" name="Text 13"/>
+          <p:cNvPr id="18" name="Text 12"/>
           <p:cNvSpPr txBox="1"/>
           <p:nvPr/>
         </p:nvSpPr>
@@ -44669,7 +43858,7 @@
       </p:sp>
       <p:sp>
         <p:nvSpPr>
-          <p:cNvPr id="19" name="Text 14"/>
+          <p:cNvPr id="19" name="Text 13"/>
           <p:cNvSpPr txBox="1"/>
           <p:nvPr/>
         </p:nvSpPr>
@@ -44708,7 +43897,7 @@
       </p:sp>
       <p:sp>
         <p:nvSpPr>
-          <p:cNvPr id="20" name="Text 15"/>
+          <p:cNvPr id="20" name="Text 14"/>
           <p:cNvSpPr txBox="1"/>
           <p:nvPr/>
         </p:nvSpPr>

</xml_diff>

<commit_message>
Update cover byline and remove firm and GPS source references
Cover now credits Sara Jankovic, Josephine Sun, Andrew Chen and Max
Salomon; firm name and logo removed; GPS model and tracker entries
dropped from slide sources and footnotes; master renamed.

Co-Authored-By: Claude Opus 5.5 <noreply@anthropic.com>
Claude-Session: https://claude.ai/code/session_01UfcjrwVkNc9oEPnjB82u2w
</commit_message>
<xml_diff>
--- a/ftai_pitch/FTAI_Long_Pitch.pptx
+++ b/ftai_pitch/FTAI_Long_Pitch.pptx
@@ -9107,7 +9107,7 @@
 
 <file path=ppt/slideLayouts/slideLayout2.xml><?xml version="1.0" encoding="utf-8"?>
 <p:sldLayout xmlns:a="http://schemas.openxmlformats.org/drawingml/2006/main" xmlns:r="http://schemas.openxmlformats.org/officeDocument/2006/relationships" xmlns:p="http://schemas.openxmlformats.org/presentationml/2006/main" preserve="1">
-  <p:cSld name="GPS">
+  <p:cSld name="Pitch">
     <p:bg>
       <p:bgPr>
         <a:solidFill>
@@ -10524,7 +10524,7 @@
         <p:spPr>
           <a:xfrm>
             <a:off x="502920" y="3749040"/>
-            <a:ext cx="5669280" cy="365760"/>
+            <a:ext cx="5577840" cy="685800"/>
           </a:xfrm>
           <a:prstGeom prst="rect">
             <a:avLst/>
@@ -10533,14 +10533,14 @@
           <a:ln/>
         </p:spPr>
         <p:txBody>
-          <a:bodyPr wrap="square" lIns="0" tIns="0" rIns="0" bIns="0" rtlCol="0" anchor="ctr"/>
+          <a:bodyPr wrap="square" lIns="0" tIns="0" rIns="0" bIns="0" rtlCol="0" anchor="t"/>
           <a:lstStyle/>
           <a:p>
             <a:pPr indent="0" marL="0">
               <a:buNone/>
             </a:pPr>
             <a:r>
-              <a:rPr lang="en-US" sz="2100" dirty="0">
+              <a:rPr lang="en-US" sz="1800" dirty="0">
                 <a:solidFill>
                   <a:srgbClr val="203040"/>
                 </a:solidFill>
@@ -10548,9 +10548,26 @@
                 <a:ea typeface="Garamond" pitchFamily="34" charset="-122"/>
                 <a:cs typeface="Garamond" pitchFamily="34" charset="-120"/>
               </a:rPr>
-              <a:t>Global Platinum Securities</a:t>
-            </a:r>
-            <a:endParaRPr lang="en-US" sz="2100" dirty="0"/>
+              <a:t>By Sara Jankovic, Josephine Sun,</a:t>
+            </a:r>
+            <a:endParaRPr lang="en-US" sz="1800" dirty="0"/>
+          </a:p>
+          <a:p>
+            <a:pPr indent="0" marL="0">
+              <a:buNone/>
+            </a:pPr>
+            <a:r>
+              <a:rPr lang="en-US" sz="1800" dirty="0">
+                <a:solidFill>
+                  <a:srgbClr val="203040"/>
+                </a:solidFill>
+                <a:latin typeface="Garamond" pitchFamily="34" charset="0"/>
+                <a:ea typeface="Garamond" pitchFamily="34" charset="-122"/>
+                <a:cs typeface="Garamond" pitchFamily="34" charset="-120"/>
+              </a:rPr>
+              <a:t>Andrew Chen, and Max Salomon</a:t>
+            </a:r>
+            <a:endParaRPr lang="en-US" sz="1800" dirty="0"/>
           </a:p>
         </p:txBody>
       </p:sp>
@@ -10562,7 +10579,7 @@
         </p:nvSpPr>
         <p:spPr>
           <a:xfrm>
-            <a:off x="502920" y="4114800"/>
+            <a:off x="502920" y="4480560"/>
             <a:ext cx="5669280" cy="274320"/>
           </a:xfrm>
           <a:prstGeom prst="rect">
@@ -10587,7 +10604,7 @@
                 <a:ea typeface="Garamond" pitchFamily="34" charset="-122"/>
                 <a:cs typeface="Garamond" pitchFamily="34" charset="-120"/>
               </a:rPr>
-              <a:t>Max Salomon  |  October 2026</a:t>
+              <a:t>October 2026</a:t>
             </a:r>
             <a:endParaRPr lang="en-US" sz="1300" dirty="0"/>
           </a:p>
@@ -10601,7 +10618,7 @@
         </p:nvSpPr>
         <p:spPr>
           <a:xfrm>
-            <a:off x="502920" y="4617720"/>
+            <a:off x="502920" y="4983480"/>
             <a:ext cx="5669280" cy="411480"/>
           </a:xfrm>
           <a:prstGeom prst="rect">
@@ -10629,79 +10646,6 @@
               <a:t>A compounder still priced for a fraud.</a:t>
             </a:r>
             <a:endParaRPr lang="en-US" sz="2100" dirty="0"/>
-          </a:p>
-        </p:txBody>
-      </p:sp>
-      <p:sp>
-        <p:nvSpPr>
-          <p:cNvPr id="27" name="Text 25"/>
-          <p:cNvSpPr txBox="1"/>
-          <p:nvPr/>
-        </p:nvSpPr>
-        <p:spPr>
-          <a:xfrm>
-            <a:off x="502920" y="5394960"/>
-            <a:ext cx="3657600" cy="1005840"/>
-          </a:xfrm>
-          <a:prstGeom prst="rect">
-            <a:avLst/>
-          </a:prstGeom>
-          <a:noFill/>
-          <a:ln/>
-        </p:spPr>
-        <p:txBody>
-          <a:bodyPr wrap="square" lIns="0" tIns="0" rIns="0" bIns="0" rtlCol="0" anchor="ctr"/>
-          <a:lstStyle/>
-          <a:p>
-            <a:pPr indent="0" marL="0">
-              <a:buNone/>
-            </a:pPr>
-            <a:r>
-              <a:rPr lang="en-US" sz="2600" b="1" spc="600" kern="0" dirty="0">
-                <a:solidFill>
-                  <a:srgbClr val="1F3864"/>
-                </a:solidFill>
-                <a:latin typeface="Garamond" pitchFamily="34" charset="0"/>
-                <a:ea typeface="Garamond" pitchFamily="34" charset="-122"/>
-                <a:cs typeface="Garamond" pitchFamily="34" charset="-120"/>
-              </a:rPr>
-              <a:t>GLOBAL</a:t>
-            </a:r>
-            <a:endParaRPr lang="en-US" sz="2600" dirty="0"/>
-          </a:p>
-          <a:p>
-            <a:pPr indent="0" marL="0">
-              <a:buNone/>
-            </a:pPr>
-            <a:r>
-              <a:rPr lang="en-US" sz="1300" spc="900" kern="0" dirty="0">
-                <a:solidFill>
-                  <a:srgbClr val="7F8FA6"/>
-                </a:solidFill>
-                <a:latin typeface="Garamond" pitchFamily="34" charset="0"/>
-                <a:ea typeface="Garamond" pitchFamily="34" charset="-122"/>
-                <a:cs typeface="Garamond" pitchFamily="34" charset="-120"/>
-              </a:rPr>
-              <a:t>PLATINUM</a:t>
-            </a:r>
-            <a:endParaRPr lang="en-US" sz="2600" dirty="0"/>
-          </a:p>
-          <a:p>
-            <a:pPr indent="0" marL="0">
-              <a:buNone/>
-            </a:pPr>
-            <a:r>
-              <a:rPr lang="en-US" sz="1300" b="1" spc="700" kern="0" dirty="0">
-                <a:solidFill>
-                  <a:srgbClr val="1F3864"/>
-                </a:solidFill>
-                <a:latin typeface="Garamond" pitchFamily="34" charset="0"/>
-                <a:ea typeface="Garamond" pitchFamily="34" charset="-122"/>
-                <a:cs typeface="Garamond" pitchFamily="34" charset="-120"/>
-              </a:rPr>
-              <a:t>SECURITIES</a:t>
-            </a:r>
-            <a:endParaRPr lang="en-US" sz="2600" dirty="0"/>
           </a:p>
         </p:txBody>
       </p:sp>
@@ -13284,7 +13228,7 @@
                 <a:ea typeface="Garamond" pitchFamily="34" charset="-122"/>
                 <a:cs typeface="Garamond" pitchFamily="34" charset="-120"/>
               </a:rPr>
-              <a:t>Source: Company filings (AMZN, GOOGL, META, MSFT), BCSE / BNEF, NERC 2025 LTRA, ERCOT, PJM, FTAI release (22-Jul-26), MDEQ, DCD, SemiAnalysis, GPS Model</a:t>
+              <a:t>Source: Company filings (AMZN, GOOGL, META, MSFT), BCSE / BNEF, NERC 2025 LTRA, ERCOT, PJM, FTAI release (22-Jul-26), MDEQ, DCD, SemiAnalysis</a:t>
             </a:r>
             <a:endParaRPr lang="en-US" sz="1100" dirty="0"/>
           </a:p>
@@ -13323,7 +13267,7 @@
                 <a:ea typeface="Garamond" pitchFamily="34" charset="-122"/>
                 <a:cs typeface="Garamond" pitchFamily="34" charset="-120"/>
               </a:rPr>
-              <a:t>1.  GPS regional model: NERC demand vs. anticipated capacity + 67 tracked hyperscaler power agreements.</a:t>
+              <a:t>1.  Regional model: NERC demand vs. anticipated capacity + 67 tracked hyperscaler power agreements.</a:t>
             </a:r>
             <a:endParaRPr lang="en-US" sz="700" dirty="0"/>
           </a:p>
@@ -18640,7 +18584,7 @@
                 <a:ea typeface="Garamond" pitchFamily="34" charset="-122"/>
                 <a:cs typeface="Garamond" pitchFamily="34" charset="-120"/>
               </a:rPr>
-              <a:t>Source: GPS Power Next-Contract Model, Jereh filings / order ledger, Company releases, TCEQ / MDEQ filings, Cleanview, Epoch AI, DCD, GE Vernova / Siemens Energy / MHI Q2'26, GridLab, JLL, FTAI calls, GPS Model</a:t>
+              <a:t>Source: Jereh filings / order ledger, Company releases, TCEQ / MDEQ filings, Cleanview, Epoch AI, DCD, GE Vernova / Siemens Energy / MHI Q2'26, GridLab, JLL, FTAI calls</a:t>
             </a:r>
             <a:endParaRPr lang="en-US" sz="1100" dirty="0"/>
           </a:p>
@@ -26586,7 +26530,7 @@
                 <a:ea typeface="Garamond" pitchFamily="34" charset="-122"/>
                 <a:cs typeface="Garamond" pitchFamily="34" charset="-120"/>
               </a:rPr>
-              <a:t>Source: GPS Model (case toggle, driver-level bear → base switch), FTAI filings; $167.03 (10/2/26); 104.0M shares</a:t>
+              <a:t>Source: FTAI filings; $167.03 (10/2/26); 104.0M shares</a:t>
             </a:r>
             <a:endParaRPr lang="en-US" sz="1100" dirty="0"/>
           </a:p>
@@ -28524,7 +28468,7 @@
                 <a:ea typeface="Garamond" pitchFamily="34" charset="-122"/>
                 <a:cs typeface="Garamond" pitchFamily="34" charset="-120"/>
               </a:rPr>
-              <a:t>Source: Company Filings and Calls, Muddy Waters, GE Aerospace, J&amp;F order release (Jul-26), TechCrunch (Boom–Crusoe), GPS Model</a:t>
+              <a:t>Source: Company Filings and Calls, Muddy Waters, GE Aerospace, J&amp;F order release (Jul-26), TechCrunch (Boom–Crusoe)</a:t>
             </a:r>
             <a:endParaRPr lang="en-US" sz="1100" dirty="0"/>
           </a:p>
@@ -29910,7 +29854,7 @@
                 <a:ea typeface="Garamond" pitchFamily="34" charset="-122"/>
                 <a:cs typeface="Garamond" pitchFamily="34" charset="-120"/>
               </a:rPr>
-              <a:t>Source: Company Filings, Muddy Waters Research (Jan-25), Earnings Calls, Bloomberg, GPS Model</a:t>
+              <a:t>Source: Company Filings, Muddy Waters Research (Jan-25), Earnings Calls, Bloomberg</a:t>
             </a:r>
             <a:endParaRPr lang="en-US" sz="1100" dirty="0"/>
           </a:p>
@@ -33002,7 +32946,7 @@
                 <a:ea typeface="Garamond" pitchFamily="34" charset="-122"/>
                 <a:cs typeface="Garamond" pitchFamily="34" charset="-120"/>
               </a:rPr>
-              <a:t>Source: Company Filings, Earnings Calls, Investor Presentation, GPS Model</a:t>
+              <a:t>Source: Company Filings, Earnings Calls, Investor Presentation</a:t>
             </a:r>
             <a:endParaRPr lang="en-US" sz="1100" dirty="0"/>
           </a:p>
@@ -34193,7 +34137,7 @@
                 <a:ea typeface="Garamond" pitchFamily="34" charset="-122"/>
                 <a:cs typeface="Garamond" pitchFamily="34" charset="-120"/>
               </a:rPr>
-              <a:t>Source: GE / Safran shop-visit outlook &amp; cohort data, Aviation Week, SR Technics CFM56 catalogues (2024–26), Company Filings, GPS Model</a:t>
+              <a:t>Source: GE / Safran shop-visit outlook &amp; cohort data, Aviation Week, SR Technics CFM56 catalogues (2024–26), Company Filings</a:t>
             </a:r>
             <a:endParaRPr lang="en-US" sz="1100" dirty="0"/>
           </a:p>
@@ -38381,7 +38325,7 @@
                 <a:ea typeface="Garamond" pitchFamily="34" charset="-122"/>
                 <a:cs typeface="Garamond" pitchFamily="34" charset="-120"/>
               </a:rPr>
-              <a:t>Source: 10-Q disclosures, Muddy Waters, Earnings Calls, In Practise, OEM cohort data, GPS Model</a:t>
+              <a:t>Source: 10-Q disclosures, Muddy Waters, Earnings Calls, In Practise, OEM cohort data</a:t>
             </a:r>
             <a:endParaRPr lang="en-US" sz="1100" dirty="0"/>
           </a:p>
@@ -41490,7 +41434,7 @@
                 <a:ea typeface="Garamond" pitchFamily="34" charset="-122"/>
                 <a:cs typeface="Garamond" pitchFamily="34" charset="-120"/>
               </a:rPr>
-              <a:t>Source: Chromalloy / FAA, Aviation Week, AviTrader, SR Technics catalogues, FTAI filings, GPS Model</a:t>
+              <a:t>Source: Chromalloy / FAA, Aviation Week, AviTrader, SR Technics catalogues, FTAI filings</a:t>
             </a:r>
             <a:endParaRPr lang="en-US" sz="1100" dirty="0"/>
           </a:p>
@@ -43889,7 +43833,7 @@
                 <a:ea typeface="Garamond" pitchFamily="34" charset="-122"/>
                 <a:cs typeface="Garamond" pitchFamily="34" charset="-120"/>
               </a:rPr>
-              <a:t>Source: GPS CFM56 Outsourcing Flip Tracker (14 tier-1 shops, Oct-26), Company Releases, GE / Safran, IATA / Platts, Aviation Week</a:t>
+              <a:t>Source: Company Releases, GE / Safran, IATA / Platts, Aviation Week</a:t>
             </a:r>
             <a:endParaRPr lang="en-US" sz="1100" dirty="0"/>
           </a:p>
@@ -43928,7 +43872,7 @@
                 <a:ea typeface="Garamond" pitchFamily="34" charset="-122"/>
                 <a:cs typeface="Garamond" pitchFamily="34" charset="-120"/>
               </a:rPr>
-              <a:t>1.  Tracker: public releases, filings, trade press; not exhaustive (a floor).</a:t>
+              <a:t>1.  Flip tracker (14 tier-1 shops, Oct-26): public sources; a floor.</a:t>
             </a:r>
             <a:endParaRPr lang="en-US" sz="700" dirty="0"/>
           </a:p>
@@ -43962,7 +43906,7 @@
                 <a:ea typeface="Garamond" pitchFamily="34" charset="-122"/>
                 <a:cs typeface="Garamond" pitchFamily="34" charset="-120"/>
               </a:rPr>
-              <a:t>3.  GPS est.: 15% fuel saving vs. $2–2.6M / yr MAX lease premium.</a:t>
+              <a:t>3.  Estimate: 15% fuel saving vs. $2–2.6M / yr MAX lease premium.</a:t>
             </a:r>
             <a:endParaRPr lang="en-US" sz="700" dirty="0"/>
           </a:p>
@@ -48065,7 +48009,7 @@
                 <a:ea typeface="Garamond" pitchFamily="34" charset="-122"/>
                 <a:cs typeface="Garamond" pitchFamily="34" charset="-120"/>
               </a:rPr>
-              <a:t>Source: FTAI Calls and Supplement, United / FTAI (Oct-26), GMF / FTAI (Sep-26), Willis Lease, SR Technics, In Practise, GPS Model</a:t>
+              <a:t>Source: FTAI Calls and Supplement, United / FTAI (Oct-26), GMF / FTAI (Sep-26), Willis Lease, SR Technics, In Practise</a:t>
             </a:r>
             <a:endParaRPr lang="en-US" sz="1100" dirty="0"/>
           </a:p>
@@ -48104,7 +48048,7 @@
                 <a:ea typeface="Garamond" pitchFamily="34" charset="-122"/>
                 <a:cs typeface="Garamond" pitchFamily="34" charset="-120"/>
               </a:rPr>
-              <a:t>1.  GPS Test Cell Tracker (18 cells, Oct-26); no public case of a cell dropping CFM56 for LEAP.</a:t>
+              <a:t>1.  Test cell tracker (18 cells, Oct-26); no public case of a cell dropping CFM56 for LEAP.</a:t>
             </a:r>
             <a:endParaRPr lang="en-US" sz="700" dirty="0"/>
           </a:p>

</xml_diff>

<commit_message>
Add appendix slide on AI usage in diligence
Maps each workstream (repair-price scrape, 10-Q extraction, flip and
test cell trackers, fuel check, campus screen, Jereh ledger, grid gap)
to what AI did, what it produced and where it is used, with guardrails.

Co-Authored-By: Claude Opus 5.5 <noreply@anthropic.com>
Claude-Session: https://claude.ai/code/session_01UfcjrwVkNc9oEPnjB82u2w
</commit_message>
<xml_diff>
--- a/ftai_pitch/FTAI_Long_Pitch.pptx
+++ b/ftai_pitch/FTAI_Long_Pitch.pptx
@@ -18,9 +18,10 @@
     <p:sldId id="266" r:id="rId12"/>
     <p:sldId id="267" r:id="rId13"/>
     <p:sldId id="268" r:id="rId14"/>
+    <p:sldId id="269" r:id="rId15"/>
   </p:sldIdLst>
   <p:notesMasterIdLst>
-    <p:notesMasterId r:id="rId15"/>
+    <p:notesMasterId r:id="rId16"/>
   </p:notesMasterIdLst>
   <p:sldSz cx="12192000" cy="6858000"/>
   <p:notesSz cx="6858000" cy="12192000"/>
@@ -8371,6 +8372,94 @@
 </p:notes>
 </file>
 
+<file path=ppt/notesSlides/notesSlide14.xml><?xml version="1.0" encoding="utf-8"?>
+<p:notes xmlns:a="http://schemas.openxmlformats.org/drawingml/2006/main" xmlns:r="http://schemas.openxmlformats.org/officeDocument/2006/relationships" xmlns:p="http://schemas.openxmlformats.org/presentationml/2006/main">
+  <p:cSld>
+    <p:spTree>
+      <p:nvGrpSpPr>
+        <p:cNvPr id="1" name=""/>
+        <p:cNvGrpSpPr/>
+        <p:nvPr/>
+      </p:nvGrpSpPr>
+      <p:grpSpPr>
+        <a:xfrm>
+          <a:off x="0" y="0"/>
+          <a:ext cx="0" cy="0"/>
+          <a:chOff x="0" y="0"/>
+          <a:chExt cx="0" cy="0"/>
+        </a:xfrm>
+      </p:grpSpPr>
+      <p:sp>
+        <p:nvSpPr>
+          <p:cNvPr id="2" name="Slide Image Placeholder 1"/>
+          <p:cNvSpPr>
+            <a:spLocks noGrp="1" noRot="1" noChangeAspect="1"/>
+          </p:cNvSpPr>
+          <p:nvPr>
+            <p:ph type="sldImg"/>
+          </p:nvPr>
+        </p:nvSpPr>
+        <p:spPr/>
+      </p:sp>
+      <p:sp>
+        <p:nvSpPr>
+          <p:cNvPr id="3" name="Notes Placeholder 2"/>
+          <p:cNvSpPr>
+            <a:spLocks noGrp="1"/>
+          </p:cNvSpPr>
+          <p:nvPr>
+            <p:ph type="body" idx="1"/>
+          </p:nvPr>
+        </p:nvSpPr>
+        <p:spPr/>
+        <p:txBody>
+          <a:bodyPr/>
+          <a:lstStyle/>
+          <a:p>
+            <a:r>
+              <a:rPr lang="en-US" dirty="0"/>
+              <a:t/>
+            </a:r>
+            <a:endParaRPr lang="en-US" dirty="0"/>
+          </a:p>
+        </p:txBody>
+      </p:sp>
+      <p:sp>
+        <p:nvSpPr>
+          <p:cNvPr id="4" name="Slide Number Placeholder 3"/>
+          <p:cNvSpPr>
+            <a:spLocks noGrp="1"/>
+          </p:cNvSpPr>
+          <p:nvPr>
+            <p:ph type="sldNum" sz="quarter" idx="10"/>
+          </p:nvPr>
+        </p:nvSpPr>
+        <p:spPr/>
+        <p:txBody>
+          <a:bodyPr/>
+          <a:lstStyle/>
+          <a:p>
+            <a:fld id="{F7021451-1387-4CA6-816F-3879F97B5CBC}" type="slidenum">
+              <a:rPr lang="en-US"/>
+              <a:t>14</a:t>
+            </a:fld>
+            <a:endParaRPr lang="en-US"/>
+          </a:p>
+        </p:txBody>
+      </p:sp>
+    </p:spTree>
+    <p:extLst>
+      <p:ext uri="{BB962C8B-B14F-4D97-AF65-F5344CB8AC3E}">
+        <p14:creationId xmlns:p14="http://schemas.microsoft.com/office/powerpoint/2010/main" val="1024086991"/>
+      </p:ext>
+    </p:extLst>
+  </p:cSld>
+  <p:clrMapOvr>
+    <a:masterClrMapping/>
+  </p:clrMapOvr>
+</p:notes>
+</file>
+
 <file path=ppt/notesSlides/notesSlide2.xml><?xml version="1.0" encoding="utf-8"?>
 <p:notes xmlns:a="http://schemas.openxmlformats.org/drawingml/2006/main" xmlns:r="http://schemas.openxmlformats.org/officeDocument/2006/relationships" xmlns:p="http://schemas.openxmlformats.org/presentationml/2006/main">
   <p:cSld>
@@ -28569,6 +28658,3181 @@
 </p:sld>
 </file>
 
+<file path=ppt/slides/slide14.xml><?xml version="1.0" encoding="utf-8"?>
+<p:sld xmlns:a="http://schemas.openxmlformats.org/drawingml/2006/main" xmlns:r="http://schemas.openxmlformats.org/officeDocument/2006/relationships" xmlns:p="http://schemas.openxmlformats.org/presentationml/2006/main">
+  <p:cSld name="Slide 14">
+    <p:spTree>
+      <p:nvGrpSpPr>
+        <p:cNvPr id="1" name=""/>
+        <p:cNvGrpSpPr/>
+        <p:nvPr/>
+      </p:nvGrpSpPr>
+      <p:grpSpPr>
+        <a:xfrm>
+          <a:off x="0" y="0"/>
+          <a:ext cx="0" cy="0"/>
+          <a:chOff x="0" y="0"/>
+          <a:chExt cx="0" cy="0"/>
+        </a:xfrm>
+      </p:grpSpPr>
+      <p:sp>
+        <p:nvSpPr>
+          <p:cNvPr id="2" name="Text 4"/>
+          <p:cNvSpPr/>
+          <p:nvPr>
+            <p:ph idx="104" type="title" hasCustomPrompt="1"/>
+          </p:nvPr>
+        </p:nvSpPr>
+        <p:spPr>
+          <a:xfrm>
+            <a:off x="621792" y="274320"/>
+            <a:ext cx="11201400" cy="475488"/>
+          </a:xfrm>
+          <a:prstGeom prst="rect">
+            <a:avLst/>
+          </a:prstGeom>
+          <a:noFill/>
+          <a:ln/>
+        </p:spPr>
+        <p:txBody>
+          <a:bodyPr wrap="square" lIns="0" tIns="0" rIns="0" bIns="0" rtlCol="0" anchor="b"/>
+          <a:lstStyle/>
+          <a:p>
+            <a:pPr algn="l" indent="0" marL="0">
+              <a:buNone/>
+            </a:pPr>
+            <a:r>
+              <a:rPr lang="en-US" sz="2500" dirty="0">
+                <a:solidFill>
+                  <a:srgbClr val="203040"/>
+                </a:solidFill>
+                <a:latin typeface="Garamond" pitchFamily="34" charset="0"/>
+                <a:ea typeface="Garamond" pitchFamily="34" charset="-122"/>
+                <a:cs typeface="Garamond" pitchFamily="34" charset="-120"/>
+              </a:rPr>
+              <a:t>Appendix: How We Used AI – Scrapes at Scale, Judgment Kept Human</a:t>
+            </a:r>
+            <a:endParaRPr lang="en-US" sz="2500" dirty="0"/>
+          </a:p>
+        </p:txBody>
+      </p:sp>
+      <p:sp>
+        <p:nvSpPr>
+          <p:cNvPr id="3" name="Text 1"/>
+          <p:cNvSpPr txBox="1"/>
+          <p:nvPr/>
+        </p:nvSpPr>
+        <p:spPr>
+          <a:xfrm>
+            <a:off x="621792" y="804672"/>
+            <a:ext cx="11201400" cy="274320"/>
+          </a:xfrm>
+          <a:prstGeom prst="rect">
+            <a:avLst/>
+          </a:prstGeom>
+          <a:noFill/>
+          <a:ln/>
+        </p:spPr>
+        <p:txBody>
+          <a:bodyPr wrap="square" lIns="0" tIns="0" rIns="0" bIns="0" rtlCol="0" anchor="b"/>
+          <a:lstStyle/>
+          <a:p>
+            <a:pPr algn="ctr" indent="0" marL="0">
+              <a:buNone/>
+            </a:pPr>
+            <a:r>
+              <a:rPr lang="en-US" sz="1350" b="1" dirty="0">
+                <a:solidFill>
+                  <a:srgbClr val="203040"/>
+                </a:solidFill>
+                <a:latin typeface="Garamond" pitchFamily="34" charset="0"/>
+                <a:ea typeface="Garamond" pitchFamily="34" charset="-122"/>
+                <a:cs typeface="Garamond" pitchFamily="34" charset="-120"/>
+              </a:rPr>
+              <a:t>AI let four analysts build datasets the street doesn't have – every number it pulled was traced back to a primary source.</a:t>
+            </a:r>
+            <a:endParaRPr lang="en-US" sz="1350" dirty="0"/>
+          </a:p>
+        </p:txBody>
+      </p:sp>
+      <p:sp>
+        <p:nvSpPr>
+          <p:cNvPr id="4" name="Shape 2"/>
+          <p:cNvSpPr/>
+          <p:nvPr/>
+        </p:nvSpPr>
+        <p:spPr>
+          <a:xfrm>
+            <a:off x="621792" y="1106424"/>
+            <a:ext cx="11201400" cy="0"/>
+          </a:xfrm>
+          <a:prstGeom prst="line">
+            <a:avLst/>
+          </a:prstGeom>
+          <a:noFill/>
+          <a:ln w="9525">
+            <a:solidFill>
+              <a:srgbClr val="203040"/>
+            </a:solidFill>
+            <a:prstDash val="solid"/>
+          </a:ln>
+        </p:spPr>
+      </p:sp>
+      <p:graphicFrame>
+        <p:nvGraphicFramePr>
+          <p:cNvPr id="15" name="Table 0"/>
+          <p:cNvGraphicFramePr>
+            <a:graphicFrameLocks noGrp="1"/>
+          </p:cNvGraphicFramePr>
+          <p:nvPr>
+            <p:extLst>
+              <p:ext uri="{D42A27DB-BD31-4B8C-83A1-F6EECF244321}">
+                <p14:modId xmlns:p14="http://schemas.microsoft.com/office/powerpoint/2010/main" val="1579011935"/>
+              </p:ext>
+            </p:extLst>
+          </p:nvPr>
+        </p:nvGraphicFramePr>
+        <p:xfrm>
+          <a:off x="621792" y="1152144"/>
+          <a:ext cx="11201400" cy="914400"/>
+        </p:xfrm>
+        <a:graphic>
+          <a:graphicData uri="http://schemas.openxmlformats.org/drawingml/2006/table">
+            <a:tbl>
+              <a:tblPr/>
+              <a:tblGrid>
+                <a:gridCol w="1920240"/>
+                <a:gridCol w="4572000"/>
+                <a:gridCol w="3749040"/>
+                <a:gridCol w="960120"/>
+              </a:tblGrid>
+              <a:tr h="301752">
+                <a:tc>
+                  <a:txBody>
+                    <a:bodyPr/>
+                    <a:lstStyle/>
+                    <a:p>
+                      <a:pPr algn="ctr" indent="0" marL="0">
+                        <a:buNone/>
+                      </a:pPr>
+                      <a:r>
+                        <a:rPr lang="en-US" sz="1000" b="1" dirty="0">
+                          <a:solidFill>
+                            <a:srgbClr val="FFFFFF"/>
+                          </a:solidFill>
+                          <a:latin typeface="Garamond" pitchFamily="34" charset="0"/>
+                          <a:ea typeface="Garamond" pitchFamily="34" charset="-122"/>
+                          <a:cs typeface="Garamond" pitchFamily="34" charset="-120"/>
+                        </a:rPr>
+                        <a:t>Workstream</a:t>
+                      </a:r>
+                      <a:endParaRPr lang="en-US" sz="1000" dirty="0">
+                        <a:latin typeface="Garamond" charset="0"/>
+                        <a:ea typeface="Garamond" charset="0"/>
+                        <a:cs typeface="Garamond" charset="0"/>
+                      </a:endParaRPr>
+                    </a:p>
+                  </a:txBody>
+                  <a:tcPr marL="50800" marR="50800" marT="12700" marB="12700" anchor="ctr">
+                    <a:lnL w="6350" cap="flat" cmpd="sng" algn="ctr">
+                      <a:solidFill>
+                        <a:srgbClr val="BFBFBF"/>
+                      </a:solidFill>
+                      <a:prstDash val="solid"/>
+                      <a:round/>
+                      <a:headEnd type="none" w="med" len="med"/>
+                      <a:tailEnd type="none" w="med" len="med"/>
+                    </a:lnL>
+                    <a:lnR w="6350" cap="flat" cmpd="sng" algn="ctr">
+                      <a:solidFill>
+                        <a:srgbClr val="BFBFBF"/>
+                      </a:solidFill>
+                      <a:prstDash val="solid"/>
+                      <a:round/>
+                      <a:headEnd type="none" w="med" len="med"/>
+                      <a:tailEnd type="none" w="med" len="med"/>
+                    </a:lnR>
+                    <a:lnT w="6350" cap="flat" cmpd="sng" algn="ctr">
+                      <a:solidFill>
+                        <a:srgbClr val="BFBFBF"/>
+                      </a:solidFill>
+                      <a:prstDash val="solid"/>
+                      <a:round/>
+                      <a:headEnd type="none" w="med" len="med"/>
+                      <a:tailEnd type="none" w="med" len="med"/>
+                    </a:lnT>
+                    <a:lnB w="6350" cap="flat" cmpd="sng" algn="ctr">
+                      <a:solidFill>
+                        <a:srgbClr val="BFBFBF"/>
+                      </a:solidFill>
+                      <a:prstDash val="solid"/>
+                      <a:round/>
+                      <a:headEnd type="none" w="med" len="med"/>
+                      <a:tailEnd type="none" w="med" len="med"/>
+                    </a:lnB>
+                    <a:solidFill>
+                      <a:srgbClr val="1F3864"/>
+                    </a:solidFill>
+                  </a:tcPr>
+                </a:tc>
+                <a:tc>
+                  <a:txBody>
+                    <a:bodyPr/>
+                    <a:lstStyle/>
+                    <a:p>
+                      <a:pPr algn="ctr" indent="0" marL="0">
+                        <a:buNone/>
+                      </a:pPr>
+                      <a:r>
+                        <a:rPr lang="en-US" sz="1000" b="1" dirty="0">
+                          <a:solidFill>
+                            <a:srgbClr val="FFFFFF"/>
+                          </a:solidFill>
+                          <a:latin typeface="Garamond" pitchFamily="34" charset="0"/>
+                          <a:ea typeface="Garamond" pitchFamily="34" charset="-122"/>
+                          <a:cs typeface="Garamond" pitchFamily="34" charset="-120"/>
+                        </a:rPr>
+                        <a:t>What AI did</a:t>
+                      </a:r>
+                      <a:endParaRPr lang="en-US" sz="1000" dirty="0">
+                        <a:latin typeface="Garamond" charset="0"/>
+                        <a:ea typeface="Garamond" charset="0"/>
+                        <a:cs typeface="Garamond" charset="0"/>
+                      </a:endParaRPr>
+                    </a:p>
+                  </a:txBody>
+                  <a:tcPr marL="50800" marR="50800" marT="12700" marB="12700" anchor="ctr">
+                    <a:lnL w="6350" cap="flat" cmpd="sng" algn="ctr">
+                      <a:solidFill>
+                        <a:srgbClr val="BFBFBF"/>
+                      </a:solidFill>
+                      <a:prstDash val="solid"/>
+                      <a:round/>
+                      <a:headEnd type="none" w="med" len="med"/>
+                      <a:tailEnd type="none" w="med" len="med"/>
+                    </a:lnL>
+                    <a:lnR w="6350" cap="flat" cmpd="sng" algn="ctr">
+                      <a:solidFill>
+                        <a:srgbClr val="BFBFBF"/>
+                      </a:solidFill>
+                      <a:prstDash val="solid"/>
+                      <a:round/>
+                      <a:headEnd type="none" w="med" len="med"/>
+                      <a:tailEnd type="none" w="med" len="med"/>
+                    </a:lnR>
+                    <a:lnT w="6350" cap="flat" cmpd="sng" algn="ctr">
+                      <a:solidFill>
+                        <a:srgbClr val="BFBFBF"/>
+                      </a:solidFill>
+                      <a:prstDash val="solid"/>
+                      <a:round/>
+                      <a:headEnd type="none" w="med" len="med"/>
+                      <a:tailEnd type="none" w="med" len="med"/>
+                    </a:lnT>
+                    <a:lnB w="6350" cap="flat" cmpd="sng" algn="ctr">
+                      <a:solidFill>
+                        <a:srgbClr val="BFBFBF"/>
+                      </a:solidFill>
+                      <a:prstDash val="solid"/>
+                      <a:round/>
+                      <a:headEnd type="none" w="med" len="med"/>
+                      <a:tailEnd type="none" w="med" len="med"/>
+                    </a:lnB>
+                    <a:solidFill>
+                      <a:srgbClr val="1F3864"/>
+                    </a:solidFill>
+                  </a:tcPr>
+                </a:tc>
+                <a:tc>
+                  <a:txBody>
+                    <a:bodyPr/>
+                    <a:lstStyle/>
+                    <a:p>
+                      <a:pPr algn="ctr" indent="0" marL="0">
+                        <a:buNone/>
+                      </a:pPr>
+                      <a:r>
+                        <a:rPr lang="en-US" sz="1000" b="1" dirty="0">
+                          <a:solidFill>
+                            <a:srgbClr val="FFFFFF"/>
+                          </a:solidFill>
+                          <a:latin typeface="Garamond" pitchFamily="34" charset="0"/>
+                          <a:ea typeface="Garamond" pitchFamily="34" charset="-122"/>
+                          <a:cs typeface="Garamond" pitchFamily="34" charset="-120"/>
+                        </a:rPr>
+                        <a:t>What it produced</a:t>
+                      </a:r>
+                      <a:endParaRPr lang="en-US" sz="1000" dirty="0">
+                        <a:latin typeface="Garamond" charset="0"/>
+                        <a:ea typeface="Garamond" charset="0"/>
+                        <a:cs typeface="Garamond" charset="0"/>
+                      </a:endParaRPr>
+                    </a:p>
+                  </a:txBody>
+                  <a:tcPr marL="50800" marR="50800" marT="12700" marB="12700" anchor="ctr">
+                    <a:lnL w="6350" cap="flat" cmpd="sng" algn="ctr">
+                      <a:solidFill>
+                        <a:srgbClr val="BFBFBF"/>
+                      </a:solidFill>
+                      <a:prstDash val="solid"/>
+                      <a:round/>
+                      <a:headEnd type="none" w="med" len="med"/>
+                      <a:tailEnd type="none" w="med" len="med"/>
+                    </a:lnL>
+                    <a:lnR w="6350" cap="flat" cmpd="sng" algn="ctr">
+                      <a:solidFill>
+                        <a:srgbClr val="BFBFBF"/>
+                      </a:solidFill>
+                      <a:prstDash val="solid"/>
+                      <a:round/>
+                      <a:headEnd type="none" w="med" len="med"/>
+                      <a:tailEnd type="none" w="med" len="med"/>
+                    </a:lnR>
+                    <a:lnT w="6350" cap="flat" cmpd="sng" algn="ctr">
+                      <a:solidFill>
+                        <a:srgbClr val="BFBFBF"/>
+                      </a:solidFill>
+                      <a:prstDash val="solid"/>
+                      <a:round/>
+                      <a:headEnd type="none" w="med" len="med"/>
+                      <a:tailEnd type="none" w="med" len="med"/>
+                    </a:lnT>
+                    <a:lnB w="6350" cap="flat" cmpd="sng" algn="ctr">
+                      <a:solidFill>
+                        <a:srgbClr val="BFBFBF"/>
+                      </a:solidFill>
+                      <a:prstDash val="solid"/>
+                      <a:round/>
+                      <a:headEnd type="none" w="med" len="med"/>
+                      <a:tailEnd type="none" w="med" len="med"/>
+                    </a:lnB>
+                    <a:solidFill>
+                      <a:srgbClr val="1F3864"/>
+                    </a:solidFill>
+                  </a:tcPr>
+                </a:tc>
+                <a:tc>
+                  <a:txBody>
+                    <a:bodyPr/>
+                    <a:lstStyle/>
+                    <a:p>
+                      <a:pPr algn="ctr" indent="0" marL="0">
+                        <a:buNone/>
+                      </a:pPr>
+                      <a:r>
+                        <a:rPr lang="en-US" sz="1000" b="1" dirty="0">
+                          <a:solidFill>
+                            <a:srgbClr val="FFFFFF"/>
+                          </a:solidFill>
+                          <a:latin typeface="Garamond" pitchFamily="34" charset="0"/>
+                          <a:ea typeface="Garamond" pitchFamily="34" charset="-122"/>
+                          <a:cs typeface="Garamond" pitchFamily="34" charset="-120"/>
+                        </a:rPr>
+                        <a:t>Used on</a:t>
+                      </a:r>
+                      <a:endParaRPr lang="en-US" sz="1000" dirty="0">
+                        <a:latin typeface="Garamond" charset="0"/>
+                        <a:ea typeface="Garamond" charset="0"/>
+                        <a:cs typeface="Garamond" charset="0"/>
+                      </a:endParaRPr>
+                    </a:p>
+                  </a:txBody>
+                  <a:tcPr marL="50800" marR="50800" marT="12700" marB="12700" anchor="ctr">
+                    <a:lnL w="6350" cap="flat" cmpd="sng" algn="ctr">
+                      <a:solidFill>
+                        <a:srgbClr val="BFBFBF"/>
+                      </a:solidFill>
+                      <a:prstDash val="solid"/>
+                      <a:round/>
+                      <a:headEnd type="none" w="med" len="med"/>
+                      <a:tailEnd type="none" w="med" len="med"/>
+                    </a:lnL>
+                    <a:lnR w="6350" cap="flat" cmpd="sng" algn="ctr">
+                      <a:solidFill>
+                        <a:srgbClr val="BFBFBF"/>
+                      </a:solidFill>
+                      <a:prstDash val="solid"/>
+                      <a:round/>
+                      <a:headEnd type="none" w="med" len="med"/>
+                      <a:tailEnd type="none" w="med" len="med"/>
+                    </a:lnR>
+                    <a:lnT w="6350" cap="flat" cmpd="sng" algn="ctr">
+                      <a:solidFill>
+                        <a:srgbClr val="BFBFBF"/>
+                      </a:solidFill>
+                      <a:prstDash val="solid"/>
+                      <a:round/>
+                      <a:headEnd type="none" w="med" len="med"/>
+                      <a:tailEnd type="none" w="med" len="med"/>
+                    </a:lnT>
+                    <a:lnB w="6350" cap="flat" cmpd="sng" algn="ctr">
+                      <a:solidFill>
+                        <a:srgbClr val="BFBFBF"/>
+                      </a:solidFill>
+                      <a:prstDash val="solid"/>
+                      <a:round/>
+                      <a:headEnd type="none" w="med" len="med"/>
+                      <a:tailEnd type="none" w="med" len="med"/>
+                    </a:lnB>
+                    <a:solidFill>
+                      <a:srgbClr val="1F3864"/>
+                    </a:solidFill>
+                  </a:tcPr>
+                </a:tc>
+              </a:tr>
+              <a:tr h="301752">
+                <a:tc>
+                  <a:txBody>
+                    <a:bodyPr/>
+                    <a:lstStyle/>
+                    <a:p>
+                      <a:pPr algn="l" indent="0" marL="0">
+                        <a:buNone/>
+                      </a:pPr>
+                      <a:r>
+                        <a:rPr lang="en-US" sz="1000" b="1" dirty="0">
+                          <a:solidFill>
+                            <a:srgbClr val="1A1A1A"/>
+                          </a:solidFill>
+                          <a:latin typeface="Garamond" pitchFamily="34" charset="0"/>
+                          <a:ea typeface="Garamond" pitchFamily="34" charset="-122"/>
+                          <a:cs typeface="Garamond" pitchFamily="34" charset="-120"/>
+                        </a:rPr>
+                        <a:t>Repair-price scrape</a:t>
+                      </a:r>
+                      <a:endParaRPr lang="en-US" sz="1200" dirty="0"/>
+                    </a:p>
+                  </a:txBody>
+                  <a:tcPr marL="50800" marR="50800" marT="12700" marB="12700" anchor="ctr">
+                    <a:lnL w="6350" cap="flat" cmpd="sng" algn="ctr">
+                      <a:solidFill>
+                        <a:srgbClr val="BFBFBF"/>
+                      </a:solidFill>
+                      <a:prstDash val="solid"/>
+                      <a:round/>
+                      <a:headEnd type="none" w="med" len="med"/>
+                      <a:tailEnd type="none" w="med" len="med"/>
+                    </a:lnL>
+                    <a:lnR w="6350" cap="flat" cmpd="sng" algn="ctr">
+                      <a:solidFill>
+                        <a:srgbClr val="BFBFBF"/>
+                      </a:solidFill>
+                      <a:prstDash val="solid"/>
+                      <a:round/>
+                      <a:headEnd type="none" w="med" len="med"/>
+                      <a:tailEnd type="none" w="med" len="med"/>
+                    </a:lnR>
+                    <a:lnT w="6350" cap="flat" cmpd="sng" algn="ctr">
+                      <a:solidFill>
+                        <a:srgbClr val="BFBFBF"/>
+                      </a:solidFill>
+                      <a:prstDash val="solid"/>
+                      <a:round/>
+                      <a:headEnd type="none" w="med" len="med"/>
+                      <a:tailEnd type="none" w="med" len="med"/>
+                    </a:lnT>
+                    <a:lnB w="6350" cap="flat" cmpd="sng" algn="ctr">
+                      <a:solidFill>
+                        <a:srgbClr val="BFBFBF"/>
+                      </a:solidFill>
+                      <a:prstDash val="solid"/>
+                      <a:round/>
+                      <a:headEnd type="none" w="med" len="med"/>
+                      <a:tailEnd type="none" w="med" len="med"/>
+                    </a:lnB>
+                    <a:solidFill>
+                      <a:srgbClr val="FFFFFF"/>
+                    </a:solidFill>
+                  </a:tcPr>
+                </a:tc>
+                <a:tc>
+                  <a:txBody>
+                    <a:bodyPr/>
+                    <a:lstStyle/>
+                    <a:p>
+                      <a:pPr algn="l" indent="0" marL="0">
+                        <a:buNone/>
+                      </a:pPr>
+                      <a:r>
+                        <a:rPr lang="en-US" sz="1000" dirty="0">
+                          <a:solidFill>
+                            <a:srgbClr val="1A1A1A"/>
+                          </a:solidFill>
+                          <a:latin typeface="Garamond" pitchFamily="34" charset="0"/>
+                          <a:ea typeface="Garamond" pitchFamily="34" charset="-122"/>
+                          <a:cs typeface="Garamond" pitchFamily="34" charset="-120"/>
+                        </a:rPr>
+                        <a:t>Parsed SR Technics CFM56 catalogues (2024–26) and matched repair packages line by line across years</a:t>
+                      </a:r>
+                      <a:endParaRPr lang="en-US" sz="1200" dirty="0"/>
+                    </a:p>
+                  </a:txBody>
+                  <a:tcPr marL="50800" marR="50800" marT="12700" marB="12700" anchor="ctr">
+                    <a:lnL w="6350" cap="flat" cmpd="sng" algn="ctr">
+                      <a:solidFill>
+                        <a:srgbClr val="BFBFBF"/>
+                      </a:solidFill>
+                      <a:prstDash val="solid"/>
+                      <a:round/>
+                      <a:headEnd type="none" w="med" len="med"/>
+                      <a:tailEnd type="none" w="med" len="med"/>
+                    </a:lnL>
+                    <a:lnR w="6350" cap="flat" cmpd="sng" algn="ctr">
+                      <a:solidFill>
+                        <a:srgbClr val="BFBFBF"/>
+                      </a:solidFill>
+                      <a:prstDash val="solid"/>
+                      <a:round/>
+                      <a:headEnd type="none" w="med" len="med"/>
+                      <a:tailEnd type="none" w="med" len="med"/>
+                    </a:lnR>
+                    <a:lnT w="6350" cap="flat" cmpd="sng" algn="ctr">
+                      <a:solidFill>
+                        <a:srgbClr val="BFBFBF"/>
+                      </a:solidFill>
+                      <a:prstDash val="solid"/>
+                      <a:round/>
+                      <a:headEnd type="none" w="med" len="med"/>
+                      <a:tailEnd type="none" w="med" len="med"/>
+                    </a:lnT>
+                    <a:lnB w="6350" cap="flat" cmpd="sng" algn="ctr">
+                      <a:solidFill>
+                        <a:srgbClr val="BFBFBF"/>
+                      </a:solidFill>
+                      <a:prstDash val="solid"/>
+                      <a:round/>
+                      <a:headEnd type="none" w="med" len="med"/>
+                      <a:tailEnd type="none" w="med" len="med"/>
+                    </a:lnB>
+                    <a:solidFill>
+                      <a:srgbClr val="FFFFFF"/>
+                    </a:solidFill>
+                  </a:tcPr>
+                </a:tc>
+                <a:tc>
+                  <a:txBody>
+                    <a:bodyPr/>
+                    <a:lstStyle/>
+                    <a:p>
+                      <a:pPr algn="l" indent="0" marL="0">
+                        <a:buNone/>
+                      </a:pPr>
+                      <a:r>
+                        <a:rPr lang="en-US" sz="1000" u="sng" dirty="0">
+                          <a:solidFill>
+                            <a:srgbClr val="1A1A1A"/>
+                          </a:solidFill>
+                          <a:latin typeface="Garamond" pitchFamily="34" charset="0"/>
+                          <a:ea typeface="Garamond" pitchFamily="34" charset="-122"/>
+                          <a:cs typeface="Garamond" pitchFamily="34" charset="-120"/>
+                        </a:rPr>
+                        <a:t>3,404 matched packages</a:t>
+                      </a:r>
+                      <a:r>
+                        <a:rPr lang="en-US" sz="1000" dirty="0">
+                          <a:solidFill>
+                            <a:srgbClr val="1A1A1A"/>
+                          </a:solidFill>
+                          <a:latin typeface="Garamond" pitchFamily="34" charset="0"/>
+                          <a:ea typeface="Garamond" pitchFamily="34" charset="-122"/>
+                          <a:cs typeface="Garamond" pitchFamily="34" charset="-120"/>
+                        </a:rPr>
+                        <a:t>: 3,376 rose, 1 fell → ~6% / yr escalator</a:t>
+                      </a:r>
+                      <a:endParaRPr lang="en-US" sz="1200" dirty="0"/>
+                    </a:p>
+                  </a:txBody>
+                  <a:tcPr marL="50800" marR="50800" marT="12700" marB="12700" anchor="ctr">
+                    <a:lnL w="6350" cap="flat" cmpd="sng" algn="ctr">
+                      <a:solidFill>
+                        <a:srgbClr val="BFBFBF"/>
+                      </a:solidFill>
+                      <a:prstDash val="solid"/>
+                      <a:round/>
+                      <a:headEnd type="none" w="med" len="med"/>
+                      <a:tailEnd type="none" w="med" len="med"/>
+                    </a:lnL>
+                    <a:lnR w="6350" cap="flat" cmpd="sng" algn="ctr">
+                      <a:solidFill>
+                        <a:srgbClr val="BFBFBF"/>
+                      </a:solidFill>
+                      <a:prstDash val="solid"/>
+                      <a:round/>
+                      <a:headEnd type="none" w="med" len="med"/>
+                      <a:tailEnd type="none" w="med" len="med"/>
+                    </a:lnR>
+                    <a:lnT w="6350" cap="flat" cmpd="sng" algn="ctr">
+                      <a:solidFill>
+                        <a:srgbClr val="BFBFBF"/>
+                      </a:solidFill>
+                      <a:prstDash val="solid"/>
+                      <a:round/>
+                      <a:headEnd type="none" w="med" len="med"/>
+                      <a:tailEnd type="none" w="med" len="med"/>
+                    </a:lnT>
+                    <a:lnB w="6350" cap="flat" cmpd="sng" algn="ctr">
+                      <a:solidFill>
+                        <a:srgbClr val="BFBFBF"/>
+                      </a:solidFill>
+                      <a:prstDash val="solid"/>
+                      <a:round/>
+                      <a:headEnd type="none" w="med" len="med"/>
+                      <a:tailEnd type="none" w="med" len="med"/>
+                    </a:lnB>
+                    <a:solidFill>
+                      <a:srgbClr val="FFFFFF"/>
+                    </a:solidFill>
+                  </a:tcPr>
+                </a:tc>
+                <a:tc>
+                  <a:txBody>
+                    <a:bodyPr/>
+                    <a:lstStyle/>
+                    <a:p>
+                      <a:pPr algn="ctr" indent="0" marL="0">
+                        <a:buNone/>
+                      </a:pPr>
+                      <a:r>
+                        <a:rPr lang="en-US" sz="1000" dirty="0">
+                          <a:solidFill>
+                            <a:srgbClr val="1A1A1A"/>
+                          </a:solidFill>
+                          <a:latin typeface="Garamond" pitchFamily="34" charset="0"/>
+                          <a:ea typeface="Garamond" pitchFamily="34" charset="-122"/>
+                          <a:cs typeface="Garamond" pitchFamily="34" charset="-120"/>
+                        </a:rPr>
+                        <a:t>Industry</a:t>
+                      </a:r>
+                      <a:endParaRPr lang="en-US" sz="1200" dirty="0"/>
+                    </a:p>
+                  </a:txBody>
+                  <a:tcPr marL="50800" marR="50800" marT="12700" marB="12700" anchor="ctr">
+                    <a:lnL w="6350" cap="flat" cmpd="sng" algn="ctr">
+                      <a:solidFill>
+                        <a:srgbClr val="BFBFBF"/>
+                      </a:solidFill>
+                      <a:prstDash val="solid"/>
+                      <a:round/>
+                      <a:headEnd type="none" w="med" len="med"/>
+                      <a:tailEnd type="none" w="med" len="med"/>
+                    </a:lnL>
+                    <a:lnR w="6350" cap="flat" cmpd="sng" algn="ctr">
+                      <a:solidFill>
+                        <a:srgbClr val="BFBFBF"/>
+                      </a:solidFill>
+                      <a:prstDash val="solid"/>
+                      <a:round/>
+                      <a:headEnd type="none" w="med" len="med"/>
+                      <a:tailEnd type="none" w="med" len="med"/>
+                    </a:lnR>
+                    <a:lnT w="6350" cap="flat" cmpd="sng" algn="ctr">
+                      <a:solidFill>
+                        <a:srgbClr val="BFBFBF"/>
+                      </a:solidFill>
+                      <a:prstDash val="solid"/>
+                      <a:round/>
+                      <a:headEnd type="none" w="med" len="med"/>
+                      <a:tailEnd type="none" w="med" len="med"/>
+                    </a:lnT>
+                    <a:lnB w="6350" cap="flat" cmpd="sng" algn="ctr">
+                      <a:solidFill>
+                        <a:srgbClr val="BFBFBF"/>
+                      </a:solidFill>
+                      <a:prstDash val="solid"/>
+                      <a:round/>
+                      <a:headEnd type="none" w="med" len="med"/>
+                      <a:tailEnd type="none" w="med" len="med"/>
+                    </a:lnB>
+                    <a:solidFill>
+                      <a:srgbClr val="FFFFFF"/>
+                    </a:solidFill>
+                  </a:tcPr>
+                </a:tc>
+              </a:tr>
+              <a:tr h="301752">
+                <a:tc>
+                  <a:txBody>
+                    <a:bodyPr/>
+                    <a:lstStyle/>
+                    <a:p>
+                      <a:pPr algn="l" indent="0" marL="0">
+                        <a:buNone/>
+                      </a:pPr>
+                      <a:r>
+                        <a:rPr lang="en-US" sz="1000" b="1" dirty="0">
+                          <a:solidFill>
+                            <a:srgbClr val="1A1A1A"/>
+                          </a:solidFill>
+                          <a:latin typeface="Garamond" pitchFamily="34" charset="0"/>
+                          <a:ea typeface="Garamond" pitchFamily="34" charset="-122"/>
+                          <a:cs typeface="Garamond" pitchFamily="34" charset="-120"/>
+                        </a:rPr>
+                        <a:t>10-Q footnote extraction</a:t>
+                      </a:r>
+                      <a:endParaRPr lang="en-US" sz="1200" dirty="0"/>
+                    </a:p>
+                  </a:txBody>
+                  <a:tcPr marL="50800" marR="50800" marT="12700" marB="12700" anchor="ctr">
+                    <a:lnL w="6350" cap="flat" cmpd="sng" algn="ctr">
+                      <a:solidFill>
+                        <a:srgbClr val="BFBFBF"/>
+                      </a:solidFill>
+                      <a:prstDash val="solid"/>
+                      <a:round/>
+                      <a:headEnd type="none" w="med" len="med"/>
+                      <a:tailEnd type="none" w="med" len="med"/>
+                    </a:lnL>
+                    <a:lnR w="6350" cap="flat" cmpd="sng" algn="ctr">
+                      <a:solidFill>
+                        <a:srgbClr val="BFBFBF"/>
+                      </a:solidFill>
+                      <a:prstDash val="solid"/>
+                      <a:round/>
+                      <a:headEnd type="none" w="med" len="med"/>
+                      <a:tailEnd type="none" w="med" len="med"/>
+                    </a:lnR>
+                    <a:lnT w="6350" cap="flat" cmpd="sng" algn="ctr">
+                      <a:solidFill>
+                        <a:srgbClr val="BFBFBF"/>
+                      </a:solidFill>
+                      <a:prstDash val="solid"/>
+                      <a:round/>
+                      <a:headEnd type="none" w="med" len="med"/>
+                      <a:tailEnd type="none" w="med" len="med"/>
+                    </a:lnT>
+                    <a:lnB w="6350" cap="flat" cmpd="sng" algn="ctr">
+                      <a:solidFill>
+                        <a:srgbClr val="BFBFBF"/>
+                      </a:solidFill>
+                      <a:prstDash val="solid"/>
+                      <a:round/>
+                      <a:headEnd type="none" w="med" len="med"/>
+                      <a:tailEnd type="none" w="med" len="med"/>
+                    </a:lnB>
+                    <a:solidFill>
+                      <a:srgbClr val="F2F2F2"/>
+                    </a:solidFill>
+                  </a:tcPr>
+                </a:tc>
+                <a:tc>
+                  <a:txBody>
+                    <a:bodyPr/>
+                    <a:lstStyle/>
+                    <a:p>
+                      <a:pPr algn="l" indent="0" marL="0">
+                        <a:buNone/>
+                      </a:pPr>
+                      <a:r>
+                        <a:rPr lang="en-US" sz="1000" dirty="0">
+                          <a:solidFill>
+                            <a:srgbClr val="1A1A1A"/>
+                          </a:solidFill>
+                          <a:latin typeface="Garamond" pitchFamily="34" charset="0"/>
+                          <a:ea typeface="Garamond" pitchFamily="34" charset="-122"/>
+                          <a:cs typeface="Garamond" pitchFamily="34" charset="-120"/>
+                        </a:rPr>
+                        <a:t>Pulled leasing ↔ inventory transfers from every quarter's non-cash cash-flow disclosures</a:t>
+                      </a:r>
+                      <a:endParaRPr lang="en-US" sz="1200" dirty="0"/>
+                    </a:p>
+                  </a:txBody>
+                  <a:tcPr marL="50800" marR="50800" marT="12700" marB="12700" anchor="ctr">
+                    <a:lnL w="6350" cap="flat" cmpd="sng" algn="ctr">
+                      <a:solidFill>
+                        <a:srgbClr val="BFBFBF"/>
+                      </a:solidFill>
+                      <a:prstDash val="solid"/>
+                      <a:round/>
+                      <a:headEnd type="none" w="med" len="med"/>
+                      <a:tailEnd type="none" w="med" len="med"/>
+                    </a:lnL>
+                    <a:lnR w="6350" cap="flat" cmpd="sng" algn="ctr">
+                      <a:solidFill>
+                        <a:srgbClr val="BFBFBF"/>
+                      </a:solidFill>
+                      <a:prstDash val="solid"/>
+                      <a:round/>
+                      <a:headEnd type="none" w="med" len="med"/>
+                      <a:tailEnd type="none" w="med" len="med"/>
+                    </a:lnR>
+                    <a:lnT w="6350" cap="flat" cmpd="sng" algn="ctr">
+                      <a:solidFill>
+                        <a:srgbClr val="BFBFBF"/>
+                      </a:solidFill>
+                      <a:prstDash val="solid"/>
+                      <a:round/>
+                      <a:headEnd type="none" w="med" len="med"/>
+                      <a:tailEnd type="none" w="med" len="med"/>
+                    </a:lnT>
+                    <a:lnB w="6350" cap="flat" cmpd="sng" algn="ctr">
+                      <a:solidFill>
+                        <a:srgbClr val="BFBFBF"/>
+                      </a:solidFill>
+                      <a:prstDash val="solid"/>
+                      <a:round/>
+                      <a:headEnd type="none" w="med" len="med"/>
+                      <a:tailEnd type="none" w="med" len="med"/>
+                    </a:lnB>
+                    <a:solidFill>
+                      <a:srgbClr val="F2F2F2"/>
+                    </a:solidFill>
+                  </a:tcPr>
+                </a:tc>
+                <a:tc>
+                  <a:txBody>
+                    <a:bodyPr/>
+                    <a:lstStyle/>
+                    <a:p>
+                      <a:pPr algn="l" indent="0" marL="0">
+                        <a:buNone/>
+                      </a:pPr>
+                      <a:r>
+                        <a:rPr lang="en-US" sz="1000" dirty="0">
+                          <a:solidFill>
+                            <a:srgbClr val="1A1A1A"/>
+                          </a:solidFill>
+                          <a:latin typeface="Garamond" pitchFamily="34" charset="0"/>
+                          <a:ea typeface="Garamond" pitchFamily="34" charset="-122"/>
+                          <a:cs typeface="Garamond" pitchFamily="34" charset="-120"/>
+                        </a:rPr>
+                        <a:t>Q1'26 transfers </a:t>
+                      </a:r>
+                      <a:r>
+                        <a:rPr lang="en-US" sz="1000" u="sng" dirty="0">
+                          <a:solidFill>
+                            <a:srgbClr val="1A1A1A"/>
+                          </a:solidFill>
+                          <a:latin typeface="Garamond" pitchFamily="34" charset="0"/>
+                          <a:ea typeface="Garamond" pitchFamily="34" charset="-122"/>
+                          <a:cs typeface="Garamond" pitchFamily="34" charset="-120"/>
+                        </a:rPr>
+                        <a:t>$89.6M vs. ~$1.4bn</a:t>
+                      </a:r>
+                      <a:r>
+                        <a:rPr lang="en-US" sz="1000" dirty="0">
+                          <a:solidFill>
+                            <a:srgbClr val="1A1A1A"/>
+                          </a:solidFill>
+                          <a:latin typeface="Garamond" pitchFamily="34" charset="0"/>
+                          <a:ea typeface="Garamond" pitchFamily="34" charset="-122"/>
+                          <a:cs typeface="Garamond" pitchFamily="34" charset="-120"/>
+                        </a:rPr>
+                        <a:t> of inventory; flow now reverses</a:t>
+                      </a:r>
+                      <a:endParaRPr lang="en-US" sz="1200" dirty="0"/>
+                    </a:p>
+                  </a:txBody>
+                  <a:tcPr marL="50800" marR="50800" marT="12700" marB="12700" anchor="ctr">
+                    <a:lnL w="6350" cap="flat" cmpd="sng" algn="ctr">
+                      <a:solidFill>
+                        <a:srgbClr val="BFBFBF"/>
+                      </a:solidFill>
+                      <a:prstDash val="solid"/>
+                      <a:round/>
+                      <a:headEnd type="none" w="med" len="med"/>
+                      <a:tailEnd type="none" w="med" len="med"/>
+                    </a:lnL>
+                    <a:lnR w="6350" cap="flat" cmpd="sng" algn="ctr">
+                      <a:solidFill>
+                        <a:srgbClr val="BFBFBF"/>
+                      </a:solidFill>
+                      <a:prstDash val="solid"/>
+                      <a:round/>
+                      <a:headEnd type="none" w="med" len="med"/>
+                      <a:tailEnd type="none" w="med" len="med"/>
+                    </a:lnR>
+                    <a:lnT w="6350" cap="flat" cmpd="sng" algn="ctr">
+                      <a:solidFill>
+                        <a:srgbClr val="BFBFBF"/>
+                      </a:solidFill>
+                      <a:prstDash val="solid"/>
+                      <a:round/>
+                      <a:headEnd type="none" w="med" len="med"/>
+                      <a:tailEnd type="none" w="med" len="med"/>
+                    </a:lnT>
+                    <a:lnB w="6350" cap="flat" cmpd="sng" algn="ctr">
+                      <a:solidFill>
+                        <a:srgbClr val="BFBFBF"/>
+                      </a:solidFill>
+                      <a:prstDash val="solid"/>
+                      <a:round/>
+                      <a:headEnd type="none" w="med" len="med"/>
+                      <a:tailEnd type="none" w="med" len="med"/>
+                    </a:lnB>
+                    <a:solidFill>
+                      <a:srgbClr val="F2F2F2"/>
+                    </a:solidFill>
+                  </a:tcPr>
+                </a:tc>
+                <a:tc>
+                  <a:txBody>
+                    <a:bodyPr/>
+                    <a:lstStyle/>
+                    <a:p>
+                      <a:pPr algn="ctr" indent="0" marL="0">
+                        <a:buNone/>
+                      </a:pPr>
+                      <a:r>
+                        <a:rPr lang="en-US" sz="1000" dirty="0">
+                          <a:solidFill>
+                            <a:srgbClr val="1A1A1A"/>
+                          </a:solidFill>
+                          <a:latin typeface="Garamond" pitchFamily="34" charset="0"/>
+                          <a:ea typeface="Garamond" pitchFamily="34" charset="-122"/>
+                          <a:cs typeface="Garamond" pitchFamily="34" charset="-120"/>
+                        </a:rPr>
+                        <a:t>Thesis I</a:t>
+                      </a:r>
+                      <a:endParaRPr lang="en-US" sz="1200" dirty="0"/>
+                    </a:p>
+                  </a:txBody>
+                  <a:tcPr marL="50800" marR="50800" marT="12700" marB="12700" anchor="ctr">
+                    <a:lnL w="6350" cap="flat" cmpd="sng" algn="ctr">
+                      <a:solidFill>
+                        <a:srgbClr val="BFBFBF"/>
+                      </a:solidFill>
+                      <a:prstDash val="solid"/>
+                      <a:round/>
+                      <a:headEnd type="none" w="med" len="med"/>
+                      <a:tailEnd type="none" w="med" len="med"/>
+                    </a:lnL>
+                    <a:lnR w="6350" cap="flat" cmpd="sng" algn="ctr">
+                      <a:solidFill>
+                        <a:srgbClr val="BFBFBF"/>
+                      </a:solidFill>
+                      <a:prstDash val="solid"/>
+                      <a:round/>
+                      <a:headEnd type="none" w="med" len="med"/>
+                      <a:tailEnd type="none" w="med" len="med"/>
+                    </a:lnR>
+                    <a:lnT w="6350" cap="flat" cmpd="sng" algn="ctr">
+                      <a:solidFill>
+                        <a:srgbClr val="BFBFBF"/>
+                      </a:solidFill>
+                      <a:prstDash val="solid"/>
+                      <a:round/>
+                      <a:headEnd type="none" w="med" len="med"/>
+                      <a:tailEnd type="none" w="med" len="med"/>
+                    </a:lnT>
+                    <a:lnB w="6350" cap="flat" cmpd="sng" algn="ctr">
+                      <a:solidFill>
+                        <a:srgbClr val="BFBFBF"/>
+                      </a:solidFill>
+                      <a:prstDash val="solid"/>
+                      <a:round/>
+                      <a:headEnd type="none" w="med" len="med"/>
+                      <a:tailEnd type="none" w="med" len="med"/>
+                    </a:lnB>
+                    <a:solidFill>
+                      <a:srgbClr val="F2F2F2"/>
+                    </a:solidFill>
+                  </a:tcPr>
+                </a:tc>
+              </a:tr>
+              <a:tr h="301752">
+                <a:tc>
+                  <a:txBody>
+                    <a:bodyPr/>
+                    <a:lstStyle/>
+                    <a:p>
+                      <a:pPr algn="l" indent="0" marL="0">
+                        <a:buNone/>
+                      </a:pPr>
+                      <a:r>
+                        <a:rPr lang="en-US" sz="1000" b="1" dirty="0">
+                          <a:solidFill>
+                            <a:srgbClr val="1A1A1A"/>
+                          </a:solidFill>
+                          <a:latin typeface="Garamond" pitchFamily="34" charset="0"/>
+                          <a:ea typeface="Garamond" pitchFamily="34" charset="-122"/>
+                          <a:cs typeface="Garamond" pitchFamily="34" charset="-120"/>
+                        </a:rPr>
+                        <a:t>Outsourcing flip tracker</a:t>
+                      </a:r>
+                      <a:endParaRPr lang="en-US" sz="1200" dirty="0"/>
+                    </a:p>
+                  </a:txBody>
+                  <a:tcPr marL="50800" marR="50800" marT="12700" marB="12700" anchor="ctr">
+                    <a:lnL w="6350" cap="flat" cmpd="sng" algn="ctr">
+                      <a:solidFill>
+                        <a:srgbClr val="BFBFBF"/>
+                      </a:solidFill>
+                      <a:prstDash val="solid"/>
+                      <a:round/>
+                      <a:headEnd type="none" w="med" len="med"/>
+                      <a:tailEnd type="none" w="med" len="med"/>
+                    </a:lnL>
+                    <a:lnR w="6350" cap="flat" cmpd="sng" algn="ctr">
+                      <a:solidFill>
+                        <a:srgbClr val="BFBFBF"/>
+                      </a:solidFill>
+                      <a:prstDash val="solid"/>
+                      <a:round/>
+                      <a:headEnd type="none" w="med" len="med"/>
+                      <a:tailEnd type="none" w="med" len="med"/>
+                    </a:lnR>
+                    <a:lnT w="6350" cap="flat" cmpd="sng" algn="ctr">
+                      <a:solidFill>
+                        <a:srgbClr val="BFBFBF"/>
+                      </a:solidFill>
+                      <a:prstDash val="solid"/>
+                      <a:round/>
+                      <a:headEnd type="none" w="med" len="med"/>
+                      <a:tailEnd type="none" w="med" len="med"/>
+                    </a:lnT>
+                    <a:lnB w="6350" cap="flat" cmpd="sng" algn="ctr">
+                      <a:solidFill>
+                        <a:srgbClr val="BFBFBF"/>
+                      </a:solidFill>
+                      <a:prstDash val="solid"/>
+                      <a:round/>
+                      <a:headEnd type="none" w="med" len="med"/>
+                      <a:tailEnd type="none" w="med" len="med"/>
+                    </a:lnB>
+                    <a:solidFill>
+                      <a:srgbClr val="FFFFFF"/>
+                    </a:solidFill>
+                  </a:tcPr>
+                </a:tc>
+                <a:tc>
+                  <a:txBody>
+                    <a:bodyPr/>
+                    <a:lstStyle/>
+                    <a:p>
+                      <a:pPr algn="l" indent="0" marL="0">
+                        <a:buNone/>
+                      </a:pPr>
+                      <a:r>
+                        <a:rPr lang="en-US" sz="1000" dirty="0">
+                          <a:solidFill>
+                            <a:srgbClr val="1A1A1A"/>
+                          </a:solidFill>
+                          <a:latin typeface="Garamond" pitchFamily="34" charset="0"/>
+                          <a:ea typeface="Garamond" pitchFamily="34" charset="-122"/>
+                          <a:cs typeface="Garamond" pitchFamily="34" charset="-120"/>
+                        </a:rPr>
+                        <a:t>Scraped releases, filings and trade press for 14 tier-1 shops; classified each shop's CFM56 / LEAP stance</a:t>
+                      </a:r>
+                      <a:endParaRPr lang="en-US" sz="1200" dirty="0"/>
+                    </a:p>
+                  </a:txBody>
+                  <a:tcPr marL="50800" marR="50800" marT="12700" marB="12700" anchor="ctr">
+                    <a:lnL w="6350" cap="flat" cmpd="sng" algn="ctr">
+                      <a:solidFill>
+                        <a:srgbClr val="BFBFBF"/>
+                      </a:solidFill>
+                      <a:prstDash val="solid"/>
+                      <a:round/>
+                      <a:headEnd type="none" w="med" len="med"/>
+                      <a:tailEnd type="none" w="med" len="med"/>
+                    </a:lnL>
+                    <a:lnR w="6350" cap="flat" cmpd="sng" algn="ctr">
+                      <a:solidFill>
+                        <a:srgbClr val="BFBFBF"/>
+                      </a:solidFill>
+                      <a:prstDash val="solid"/>
+                      <a:round/>
+                      <a:headEnd type="none" w="med" len="med"/>
+                      <a:tailEnd type="none" w="med" len="med"/>
+                    </a:lnR>
+                    <a:lnT w="6350" cap="flat" cmpd="sng" algn="ctr">
+                      <a:solidFill>
+                        <a:srgbClr val="BFBFBF"/>
+                      </a:solidFill>
+                      <a:prstDash val="solid"/>
+                      <a:round/>
+                      <a:headEnd type="none" w="med" len="med"/>
+                      <a:tailEnd type="none" w="med" len="med"/>
+                    </a:lnT>
+                    <a:lnB w="6350" cap="flat" cmpd="sng" algn="ctr">
+                      <a:solidFill>
+                        <a:srgbClr val="BFBFBF"/>
+                      </a:solidFill>
+                      <a:prstDash val="solid"/>
+                      <a:round/>
+                      <a:headEnd type="none" w="med" len="med"/>
+                      <a:tailEnd type="none" w="med" len="med"/>
+                    </a:lnB>
+                    <a:solidFill>
+                      <a:srgbClr val="FFFFFF"/>
+                    </a:solidFill>
+                  </a:tcPr>
+                </a:tc>
+                <a:tc>
+                  <a:txBody>
+                    <a:bodyPr/>
+                    <a:lstStyle/>
+                    <a:p>
+                      <a:pPr algn="l" indent="0" marL="0">
+                        <a:buNone/>
+                      </a:pPr>
+                      <a:r>
+                        <a:rPr lang="en-US" sz="1000" dirty="0">
+                          <a:solidFill>
+                            <a:srgbClr val="1A1A1A"/>
+                          </a:solidFill>
+                          <a:latin typeface="Garamond" pitchFamily="34" charset="0"/>
+                          <a:ea typeface="Garamond" pitchFamily="34" charset="-122"/>
+                          <a:cs typeface="Garamond" pitchFamily="34" charset="-120"/>
+                        </a:rPr>
+                        <a:t>Positioning map: OEMs pulling back, </a:t>
+                      </a:r>
+                      <a:r>
+                        <a:rPr lang="en-US" sz="1000" u="sng" dirty="0">
+                          <a:solidFill>
+                            <a:srgbClr val="1A1A1A"/>
+                          </a:solidFill>
+                          <a:latin typeface="Garamond" pitchFamily="34" charset="0"/>
+                          <a:ea typeface="Garamond" pitchFamily="34" charset="-122"/>
+                          <a:cs typeface="Garamond" pitchFamily="34" charset="-120"/>
+                        </a:rPr>
+                        <a:t>independents adding</a:t>
+                      </a:r>
+                      <a:endParaRPr lang="en-US" sz="1200" dirty="0"/>
+                    </a:p>
+                  </a:txBody>
+                  <a:tcPr marL="50800" marR="50800" marT="12700" marB="12700" anchor="ctr">
+                    <a:lnL w="6350" cap="flat" cmpd="sng" algn="ctr">
+                      <a:solidFill>
+                        <a:srgbClr val="BFBFBF"/>
+                      </a:solidFill>
+                      <a:prstDash val="solid"/>
+                      <a:round/>
+                      <a:headEnd type="none" w="med" len="med"/>
+                      <a:tailEnd type="none" w="med" len="med"/>
+                    </a:lnL>
+                    <a:lnR w="6350" cap="flat" cmpd="sng" algn="ctr">
+                      <a:solidFill>
+                        <a:srgbClr val="BFBFBF"/>
+                      </a:solidFill>
+                      <a:prstDash val="solid"/>
+                      <a:round/>
+                      <a:headEnd type="none" w="med" len="med"/>
+                      <a:tailEnd type="none" w="med" len="med"/>
+                    </a:lnR>
+                    <a:lnT w="6350" cap="flat" cmpd="sng" algn="ctr">
+                      <a:solidFill>
+                        <a:srgbClr val="BFBFBF"/>
+                      </a:solidFill>
+                      <a:prstDash val="solid"/>
+                      <a:round/>
+                      <a:headEnd type="none" w="med" len="med"/>
+                      <a:tailEnd type="none" w="med" len="med"/>
+                    </a:lnT>
+                    <a:lnB w="6350" cap="flat" cmpd="sng" algn="ctr">
+                      <a:solidFill>
+                        <a:srgbClr val="BFBFBF"/>
+                      </a:solidFill>
+                      <a:prstDash val="solid"/>
+                      <a:round/>
+                      <a:headEnd type="none" w="med" len="med"/>
+                      <a:tailEnd type="none" w="med" len="med"/>
+                    </a:lnB>
+                    <a:solidFill>
+                      <a:srgbClr val="FFFFFF"/>
+                    </a:solidFill>
+                  </a:tcPr>
+                </a:tc>
+                <a:tc>
+                  <a:txBody>
+                    <a:bodyPr/>
+                    <a:lstStyle/>
+                    <a:p>
+                      <a:pPr algn="ctr" indent="0" marL="0">
+                        <a:buNone/>
+                      </a:pPr>
+                      <a:r>
+                        <a:rPr lang="en-US" sz="1000" dirty="0">
+                          <a:solidFill>
+                            <a:srgbClr val="1A1A1A"/>
+                          </a:solidFill>
+                          <a:latin typeface="Garamond" pitchFamily="34" charset="0"/>
+                          <a:ea typeface="Garamond" pitchFamily="34" charset="-122"/>
+                          <a:cs typeface="Garamond" pitchFamily="34" charset="-120"/>
+                        </a:rPr>
+                        <a:t>Thesis II</a:t>
+                      </a:r>
+                      <a:endParaRPr lang="en-US" sz="1200" dirty="0"/>
+                    </a:p>
+                  </a:txBody>
+                  <a:tcPr marL="50800" marR="50800" marT="12700" marB="12700" anchor="ctr">
+                    <a:lnL w="6350" cap="flat" cmpd="sng" algn="ctr">
+                      <a:solidFill>
+                        <a:srgbClr val="BFBFBF"/>
+                      </a:solidFill>
+                      <a:prstDash val="solid"/>
+                      <a:round/>
+                      <a:headEnd type="none" w="med" len="med"/>
+                      <a:tailEnd type="none" w="med" len="med"/>
+                    </a:lnL>
+                    <a:lnR w="6350" cap="flat" cmpd="sng" algn="ctr">
+                      <a:solidFill>
+                        <a:srgbClr val="BFBFBF"/>
+                      </a:solidFill>
+                      <a:prstDash val="solid"/>
+                      <a:round/>
+                      <a:headEnd type="none" w="med" len="med"/>
+                      <a:tailEnd type="none" w="med" len="med"/>
+                    </a:lnR>
+                    <a:lnT w="6350" cap="flat" cmpd="sng" algn="ctr">
+                      <a:solidFill>
+                        <a:srgbClr val="BFBFBF"/>
+                      </a:solidFill>
+                      <a:prstDash val="solid"/>
+                      <a:round/>
+                      <a:headEnd type="none" w="med" len="med"/>
+                      <a:tailEnd type="none" w="med" len="med"/>
+                    </a:lnT>
+                    <a:lnB w="6350" cap="flat" cmpd="sng" algn="ctr">
+                      <a:solidFill>
+                        <a:srgbClr val="BFBFBF"/>
+                      </a:solidFill>
+                      <a:prstDash val="solid"/>
+                      <a:round/>
+                      <a:headEnd type="none" w="med" len="med"/>
+                      <a:tailEnd type="none" w="med" len="med"/>
+                    </a:lnB>
+                    <a:solidFill>
+                      <a:srgbClr val="FFFFFF"/>
+                    </a:solidFill>
+                  </a:tcPr>
+                </a:tc>
+              </a:tr>
+              <a:tr h="301752">
+                <a:tc>
+                  <a:txBody>
+                    <a:bodyPr/>
+                    <a:lstStyle/>
+                    <a:p>
+                      <a:pPr algn="l" indent="0" marL="0">
+                        <a:buNone/>
+                      </a:pPr>
+                      <a:r>
+                        <a:rPr lang="en-US" sz="1000" b="1" dirty="0">
+                          <a:solidFill>
+                            <a:srgbClr val="1A1A1A"/>
+                          </a:solidFill>
+                          <a:latin typeface="Garamond" pitchFamily="34" charset="0"/>
+                          <a:ea typeface="Garamond" pitchFamily="34" charset="-122"/>
+                          <a:cs typeface="Garamond" pitchFamily="34" charset="-120"/>
+                        </a:rPr>
+                        <a:t>Test cell tracker</a:t>
+                      </a:r>
+                      <a:endParaRPr lang="en-US" sz="1200" dirty="0"/>
+                    </a:p>
+                  </a:txBody>
+                  <a:tcPr marL="50800" marR="50800" marT="12700" marB="12700" anchor="ctr">
+                    <a:lnL w="6350" cap="flat" cmpd="sng" algn="ctr">
+                      <a:solidFill>
+                        <a:srgbClr val="BFBFBF"/>
+                      </a:solidFill>
+                      <a:prstDash val="solid"/>
+                      <a:round/>
+                      <a:headEnd type="none" w="med" len="med"/>
+                      <a:tailEnd type="none" w="med" len="med"/>
+                    </a:lnL>
+                    <a:lnR w="6350" cap="flat" cmpd="sng" algn="ctr">
+                      <a:solidFill>
+                        <a:srgbClr val="BFBFBF"/>
+                      </a:solidFill>
+                      <a:prstDash val="solid"/>
+                      <a:round/>
+                      <a:headEnd type="none" w="med" len="med"/>
+                      <a:tailEnd type="none" w="med" len="med"/>
+                    </a:lnR>
+                    <a:lnT w="6350" cap="flat" cmpd="sng" algn="ctr">
+                      <a:solidFill>
+                        <a:srgbClr val="BFBFBF"/>
+                      </a:solidFill>
+                      <a:prstDash val="solid"/>
+                      <a:round/>
+                      <a:headEnd type="none" w="med" len="med"/>
+                      <a:tailEnd type="none" w="med" len="med"/>
+                    </a:lnT>
+                    <a:lnB w="6350" cap="flat" cmpd="sng" algn="ctr">
+                      <a:solidFill>
+                        <a:srgbClr val="BFBFBF"/>
+                      </a:solidFill>
+                      <a:prstDash val="solid"/>
+                      <a:round/>
+                      <a:headEnd type="none" w="med" len="med"/>
+                      <a:tailEnd type="none" w="med" len="med"/>
+                    </a:lnB>
+                    <a:solidFill>
+                      <a:srgbClr val="F2F2F2"/>
+                    </a:solidFill>
+                  </a:tcPr>
+                </a:tc>
+                <a:tc>
+                  <a:txBody>
+                    <a:bodyPr/>
+                    <a:lstStyle/>
+                    <a:p>
+                      <a:pPr algn="l" indent="0" marL="0">
+                        <a:buNone/>
+                      </a:pPr>
+                      <a:r>
+                        <a:rPr lang="en-US" sz="1000" dirty="0">
+                          <a:solidFill>
+                            <a:srgbClr val="1A1A1A"/>
+                          </a:solidFill>
+                          <a:latin typeface="Garamond" pitchFamily="34" charset="0"/>
+                          <a:ea typeface="Garamond" pitchFamily="34" charset="-122"/>
+                          <a:cs typeface="Garamond" pitchFamily="34" charset="-120"/>
+                        </a:rPr>
+                        <a:t>Searched shop announcements and trade press for engine test cells; tagged engine types per cell</a:t>
+                      </a:r>
+                      <a:endParaRPr lang="en-US" sz="1200" dirty="0"/>
+                    </a:p>
+                  </a:txBody>
+                  <a:tcPr marL="50800" marR="50800" marT="12700" marB="12700" anchor="ctr">
+                    <a:lnL w="6350" cap="flat" cmpd="sng" algn="ctr">
+                      <a:solidFill>
+                        <a:srgbClr val="BFBFBF"/>
+                      </a:solidFill>
+                      <a:prstDash val="solid"/>
+                      <a:round/>
+                      <a:headEnd type="none" w="med" len="med"/>
+                      <a:tailEnd type="none" w="med" len="med"/>
+                    </a:lnL>
+                    <a:lnR w="6350" cap="flat" cmpd="sng" algn="ctr">
+                      <a:solidFill>
+                        <a:srgbClr val="BFBFBF"/>
+                      </a:solidFill>
+                      <a:prstDash val="solid"/>
+                      <a:round/>
+                      <a:headEnd type="none" w="med" len="med"/>
+                      <a:tailEnd type="none" w="med" len="med"/>
+                    </a:lnR>
+                    <a:lnT w="6350" cap="flat" cmpd="sng" algn="ctr">
+                      <a:solidFill>
+                        <a:srgbClr val="BFBFBF"/>
+                      </a:solidFill>
+                      <a:prstDash val="solid"/>
+                      <a:round/>
+                      <a:headEnd type="none" w="med" len="med"/>
+                      <a:tailEnd type="none" w="med" len="med"/>
+                    </a:lnT>
+                    <a:lnB w="6350" cap="flat" cmpd="sng" algn="ctr">
+                      <a:solidFill>
+                        <a:srgbClr val="BFBFBF"/>
+                      </a:solidFill>
+                      <a:prstDash val="solid"/>
+                      <a:round/>
+                      <a:headEnd type="none" w="med" len="med"/>
+                      <a:tailEnd type="none" w="med" len="med"/>
+                    </a:lnB>
+                    <a:solidFill>
+                      <a:srgbClr val="F2F2F2"/>
+                    </a:solidFill>
+                  </a:tcPr>
+                </a:tc>
+                <a:tc>
+                  <a:txBody>
+                    <a:bodyPr/>
+                    <a:lstStyle/>
+                    <a:p>
+                      <a:pPr algn="l" indent="0" marL="0">
+                        <a:buNone/>
+                      </a:pPr>
+                      <a:r>
+                        <a:rPr lang="en-US" sz="1000" dirty="0">
+                          <a:solidFill>
+                            <a:srgbClr val="1A1A1A"/>
+                          </a:solidFill>
+                          <a:latin typeface="Garamond" pitchFamily="34" charset="0"/>
+                          <a:ea typeface="Garamond" pitchFamily="34" charset="-122"/>
+                          <a:cs typeface="Garamond" pitchFamily="34" charset="-120"/>
+                        </a:rPr>
+                        <a:t>18 cells: </a:t>
+                      </a:r>
+                      <a:r>
+                        <a:rPr lang="en-US" sz="1000" u="sng" dirty="0">
+                          <a:solidFill>
+                            <a:srgbClr val="1A1A1A"/>
+                          </a:solidFill>
+                          <a:latin typeface="Garamond" pitchFamily="34" charset="0"/>
+                          <a:ea typeface="Garamond" pitchFamily="34" charset="-122"/>
+                          <a:cs typeface="Garamond" pitchFamily="34" charset="-120"/>
+                        </a:rPr>
+                        <a:t>9 adapted to LEAP, 0 dropped CFM56</a:t>
+                      </a:r>
+                      <a:endParaRPr lang="en-US" sz="1200" dirty="0"/>
+                    </a:p>
+                  </a:txBody>
+                  <a:tcPr marL="50800" marR="50800" marT="12700" marB="12700" anchor="ctr">
+                    <a:lnL w="6350" cap="flat" cmpd="sng" algn="ctr">
+                      <a:solidFill>
+                        <a:srgbClr val="BFBFBF"/>
+                      </a:solidFill>
+                      <a:prstDash val="solid"/>
+                      <a:round/>
+                      <a:headEnd type="none" w="med" len="med"/>
+                      <a:tailEnd type="none" w="med" len="med"/>
+                    </a:lnL>
+                    <a:lnR w="6350" cap="flat" cmpd="sng" algn="ctr">
+                      <a:solidFill>
+                        <a:srgbClr val="BFBFBF"/>
+                      </a:solidFill>
+                      <a:prstDash val="solid"/>
+                      <a:round/>
+                      <a:headEnd type="none" w="med" len="med"/>
+                      <a:tailEnd type="none" w="med" len="med"/>
+                    </a:lnR>
+                    <a:lnT w="6350" cap="flat" cmpd="sng" algn="ctr">
+                      <a:solidFill>
+                        <a:srgbClr val="BFBFBF"/>
+                      </a:solidFill>
+                      <a:prstDash val="solid"/>
+                      <a:round/>
+                      <a:headEnd type="none" w="med" len="med"/>
+                      <a:tailEnd type="none" w="med" len="med"/>
+                    </a:lnT>
+                    <a:lnB w="6350" cap="flat" cmpd="sng" algn="ctr">
+                      <a:solidFill>
+                        <a:srgbClr val="BFBFBF"/>
+                      </a:solidFill>
+                      <a:prstDash val="solid"/>
+                      <a:round/>
+                      <a:headEnd type="none" w="med" len="med"/>
+                      <a:tailEnd type="none" w="med" len="med"/>
+                    </a:lnB>
+                    <a:solidFill>
+                      <a:srgbClr val="F2F2F2"/>
+                    </a:solidFill>
+                  </a:tcPr>
+                </a:tc>
+                <a:tc>
+                  <a:txBody>
+                    <a:bodyPr/>
+                    <a:lstStyle/>
+                    <a:p>
+                      <a:pPr algn="ctr" indent="0" marL="0">
+                        <a:buNone/>
+                      </a:pPr>
+                      <a:r>
+                        <a:rPr lang="en-US" sz="1000" dirty="0">
+                          <a:solidFill>
+                            <a:srgbClr val="1A1A1A"/>
+                          </a:solidFill>
+                          <a:latin typeface="Garamond" pitchFamily="34" charset="0"/>
+                          <a:ea typeface="Garamond" pitchFamily="34" charset="-122"/>
+                          <a:cs typeface="Garamond" pitchFamily="34" charset="-120"/>
+                        </a:rPr>
+                        <a:t>Thesis II</a:t>
+                      </a:r>
+                      <a:endParaRPr lang="en-US" sz="1200" dirty="0"/>
+                    </a:p>
+                  </a:txBody>
+                  <a:tcPr marL="50800" marR="50800" marT="12700" marB="12700" anchor="ctr">
+                    <a:lnL w="6350" cap="flat" cmpd="sng" algn="ctr">
+                      <a:solidFill>
+                        <a:srgbClr val="BFBFBF"/>
+                      </a:solidFill>
+                      <a:prstDash val="solid"/>
+                      <a:round/>
+                      <a:headEnd type="none" w="med" len="med"/>
+                      <a:tailEnd type="none" w="med" len="med"/>
+                    </a:lnL>
+                    <a:lnR w="6350" cap="flat" cmpd="sng" algn="ctr">
+                      <a:solidFill>
+                        <a:srgbClr val="BFBFBF"/>
+                      </a:solidFill>
+                      <a:prstDash val="solid"/>
+                      <a:round/>
+                      <a:headEnd type="none" w="med" len="med"/>
+                      <a:tailEnd type="none" w="med" len="med"/>
+                    </a:lnR>
+                    <a:lnT w="6350" cap="flat" cmpd="sng" algn="ctr">
+                      <a:solidFill>
+                        <a:srgbClr val="BFBFBF"/>
+                      </a:solidFill>
+                      <a:prstDash val="solid"/>
+                      <a:round/>
+                      <a:headEnd type="none" w="med" len="med"/>
+                      <a:tailEnd type="none" w="med" len="med"/>
+                    </a:lnT>
+                    <a:lnB w="6350" cap="flat" cmpd="sng" algn="ctr">
+                      <a:solidFill>
+                        <a:srgbClr val="BFBFBF"/>
+                      </a:solidFill>
+                      <a:prstDash val="solid"/>
+                      <a:round/>
+                      <a:headEnd type="none" w="med" len="med"/>
+                      <a:tailEnd type="none" w="med" len="med"/>
+                    </a:lnB>
+                    <a:solidFill>
+                      <a:srgbClr val="F2F2F2"/>
+                    </a:solidFill>
+                  </a:tcPr>
+                </a:tc>
+              </a:tr>
+              <a:tr h="301752">
+                <a:tc>
+                  <a:txBody>
+                    <a:bodyPr/>
+                    <a:lstStyle/>
+                    <a:p>
+                      <a:pPr algn="l" indent="0" marL="0">
+                        <a:buNone/>
+                      </a:pPr>
+                      <a:r>
+                        <a:rPr lang="en-US" sz="1000" b="1" dirty="0">
+                          <a:solidFill>
+                            <a:srgbClr val="1A1A1A"/>
+                          </a:solidFill>
+                          <a:latin typeface="Garamond" pitchFamily="34" charset="0"/>
+                          <a:ea typeface="Garamond" pitchFamily="34" charset="-122"/>
+                          <a:cs typeface="Garamond" pitchFamily="34" charset="-120"/>
+                        </a:rPr>
+                        <a:t>Fuel &amp; retirement check</a:t>
+                      </a:r>
+                      <a:endParaRPr lang="en-US" sz="1200" dirty="0"/>
+                    </a:p>
+                  </a:txBody>
+                  <a:tcPr marL="50800" marR="50800" marT="12700" marB="12700" anchor="ctr">
+                    <a:lnL w="6350" cap="flat" cmpd="sng" algn="ctr">
+                      <a:solidFill>
+                        <a:srgbClr val="BFBFBF"/>
+                      </a:solidFill>
+                      <a:prstDash val="solid"/>
+                      <a:round/>
+                      <a:headEnd type="none" w="med" len="med"/>
+                      <a:tailEnd type="none" w="med" len="med"/>
+                    </a:lnL>
+                    <a:lnR w="6350" cap="flat" cmpd="sng" algn="ctr">
+                      <a:solidFill>
+                        <a:srgbClr val="BFBFBF"/>
+                      </a:solidFill>
+                      <a:prstDash val="solid"/>
+                      <a:round/>
+                      <a:headEnd type="none" w="med" len="med"/>
+                      <a:tailEnd type="none" w="med" len="med"/>
+                    </a:lnR>
+                    <a:lnT w="6350" cap="flat" cmpd="sng" algn="ctr">
+                      <a:solidFill>
+                        <a:srgbClr val="BFBFBF"/>
+                      </a:solidFill>
+                      <a:prstDash val="solid"/>
+                      <a:round/>
+                      <a:headEnd type="none" w="med" len="med"/>
+                      <a:tailEnd type="none" w="med" len="med"/>
+                    </a:lnT>
+                    <a:lnB w="6350" cap="flat" cmpd="sng" algn="ctr">
+                      <a:solidFill>
+                        <a:srgbClr val="BFBFBF"/>
+                      </a:solidFill>
+                      <a:prstDash val="solid"/>
+                      <a:round/>
+                      <a:headEnd type="none" w="med" len="med"/>
+                      <a:tailEnd type="none" w="med" len="med"/>
+                    </a:lnB>
+                    <a:solidFill>
+                      <a:srgbClr val="FFFFFF"/>
+                    </a:solidFill>
+                  </a:tcPr>
+                </a:tc>
+                <a:tc>
+                  <a:txBody>
+                    <a:bodyPr/>
+                    <a:lstStyle/>
+                    <a:p>
+                      <a:pPr algn="l" indent="0" marL="0">
+                        <a:buNone/>
+                      </a:pPr>
+                      <a:r>
+                        <a:rPr lang="en-US" sz="1000" dirty="0">
+                          <a:solidFill>
+                            <a:srgbClr val="1A1A1A"/>
+                          </a:solidFill>
+                          <a:latin typeface="Garamond" pitchFamily="34" charset="0"/>
+                          <a:ea typeface="Garamond" pitchFamily="34" charset="-122"/>
+                          <a:cs typeface="Garamond" pitchFamily="34" charset="-120"/>
+                        </a:rPr>
+                        <a:t>Assembled jet-fuel series, GE / Safran commentary, airline capacity and hedge disclosures</a:t>
+                      </a:r>
+                      <a:endParaRPr lang="en-US" sz="1200" dirty="0"/>
+                    </a:p>
+                  </a:txBody>
+                  <a:tcPr marL="50800" marR="50800" marT="12700" marB="12700" anchor="ctr">
+                    <a:lnL w="6350" cap="flat" cmpd="sng" algn="ctr">
+                      <a:solidFill>
+                        <a:srgbClr val="BFBFBF"/>
+                      </a:solidFill>
+                      <a:prstDash val="solid"/>
+                      <a:round/>
+                      <a:headEnd type="none" w="med" len="med"/>
+                      <a:tailEnd type="none" w="med" len="med"/>
+                    </a:lnL>
+                    <a:lnR w="6350" cap="flat" cmpd="sng" algn="ctr">
+                      <a:solidFill>
+                        <a:srgbClr val="BFBFBF"/>
+                      </a:solidFill>
+                      <a:prstDash val="solid"/>
+                      <a:round/>
+                      <a:headEnd type="none" w="med" len="med"/>
+                      <a:tailEnd type="none" w="med" len="med"/>
+                    </a:lnR>
+                    <a:lnT w="6350" cap="flat" cmpd="sng" algn="ctr">
+                      <a:solidFill>
+                        <a:srgbClr val="BFBFBF"/>
+                      </a:solidFill>
+                      <a:prstDash val="solid"/>
+                      <a:round/>
+                      <a:headEnd type="none" w="med" len="med"/>
+                      <a:tailEnd type="none" w="med" len="med"/>
+                    </a:lnT>
+                    <a:lnB w="6350" cap="flat" cmpd="sng" algn="ctr">
+                      <a:solidFill>
+                        <a:srgbClr val="BFBFBF"/>
+                      </a:solidFill>
+                      <a:prstDash val="solid"/>
+                      <a:round/>
+                      <a:headEnd type="none" w="med" len="med"/>
+                      <a:tailEnd type="none" w="med" len="med"/>
+                    </a:lnB>
+                    <a:solidFill>
+                      <a:srgbClr val="FFFFFF"/>
+                    </a:solidFill>
+                  </a:tcPr>
+                </a:tc>
+                <a:tc>
+                  <a:txBody>
+                    <a:bodyPr/>
+                    <a:lstStyle/>
+                    <a:p>
+                      <a:pPr algn="l" indent="0" marL="0">
+                        <a:buNone/>
+                      </a:pPr>
+                      <a:r>
+                        <a:rPr lang="en-US" sz="1000" dirty="0">
+                          <a:solidFill>
+                            <a:srgbClr val="1A1A1A"/>
+                          </a:solidFill>
+                          <a:latin typeface="Garamond" pitchFamily="34" charset="0"/>
+                          <a:ea typeface="Garamond" pitchFamily="34" charset="-122"/>
+                          <a:cs typeface="Garamond" pitchFamily="34" charset="-120"/>
+                        </a:rPr>
+                        <a:t>Fuel up ~2.3x, </a:t>
+                      </a:r>
+                      <a:r>
+                        <a:rPr lang="en-US" sz="1000" u="sng" dirty="0">
+                          <a:solidFill>
+                            <a:srgbClr val="1A1A1A"/>
+                          </a:solidFill>
+                          <a:latin typeface="Garamond" pitchFamily="34" charset="0"/>
+                          <a:ea typeface="Garamond" pitchFamily="34" charset="-122"/>
+                          <a:cs typeface="Garamond" pitchFamily="34" charset="-120"/>
+                        </a:rPr>
+                        <a:t>parked CFM56s falling</a:t>
+                      </a:r>
+                      <a:endParaRPr lang="en-US" sz="1200" dirty="0"/>
+                    </a:p>
+                  </a:txBody>
+                  <a:tcPr marL="50800" marR="50800" marT="12700" marB="12700" anchor="ctr">
+                    <a:lnL w="6350" cap="flat" cmpd="sng" algn="ctr">
+                      <a:solidFill>
+                        <a:srgbClr val="BFBFBF"/>
+                      </a:solidFill>
+                      <a:prstDash val="solid"/>
+                      <a:round/>
+                      <a:headEnd type="none" w="med" len="med"/>
+                      <a:tailEnd type="none" w="med" len="med"/>
+                    </a:lnL>
+                    <a:lnR w="6350" cap="flat" cmpd="sng" algn="ctr">
+                      <a:solidFill>
+                        <a:srgbClr val="BFBFBF"/>
+                      </a:solidFill>
+                      <a:prstDash val="solid"/>
+                      <a:round/>
+                      <a:headEnd type="none" w="med" len="med"/>
+                      <a:tailEnd type="none" w="med" len="med"/>
+                    </a:lnR>
+                    <a:lnT w="6350" cap="flat" cmpd="sng" algn="ctr">
+                      <a:solidFill>
+                        <a:srgbClr val="BFBFBF"/>
+                      </a:solidFill>
+                      <a:prstDash val="solid"/>
+                      <a:round/>
+                      <a:headEnd type="none" w="med" len="med"/>
+                      <a:tailEnd type="none" w="med" len="med"/>
+                    </a:lnT>
+                    <a:lnB w="6350" cap="flat" cmpd="sng" algn="ctr">
+                      <a:solidFill>
+                        <a:srgbClr val="BFBFBF"/>
+                      </a:solidFill>
+                      <a:prstDash val="solid"/>
+                      <a:round/>
+                      <a:headEnd type="none" w="med" len="med"/>
+                      <a:tailEnd type="none" w="med" len="med"/>
+                    </a:lnB>
+                    <a:solidFill>
+                      <a:srgbClr val="FFFFFF"/>
+                    </a:solidFill>
+                  </a:tcPr>
+                </a:tc>
+                <a:tc>
+                  <a:txBody>
+                    <a:bodyPr/>
+                    <a:lstStyle/>
+                    <a:p>
+                      <a:pPr algn="ctr" indent="0" marL="0">
+                        <a:buNone/>
+                      </a:pPr>
+                      <a:r>
+                        <a:rPr lang="en-US" sz="1000" dirty="0">
+                          <a:solidFill>
+                            <a:srgbClr val="1A1A1A"/>
+                          </a:solidFill>
+                          <a:latin typeface="Garamond" pitchFamily="34" charset="0"/>
+                          <a:ea typeface="Garamond" pitchFamily="34" charset="-122"/>
+                          <a:cs typeface="Garamond" pitchFamily="34" charset="-120"/>
+                        </a:rPr>
+                        <a:t>Thesis II</a:t>
+                      </a:r>
+                      <a:endParaRPr lang="en-US" sz="1200" dirty="0"/>
+                    </a:p>
+                  </a:txBody>
+                  <a:tcPr marL="50800" marR="50800" marT="12700" marB="12700" anchor="ctr">
+                    <a:lnL w="6350" cap="flat" cmpd="sng" algn="ctr">
+                      <a:solidFill>
+                        <a:srgbClr val="BFBFBF"/>
+                      </a:solidFill>
+                      <a:prstDash val="solid"/>
+                      <a:round/>
+                      <a:headEnd type="none" w="med" len="med"/>
+                      <a:tailEnd type="none" w="med" len="med"/>
+                    </a:lnL>
+                    <a:lnR w="6350" cap="flat" cmpd="sng" algn="ctr">
+                      <a:solidFill>
+                        <a:srgbClr val="BFBFBF"/>
+                      </a:solidFill>
+                      <a:prstDash val="solid"/>
+                      <a:round/>
+                      <a:headEnd type="none" w="med" len="med"/>
+                      <a:tailEnd type="none" w="med" len="med"/>
+                    </a:lnR>
+                    <a:lnT w="6350" cap="flat" cmpd="sng" algn="ctr">
+                      <a:solidFill>
+                        <a:srgbClr val="BFBFBF"/>
+                      </a:solidFill>
+                      <a:prstDash val="solid"/>
+                      <a:round/>
+                      <a:headEnd type="none" w="med" len="med"/>
+                      <a:tailEnd type="none" w="med" len="med"/>
+                    </a:lnT>
+                    <a:lnB w="6350" cap="flat" cmpd="sng" algn="ctr">
+                      <a:solidFill>
+                        <a:srgbClr val="BFBFBF"/>
+                      </a:solidFill>
+                      <a:prstDash val="solid"/>
+                      <a:round/>
+                      <a:headEnd type="none" w="med" len="med"/>
+                      <a:tailEnd type="none" w="med" len="med"/>
+                    </a:lnB>
+                    <a:solidFill>
+                      <a:srgbClr val="FFFFFF"/>
+                    </a:solidFill>
+                  </a:tcPr>
+                </a:tc>
+              </a:tr>
+              <a:tr h="301752">
+                <a:tc>
+                  <a:txBody>
+                    <a:bodyPr/>
+                    <a:lstStyle/>
+                    <a:p>
+                      <a:pPr algn="l" indent="0" marL="0">
+                        <a:buNone/>
+                      </a:pPr>
+                      <a:r>
+                        <a:rPr lang="en-US" sz="1000" b="1" dirty="0">
+                          <a:solidFill>
+                            <a:srgbClr val="1A1A1A"/>
+                          </a:solidFill>
+                          <a:latin typeface="Garamond" pitchFamily="34" charset="0"/>
+                          <a:ea typeface="Garamond" pitchFamily="34" charset="-122"/>
+                          <a:cs typeface="Garamond" pitchFamily="34" charset="-120"/>
+                        </a:rPr>
+                        <a:t>AI campus &amp; permit screen</a:t>
+                      </a:r>
+                      <a:endParaRPr lang="en-US" sz="1200" dirty="0"/>
+                    </a:p>
+                  </a:txBody>
+                  <a:tcPr marL="50800" marR="50800" marT="12700" marB="12700" anchor="ctr">
+                    <a:lnL w="6350" cap="flat" cmpd="sng" algn="ctr">
+                      <a:solidFill>
+                        <a:srgbClr val="BFBFBF"/>
+                      </a:solidFill>
+                      <a:prstDash val="solid"/>
+                      <a:round/>
+                      <a:headEnd type="none" w="med" len="med"/>
+                      <a:tailEnd type="none" w="med" len="med"/>
+                    </a:lnL>
+                    <a:lnR w="6350" cap="flat" cmpd="sng" algn="ctr">
+                      <a:solidFill>
+                        <a:srgbClr val="BFBFBF"/>
+                      </a:solidFill>
+                      <a:prstDash val="solid"/>
+                      <a:round/>
+                      <a:headEnd type="none" w="med" len="med"/>
+                      <a:tailEnd type="none" w="med" len="med"/>
+                    </a:lnR>
+                    <a:lnT w="6350" cap="flat" cmpd="sng" algn="ctr">
+                      <a:solidFill>
+                        <a:srgbClr val="BFBFBF"/>
+                      </a:solidFill>
+                      <a:prstDash val="solid"/>
+                      <a:round/>
+                      <a:headEnd type="none" w="med" len="med"/>
+                      <a:tailEnd type="none" w="med" len="med"/>
+                    </a:lnT>
+                    <a:lnB w="6350" cap="flat" cmpd="sng" algn="ctr">
+                      <a:solidFill>
+                        <a:srgbClr val="BFBFBF"/>
+                      </a:solidFill>
+                      <a:prstDash val="solid"/>
+                      <a:round/>
+                      <a:headEnd type="none" w="med" len="med"/>
+                      <a:tailEnd type="none" w="med" len="med"/>
+                    </a:lnB>
+                    <a:solidFill>
+                      <a:srgbClr val="F2F2F2"/>
+                    </a:solidFill>
+                  </a:tcPr>
+                </a:tc>
+                <a:tc>
+                  <a:txBody>
+                    <a:bodyPr/>
+                    <a:lstStyle/>
+                    <a:p>
+                      <a:pPr algn="l" indent="0" marL="0">
+                        <a:buNone/>
+                      </a:pPr>
+                      <a:r>
+                        <a:rPr lang="en-US" sz="1000" dirty="0">
+                          <a:solidFill>
+                            <a:srgbClr val="1A1A1A"/>
+                          </a:solidFill>
+                          <a:latin typeface="Garamond" pitchFamily="34" charset="0"/>
+                          <a:ea typeface="Garamond" pitchFamily="34" charset="-122"/>
+                          <a:cs typeface="Garamond" pitchFamily="34" charset="-120"/>
+                        </a:rPr>
+                        <a:t>Read TCEQ / MDEQ permits, utility filings and project trackers; scored 37 sites on 7 win factors</a:t>
+                      </a:r>
+                      <a:endParaRPr lang="en-US" sz="1200" dirty="0"/>
+                    </a:p>
+                  </a:txBody>
+                  <a:tcPr marL="50800" marR="50800" marT="12700" marB="12700" anchor="ctr">
+                    <a:lnL w="6350" cap="flat" cmpd="sng" algn="ctr">
+                      <a:solidFill>
+                        <a:srgbClr val="BFBFBF"/>
+                      </a:solidFill>
+                      <a:prstDash val="solid"/>
+                      <a:round/>
+                      <a:headEnd type="none" w="med" len="med"/>
+                      <a:tailEnd type="none" w="med" len="med"/>
+                    </a:lnL>
+                    <a:lnR w="6350" cap="flat" cmpd="sng" algn="ctr">
+                      <a:solidFill>
+                        <a:srgbClr val="BFBFBF"/>
+                      </a:solidFill>
+                      <a:prstDash val="solid"/>
+                      <a:round/>
+                      <a:headEnd type="none" w="med" len="med"/>
+                      <a:tailEnd type="none" w="med" len="med"/>
+                    </a:lnR>
+                    <a:lnT w="6350" cap="flat" cmpd="sng" algn="ctr">
+                      <a:solidFill>
+                        <a:srgbClr val="BFBFBF"/>
+                      </a:solidFill>
+                      <a:prstDash val="solid"/>
+                      <a:round/>
+                      <a:headEnd type="none" w="med" len="med"/>
+                      <a:tailEnd type="none" w="med" len="med"/>
+                    </a:lnT>
+                    <a:lnB w="6350" cap="flat" cmpd="sng" algn="ctr">
+                      <a:solidFill>
+                        <a:srgbClr val="BFBFBF"/>
+                      </a:solidFill>
+                      <a:prstDash val="solid"/>
+                      <a:round/>
+                      <a:headEnd type="none" w="med" len="med"/>
+                      <a:tailEnd type="none" w="med" len="med"/>
+                    </a:lnB>
+                    <a:solidFill>
+                      <a:srgbClr val="F2F2F2"/>
+                    </a:solidFill>
+                  </a:tcPr>
+                </a:tc>
+                <a:tc>
+                  <a:txBody>
+                    <a:bodyPr/>
+                    <a:lstStyle/>
+                    <a:p>
+                      <a:pPr algn="l" indent="0" marL="0">
+                        <a:buNone/>
+                      </a:pPr>
+                      <a:r>
+                        <a:rPr lang="en-US" sz="1000" dirty="0">
+                          <a:solidFill>
+                            <a:srgbClr val="1A1A1A"/>
+                          </a:solidFill>
+                          <a:latin typeface="Garamond" pitchFamily="34" charset="0"/>
+                          <a:ea typeface="Garamond" pitchFamily="34" charset="-122"/>
+                          <a:cs typeface="Garamond" pitchFamily="34" charset="-120"/>
+                        </a:rPr>
+                        <a:t>Site-level next-order model: </a:t>
+                      </a:r>
+                      <a:r>
+                        <a:rPr lang="en-US" sz="1000" u="sng" dirty="0">
+                          <a:solidFill>
+                            <a:srgbClr val="1A1A1A"/>
+                          </a:solidFill>
+                          <a:latin typeface="Garamond" pitchFamily="34" charset="0"/>
+                          <a:ea typeface="Garamond" pitchFamily="34" charset="-122"/>
+                          <a:cs typeface="Garamond" pitchFamily="34" charset="-120"/>
+                        </a:rPr>
+                        <a:t>~75% odds</a:t>
+                      </a:r>
+                      <a:r>
+                        <a:rPr lang="en-US" sz="1000" dirty="0">
+                          <a:solidFill>
+                            <a:srgbClr val="1A1A1A"/>
+                          </a:solidFill>
+                          <a:latin typeface="Garamond" pitchFamily="34" charset="0"/>
+                          <a:ea typeface="Garamond" pitchFamily="34" charset="-122"/>
+                          <a:cs typeface="Garamond" pitchFamily="34" charset="-120"/>
+                        </a:rPr>
+                        <a:t> in 12M</a:t>
+                      </a:r>
+                      <a:endParaRPr lang="en-US" sz="1200" dirty="0"/>
+                    </a:p>
+                  </a:txBody>
+                  <a:tcPr marL="50800" marR="50800" marT="12700" marB="12700" anchor="ctr">
+                    <a:lnL w="6350" cap="flat" cmpd="sng" algn="ctr">
+                      <a:solidFill>
+                        <a:srgbClr val="BFBFBF"/>
+                      </a:solidFill>
+                      <a:prstDash val="solid"/>
+                      <a:round/>
+                      <a:headEnd type="none" w="med" len="med"/>
+                      <a:tailEnd type="none" w="med" len="med"/>
+                    </a:lnL>
+                    <a:lnR w="6350" cap="flat" cmpd="sng" algn="ctr">
+                      <a:solidFill>
+                        <a:srgbClr val="BFBFBF"/>
+                      </a:solidFill>
+                      <a:prstDash val="solid"/>
+                      <a:round/>
+                      <a:headEnd type="none" w="med" len="med"/>
+                      <a:tailEnd type="none" w="med" len="med"/>
+                    </a:lnR>
+                    <a:lnT w="6350" cap="flat" cmpd="sng" algn="ctr">
+                      <a:solidFill>
+                        <a:srgbClr val="BFBFBF"/>
+                      </a:solidFill>
+                      <a:prstDash val="solid"/>
+                      <a:round/>
+                      <a:headEnd type="none" w="med" len="med"/>
+                      <a:tailEnd type="none" w="med" len="med"/>
+                    </a:lnT>
+                    <a:lnB w="6350" cap="flat" cmpd="sng" algn="ctr">
+                      <a:solidFill>
+                        <a:srgbClr val="BFBFBF"/>
+                      </a:solidFill>
+                      <a:prstDash val="solid"/>
+                      <a:round/>
+                      <a:headEnd type="none" w="med" len="med"/>
+                      <a:tailEnd type="none" w="med" len="med"/>
+                    </a:lnB>
+                    <a:solidFill>
+                      <a:srgbClr val="F2F2F2"/>
+                    </a:solidFill>
+                  </a:tcPr>
+                </a:tc>
+                <a:tc>
+                  <a:txBody>
+                    <a:bodyPr/>
+                    <a:lstStyle/>
+                    <a:p>
+                      <a:pPr algn="ctr" indent="0" marL="0">
+                        <a:buNone/>
+                      </a:pPr>
+                      <a:r>
+                        <a:rPr lang="en-US" sz="1000" dirty="0">
+                          <a:solidFill>
+                            <a:srgbClr val="1A1A1A"/>
+                          </a:solidFill>
+                          <a:latin typeface="Garamond" pitchFamily="34" charset="0"/>
+                          <a:ea typeface="Garamond" pitchFamily="34" charset="-122"/>
+                          <a:cs typeface="Garamond" pitchFamily="34" charset="-120"/>
+                        </a:rPr>
+                        <a:t>Thesis III</a:t>
+                      </a:r>
+                      <a:endParaRPr lang="en-US" sz="1200" dirty="0"/>
+                    </a:p>
+                  </a:txBody>
+                  <a:tcPr marL="50800" marR="50800" marT="12700" marB="12700" anchor="ctr">
+                    <a:lnL w="6350" cap="flat" cmpd="sng" algn="ctr">
+                      <a:solidFill>
+                        <a:srgbClr val="BFBFBF"/>
+                      </a:solidFill>
+                      <a:prstDash val="solid"/>
+                      <a:round/>
+                      <a:headEnd type="none" w="med" len="med"/>
+                      <a:tailEnd type="none" w="med" len="med"/>
+                    </a:lnL>
+                    <a:lnR w="6350" cap="flat" cmpd="sng" algn="ctr">
+                      <a:solidFill>
+                        <a:srgbClr val="BFBFBF"/>
+                      </a:solidFill>
+                      <a:prstDash val="solid"/>
+                      <a:round/>
+                      <a:headEnd type="none" w="med" len="med"/>
+                      <a:tailEnd type="none" w="med" len="med"/>
+                    </a:lnR>
+                    <a:lnT w="6350" cap="flat" cmpd="sng" algn="ctr">
+                      <a:solidFill>
+                        <a:srgbClr val="BFBFBF"/>
+                      </a:solidFill>
+                      <a:prstDash val="solid"/>
+                      <a:round/>
+                      <a:headEnd type="none" w="med" len="med"/>
+                      <a:tailEnd type="none" w="med" len="med"/>
+                    </a:lnT>
+                    <a:lnB w="6350" cap="flat" cmpd="sng" algn="ctr">
+                      <a:solidFill>
+                        <a:srgbClr val="BFBFBF"/>
+                      </a:solidFill>
+                      <a:prstDash val="solid"/>
+                      <a:round/>
+                      <a:headEnd type="none" w="med" len="med"/>
+                      <a:tailEnd type="none" w="med" len="med"/>
+                    </a:lnB>
+                    <a:solidFill>
+                      <a:srgbClr val="F2F2F2"/>
+                    </a:solidFill>
+                  </a:tcPr>
+                </a:tc>
+              </a:tr>
+              <a:tr h="301752">
+                <a:tc>
+                  <a:txBody>
+                    <a:bodyPr/>
+                    <a:lstStyle/>
+                    <a:p>
+                      <a:pPr algn="l" indent="0" marL="0">
+                        <a:buNone/>
+                      </a:pPr>
+                      <a:r>
+                        <a:rPr lang="en-US" sz="1000" b="1" dirty="0">
+                          <a:solidFill>
+                            <a:srgbClr val="1A1A1A"/>
+                          </a:solidFill>
+                          <a:latin typeface="Garamond" pitchFamily="34" charset="0"/>
+                          <a:ea typeface="Garamond" pitchFamily="34" charset="-122"/>
+                          <a:cs typeface="Garamond" pitchFamily="34" charset="-120"/>
+                        </a:rPr>
+                        <a:t>Jereh order ledger</a:t>
+                      </a:r>
+                      <a:endParaRPr lang="en-US" sz="1200" dirty="0"/>
+                    </a:p>
+                  </a:txBody>
+                  <a:tcPr marL="50800" marR="50800" marT="12700" marB="12700" anchor="ctr">
+                    <a:lnL w="6350" cap="flat" cmpd="sng" algn="ctr">
+                      <a:solidFill>
+                        <a:srgbClr val="BFBFBF"/>
+                      </a:solidFill>
+                      <a:prstDash val="solid"/>
+                      <a:round/>
+                      <a:headEnd type="none" w="med" len="med"/>
+                      <a:tailEnd type="none" w="med" len="med"/>
+                    </a:lnL>
+                    <a:lnR w="6350" cap="flat" cmpd="sng" algn="ctr">
+                      <a:solidFill>
+                        <a:srgbClr val="BFBFBF"/>
+                      </a:solidFill>
+                      <a:prstDash val="solid"/>
+                      <a:round/>
+                      <a:headEnd type="none" w="med" len="med"/>
+                      <a:tailEnd type="none" w="med" len="med"/>
+                    </a:lnR>
+                    <a:lnT w="6350" cap="flat" cmpd="sng" algn="ctr">
+                      <a:solidFill>
+                        <a:srgbClr val="BFBFBF"/>
+                      </a:solidFill>
+                      <a:prstDash val="solid"/>
+                      <a:round/>
+                      <a:headEnd type="none" w="med" len="med"/>
+                      <a:tailEnd type="none" w="med" len="med"/>
+                    </a:lnT>
+                    <a:lnB w="6350" cap="flat" cmpd="sng" algn="ctr">
+                      <a:solidFill>
+                        <a:srgbClr val="BFBFBF"/>
+                      </a:solidFill>
+                      <a:prstDash val="solid"/>
+                      <a:round/>
+                      <a:headEnd type="none" w="med" len="med"/>
+                      <a:tailEnd type="none" w="med" len="med"/>
+                    </a:lnB>
+                    <a:solidFill>
+                      <a:srgbClr val="FFFFFF"/>
+                    </a:solidFill>
+                  </a:tcPr>
+                </a:tc>
+                <a:tc>
+                  <a:txBody>
+                    <a:bodyPr/>
+                    <a:lstStyle/>
+                    <a:p>
+                      <a:pPr algn="l" indent="0" marL="0">
+                        <a:buNone/>
+                      </a:pPr>
+                      <a:r>
+                        <a:rPr lang="en-US" sz="1000" dirty="0">
+                          <a:solidFill>
+                            <a:srgbClr val="1A1A1A"/>
+                          </a:solidFill>
+                          <a:latin typeface="Garamond" pitchFamily="34" charset="0"/>
+                          <a:ea typeface="Garamond" pitchFamily="34" charset="-122"/>
+                          <a:cs typeface="Garamond" pitchFamily="34" charset="-120"/>
+                        </a:rPr>
+                        <a:t>Translated Chinese-language filings and press (Jiemian, NBD, TMTPost) into one reconciled ledger</a:t>
+                      </a:r>
+                      <a:endParaRPr lang="en-US" sz="1200" dirty="0"/>
+                    </a:p>
+                  </a:txBody>
+                  <a:tcPr marL="50800" marR="50800" marT="12700" marB="12700" anchor="ctr">
+                    <a:lnL w="6350" cap="flat" cmpd="sng" algn="ctr">
+                      <a:solidFill>
+                        <a:srgbClr val="BFBFBF"/>
+                      </a:solidFill>
+                      <a:prstDash val="solid"/>
+                      <a:round/>
+                      <a:headEnd type="none" w="med" len="med"/>
+                      <a:tailEnd type="none" w="med" len="med"/>
+                    </a:lnL>
+                    <a:lnR w="6350" cap="flat" cmpd="sng" algn="ctr">
+                      <a:solidFill>
+                        <a:srgbClr val="BFBFBF"/>
+                      </a:solidFill>
+                      <a:prstDash val="solid"/>
+                      <a:round/>
+                      <a:headEnd type="none" w="med" len="med"/>
+                      <a:tailEnd type="none" w="med" len="med"/>
+                    </a:lnR>
+                    <a:lnT w="6350" cap="flat" cmpd="sng" algn="ctr">
+                      <a:solidFill>
+                        <a:srgbClr val="BFBFBF"/>
+                      </a:solidFill>
+                      <a:prstDash val="solid"/>
+                      <a:round/>
+                      <a:headEnd type="none" w="med" len="med"/>
+                      <a:tailEnd type="none" w="med" len="med"/>
+                    </a:lnT>
+                    <a:lnB w="6350" cap="flat" cmpd="sng" algn="ctr">
+                      <a:solidFill>
+                        <a:srgbClr val="BFBFBF"/>
+                      </a:solidFill>
+                      <a:prstDash val="solid"/>
+                      <a:round/>
+                      <a:headEnd type="none" w="med" len="med"/>
+                      <a:tailEnd type="none" w="med" len="med"/>
+                    </a:lnB>
+                    <a:solidFill>
+                      <a:srgbClr val="FFFFFF"/>
+                    </a:solidFill>
+                  </a:tcPr>
+                </a:tc>
+                <a:tc>
+                  <a:txBody>
+                    <a:bodyPr/>
+                    <a:lstStyle/>
+                    <a:p>
+                      <a:pPr algn="l" indent="0" marL="0">
+                        <a:buNone/>
+                      </a:pPr>
+                      <a:r>
+                        <a:rPr lang="en-US" sz="1000" dirty="0">
+                          <a:solidFill>
+                            <a:srgbClr val="1A1A1A"/>
+                          </a:solidFill>
+                          <a:latin typeface="Garamond" pitchFamily="34" charset="0"/>
+                          <a:ea typeface="Garamond" pitchFamily="34" charset="-122"/>
+                          <a:cs typeface="Garamond" pitchFamily="34" charset="-120"/>
+                        </a:rPr>
+                        <a:t>7 orders, </a:t>
+                      </a:r>
+                      <a:r>
+                        <a:rPr lang="en-US" sz="1000" u="sng" dirty="0">
+                          <a:solidFill>
+                            <a:srgbClr val="1A1A1A"/>
+                          </a:solidFill>
+                          <a:latin typeface="Garamond" pitchFamily="34" charset="0"/>
+                          <a:ea typeface="Garamond" pitchFamily="34" charset="-122"/>
+                          <a:cs typeface="Garamond" pitchFamily="34" charset="-120"/>
+                        </a:rPr>
+                        <a:t>$2.6bn</a:t>
+                      </a:r>
+                      <a:r>
+                        <a:rPr lang="en-US" sz="1000" dirty="0">
+                          <a:solidFill>
+                            <a:srgbClr val="1A1A1A"/>
+                          </a:solidFill>
+                          <a:latin typeface="Garamond" pitchFamily="34" charset="0"/>
+                          <a:ea typeface="Garamond" pitchFamily="34" charset="-122"/>
+                          <a:cs typeface="Garamond" pitchFamily="34" charset="-120"/>
+                        </a:rPr>
+                        <a:t>; J&amp;F routing share for the Poisson check</a:t>
+                      </a:r>
+                      <a:endParaRPr lang="en-US" sz="1200" dirty="0"/>
+                    </a:p>
+                  </a:txBody>
+                  <a:tcPr marL="50800" marR="50800" marT="12700" marB="12700" anchor="ctr">
+                    <a:lnL w="6350" cap="flat" cmpd="sng" algn="ctr">
+                      <a:solidFill>
+                        <a:srgbClr val="BFBFBF"/>
+                      </a:solidFill>
+                      <a:prstDash val="solid"/>
+                      <a:round/>
+                      <a:headEnd type="none" w="med" len="med"/>
+                      <a:tailEnd type="none" w="med" len="med"/>
+                    </a:lnL>
+                    <a:lnR w="6350" cap="flat" cmpd="sng" algn="ctr">
+                      <a:solidFill>
+                        <a:srgbClr val="BFBFBF"/>
+                      </a:solidFill>
+                      <a:prstDash val="solid"/>
+                      <a:round/>
+                      <a:headEnd type="none" w="med" len="med"/>
+                      <a:tailEnd type="none" w="med" len="med"/>
+                    </a:lnR>
+                    <a:lnT w="6350" cap="flat" cmpd="sng" algn="ctr">
+                      <a:solidFill>
+                        <a:srgbClr val="BFBFBF"/>
+                      </a:solidFill>
+                      <a:prstDash val="solid"/>
+                      <a:round/>
+                      <a:headEnd type="none" w="med" len="med"/>
+                      <a:tailEnd type="none" w="med" len="med"/>
+                    </a:lnT>
+                    <a:lnB w="6350" cap="flat" cmpd="sng" algn="ctr">
+                      <a:solidFill>
+                        <a:srgbClr val="BFBFBF"/>
+                      </a:solidFill>
+                      <a:prstDash val="solid"/>
+                      <a:round/>
+                      <a:headEnd type="none" w="med" len="med"/>
+                      <a:tailEnd type="none" w="med" len="med"/>
+                    </a:lnB>
+                    <a:solidFill>
+                      <a:srgbClr val="FFFFFF"/>
+                    </a:solidFill>
+                  </a:tcPr>
+                </a:tc>
+                <a:tc>
+                  <a:txBody>
+                    <a:bodyPr/>
+                    <a:lstStyle/>
+                    <a:p>
+                      <a:pPr algn="ctr" indent="0" marL="0">
+                        <a:buNone/>
+                      </a:pPr>
+                      <a:r>
+                        <a:rPr lang="en-US" sz="1000" dirty="0">
+                          <a:solidFill>
+                            <a:srgbClr val="1A1A1A"/>
+                          </a:solidFill>
+                          <a:latin typeface="Garamond" pitchFamily="34" charset="0"/>
+                          <a:ea typeface="Garamond" pitchFamily="34" charset="-122"/>
+                          <a:cs typeface="Garamond" pitchFamily="34" charset="-120"/>
+                        </a:rPr>
+                        <a:t>Thesis III</a:t>
+                      </a:r>
+                      <a:endParaRPr lang="en-US" sz="1200" dirty="0"/>
+                    </a:p>
+                  </a:txBody>
+                  <a:tcPr marL="50800" marR="50800" marT="12700" marB="12700" anchor="ctr">
+                    <a:lnL w="6350" cap="flat" cmpd="sng" algn="ctr">
+                      <a:solidFill>
+                        <a:srgbClr val="BFBFBF"/>
+                      </a:solidFill>
+                      <a:prstDash val="solid"/>
+                      <a:round/>
+                      <a:headEnd type="none" w="med" len="med"/>
+                      <a:tailEnd type="none" w="med" len="med"/>
+                    </a:lnL>
+                    <a:lnR w="6350" cap="flat" cmpd="sng" algn="ctr">
+                      <a:solidFill>
+                        <a:srgbClr val="BFBFBF"/>
+                      </a:solidFill>
+                      <a:prstDash val="solid"/>
+                      <a:round/>
+                      <a:headEnd type="none" w="med" len="med"/>
+                      <a:tailEnd type="none" w="med" len="med"/>
+                    </a:lnR>
+                    <a:lnT w="6350" cap="flat" cmpd="sng" algn="ctr">
+                      <a:solidFill>
+                        <a:srgbClr val="BFBFBF"/>
+                      </a:solidFill>
+                      <a:prstDash val="solid"/>
+                      <a:round/>
+                      <a:headEnd type="none" w="med" len="med"/>
+                      <a:tailEnd type="none" w="med" len="med"/>
+                    </a:lnT>
+                    <a:lnB w="6350" cap="flat" cmpd="sng" algn="ctr">
+                      <a:solidFill>
+                        <a:srgbClr val="BFBFBF"/>
+                      </a:solidFill>
+                      <a:prstDash val="solid"/>
+                      <a:round/>
+                      <a:headEnd type="none" w="med" len="med"/>
+                      <a:tailEnd type="none" w="med" len="med"/>
+                    </a:lnB>
+                    <a:solidFill>
+                      <a:srgbClr val="FFFFFF"/>
+                    </a:solidFill>
+                  </a:tcPr>
+                </a:tc>
+              </a:tr>
+              <a:tr h="301752">
+                <a:tc>
+                  <a:txBody>
+                    <a:bodyPr/>
+                    <a:lstStyle/>
+                    <a:p>
+                      <a:pPr algn="l" indent="0" marL="0">
+                        <a:buNone/>
+                      </a:pPr>
+                      <a:r>
+                        <a:rPr lang="en-US" sz="1000" b="1" dirty="0">
+                          <a:solidFill>
+                            <a:srgbClr val="1A1A1A"/>
+                          </a:solidFill>
+                          <a:latin typeface="Garamond" pitchFamily="34" charset="0"/>
+                          <a:ea typeface="Garamond" pitchFamily="34" charset="-122"/>
+                          <a:cs typeface="Garamond" pitchFamily="34" charset="-120"/>
+                        </a:rPr>
+                        <a:t>Grid gap model</a:t>
+                      </a:r>
+                      <a:endParaRPr lang="en-US" sz="1200" dirty="0"/>
+                    </a:p>
+                  </a:txBody>
+                  <a:tcPr marL="50800" marR="50800" marT="12700" marB="12700" anchor="ctr">
+                    <a:lnL w="6350" cap="flat" cmpd="sng" algn="ctr">
+                      <a:solidFill>
+                        <a:srgbClr val="BFBFBF"/>
+                      </a:solidFill>
+                      <a:prstDash val="solid"/>
+                      <a:round/>
+                      <a:headEnd type="none" w="med" len="med"/>
+                      <a:tailEnd type="none" w="med" len="med"/>
+                    </a:lnL>
+                    <a:lnR w="6350" cap="flat" cmpd="sng" algn="ctr">
+                      <a:solidFill>
+                        <a:srgbClr val="BFBFBF"/>
+                      </a:solidFill>
+                      <a:prstDash val="solid"/>
+                      <a:round/>
+                      <a:headEnd type="none" w="med" len="med"/>
+                      <a:tailEnd type="none" w="med" len="med"/>
+                    </a:lnR>
+                    <a:lnT w="6350" cap="flat" cmpd="sng" algn="ctr">
+                      <a:solidFill>
+                        <a:srgbClr val="BFBFBF"/>
+                      </a:solidFill>
+                      <a:prstDash val="solid"/>
+                      <a:round/>
+                      <a:headEnd type="none" w="med" len="med"/>
+                      <a:tailEnd type="none" w="med" len="med"/>
+                    </a:lnT>
+                    <a:lnB w="6350" cap="flat" cmpd="sng" algn="ctr">
+                      <a:solidFill>
+                        <a:srgbClr val="BFBFBF"/>
+                      </a:solidFill>
+                      <a:prstDash val="solid"/>
+                      <a:round/>
+                      <a:headEnd type="none" w="med" len="med"/>
+                      <a:tailEnd type="none" w="med" len="med"/>
+                    </a:lnB>
+                    <a:solidFill>
+                      <a:srgbClr val="F2F2F2"/>
+                    </a:solidFill>
+                  </a:tcPr>
+                </a:tc>
+                <a:tc>
+                  <a:txBody>
+                    <a:bodyPr/>
+                    <a:lstStyle/>
+                    <a:p>
+                      <a:pPr algn="l" indent="0" marL="0">
+                        <a:buNone/>
+                      </a:pPr>
+                      <a:r>
+                        <a:rPr lang="en-US" sz="1000" dirty="0">
+                          <a:solidFill>
+                            <a:srgbClr val="1A1A1A"/>
+                          </a:solidFill>
+                          <a:latin typeface="Garamond" pitchFamily="34" charset="0"/>
+                          <a:ea typeface="Garamond" pitchFamily="34" charset="-122"/>
+                          <a:cs typeface="Garamond" pitchFamily="34" charset="-120"/>
+                        </a:rPr>
+                        <a:t>Compiled NERC LTRA demand vs. capacity and 67 hyperscaler power agreements by region</a:t>
+                      </a:r>
+                      <a:endParaRPr lang="en-US" sz="1200" dirty="0"/>
+                    </a:p>
+                  </a:txBody>
+                  <a:tcPr marL="50800" marR="50800" marT="12700" marB="12700" anchor="ctr">
+                    <a:lnL w="6350" cap="flat" cmpd="sng" algn="ctr">
+                      <a:solidFill>
+                        <a:srgbClr val="BFBFBF"/>
+                      </a:solidFill>
+                      <a:prstDash val="solid"/>
+                      <a:round/>
+                      <a:headEnd type="none" w="med" len="med"/>
+                      <a:tailEnd type="none" w="med" len="med"/>
+                    </a:lnL>
+                    <a:lnR w="6350" cap="flat" cmpd="sng" algn="ctr">
+                      <a:solidFill>
+                        <a:srgbClr val="BFBFBF"/>
+                      </a:solidFill>
+                      <a:prstDash val="solid"/>
+                      <a:round/>
+                      <a:headEnd type="none" w="med" len="med"/>
+                      <a:tailEnd type="none" w="med" len="med"/>
+                    </a:lnR>
+                    <a:lnT w="6350" cap="flat" cmpd="sng" algn="ctr">
+                      <a:solidFill>
+                        <a:srgbClr val="BFBFBF"/>
+                      </a:solidFill>
+                      <a:prstDash val="solid"/>
+                      <a:round/>
+                      <a:headEnd type="none" w="med" len="med"/>
+                      <a:tailEnd type="none" w="med" len="med"/>
+                    </a:lnT>
+                    <a:lnB w="6350" cap="flat" cmpd="sng" algn="ctr">
+                      <a:solidFill>
+                        <a:srgbClr val="BFBFBF"/>
+                      </a:solidFill>
+                      <a:prstDash val="solid"/>
+                      <a:round/>
+                      <a:headEnd type="none" w="med" len="med"/>
+                      <a:tailEnd type="none" w="med" len="med"/>
+                    </a:lnB>
+                    <a:solidFill>
+                      <a:srgbClr val="F2F2F2"/>
+                    </a:solidFill>
+                  </a:tcPr>
+                </a:tc>
+                <a:tc>
+                  <a:txBody>
+                    <a:bodyPr/>
+                    <a:lstStyle/>
+                    <a:p>
+                      <a:pPr algn="l" indent="0" marL="0">
+                        <a:buNone/>
+                      </a:pPr>
+                      <a:r>
+                        <a:rPr lang="en-US" sz="1000" u="sng" dirty="0">
+                          <a:solidFill>
+                            <a:srgbClr val="1A1A1A"/>
+                          </a:solidFill>
+                          <a:latin typeface="Garamond" pitchFamily="34" charset="0"/>
+                          <a:ea typeface="Garamond" pitchFamily="34" charset="-122"/>
+                          <a:cs typeface="Garamond" pitchFamily="34" charset="-120"/>
+                        </a:rPr>
+                        <a:t>8–47 GW</a:t>
+                      </a:r>
+                      <a:r>
+                        <a:rPr lang="en-US" sz="1000" dirty="0">
+                          <a:solidFill>
+                            <a:srgbClr val="1A1A1A"/>
+                          </a:solidFill>
+                          <a:latin typeface="Garamond" pitchFamily="34" charset="0"/>
+                          <a:ea typeface="Garamond" pitchFamily="34" charset="-122"/>
+                          <a:cs typeface="Garamond" pitchFamily="34" charset="-120"/>
+                        </a:rPr>
+                        <a:t> reserve shortfall from 2029</a:t>
+                      </a:r>
+                      <a:endParaRPr lang="en-US" sz="1200" dirty="0"/>
+                    </a:p>
+                  </a:txBody>
+                  <a:tcPr marL="50800" marR="50800" marT="12700" marB="12700" anchor="ctr">
+                    <a:lnL w="6350" cap="flat" cmpd="sng" algn="ctr">
+                      <a:solidFill>
+                        <a:srgbClr val="BFBFBF"/>
+                      </a:solidFill>
+                      <a:prstDash val="solid"/>
+                      <a:round/>
+                      <a:headEnd type="none" w="med" len="med"/>
+                      <a:tailEnd type="none" w="med" len="med"/>
+                    </a:lnL>
+                    <a:lnR w="6350" cap="flat" cmpd="sng" algn="ctr">
+                      <a:solidFill>
+                        <a:srgbClr val="BFBFBF"/>
+                      </a:solidFill>
+                      <a:prstDash val="solid"/>
+                      <a:round/>
+                      <a:headEnd type="none" w="med" len="med"/>
+                      <a:tailEnd type="none" w="med" len="med"/>
+                    </a:lnR>
+                    <a:lnT w="6350" cap="flat" cmpd="sng" algn="ctr">
+                      <a:solidFill>
+                        <a:srgbClr val="BFBFBF"/>
+                      </a:solidFill>
+                      <a:prstDash val="solid"/>
+                      <a:round/>
+                      <a:headEnd type="none" w="med" len="med"/>
+                      <a:tailEnd type="none" w="med" len="med"/>
+                    </a:lnT>
+                    <a:lnB w="6350" cap="flat" cmpd="sng" algn="ctr">
+                      <a:solidFill>
+                        <a:srgbClr val="BFBFBF"/>
+                      </a:solidFill>
+                      <a:prstDash val="solid"/>
+                      <a:round/>
+                      <a:headEnd type="none" w="med" len="med"/>
+                      <a:tailEnd type="none" w="med" len="med"/>
+                    </a:lnB>
+                    <a:solidFill>
+                      <a:srgbClr val="F2F2F2"/>
+                    </a:solidFill>
+                  </a:tcPr>
+                </a:tc>
+                <a:tc>
+                  <a:txBody>
+                    <a:bodyPr/>
+                    <a:lstStyle/>
+                    <a:p>
+                      <a:pPr algn="ctr" indent="0" marL="0">
+                        <a:buNone/>
+                      </a:pPr>
+                      <a:r>
+                        <a:rPr lang="en-US" sz="1000" dirty="0">
+                          <a:solidFill>
+                            <a:srgbClr val="1A1A1A"/>
+                          </a:solidFill>
+                          <a:latin typeface="Garamond" pitchFamily="34" charset="0"/>
+                          <a:ea typeface="Garamond" pitchFamily="34" charset="-122"/>
+                          <a:cs typeface="Garamond" pitchFamily="34" charset="-120"/>
+                        </a:rPr>
+                        <a:t>Thesis III</a:t>
+                      </a:r>
+                      <a:endParaRPr lang="en-US" sz="1200" dirty="0"/>
+                    </a:p>
+                  </a:txBody>
+                  <a:tcPr marL="50800" marR="50800" marT="12700" marB="12700" anchor="ctr">
+                    <a:lnL w="6350" cap="flat" cmpd="sng" algn="ctr">
+                      <a:solidFill>
+                        <a:srgbClr val="BFBFBF"/>
+                      </a:solidFill>
+                      <a:prstDash val="solid"/>
+                      <a:round/>
+                      <a:headEnd type="none" w="med" len="med"/>
+                      <a:tailEnd type="none" w="med" len="med"/>
+                    </a:lnL>
+                    <a:lnR w="6350" cap="flat" cmpd="sng" algn="ctr">
+                      <a:solidFill>
+                        <a:srgbClr val="BFBFBF"/>
+                      </a:solidFill>
+                      <a:prstDash val="solid"/>
+                      <a:round/>
+                      <a:headEnd type="none" w="med" len="med"/>
+                      <a:tailEnd type="none" w="med" len="med"/>
+                    </a:lnR>
+                    <a:lnT w="6350" cap="flat" cmpd="sng" algn="ctr">
+                      <a:solidFill>
+                        <a:srgbClr val="BFBFBF"/>
+                      </a:solidFill>
+                      <a:prstDash val="solid"/>
+                      <a:round/>
+                      <a:headEnd type="none" w="med" len="med"/>
+                      <a:tailEnd type="none" w="med" len="med"/>
+                    </a:lnT>
+                    <a:lnB w="6350" cap="flat" cmpd="sng" algn="ctr">
+                      <a:solidFill>
+                        <a:srgbClr val="BFBFBF"/>
+                      </a:solidFill>
+                      <a:prstDash val="solid"/>
+                      <a:round/>
+                      <a:headEnd type="none" w="med" len="med"/>
+                      <a:tailEnd type="none" w="med" len="med"/>
+                    </a:lnB>
+                    <a:solidFill>
+                      <a:srgbClr val="F2F2F2"/>
+                    </a:solidFill>
+                  </a:tcPr>
+                </a:tc>
+              </a:tr>
+            </a:tbl>
+          </a:graphicData>
+        </a:graphic>
+      </p:graphicFrame>
+      <p:sp>
+        <p:nvSpPr>
+          <p:cNvPr id="6" name="Text 3"/>
+          <p:cNvSpPr txBox="1"/>
+          <p:nvPr/>
+        </p:nvSpPr>
+        <p:spPr>
+          <a:xfrm>
+            <a:off x="621792" y="3986784"/>
+            <a:ext cx="11201400" cy="274320"/>
+          </a:xfrm>
+          <a:prstGeom prst="rect">
+            <a:avLst/>
+          </a:prstGeom>
+          <a:noFill/>
+          <a:ln/>
+        </p:spPr>
+        <p:txBody>
+          <a:bodyPr wrap="square" lIns="0" tIns="0" rIns="0" bIns="0" rtlCol="0" anchor="b"/>
+          <a:lstStyle/>
+          <a:p>
+            <a:pPr algn="ctr" indent="0" marL="0">
+              <a:buNone/>
+            </a:pPr>
+            <a:r>
+              <a:rPr lang="en-US" sz="1350" b="1" dirty="0">
+                <a:solidFill>
+                  <a:srgbClr val="203040"/>
+                </a:solidFill>
+                <a:latin typeface="Garamond" pitchFamily="34" charset="0"/>
+                <a:ea typeface="Garamond" pitchFamily="34" charset="-122"/>
+                <a:cs typeface="Garamond" pitchFamily="34" charset="-120"/>
+              </a:rPr>
+              <a:t>AI did the reading and the arithmetic; the team made every call that moves the price target.</a:t>
+            </a:r>
+            <a:endParaRPr lang="en-US" sz="1350" dirty="0"/>
+          </a:p>
+        </p:txBody>
+      </p:sp>
+      <p:sp>
+        <p:nvSpPr>
+          <p:cNvPr id="7" name="Shape 4"/>
+          <p:cNvSpPr/>
+          <p:nvPr/>
+        </p:nvSpPr>
+        <p:spPr>
+          <a:xfrm>
+            <a:off x="621792" y="4288536"/>
+            <a:ext cx="11201400" cy="0"/>
+          </a:xfrm>
+          <a:prstGeom prst="line">
+            <a:avLst/>
+          </a:prstGeom>
+          <a:noFill/>
+          <a:ln w="9525">
+            <a:solidFill>
+              <a:srgbClr val="203040"/>
+            </a:solidFill>
+            <a:prstDash val="solid"/>
+          </a:ln>
+        </p:spPr>
+      </p:sp>
+      <p:sp>
+        <p:nvSpPr>
+          <p:cNvPr id="8" name="Text 5"/>
+          <p:cNvSpPr txBox="1"/>
+          <p:nvPr/>
+        </p:nvSpPr>
+        <p:spPr>
+          <a:xfrm>
+            <a:off x="621792" y="4334256"/>
+            <a:ext cx="5486400" cy="237744"/>
+          </a:xfrm>
+          <a:prstGeom prst="rect">
+            <a:avLst/>
+          </a:prstGeom>
+          <a:noFill/>
+          <a:ln/>
+        </p:spPr>
+        <p:txBody>
+          <a:bodyPr wrap="square" lIns="25400" tIns="25400" rIns="25400" bIns="25400" rtlCol="0" anchor="t"/>
+          <a:lstStyle/>
+          <a:p>
+            <a:pPr algn="ctr" indent="0" marL="0">
+              <a:lnSpc>
+                <a:spcPct val="100000"/>
+              </a:lnSpc>
+              <a:buNone/>
+            </a:pPr>
+            <a:r>
+              <a:rPr lang="en-US" sz="1150" b="1" u="sng" dirty="0">
+                <a:solidFill>
+                  <a:srgbClr val="1A1A1A"/>
+                </a:solidFill>
+                <a:latin typeface="Garamond" pitchFamily="34" charset="0"/>
+                <a:ea typeface="Garamond" pitchFamily="34" charset="-122"/>
+                <a:cs typeface="Garamond" pitchFamily="34" charset="-120"/>
+              </a:rPr>
+              <a:t>Where AI helped</a:t>
+            </a:r>
+            <a:endParaRPr lang="en-US" sz="1150" dirty="0"/>
+          </a:p>
+        </p:txBody>
+      </p:sp>
+      <p:sp>
+        <p:nvSpPr>
+          <p:cNvPr id="9" name="Text 6"/>
+          <p:cNvSpPr txBox="1"/>
+          <p:nvPr/>
+        </p:nvSpPr>
+        <p:spPr>
+          <a:xfrm>
+            <a:off x="621792" y="4572000"/>
+            <a:ext cx="5486400" cy="1280160"/>
+          </a:xfrm>
+          <a:prstGeom prst="rect">
+            <a:avLst/>
+          </a:prstGeom>
+          <a:noFill/>
+          <a:ln/>
+        </p:spPr>
+        <p:txBody>
+          <a:bodyPr wrap="square" lIns="25400" tIns="25400" rIns="25400" bIns="25400" rtlCol="0" anchor="t"/>
+          <a:lstStyle/>
+          <a:p>
+            <a:pPr marL="177800" indent="-177800">
+              <a:spcAft>
+                <a:spcPts val="300"/>
+              </a:spcAft>
+              <a:buSzPct val="100000"/>
+              <a:buChar char="•"/>
+            </a:pPr>
+            <a:r>
+              <a:rPr lang="en-US" sz="1100" b="1" dirty="0">
+                <a:solidFill>
+                  <a:srgbClr val="1A1A1A"/>
+                </a:solidFill>
+                <a:latin typeface="Garamond" pitchFamily="34" charset="0"/>
+                <a:ea typeface="Garamond" pitchFamily="34" charset="-122"/>
+                <a:cs typeface="Garamond" pitchFamily="34" charset="-120"/>
+              </a:rPr>
+              <a:t>Scale:</a:t>
+            </a:r>
+            <a:r>
+              <a:rPr lang="en-US" sz="1100" dirty="0">
+                <a:solidFill>
+                  <a:srgbClr val="1A1A1A"/>
+                </a:solidFill>
+                <a:latin typeface="Garamond" pitchFamily="34" charset="0"/>
+                <a:ea typeface="Garamond" pitchFamily="34" charset="-122"/>
+                <a:cs typeface="Garamond" pitchFamily="34" charset="-120"/>
+              </a:rPr>
+              <a:t> thousands of catalogue lines and dozens of filings read in days, not weeks</a:t>
+            </a:r>
+            <a:endParaRPr lang="en-US" sz="1100" dirty="0"/>
+          </a:p>
+          <a:p>
+            <a:pPr marL="177800" indent="-177800">
+              <a:spcAft>
+                <a:spcPts val="300"/>
+              </a:spcAft>
+              <a:buSzPct val="100000"/>
+              <a:buChar char="•"/>
+            </a:pPr>
+            <a:r>
+              <a:rPr lang="en-US" sz="1100" b="1" dirty="0">
+                <a:solidFill>
+                  <a:srgbClr val="1A1A1A"/>
+                </a:solidFill>
+                <a:latin typeface="Garamond" pitchFamily="34" charset="0"/>
+                <a:ea typeface="Garamond" pitchFamily="34" charset="-122"/>
+                <a:cs typeface="Garamond" pitchFamily="34" charset="-120"/>
+              </a:rPr>
+              <a:t>Reach:</a:t>
+            </a:r>
+            <a:r>
+              <a:rPr lang="en-US" sz="1100" dirty="0">
+                <a:solidFill>
+                  <a:srgbClr val="1A1A1A"/>
+                </a:solidFill>
+                <a:latin typeface="Garamond" pitchFamily="34" charset="0"/>
+                <a:ea typeface="Garamond" pitchFamily="34" charset="-122"/>
+                <a:cs typeface="Garamond" pitchFamily="34" charset="-120"/>
+              </a:rPr>
+              <a:t> Chinese-language and state-permit sources the street rarely reads</a:t>
+            </a:r>
+            <a:endParaRPr lang="en-US" sz="1100" dirty="0"/>
+          </a:p>
+          <a:p>
+            <a:pPr marL="177800" indent="-177800">
+              <a:spcAft>
+                <a:spcPts val="300"/>
+              </a:spcAft>
+              <a:buSzPct val="100000"/>
+              <a:buChar char="•"/>
+            </a:pPr>
+            <a:r>
+              <a:rPr lang="en-US" sz="1100" b="1" dirty="0">
+                <a:solidFill>
+                  <a:srgbClr val="1A1A1A"/>
+                </a:solidFill>
+                <a:latin typeface="Garamond" pitchFamily="34" charset="0"/>
+                <a:ea typeface="Garamond" pitchFamily="34" charset="-122"/>
+                <a:cs typeface="Garamond" pitchFamily="34" charset="-120"/>
+              </a:rPr>
+              <a:t>Consistency:</a:t>
+            </a:r>
+            <a:r>
+              <a:rPr lang="en-US" sz="1100" dirty="0">
+                <a:solidFill>
+                  <a:srgbClr val="1A1A1A"/>
+                </a:solidFill>
+                <a:latin typeface="Garamond" pitchFamily="34" charset="0"/>
+                <a:ea typeface="Garamond" pitchFamily="34" charset="-122"/>
+                <a:cs typeface="Garamond" pitchFamily="34" charset="-120"/>
+              </a:rPr>
+              <a:t> one model feeds every slide; AI re-checked each figure across the deck</a:t>
+            </a:r>
+            <a:endParaRPr lang="en-US" sz="1100" dirty="0"/>
+          </a:p>
+        </p:txBody>
+      </p:sp>
+      <p:sp>
+        <p:nvSpPr>
+          <p:cNvPr id="10" name="Shape 7"/>
+          <p:cNvSpPr/>
+          <p:nvPr/>
+        </p:nvSpPr>
+        <p:spPr>
+          <a:xfrm>
+            <a:off x="6227064" y="4352544"/>
+            <a:ext cx="0" cy="1481328"/>
+          </a:xfrm>
+          <a:prstGeom prst="line">
+            <a:avLst/>
+          </a:prstGeom>
+          <a:noFill/>
+          <a:ln w="12700">
+            <a:solidFill>
+              <a:srgbClr val="1A1A1A"/>
+            </a:solidFill>
+            <a:prstDash val="sysDot"/>
+          </a:ln>
+        </p:spPr>
+      </p:sp>
+      <p:sp>
+        <p:nvSpPr>
+          <p:cNvPr id="11" name="Text 8"/>
+          <p:cNvSpPr txBox="1"/>
+          <p:nvPr/>
+        </p:nvSpPr>
+        <p:spPr>
+          <a:xfrm>
+            <a:off x="6336792" y="4334256"/>
+            <a:ext cx="5486400" cy="237744"/>
+          </a:xfrm>
+          <a:prstGeom prst="rect">
+            <a:avLst/>
+          </a:prstGeom>
+          <a:noFill/>
+          <a:ln/>
+        </p:spPr>
+        <p:txBody>
+          <a:bodyPr wrap="square" lIns="25400" tIns="25400" rIns="25400" bIns="25400" rtlCol="0" anchor="t"/>
+          <a:lstStyle/>
+          <a:p>
+            <a:pPr algn="ctr" indent="0" marL="0">
+              <a:lnSpc>
+                <a:spcPct val="100000"/>
+              </a:lnSpc>
+              <a:buNone/>
+            </a:pPr>
+            <a:r>
+              <a:rPr lang="en-US" sz="1150" b="1" u="sng" dirty="0">
+                <a:solidFill>
+                  <a:srgbClr val="1A1A1A"/>
+                </a:solidFill>
+                <a:latin typeface="Garamond" pitchFamily="34" charset="0"/>
+                <a:ea typeface="Garamond" pitchFamily="34" charset="-122"/>
+                <a:cs typeface="Garamond" pitchFamily="34" charset="-120"/>
+              </a:rPr>
+              <a:t>Guardrails we kept</a:t>
+            </a:r>
+            <a:endParaRPr lang="en-US" sz="1150" dirty="0"/>
+          </a:p>
+        </p:txBody>
+      </p:sp>
+      <p:sp>
+        <p:nvSpPr>
+          <p:cNvPr id="12" name="Text 9"/>
+          <p:cNvSpPr txBox="1"/>
+          <p:nvPr/>
+        </p:nvSpPr>
+        <p:spPr>
+          <a:xfrm>
+            <a:off x="6336792" y="4572000"/>
+            <a:ext cx="5486400" cy="1280160"/>
+          </a:xfrm>
+          <a:prstGeom prst="rect">
+            <a:avLst/>
+          </a:prstGeom>
+          <a:noFill/>
+          <a:ln/>
+        </p:spPr>
+        <p:txBody>
+          <a:bodyPr wrap="square" lIns="25400" tIns="25400" rIns="25400" bIns="25400" rtlCol="0" anchor="t"/>
+          <a:lstStyle/>
+          <a:p>
+            <a:pPr marL="177800" indent="-177800">
+              <a:spcAft>
+                <a:spcPts val="300"/>
+              </a:spcAft>
+              <a:buSzPct val="100000"/>
+              <a:buChar char="•"/>
+            </a:pPr>
+            <a:r>
+              <a:rPr lang="en-US" sz="1100" b="1" dirty="0">
+                <a:solidFill>
+                  <a:srgbClr val="1A1A1A"/>
+                </a:solidFill>
+                <a:latin typeface="Garamond" pitchFamily="34" charset="0"/>
+                <a:ea typeface="Garamond" pitchFamily="34" charset="-122"/>
+                <a:cs typeface="Garamond" pitchFamily="34" charset="-120"/>
+              </a:rPr>
+              <a:t>Source or cut:</a:t>
+            </a:r>
+            <a:r>
+              <a:rPr lang="en-US" sz="1100" dirty="0">
+                <a:solidFill>
+                  <a:srgbClr val="1A1A1A"/>
+                </a:solidFill>
+                <a:latin typeface="Garamond" pitchFamily="34" charset="0"/>
+                <a:ea typeface="Garamond" pitchFamily="34" charset="-122"/>
+                <a:cs typeface="Garamond" pitchFamily="34" charset="-120"/>
+              </a:rPr>
+              <a:t> every AI-pulled number was checked against the document; claims with no source were dropped</a:t>
+            </a:r>
+            <a:endParaRPr lang="en-US" sz="1100" dirty="0"/>
+          </a:p>
+          <a:p>
+            <a:pPr marL="177800" indent="-177800">
+              <a:spcAft>
+                <a:spcPts val="300"/>
+              </a:spcAft>
+              <a:buSzPct val="100000"/>
+              <a:buChar char="•"/>
+            </a:pPr>
+            <a:r>
+              <a:rPr lang="en-US" sz="1100" b="1" dirty="0">
+                <a:solidFill>
+                  <a:srgbClr val="1A1A1A"/>
+                </a:solidFill>
+                <a:latin typeface="Garamond" pitchFamily="34" charset="0"/>
+                <a:ea typeface="Garamond" pitchFamily="34" charset="-122"/>
+                <a:cs typeface="Garamond" pitchFamily="34" charset="-120"/>
+              </a:rPr>
+              <a:t>Say what we didn't find:</a:t>
+            </a:r>
+            <a:r>
+              <a:rPr lang="en-US" sz="1100" dirty="0">
+                <a:solidFill>
+                  <a:srgbClr val="1A1A1A"/>
+                </a:solidFill>
+                <a:latin typeface="Garamond" pitchFamily="34" charset="0"/>
+                <a:ea typeface="Garamond" pitchFamily="34" charset="-122"/>
+                <a:cs typeface="Garamond" pitchFamily="34" charset="-120"/>
+              </a:rPr>
+              <a:t> no public case of an OEM cutting CFM56 cells – so we frame it as LEAP sharing slots</a:t>
+            </a:r>
+            <a:endParaRPr lang="en-US" sz="1100" dirty="0"/>
+          </a:p>
+          <a:p>
+            <a:pPr marL="177800" indent="-177800">
+              <a:spcAft>
+                <a:spcPts val="300"/>
+              </a:spcAft>
+              <a:buSzPct val="100000"/>
+              <a:buChar char="•"/>
+            </a:pPr>
+            <a:r>
+              <a:rPr lang="en-US" sz="1100" b="1" dirty="0">
+                <a:solidFill>
+                  <a:srgbClr val="1A1A1A"/>
+                </a:solidFill>
+                <a:latin typeface="Garamond" pitchFamily="34" charset="0"/>
+                <a:ea typeface="Garamond" pitchFamily="34" charset="-122"/>
+                <a:cs typeface="Garamond" pitchFamily="34" charset="-120"/>
+              </a:rPr>
+              <a:t>Human judgment:</a:t>
+            </a:r>
+            <a:r>
+              <a:rPr lang="en-US" sz="1100" dirty="0">
+                <a:solidFill>
+                  <a:srgbClr val="1A1A1A"/>
+                </a:solidFill>
+                <a:latin typeface="Garamond" pitchFamily="34" charset="0"/>
+                <a:ea typeface="Garamond" pitchFamily="34" charset="-122"/>
+                <a:cs typeface="Garamond" pitchFamily="34" charset="-120"/>
+              </a:rPr>
+              <a:t> probabilities, win scores, multiples and cases were set by the team; public information only</a:t>
+            </a:r>
+            <a:endParaRPr lang="en-US" sz="1100" dirty="0"/>
+          </a:p>
+        </p:txBody>
+      </p:sp>
+      <p:sp>
+        <p:nvSpPr>
+          <p:cNvPr id="13" name="Shape 10"/>
+          <p:cNvSpPr/>
+          <p:nvPr/>
+        </p:nvSpPr>
+        <p:spPr>
+          <a:xfrm>
+            <a:off x="621792" y="5925312"/>
+            <a:ext cx="11201400" cy="402336"/>
+          </a:xfrm>
+          <a:prstGeom prst="rect">
+            <a:avLst/>
+          </a:prstGeom>
+          <a:solidFill>
+            <a:srgbClr val="1F3864"/>
+          </a:solidFill>
+          <a:ln w="12700">
+            <a:solidFill>
+              <a:srgbClr val="1F3864"/>
+            </a:solidFill>
+            <a:prstDash val="solid"/>
+          </a:ln>
+        </p:spPr>
+      </p:sp>
+      <p:sp>
+        <p:nvSpPr>
+          <p:cNvPr id="14" name="Text 11"/>
+          <p:cNvSpPr txBox="1"/>
+          <p:nvPr/>
+        </p:nvSpPr>
+        <p:spPr>
+          <a:xfrm>
+            <a:off x="621792" y="5925312"/>
+            <a:ext cx="11201400" cy="402336"/>
+          </a:xfrm>
+          <a:prstGeom prst="rect">
+            <a:avLst/>
+          </a:prstGeom>
+          <a:noFill/>
+          <a:ln/>
+        </p:spPr>
+        <p:txBody>
+          <a:bodyPr wrap="square" lIns="25400" tIns="25400" rIns="25400" bIns="25400" rtlCol="0" anchor="ctr"/>
+          <a:lstStyle/>
+          <a:p>
+            <a:pPr algn="ctr" indent="0" marL="0">
+              <a:buNone/>
+            </a:pPr>
+            <a:r>
+              <a:rPr lang="en-US" sz="1400" b="1" dirty="0">
+                <a:solidFill>
+                  <a:srgbClr val="FFFFFF"/>
+                </a:solidFill>
+                <a:latin typeface="Garamond" pitchFamily="34" charset="0"/>
+                <a:ea typeface="Garamond" pitchFamily="34" charset="-122"/>
+                <a:cs typeface="Garamond" pitchFamily="34" charset="-120"/>
+              </a:rPr>
+              <a:t>AI widened what we could check; it never decided what we believe – the thesis rests on sourced, team-verified data.</a:t>
+            </a:r>
+            <a:endParaRPr lang="en-US" sz="1400" dirty="0"/>
+          </a:p>
+        </p:txBody>
+      </p:sp>
+      <p:sp>
+        <p:nvSpPr>
+          <p:cNvPr id="15" name="Text 12"/>
+          <p:cNvSpPr txBox="1"/>
+          <p:nvPr/>
+        </p:nvSpPr>
+        <p:spPr>
+          <a:xfrm>
+            <a:off x="621792" y="6473952"/>
+            <a:ext cx="10515600" cy="347472"/>
+          </a:xfrm>
+          <a:prstGeom prst="rect">
+            <a:avLst/>
+          </a:prstGeom>
+          <a:noFill/>
+          <a:ln/>
+        </p:spPr>
+        <p:txBody>
+          <a:bodyPr wrap="square" lIns="0" tIns="0" rIns="0" bIns="0" rtlCol="0" anchor="t"/>
+          <a:lstStyle/>
+          <a:p>
+            <a:pPr indent="0" marL="0">
+              <a:buNone/>
+            </a:pPr>
+            <a:r>
+              <a:rPr lang="en-US" sz="1100" dirty="0">
+                <a:solidFill>
+                  <a:srgbClr val="1A1A1A"/>
+                </a:solidFill>
+                <a:latin typeface="Garamond" pitchFamily="34" charset="0"/>
+                <a:ea typeface="Garamond" pitchFamily="34" charset="-122"/>
+                <a:cs typeface="Garamond" pitchFamily="34" charset="-120"/>
+              </a:rPr>
+              <a:t>Source: Team diligence files: flip tracker, test cell tracker, Power next-contract model, repair-price scrape; sources as cited on each slide</a:t>
+            </a:r>
+            <a:endParaRPr lang="en-US" sz="1100" dirty="0"/>
+          </a:p>
+        </p:txBody>
+      </p:sp>
+      <p:sp>
+        <p:nvSpPr>
+          <p:cNvPr id="25" name="Slide Number Placeholder 0"/>
+          <p:cNvSpPr>
+            <a:spLocks noGrp="1"/>
+          </p:cNvSpPr>
+          <p:nvPr>
+            <p:ph type="sldNum" sz="quarter" idx="4294967295"/>
+          </p:nvPr>
+        </p:nvSpPr>
+        <p:spPr>
+          <a:xfrm>
+            <a:off x="11475720" y="6492240"/>
+            <a:ext cx="365760" cy="274320"/>
+          </a:xfrm>
+          <a:prstGeom prst="rect">
+            <a:avLst/>
+          </a:prstGeom>
+          <a:extLst>
+            <a:ext uri="{C572A759-6A51-4108-AA02-DFA0A04FC94B}">
+              <ma14:wrappingTextBoxFlag xmlns:ma14="http://schemas.microsoft.com/office/mac/drawingml/2011/main" val="0"/>
+            </a:ext>
+          </a:extLst>
+        </p:spPr>
+        <p:txBody>
+          <a:bodyPr/>
+          <a:lstStyle>
+            <a:lvl1pPr>
+              <a:defRPr sz="1200">
+                <a:solidFill>
+                  <a:srgbClr val="1A1A1A"/>
+                </a:solidFill>
+                <a:latin typeface="Garamond"/>
+                <a:ea typeface="Garamond"/>
+                <a:cs typeface="Garamond"/>
+              </a:defRPr>
+            </a:lvl1pPr>
+          </a:lstStyle>
+          <a:p>
+            <a:pPr algn="r"/>
+            <a:fld id="{F7021451-1387-4CA6-816F-3879F97B5CBC}" type="slidenum">
+              <a:rPr b="0" lang="en-US"/>
+              <a:t>14</a:t>
+            </a:fld>
+            <a:endParaRPr lang="en-US"/>
+          </a:p>
+        </p:txBody>
+      </p:sp>
+    </p:spTree>
+  </p:cSld>
+  <p:clrMapOvr>
+    <a:masterClrMapping/>
+  </p:clrMapOvr>
+</p:sld>
+</file>
+
 <file path=ppt/slides/slide2.xml><?xml version="1.0" encoding="utf-8"?>
 <p:sld xmlns:a="http://schemas.openxmlformats.org/drawingml/2006/main" xmlns:r="http://schemas.openxmlformats.org/officeDocument/2006/relationships" xmlns:p="http://schemas.openxmlformats.org/presentationml/2006/main">
   <p:cSld name="Slide 2">

</xml_diff>